<commit_message>
feature: generate a season cover before the songs
</commit_message>
<xml_diff>
--- a/backend/data/template_4x3.pptx
+++ b/backend/data/template_4x3.pptx
@@ -653,6 +653,662 @@
 
 <file path=ppt/slideLayouts/slideLayout10.xml><?xml version="1.0" encoding="utf-8"?>
 <p:sldLayout xmlns:a="http://schemas.openxmlformats.org/drawingml/2006/main" xmlns:r="http://schemas.openxmlformats.org/officeDocument/2006/relationships" xmlns:p="http://schemas.openxmlformats.org/presentationml/2006/main" preserve="1" userDrawn="1">
+  <p:cSld name="Título e letra">
+    <p:spTree>
+      <p:nvGrpSpPr>
+        <p:cNvPr id="1" name=""/>
+        <p:cNvGrpSpPr/>
+        <p:nvPr/>
+      </p:nvGrpSpPr>
+      <p:grpSpPr>
+        <a:xfrm>
+          <a:off x="0" y="0"/>
+          <a:ext cx="0" cy="0"/>
+          <a:chOff x="0" y="0"/>
+          <a:chExt cx="0" cy="0"/>
+        </a:xfrm>
+      </p:grpSpPr>
+      <p:sp>
+        <p:nvSpPr>
+          <p:cNvPr id="7" name="Header">
+            <a:extLst>
+              <a:ext uri="{FF2B5EF4-FFF2-40B4-BE49-F238E27FC236}">
+                <a16:creationId xmlns:a16="http://schemas.microsoft.com/office/drawing/2014/main" id="{9C521DED-F031-73C8-3FE1-6EDC94DF1880}"/>
+              </a:ext>
+            </a:extLst>
+          </p:cNvPr>
+          <p:cNvSpPr/>
+          <p:nvPr userDrawn="1"/>
+        </p:nvSpPr>
+        <p:spPr>
+          <a:xfrm>
+            <a:off x="0" y="0"/>
+            <a:ext cx="9144000" cy="801278"/>
+          </a:xfrm>
+          <a:prstGeom prst="rect">
+            <a:avLst/>
+          </a:prstGeom>
+          <a:solidFill>
+            <a:schemeClr val="accent1"/>
+          </a:solidFill>
+          <a:ln>
+            <a:noFill/>
+          </a:ln>
+        </p:spPr>
+        <p:style>
+          <a:lnRef idx="2">
+            <a:schemeClr val="accent1">
+              <a:shade val="15000"/>
+            </a:schemeClr>
+          </a:lnRef>
+          <a:fillRef idx="1">
+            <a:schemeClr val="accent1"/>
+          </a:fillRef>
+          <a:effectRef idx="0">
+            <a:schemeClr val="accent1"/>
+          </a:effectRef>
+          <a:fontRef idx="minor">
+            <a:schemeClr val="lt1"/>
+          </a:fontRef>
+        </p:style>
+        <p:txBody>
+          <a:bodyPr wrap="none" rtlCol="0" anchor="ctr">
+            <a:normAutofit/>
+          </a:bodyPr>
+          <a:lstStyle/>
+          <a:p>
+            <a:pPr algn="ctr"/>
+            <a:endParaRPr lang="pt-PT"/>
+          </a:p>
+        </p:txBody>
+      </p:sp>
+      <p:sp>
+        <p:nvSpPr>
+          <p:cNvPr id="2" name="Título">
+            <a:extLst>
+              <a:ext uri="{FF2B5EF4-FFF2-40B4-BE49-F238E27FC236}">
+                <a16:creationId xmlns:a16="http://schemas.microsoft.com/office/drawing/2014/main" id="{29D85961-FC26-87D6-F7CF-D2E332EB5E80}"/>
+              </a:ext>
+            </a:extLst>
+          </p:cNvPr>
+          <p:cNvSpPr>
+            <a:spLocks noGrp="1"/>
+          </p:cNvSpPr>
+          <p:nvPr>
+            <p:ph type="title" hasCustomPrompt="1"/>
+          </p:nvPr>
+        </p:nvSpPr>
+        <p:spPr>
+          <a:xfrm>
+            <a:off x="240890" y="245096"/>
+            <a:ext cx="8662220" cy="525262"/>
+          </a:xfrm>
+        </p:spPr>
+        <p:txBody>
+          <a:bodyPr wrap="square">
+            <a:normAutofit/>
+          </a:bodyPr>
+          <a:lstStyle>
+            <a:lvl1pPr algn="ctr">
+              <a:defRPr sz="3400">
+                <a:solidFill>
+                  <a:schemeClr val="bg1"/>
+                </a:solidFill>
+                <a:latin typeface="Livvic SemiBold" pitchFamily="2" charset="0"/>
+              </a:defRPr>
+            </a:lvl1pPr>
+          </a:lstStyle>
+          <a:p>
+            <a:r>
+              <a:rPr lang="en-US" dirty="0"/>
+              <a:t>Cristo </a:t>
+            </a:r>
+            <a:r>
+              <a:rPr lang="en-US" dirty="0" err="1"/>
+              <a:t>em</a:t>
+            </a:r>
+            <a:r>
+              <a:rPr lang="en-US" dirty="0"/>
+              <a:t> </a:t>
+            </a:r>
+            <a:r>
+              <a:rPr lang="en-US" dirty="0" err="1"/>
+              <a:t>mim</a:t>
+            </a:r>
+            <a:endParaRPr lang="pt-PT" dirty="0"/>
+          </a:p>
+        </p:txBody>
+      </p:sp>
+      <p:sp>
+        <p:nvSpPr>
+          <p:cNvPr id="3" name="Letra">
+            <a:extLst>
+              <a:ext uri="{FF2B5EF4-FFF2-40B4-BE49-F238E27FC236}">
+                <a16:creationId xmlns:a16="http://schemas.microsoft.com/office/drawing/2014/main" id="{7FBA5054-2BE0-6B52-7485-0B10968F39E5}"/>
+              </a:ext>
+            </a:extLst>
+          </p:cNvPr>
+          <p:cNvSpPr>
+            <a:spLocks noGrp="1"/>
+          </p:cNvSpPr>
+          <p:nvPr>
+            <p:ph idx="1" hasCustomPrompt="1"/>
+          </p:nvPr>
+        </p:nvSpPr>
+        <p:spPr>
+          <a:xfrm>
+            <a:off x="549995" y="961533"/>
+            <a:ext cx="8044010" cy="5670225"/>
+          </a:xfrm>
+        </p:spPr>
+        <p:txBody>
+          <a:bodyPr tIns="0" anchor="ctr" anchorCtr="1">
+            <a:normAutofit/>
+          </a:bodyPr>
+          <a:lstStyle>
+            <a:lvl1pPr marL="0" marR="0" indent="0" algn="ctr" defTabSz="685800" rtl="0" eaLnBrk="1" fontAlgn="auto" latinLnBrk="0" hangingPunct="1">
+              <a:lnSpc>
+                <a:spcPct val="130000"/>
+              </a:lnSpc>
+              <a:spcBef>
+                <a:spcPts val="0"/>
+              </a:spcBef>
+              <a:spcAft>
+                <a:spcPts val="0"/>
+              </a:spcAft>
+              <a:buClrTx/>
+              <a:buSzTx/>
+              <a:buFont typeface="Arial" panose="020B0604020202020204" pitchFamily="34" charset="0"/>
+              <a:buNone/>
+              <a:tabLst/>
+              <a:defRPr sz="6000"/>
+            </a:lvl1pPr>
+            <a:lvl2pPr algn="ctr">
+              <a:defRPr/>
+            </a:lvl2pPr>
+            <a:lvl3pPr algn="ctr">
+              <a:defRPr/>
+            </a:lvl3pPr>
+            <a:lvl4pPr algn="ctr">
+              <a:defRPr/>
+            </a:lvl4pPr>
+            <a:lvl5pPr algn="ctr">
+              <a:defRPr/>
+            </a:lvl5pPr>
+          </a:lstStyle>
+          <a:p>
+            <a:pPr lvl="0"/>
+            <a:r>
+              <a:rPr lang="en-US" dirty="0"/>
+              <a:t>Música com </a:t>
+            </a:r>
+            <a:r>
+              <a:rPr lang="en-US" dirty="0" err="1"/>
+              <a:t>linha</a:t>
+            </a:r>
+            <a:r>
+              <a:rPr lang="en-US" dirty="0"/>
+              <a:t> 1</a:t>
+            </a:r>
+          </a:p>
+          <a:p>
+            <a:pPr marL="0" marR="0" lvl="0" indent="0" algn="ctr" defTabSz="685800" rtl="0" eaLnBrk="1" fontAlgn="auto" latinLnBrk="0" hangingPunct="1">
+              <a:lnSpc>
+                <a:spcPct val="90000"/>
+              </a:lnSpc>
+              <a:spcBef>
+                <a:spcPts val="750"/>
+              </a:spcBef>
+              <a:spcAft>
+                <a:spcPts val="0"/>
+              </a:spcAft>
+              <a:buClrTx/>
+              <a:buSzTx/>
+              <a:buFont typeface="Arial" panose="020B0604020202020204" pitchFamily="34" charset="0"/>
+              <a:buNone/>
+              <a:tabLst/>
+              <a:defRPr/>
+            </a:pPr>
+            <a:r>
+              <a:rPr lang="en-US" dirty="0"/>
+              <a:t>Música com </a:t>
+            </a:r>
+            <a:r>
+              <a:rPr lang="en-US" dirty="0" err="1"/>
+              <a:t>linha</a:t>
+            </a:r>
+            <a:r>
+              <a:rPr lang="en-US" dirty="0"/>
+              <a:t> 2 e </a:t>
+            </a:r>
+            <a:r>
+              <a:rPr lang="en-US" dirty="0" err="1"/>
+              <a:t>mais</a:t>
+            </a:r>
+            <a:r>
+              <a:rPr lang="en-US" dirty="0"/>
+              <a:t> </a:t>
+            </a:r>
+          </a:p>
+          <a:p>
+            <a:pPr marL="0" marR="0" lvl="0" indent="0" algn="ctr" defTabSz="685800" rtl="0" eaLnBrk="1" fontAlgn="auto" latinLnBrk="0" hangingPunct="1">
+              <a:lnSpc>
+                <a:spcPct val="90000"/>
+              </a:lnSpc>
+              <a:spcBef>
+                <a:spcPts val="750"/>
+              </a:spcBef>
+              <a:spcAft>
+                <a:spcPts val="0"/>
+              </a:spcAft>
+              <a:buClrTx/>
+              <a:buSzTx/>
+              <a:buFont typeface="Arial" panose="020B0604020202020204" pitchFamily="34" charset="0"/>
+              <a:buNone/>
+              <a:tabLst/>
+              <a:defRPr/>
+            </a:pPr>
+            <a:r>
+              <a:rPr lang="en-US" dirty="0"/>
+              <a:t>Música com </a:t>
+            </a:r>
+            <a:r>
+              <a:rPr lang="en-US" dirty="0" err="1"/>
+              <a:t>linha</a:t>
+            </a:r>
+            <a:r>
+              <a:rPr lang="en-US" dirty="0"/>
+              <a:t> 3</a:t>
+            </a:r>
+          </a:p>
+          <a:p>
+            <a:pPr marL="0" marR="0" lvl="0" indent="0" algn="ctr" defTabSz="685800" rtl="0" eaLnBrk="1" fontAlgn="auto" latinLnBrk="0" hangingPunct="1">
+              <a:lnSpc>
+                <a:spcPct val="90000"/>
+              </a:lnSpc>
+              <a:spcBef>
+                <a:spcPts val="750"/>
+              </a:spcBef>
+              <a:spcAft>
+                <a:spcPts val="0"/>
+              </a:spcAft>
+              <a:buClrTx/>
+              <a:buSzTx/>
+              <a:buFont typeface="Arial" panose="020B0604020202020204" pitchFamily="34" charset="0"/>
+              <a:buNone/>
+              <a:tabLst/>
+              <a:defRPr/>
+            </a:pPr>
+            <a:r>
+              <a:rPr lang="en-US" dirty="0"/>
+              <a:t>Música com a </a:t>
+            </a:r>
+            <a:r>
+              <a:rPr lang="en-US" dirty="0" err="1"/>
+              <a:t>linha</a:t>
+            </a:r>
+            <a:r>
+              <a:rPr lang="en-US" dirty="0"/>
+              <a:t> final </a:t>
+            </a:r>
+            <a:r>
+              <a:rPr lang="en-US" dirty="0" err="1"/>
+              <a:t>aqui</a:t>
+            </a:r>
+            <a:endParaRPr lang="en-US" dirty="0"/>
+          </a:p>
+        </p:txBody>
+      </p:sp>
+    </p:spTree>
+    <p:extLst>
+      <p:ext uri="{BB962C8B-B14F-4D97-AF65-F5344CB8AC3E}">
+        <p14:creationId xmlns:p14="http://schemas.microsoft.com/office/powerpoint/2010/main" val="2195698647"/>
+      </p:ext>
+    </p:extLst>
+  </p:cSld>
+  <p:clrMapOvr>
+    <a:masterClrMapping/>
+  </p:clrMapOvr>
+</p:sldLayout>
+</file>
+
+<file path=ppt/slideLayouts/slideLayout11.xml><?xml version="1.0" encoding="utf-8"?>
+<p:sldLayout xmlns:a="http://schemas.openxmlformats.org/drawingml/2006/main" xmlns:r="http://schemas.openxmlformats.org/officeDocument/2006/relationships" xmlns:p="http://schemas.openxmlformats.org/presentationml/2006/main" preserve="1" userDrawn="1">
+  <p:cSld name="Título e letra - Natal e Páscoa">
+    <p:spTree>
+      <p:nvGrpSpPr>
+        <p:cNvPr id="1" name=""/>
+        <p:cNvGrpSpPr/>
+        <p:nvPr/>
+      </p:nvGrpSpPr>
+      <p:grpSpPr>
+        <a:xfrm>
+          <a:off x="0" y="0"/>
+          <a:ext cx="0" cy="0"/>
+          <a:chOff x="0" y="0"/>
+          <a:chExt cx="0" cy="0"/>
+        </a:xfrm>
+      </p:grpSpPr>
+      <p:sp>
+        <p:nvSpPr>
+          <p:cNvPr id="7" name="Header">
+            <a:extLst>
+              <a:ext uri="{FF2B5EF4-FFF2-40B4-BE49-F238E27FC236}">
+                <a16:creationId xmlns:a16="http://schemas.microsoft.com/office/drawing/2014/main" id="{9C521DED-F031-73C8-3FE1-6EDC94DF1880}"/>
+              </a:ext>
+            </a:extLst>
+          </p:cNvPr>
+          <p:cNvSpPr/>
+          <p:nvPr userDrawn="1"/>
+        </p:nvSpPr>
+        <p:spPr>
+          <a:xfrm>
+            <a:off x="0" y="0"/>
+            <a:ext cx="9144000" cy="801278"/>
+          </a:xfrm>
+          <a:prstGeom prst="rect">
+            <a:avLst/>
+          </a:prstGeom>
+          <a:solidFill>
+            <a:schemeClr val="bg1"/>
+          </a:solidFill>
+          <a:ln>
+            <a:noFill/>
+          </a:ln>
+          <a:effectLst>
+            <a:innerShdw blurRad="254000" dist="101600" dir="5400000">
+              <a:schemeClr val="accent4">
+                <a:alpha val="50000"/>
+              </a:schemeClr>
+            </a:innerShdw>
+          </a:effectLst>
+        </p:spPr>
+        <p:style>
+          <a:lnRef idx="2">
+            <a:schemeClr val="accent1">
+              <a:shade val="15000"/>
+            </a:schemeClr>
+          </a:lnRef>
+          <a:fillRef idx="1">
+            <a:schemeClr val="accent1"/>
+          </a:fillRef>
+          <a:effectRef idx="0">
+            <a:schemeClr val="accent1"/>
+          </a:effectRef>
+          <a:fontRef idx="minor">
+            <a:schemeClr val="lt1"/>
+          </a:fontRef>
+        </p:style>
+        <p:txBody>
+          <a:bodyPr wrap="none" rtlCol="0" anchor="ctr">
+            <a:normAutofit/>
+          </a:bodyPr>
+          <a:lstStyle/>
+          <a:p>
+            <a:pPr algn="ctr"/>
+            <a:endParaRPr lang="pt-PT" dirty="0">
+              <a:solidFill>
+                <a:schemeClr val="accent4">
+                  <a:lumMod val="20000"/>
+                  <a:lumOff val="80000"/>
+                </a:schemeClr>
+              </a:solidFill>
+            </a:endParaRPr>
+          </a:p>
+        </p:txBody>
+      </p:sp>
+      <p:sp>
+        <p:nvSpPr>
+          <p:cNvPr id="2" name="Título">
+            <a:extLst>
+              <a:ext uri="{FF2B5EF4-FFF2-40B4-BE49-F238E27FC236}">
+                <a16:creationId xmlns:a16="http://schemas.microsoft.com/office/drawing/2014/main" id="{29D85961-FC26-87D6-F7CF-D2E332EB5E80}"/>
+              </a:ext>
+            </a:extLst>
+          </p:cNvPr>
+          <p:cNvSpPr>
+            <a:spLocks noGrp="1"/>
+          </p:cNvSpPr>
+          <p:nvPr>
+            <p:ph type="title" hasCustomPrompt="1"/>
+          </p:nvPr>
+        </p:nvSpPr>
+        <p:spPr>
+          <a:xfrm>
+            <a:off x="240890" y="245096"/>
+            <a:ext cx="8662220" cy="525262"/>
+          </a:xfrm>
+        </p:spPr>
+        <p:txBody>
+          <a:bodyPr wrap="square">
+            <a:normAutofit/>
+          </a:bodyPr>
+          <a:lstStyle>
+            <a:lvl1pPr algn="ctr">
+              <a:defRPr sz="3400">
+                <a:solidFill>
+                  <a:schemeClr val="accent4"/>
+                </a:solidFill>
+                <a:latin typeface="Livvic SemiBold" pitchFamily="2" charset="0"/>
+              </a:defRPr>
+            </a:lvl1pPr>
+          </a:lstStyle>
+          <a:p>
+            <a:r>
+              <a:rPr lang="en-US" dirty="0"/>
+              <a:t>Cristo </a:t>
+            </a:r>
+            <a:r>
+              <a:rPr lang="en-US" dirty="0" err="1"/>
+              <a:t>em</a:t>
+            </a:r>
+            <a:r>
+              <a:rPr lang="en-US" dirty="0"/>
+              <a:t> </a:t>
+            </a:r>
+            <a:r>
+              <a:rPr lang="en-US" dirty="0" err="1"/>
+              <a:t>mim</a:t>
+            </a:r>
+            <a:endParaRPr lang="pt-PT" dirty="0"/>
+          </a:p>
+        </p:txBody>
+      </p:sp>
+      <p:sp>
+        <p:nvSpPr>
+          <p:cNvPr id="3" name="Letra">
+            <a:extLst>
+              <a:ext uri="{FF2B5EF4-FFF2-40B4-BE49-F238E27FC236}">
+                <a16:creationId xmlns:a16="http://schemas.microsoft.com/office/drawing/2014/main" id="{7FBA5054-2BE0-6B52-7485-0B10968F39E5}"/>
+              </a:ext>
+            </a:extLst>
+          </p:cNvPr>
+          <p:cNvSpPr>
+            <a:spLocks noGrp="1"/>
+          </p:cNvSpPr>
+          <p:nvPr>
+            <p:ph idx="1" hasCustomPrompt="1"/>
+          </p:nvPr>
+        </p:nvSpPr>
+        <p:spPr>
+          <a:xfrm>
+            <a:off x="549995" y="961533"/>
+            <a:ext cx="8044010" cy="5670225"/>
+          </a:xfrm>
+        </p:spPr>
+        <p:txBody>
+          <a:bodyPr tIns="0" anchor="ctr" anchorCtr="1">
+            <a:normAutofit/>
+          </a:bodyPr>
+          <a:lstStyle>
+            <a:lvl1pPr marL="0" marR="0" indent="0" algn="ctr" defTabSz="685800" rtl="0" eaLnBrk="1" fontAlgn="auto" latinLnBrk="0" hangingPunct="1">
+              <a:lnSpc>
+                <a:spcPct val="130000"/>
+              </a:lnSpc>
+              <a:spcBef>
+                <a:spcPts val="0"/>
+              </a:spcBef>
+              <a:spcAft>
+                <a:spcPts val="0"/>
+              </a:spcAft>
+              <a:buClrTx/>
+              <a:buSzTx/>
+              <a:buFont typeface="Arial" panose="020B0604020202020204" pitchFamily="34" charset="0"/>
+              <a:buNone/>
+              <a:tabLst/>
+              <a:defRPr sz="6000"/>
+            </a:lvl1pPr>
+            <a:lvl2pPr algn="ctr">
+              <a:defRPr/>
+            </a:lvl2pPr>
+            <a:lvl3pPr algn="ctr">
+              <a:defRPr/>
+            </a:lvl3pPr>
+            <a:lvl4pPr algn="ctr">
+              <a:defRPr/>
+            </a:lvl4pPr>
+            <a:lvl5pPr algn="ctr">
+              <a:defRPr/>
+            </a:lvl5pPr>
+          </a:lstStyle>
+          <a:p>
+            <a:pPr lvl="0"/>
+            <a:r>
+              <a:rPr lang="en-US" dirty="0"/>
+              <a:t>Música com </a:t>
+            </a:r>
+            <a:r>
+              <a:rPr lang="en-US" dirty="0" err="1"/>
+              <a:t>linha</a:t>
+            </a:r>
+            <a:r>
+              <a:rPr lang="en-US" dirty="0"/>
+              <a:t> 1</a:t>
+            </a:r>
+          </a:p>
+          <a:p>
+            <a:pPr marL="0" marR="0" lvl="0" indent="0" algn="ctr" defTabSz="685800" rtl="0" eaLnBrk="1" fontAlgn="auto" latinLnBrk="0" hangingPunct="1">
+              <a:lnSpc>
+                <a:spcPct val="90000"/>
+              </a:lnSpc>
+              <a:spcBef>
+                <a:spcPts val="750"/>
+              </a:spcBef>
+              <a:spcAft>
+                <a:spcPts val="0"/>
+              </a:spcAft>
+              <a:buClrTx/>
+              <a:buSzTx/>
+              <a:buFont typeface="Arial" panose="020B0604020202020204" pitchFamily="34" charset="0"/>
+              <a:buNone/>
+              <a:tabLst/>
+              <a:defRPr/>
+            </a:pPr>
+            <a:r>
+              <a:rPr lang="en-US" dirty="0"/>
+              <a:t>Música com </a:t>
+            </a:r>
+            <a:r>
+              <a:rPr lang="en-US" dirty="0" err="1"/>
+              <a:t>linha</a:t>
+            </a:r>
+            <a:r>
+              <a:rPr lang="en-US" dirty="0"/>
+              <a:t> 2 e </a:t>
+            </a:r>
+            <a:r>
+              <a:rPr lang="en-US" dirty="0" err="1"/>
+              <a:t>mais</a:t>
+            </a:r>
+            <a:r>
+              <a:rPr lang="en-US" dirty="0"/>
+              <a:t> </a:t>
+            </a:r>
+          </a:p>
+          <a:p>
+            <a:pPr marL="0" marR="0" lvl="0" indent="0" algn="ctr" defTabSz="685800" rtl="0" eaLnBrk="1" fontAlgn="auto" latinLnBrk="0" hangingPunct="1">
+              <a:lnSpc>
+                <a:spcPct val="90000"/>
+              </a:lnSpc>
+              <a:spcBef>
+                <a:spcPts val="750"/>
+              </a:spcBef>
+              <a:spcAft>
+                <a:spcPts val="0"/>
+              </a:spcAft>
+              <a:buClrTx/>
+              <a:buSzTx/>
+              <a:buFont typeface="Arial" panose="020B0604020202020204" pitchFamily="34" charset="0"/>
+              <a:buNone/>
+              <a:tabLst/>
+              <a:defRPr/>
+            </a:pPr>
+            <a:r>
+              <a:rPr lang="en-US" dirty="0"/>
+              <a:t>Música com </a:t>
+            </a:r>
+            <a:r>
+              <a:rPr lang="en-US" dirty="0" err="1"/>
+              <a:t>linha</a:t>
+            </a:r>
+            <a:r>
+              <a:rPr lang="en-US" dirty="0"/>
+              <a:t> 3</a:t>
+            </a:r>
+          </a:p>
+          <a:p>
+            <a:pPr marL="0" marR="0" lvl="0" indent="0" algn="ctr" defTabSz="685800" rtl="0" eaLnBrk="1" fontAlgn="auto" latinLnBrk="0" hangingPunct="1">
+              <a:lnSpc>
+                <a:spcPct val="90000"/>
+              </a:lnSpc>
+              <a:spcBef>
+                <a:spcPts val="750"/>
+              </a:spcBef>
+              <a:spcAft>
+                <a:spcPts val="0"/>
+              </a:spcAft>
+              <a:buClrTx/>
+              <a:buSzTx/>
+              <a:buFont typeface="Arial" panose="020B0604020202020204" pitchFamily="34" charset="0"/>
+              <a:buNone/>
+              <a:tabLst/>
+              <a:defRPr/>
+            </a:pPr>
+            <a:r>
+              <a:rPr lang="en-US" dirty="0"/>
+              <a:t>Música com a </a:t>
+            </a:r>
+            <a:r>
+              <a:rPr lang="en-US" dirty="0" err="1"/>
+              <a:t>linha</a:t>
+            </a:r>
+            <a:r>
+              <a:rPr lang="en-US" dirty="0"/>
+              <a:t> final </a:t>
+            </a:r>
+            <a:r>
+              <a:rPr lang="en-US" dirty="0" err="1"/>
+              <a:t>aqui</a:t>
+            </a:r>
+            <a:endParaRPr lang="en-US" dirty="0"/>
+          </a:p>
+        </p:txBody>
+      </p:sp>
+    </p:spTree>
+    <p:extLst>
+      <p:ext uri="{BB962C8B-B14F-4D97-AF65-F5344CB8AC3E}">
+        <p14:creationId xmlns:p14="http://schemas.microsoft.com/office/powerpoint/2010/main" val="1378027913"/>
+      </p:ext>
+    </p:extLst>
+  </p:cSld>
+  <p:clrMapOvr>
+    <a:masterClrMapping/>
+  </p:clrMapOvr>
+</p:sldLayout>
+</file>
+
+<file path=ppt/slideLayouts/slideLayout12.xml><?xml version="1.0" encoding="utf-8"?>
+<p:sldLayout xmlns:a="http://schemas.openxmlformats.org/drawingml/2006/main" xmlns:r="http://schemas.openxmlformats.org/officeDocument/2006/relationships" xmlns:p="http://schemas.openxmlformats.org/presentationml/2006/main" preserve="1" userDrawn="1">
   <p:cSld name="Letra">
     <p:spTree>
       <p:nvGrpSpPr>
@@ -863,7 +1519,7 @@
 
 <file path=ppt/slideLayouts/slideLayout2.xml><?xml version="1.0" encoding="utf-8"?>
 <p:sldLayout xmlns:a="http://schemas.openxmlformats.org/drawingml/2006/main" xmlns:r="http://schemas.openxmlformats.org/officeDocument/2006/relationships" xmlns:p="http://schemas.openxmlformats.org/presentationml/2006/main" preserve="1" userDrawn="1">
-  <p:cSld name="Capa - Tempo de Advento">
+  <p:cSld name="Capa - Advento">
     <p:bg>
       <p:bgPr>
         <a:solidFill>
@@ -1212,7 +1868,7 @@
     <p:bg>
       <p:bgPr>
         <a:solidFill>
-          <a:schemeClr val="bg2">
+          <a:schemeClr val="accent3">
             <a:lumMod val="40000"/>
             <a:lumOff val="60000"/>
             <a:alpha val="25000"/>
@@ -1265,7 +1921,7 @@
             <a:lvl1pPr algn="ctr">
               <a:defRPr sz="6600" b="1">
                 <a:solidFill>
-                  <a:schemeClr val="bg2"/>
+                  <a:schemeClr val="accent3"/>
                 </a:solidFill>
                 <a:latin typeface="Playfair Display" pitchFamily="2" charset="0"/>
               </a:defRPr>
@@ -1553,14 +2209,14 @@
 
 <file path=ppt/slideLayouts/slideLayout4.xml><?xml version="1.0" encoding="utf-8"?>
 <p:sldLayout xmlns:a="http://schemas.openxmlformats.org/drawingml/2006/main" xmlns:r="http://schemas.openxmlformats.org/officeDocument/2006/relationships" xmlns:p="http://schemas.openxmlformats.org/presentationml/2006/main" preserve="1" userDrawn="1">
-  <p:cSld name="Capa - Tempo de Natal">
+  <p:cSld name="Capa - Natal">
     <p:bg>
       <p:bgPr>
         <a:solidFill>
           <a:schemeClr val="accent4">
             <a:lumMod val="20000"/>
             <a:lumOff val="80000"/>
-            <a:alpha val="25000"/>
+            <a:alpha val="20000"/>
           </a:schemeClr>
         </a:solidFill>
         <a:effectLst/>
@@ -1890,7 +2546,7 @@
 
 <file path=ppt/slideLayouts/slideLayout5.xml><?xml version="1.0" encoding="utf-8"?>
 <p:sldLayout xmlns:a="http://schemas.openxmlformats.org/drawingml/2006/main" xmlns:r="http://schemas.openxmlformats.org/officeDocument/2006/relationships" xmlns:p="http://schemas.openxmlformats.org/presentationml/2006/main" preserve="1" userDrawn="1">
-  <p:cSld name="Capa - Tempo de Quaresma">
+  <p:cSld name="Capa - Quaresma">
     <p:bg>
       <p:bgPr>
         <a:solidFill>
@@ -1956,7 +2612,7 @@
           <a:p>
             <a:r>
               <a:rPr lang="en-US" dirty="0"/>
-              <a:t>Domingo VI</a:t>
+              <a:t>Domingo III</a:t>
             </a:r>
             <a:endParaRPr lang="pt-PT" dirty="0"/>
           </a:p>
@@ -2227,11 +2883,11 @@
 
 <file path=ppt/slideLayouts/slideLayout6.xml><?xml version="1.0" encoding="utf-8"?>
 <p:sldLayout xmlns:a="http://schemas.openxmlformats.org/drawingml/2006/main" xmlns:r="http://schemas.openxmlformats.org/officeDocument/2006/relationships" xmlns:p="http://schemas.openxmlformats.org/presentationml/2006/main" preserve="1" userDrawn="1">
-  <p:cSld name="Capa - Domingo IV Advento">
+  <p:cSld name="Capa - Domingo IV Quaresma">
     <p:bg>
       <p:bgPr>
         <a:solidFill>
-          <a:schemeClr val="bg2">
+          <a:schemeClr val="accent3">
             <a:lumMod val="40000"/>
             <a:lumOff val="60000"/>
             <a:alpha val="25000"/>
@@ -2284,7 +2940,7 @@
             <a:lvl1pPr algn="ctr">
               <a:defRPr sz="6600" b="1">
                 <a:solidFill>
-                  <a:schemeClr val="bg2"/>
+                  <a:schemeClr val="accent3"/>
                 </a:solidFill>
                 <a:latin typeface="Playfair Display" pitchFamily="2" charset="0"/>
               </a:defRPr>
@@ -2564,7 +3220,7 @@
 
 <file path=ppt/slideLayouts/slideLayout7.xml><?xml version="1.0" encoding="utf-8"?>
 <p:sldLayout xmlns:a="http://schemas.openxmlformats.org/drawingml/2006/main" xmlns:r="http://schemas.openxmlformats.org/officeDocument/2006/relationships" xmlns:p="http://schemas.openxmlformats.org/presentationml/2006/main" preserve="1" userDrawn="1">
-  <p:cSld name="Capa - Domingo Páscoa">
+  <p:cSld name="Capa - Ramos">
     <p:bg>
       <p:bgPr>
         <a:solidFill>
@@ -2609,17 +3265,17 @@
         </p:nvSpPr>
         <p:spPr>
           <a:xfrm>
-            <a:off x="1143000" y="1129506"/>
-            <a:ext cx="6858000" cy="1106127"/>
+            <a:off x="0" y="1129506"/>
+            <a:ext cx="9144000" cy="1106127"/>
           </a:xfrm>
         </p:spPr>
         <p:txBody>
           <a:bodyPr anchor="b">
-            <a:normAutofit/>
+            <a:noAutofit/>
           </a:bodyPr>
           <a:lstStyle>
             <a:lvl1pPr algn="ctr">
-              <a:defRPr sz="6600" b="1">
+              <a:defRPr sz="6000" b="1">
                 <a:solidFill>
                   <a:schemeClr val="accent5"/>
                 </a:solidFill>
@@ -2630,7 +3286,7 @@
           <a:p>
             <a:r>
               <a:rPr lang="en-US" dirty="0"/>
-              <a:t>Domingo IV</a:t>
+              <a:t>Domingo de Ramos</a:t>
             </a:r>
             <a:endParaRPr lang="pt-PT" dirty="0"/>
           </a:p>
@@ -2872,7 +3528,7 @@
             <a:pPr lvl="0"/>
             <a:r>
               <a:rPr lang="en-US" dirty="0"/>
-              <a:t>Tempo de Páscoa </a:t>
+              <a:t>Tempo de Quaresma </a:t>
             </a:r>
             <a:r>
               <a:rPr lang="pt-PT" dirty="0"/>
@@ -2889,7 +3545,7 @@
     </p:spTree>
     <p:extLst>
       <p:ext uri="{BB962C8B-B14F-4D97-AF65-F5344CB8AC3E}">
-        <p14:creationId xmlns:p14="http://schemas.microsoft.com/office/powerpoint/2010/main" val="3276494890"/>
+        <p14:creationId xmlns:p14="http://schemas.microsoft.com/office/powerpoint/2010/main" val="3202388809"/>
       </p:ext>
     </p:extLst>
   </p:cSld>
@@ -2901,7 +3557,19 @@
 
 <file path=ppt/slideLayouts/slideLayout8.xml><?xml version="1.0" encoding="utf-8"?>
 <p:sldLayout xmlns:a="http://schemas.openxmlformats.org/drawingml/2006/main" xmlns:r="http://schemas.openxmlformats.org/officeDocument/2006/relationships" xmlns:p="http://schemas.openxmlformats.org/presentationml/2006/main" preserve="1" userDrawn="1">
-  <p:cSld name="Título e letra - Tempo comum">
+  <p:cSld name="Capa - Páscoa">
+    <p:bg>
+      <p:bgPr>
+        <a:solidFill>
+          <a:schemeClr val="accent4">
+            <a:lumMod val="20000"/>
+            <a:lumOff val="80000"/>
+            <a:alpha val="20000"/>
+          </a:schemeClr>
+        </a:solidFill>
+        <a:effectLst/>
+      </p:bgPr>
+    </p:bg>
     <p:spTree>
       <p:nvGrpSpPr>
         <p:cNvPr id="1" name=""/>
@@ -2918,64 +3586,55 @@
       </p:grpSpPr>
       <p:sp>
         <p:nvSpPr>
-          <p:cNvPr id="7" name="Header">
-            <a:extLst>
-              <a:ext uri="{FF2B5EF4-FFF2-40B4-BE49-F238E27FC236}">
-                <a16:creationId xmlns:a16="http://schemas.microsoft.com/office/drawing/2014/main" id="{9C521DED-F031-73C8-3FE1-6EDC94DF1880}"/>
-              </a:ext>
-            </a:extLst>
-          </p:cNvPr>
-          <p:cNvSpPr/>
-          <p:nvPr userDrawn="1"/>
+          <p:cNvPr id="2" name="Domingo">
+            <a:extLst>
+              <a:ext uri="{FF2B5EF4-FFF2-40B4-BE49-F238E27FC236}">
+                <a16:creationId xmlns:a16="http://schemas.microsoft.com/office/drawing/2014/main" id="{AC6EEB27-5DD2-414A-A29B-10D30F19AC21}"/>
+              </a:ext>
+            </a:extLst>
+          </p:cNvPr>
+          <p:cNvSpPr>
+            <a:spLocks noGrp="1"/>
+          </p:cNvSpPr>
+          <p:nvPr>
+            <p:ph type="ctrTitle" hasCustomPrompt="1"/>
+          </p:nvPr>
         </p:nvSpPr>
         <p:spPr>
           <a:xfrm>
-            <a:off x="0" y="0"/>
-            <a:ext cx="9144000" cy="801278"/>
-          </a:xfrm>
-          <a:prstGeom prst="rect">
-            <a:avLst/>
-          </a:prstGeom>
-          <a:solidFill>
-            <a:schemeClr val="accent1"/>
-          </a:solidFill>
-          <a:ln>
-            <a:noFill/>
-          </a:ln>
-        </p:spPr>
-        <p:style>
-          <a:lnRef idx="2">
-            <a:schemeClr val="accent1">
-              <a:shade val="15000"/>
-            </a:schemeClr>
-          </a:lnRef>
-          <a:fillRef idx="1">
-            <a:schemeClr val="accent1"/>
-          </a:fillRef>
-          <a:effectRef idx="0">
-            <a:schemeClr val="accent1"/>
-          </a:effectRef>
-          <a:fontRef idx="minor">
-            <a:schemeClr val="lt1"/>
-          </a:fontRef>
-        </p:style>
+            <a:off x="1143000" y="1129506"/>
+            <a:ext cx="6858000" cy="1106127"/>
+          </a:xfrm>
+        </p:spPr>
         <p:txBody>
-          <a:bodyPr wrap="none" rtlCol="0" anchor="ctr">
+          <a:bodyPr anchor="b">
             <a:normAutofit/>
           </a:bodyPr>
-          <a:lstStyle/>
-          <a:p>
-            <a:pPr algn="ctr"/>
-            <a:endParaRPr lang="pt-PT"/>
+          <a:lstStyle>
+            <a:lvl1pPr algn="ctr">
+              <a:defRPr sz="6600" b="1">
+                <a:solidFill>
+                  <a:schemeClr val="accent4"/>
+                </a:solidFill>
+                <a:latin typeface="Playfair Display" pitchFamily="2" charset="0"/>
+              </a:defRPr>
+            </a:lvl1pPr>
+          </a:lstStyle>
+          <a:p>
+            <a:r>
+              <a:rPr lang="en-US" dirty="0"/>
+              <a:t>Domingo VIII</a:t>
+            </a:r>
+            <a:endParaRPr lang="pt-PT" dirty="0"/>
           </a:p>
         </p:txBody>
       </p:sp>
       <p:sp>
         <p:nvSpPr>
-          <p:cNvPr id="2" name="Título">
-            <a:extLst>
-              <a:ext uri="{FF2B5EF4-FFF2-40B4-BE49-F238E27FC236}">
-                <a16:creationId xmlns:a16="http://schemas.microsoft.com/office/drawing/2014/main" id="{29D85961-FC26-87D6-F7CF-D2E332EB5E80}"/>
+          <p:cNvPr id="3" name="Frase">
+            <a:extLst>
+              <a:ext uri="{FF2B5EF4-FFF2-40B4-BE49-F238E27FC236}">
+                <a16:creationId xmlns:a16="http://schemas.microsoft.com/office/drawing/2014/main" id="{F5DEF8E5-A6D3-FF16-3A4C-6762958F1B84}"/>
               </a:ext>
             </a:extLst>
           </p:cNvPr>
@@ -2983,56 +3642,82 @@
             <a:spLocks noGrp="1"/>
           </p:cNvSpPr>
           <p:nvPr>
-            <p:ph type="title" hasCustomPrompt="1"/>
+            <p:ph type="subTitle" idx="1" hasCustomPrompt="1"/>
           </p:nvPr>
         </p:nvSpPr>
         <p:spPr>
           <a:xfrm>
-            <a:off x="240890" y="245096"/>
-            <a:ext cx="8662220" cy="525262"/>
+            <a:off x="494907" y="2525677"/>
+            <a:ext cx="8154186" cy="914255"/>
           </a:xfrm>
         </p:spPr>
         <p:txBody>
-          <a:bodyPr wrap="square">
-            <a:normAutofit/>
+          <a:bodyPr>
+            <a:noAutofit/>
           </a:bodyPr>
           <a:lstStyle>
-            <a:lvl1pPr algn="ctr">
-              <a:defRPr sz="3400">
-                <a:solidFill>
-                  <a:schemeClr val="bg1"/>
-                </a:solidFill>
-                <a:latin typeface="Livvic SemiBold" pitchFamily="2" charset="0"/>
+            <a:lvl1pPr marL="0" indent="0" algn="ctr">
+              <a:buNone/>
+              <a:defRPr sz="2400">
+                <a:latin typeface="Shadows Into Light Two" panose="02000506000000020004" pitchFamily="2" charset="0"/>
               </a:defRPr>
             </a:lvl1pPr>
+            <a:lvl2pPr marL="342900" indent="0" algn="ctr">
+              <a:buNone/>
+              <a:defRPr sz="1500"/>
+            </a:lvl2pPr>
+            <a:lvl3pPr marL="685800" indent="0" algn="ctr">
+              <a:buNone/>
+              <a:defRPr sz="1350"/>
+            </a:lvl3pPr>
+            <a:lvl4pPr marL="1028700" indent="0" algn="ctr">
+              <a:buNone/>
+              <a:defRPr sz="1200"/>
+            </a:lvl4pPr>
+            <a:lvl5pPr marL="1371600" indent="0" algn="ctr">
+              <a:buNone/>
+              <a:defRPr sz="1200"/>
+            </a:lvl5pPr>
+            <a:lvl6pPr marL="1714500" indent="0" algn="ctr">
+              <a:buNone/>
+              <a:defRPr sz="1200"/>
+            </a:lvl6pPr>
+            <a:lvl7pPr marL="2057400" indent="0" algn="ctr">
+              <a:buNone/>
+              <a:defRPr sz="1200"/>
+            </a:lvl7pPr>
+            <a:lvl8pPr marL="2400300" indent="0" algn="ctr">
+              <a:buNone/>
+              <a:defRPr sz="1200"/>
+            </a:lvl8pPr>
+            <a:lvl9pPr marL="2743200" indent="0" algn="ctr">
+              <a:buNone/>
+              <a:defRPr sz="1200"/>
+            </a:lvl9pPr>
           </a:lstStyle>
           <a:p>
             <a:r>
-              <a:rPr lang="en-US" dirty="0"/>
-              <a:t>Cristo </a:t>
-            </a:r>
-            <a:r>
-              <a:rPr lang="en-US" dirty="0" err="1"/>
-              <a:t>em</a:t>
-            </a:r>
-            <a:r>
-              <a:rPr lang="en-US" dirty="0"/>
-              <a:t> </a:t>
-            </a:r>
-            <a:r>
-              <a:rPr lang="en-US" dirty="0" err="1"/>
-              <a:t>mim</a:t>
-            </a:r>
+              <a:rPr lang="pt-PT" dirty="0"/>
+              <a:t>«Foste fiel em coisas pequenas:</a:t>
+            </a:r>
+          </a:p>
+          <a:p>
+            <a:r>
+              <a:rPr lang="pt-PT" dirty="0"/>
+              <a:t>vem tomar parte na alegria do teu Senhor»</a:t>
+            </a:r>
+          </a:p>
+          <a:p>
             <a:endParaRPr lang="pt-PT" dirty="0"/>
           </a:p>
         </p:txBody>
       </p:sp>
       <p:sp>
         <p:nvSpPr>
-          <p:cNvPr id="3" name="Letra">
-            <a:extLst>
-              <a:ext uri="{FF2B5EF4-FFF2-40B4-BE49-F238E27FC236}">
-                <a16:creationId xmlns:a16="http://schemas.microsoft.com/office/drawing/2014/main" id="{7FBA5054-2BE0-6B52-7485-0B10968F39E5}"/>
+          <p:cNvPr id="10" name="Versiculo">
+            <a:extLst>
+              <a:ext uri="{FF2B5EF4-FFF2-40B4-BE49-F238E27FC236}">
+                <a16:creationId xmlns:a16="http://schemas.microsoft.com/office/drawing/2014/main" id="{5E840FDF-3863-C2D2-A15A-5646F8E54972}"/>
               </a:ext>
             </a:extLst>
           </p:cNvPr>
@@ -3040,177 +3725,164 @@
             <a:spLocks noGrp="1"/>
           </p:cNvSpPr>
           <p:nvPr>
-            <p:ph idx="1" hasCustomPrompt="1"/>
+            <p:ph type="body" sz="quarter" idx="11" hasCustomPrompt="1"/>
           </p:nvPr>
         </p:nvSpPr>
         <p:spPr>
           <a:xfrm>
-            <a:off x="549995" y="961533"/>
-            <a:ext cx="8044010" cy="5670225"/>
+            <a:off x="2597150" y="3439932"/>
+            <a:ext cx="3949700" cy="369838"/>
           </a:xfrm>
         </p:spPr>
         <p:txBody>
-          <a:bodyPr tIns="0" anchor="ctr" anchorCtr="1">
-            <a:normAutofit/>
+          <a:bodyPr>
+            <a:noAutofit/>
           </a:bodyPr>
           <a:lstStyle>
-            <a:lvl1pPr marL="0" marR="0" indent="0" algn="ctr" defTabSz="685800" rtl="0" eaLnBrk="1" fontAlgn="auto" latinLnBrk="0" hangingPunct="1">
-              <a:lnSpc>
-                <a:spcPct val="130000"/>
-              </a:lnSpc>
-              <a:spcBef>
-                <a:spcPts val="0"/>
-              </a:spcBef>
-              <a:spcAft>
-                <a:spcPts val="0"/>
-              </a:spcAft>
-              <a:buClrTx/>
-              <a:buSzTx/>
-              <a:buFont typeface="Arial" panose="020B0604020202020204" pitchFamily="34" charset="0"/>
-              <a:buNone/>
-              <a:tabLst/>
-              <a:defRPr sz="6000"/>
+            <a:lvl1pPr algn="ctr">
+              <a:defRPr lang="pt-PT" sz="1600" b="0" kern="1200" cap="small" spc="0" baseline="0" dirty="0">
+                <a:solidFill>
+                  <a:schemeClr val="tx1"/>
+                </a:solidFill>
+                <a:latin typeface="Livvic" pitchFamily="2" charset="0"/>
+                <a:ea typeface="+mn-ea"/>
+                <a:cs typeface="+mn-cs"/>
+              </a:defRPr>
             </a:lvl1pPr>
-            <a:lvl2pPr algn="ctr">
-              <a:defRPr/>
+            <a:lvl2pPr>
+              <a:defRPr sz="1800"/>
             </a:lvl2pPr>
-            <a:lvl3pPr algn="ctr">
-              <a:defRPr/>
+            <a:lvl3pPr>
+              <a:defRPr sz="1600"/>
             </a:lvl3pPr>
-            <a:lvl4pPr algn="ctr">
-              <a:defRPr/>
+            <a:lvl4pPr>
+              <a:defRPr sz="1600"/>
             </a:lvl4pPr>
-            <a:lvl5pPr algn="ctr">
-              <a:defRPr/>
+            <a:lvl5pPr>
+              <a:defRPr sz="1600"/>
             </a:lvl5pPr>
           </a:lstStyle>
           <a:p>
-            <a:pPr lvl="0"/>
-            <a:r>
-              <a:rPr lang="en-US" dirty="0"/>
-              <a:t>Música com </a:t>
-            </a:r>
-            <a:r>
-              <a:rPr lang="en-US" dirty="0" err="1"/>
-              <a:t>linha</a:t>
-            </a:r>
-            <a:r>
-              <a:rPr lang="en-US" dirty="0"/>
-              <a:t> 1</a:t>
-            </a:r>
-          </a:p>
-          <a:p>
-            <a:pPr marL="0" marR="0" lvl="0" indent="0" algn="ctr" defTabSz="685800" rtl="0" eaLnBrk="1" fontAlgn="auto" latinLnBrk="0" hangingPunct="1">
+            <a:pPr marL="0" lvl="0" indent="0" algn="ctr" defTabSz="685800" rtl="0" eaLnBrk="1" latinLnBrk="0" hangingPunct="1">
               <a:lnSpc>
                 <a:spcPct val="90000"/>
               </a:lnSpc>
               <a:spcBef>
                 <a:spcPts val="750"/>
               </a:spcBef>
-              <a:spcAft>
-                <a:spcPts val="0"/>
-              </a:spcAft>
-              <a:buClrTx/>
-              <a:buSzTx/>
               <a:buFont typeface="Arial" panose="020B0604020202020204" pitchFamily="34" charset="0"/>
               <a:buNone/>
-              <a:tabLst/>
-              <a:defRPr/>
             </a:pPr>
             <a:r>
               <a:rPr lang="en-US" dirty="0"/>
-              <a:t>Música com </a:t>
-            </a:r>
-            <a:r>
-              <a:rPr lang="en-US" dirty="0" err="1"/>
-              <a:t>linha</a:t>
-            </a:r>
-            <a:r>
-              <a:rPr lang="en-US" dirty="0"/>
-              <a:t> 2 e </a:t>
-            </a:r>
-            <a:r>
-              <a:rPr lang="en-US" dirty="0" err="1"/>
-              <a:t>mais</a:t>
-            </a:r>
-            <a:r>
-              <a:rPr lang="en-US" dirty="0"/>
-              <a:t> </a:t>
-            </a:r>
-          </a:p>
-          <a:p>
-            <a:pPr marL="0" marR="0" lvl="0" indent="0" algn="ctr" defTabSz="685800" rtl="0" eaLnBrk="1" fontAlgn="auto" latinLnBrk="0" hangingPunct="1">
-              <a:lnSpc>
-                <a:spcPct val="90000"/>
-              </a:lnSpc>
-              <a:spcBef>
-                <a:spcPts val="750"/>
-              </a:spcBef>
-              <a:spcAft>
-                <a:spcPts val="0"/>
-              </a:spcAft>
-              <a:buClrTx/>
-              <a:buSzTx/>
-              <a:buFont typeface="Arial" panose="020B0604020202020204" pitchFamily="34" charset="0"/>
-              <a:buNone/>
-              <a:tabLst/>
-              <a:defRPr/>
-            </a:pPr>
-            <a:r>
-              <a:rPr lang="en-US" dirty="0"/>
-              <a:t>Música com </a:t>
-            </a:r>
-            <a:r>
-              <a:rPr lang="en-US" dirty="0" err="1"/>
-              <a:t>linha</a:t>
-            </a:r>
-            <a:r>
-              <a:rPr lang="en-US" dirty="0"/>
-              <a:t> 3</a:t>
-            </a:r>
-          </a:p>
-          <a:p>
-            <a:pPr marL="0" marR="0" lvl="0" indent="0" algn="ctr" defTabSz="685800" rtl="0" eaLnBrk="1" fontAlgn="auto" latinLnBrk="0" hangingPunct="1">
-              <a:lnSpc>
-                <a:spcPct val="90000"/>
-              </a:lnSpc>
-              <a:spcBef>
-                <a:spcPts val="750"/>
-              </a:spcBef>
-              <a:spcAft>
-                <a:spcPts val="0"/>
-              </a:spcAft>
-              <a:buClrTx/>
-              <a:buSzTx/>
-              <a:buFont typeface="Arial" panose="020B0604020202020204" pitchFamily="34" charset="0"/>
-              <a:buNone/>
-              <a:tabLst/>
-              <a:defRPr/>
-            </a:pPr>
-            <a:r>
-              <a:rPr lang="en-US" dirty="0"/>
-              <a:t>Música com a </a:t>
-            </a:r>
-            <a:r>
-              <a:rPr lang="en-US" dirty="0" err="1"/>
-              <a:t>linha</a:t>
-            </a:r>
-            <a:r>
-              <a:rPr lang="en-US" dirty="0"/>
-              <a:t> final </a:t>
-            </a:r>
-            <a:r>
-              <a:rPr lang="en-US" dirty="0" err="1"/>
-              <a:t>aqui</a:t>
-            </a:r>
-            <a:endParaRPr lang="en-US" dirty="0"/>
+              <a:t>Mt 25, 14-30</a:t>
+            </a:r>
+            <a:endParaRPr lang="pt-PT" dirty="0"/>
+          </a:p>
+        </p:txBody>
+      </p:sp>
+      <p:pic>
+        <p:nvPicPr>
+          <p:cNvPr id="5" name="Picture 4">
+            <a:extLst>
+              <a:ext uri="{FF2B5EF4-FFF2-40B4-BE49-F238E27FC236}">
+                <a16:creationId xmlns:a16="http://schemas.microsoft.com/office/drawing/2014/main" id="{CFFB9FFB-187A-E58F-9BD3-81D67A3BC287}"/>
+              </a:ext>
+            </a:extLst>
+          </p:cNvPr>
+          <p:cNvPicPr>
+            <a:picLocks noChangeAspect="1"/>
+          </p:cNvPicPr>
+          <p:nvPr userDrawn="1"/>
+        </p:nvPicPr>
+        <p:blipFill>
+          <a:blip r:embed="rId2">
+            <a:extLst>
+              <a:ext uri="{28A0092B-C50C-407E-A947-70E740481C1C}">
+                <a14:useLocalDpi xmlns:a14="http://schemas.microsoft.com/office/drawing/2010/main" val="0"/>
+              </a:ext>
+            </a:extLst>
+          </a:blip>
+          <a:srcRect t="13134" b="13134"/>
+          <a:stretch/>
+        </p:blipFill>
+        <p:spPr>
+          <a:xfrm>
+            <a:off x="2597150" y="3940404"/>
+            <a:ext cx="3867487" cy="2851608"/>
+          </a:xfrm>
+          <a:prstGeom prst="rect">
+            <a:avLst/>
+          </a:prstGeom>
+        </p:spPr>
+      </p:pic>
+      <p:sp>
+        <p:nvSpPr>
+          <p:cNvPr id="4" name="Tempo">
+            <a:extLst>
+              <a:ext uri="{FF2B5EF4-FFF2-40B4-BE49-F238E27FC236}">
+                <a16:creationId xmlns:a16="http://schemas.microsoft.com/office/drawing/2014/main" id="{FC37DF36-BF80-AA4F-FD0F-95E21C3011EC}"/>
+              </a:ext>
+            </a:extLst>
+          </p:cNvPr>
+          <p:cNvSpPr>
+            <a:spLocks noGrp="1"/>
+          </p:cNvSpPr>
+          <p:nvPr>
+            <p:ph type="body" sz="quarter" idx="10" hasCustomPrompt="1"/>
+          </p:nvPr>
+        </p:nvSpPr>
+        <p:spPr>
+          <a:xfrm>
+            <a:off x="2074048" y="654543"/>
+            <a:ext cx="4913689" cy="369838"/>
+          </a:xfrm>
+        </p:spPr>
+        <p:txBody>
+          <a:bodyPr>
+            <a:noAutofit/>
+          </a:bodyPr>
+          <a:lstStyle>
+            <a:lvl1pPr algn="ctr">
+              <a:defRPr sz="1800" b="0" cap="small" spc="600" baseline="0">
+                <a:latin typeface="Livvic" pitchFamily="2" charset="0"/>
+              </a:defRPr>
+            </a:lvl1pPr>
+            <a:lvl2pPr>
+              <a:defRPr sz="1800"/>
+            </a:lvl2pPr>
+            <a:lvl3pPr>
+              <a:defRPr sz="1600"/>
+            </a:lvl3pPr>
+            <a:lvl4pPr>
+              <a:defRPr sz="1600"/>
+            </a:lvl4pPr>
+            <a:lvl5pPr>
+              <a:defRPr sz="1600"/>
+            </a:lvl5pPr>
+          </a:lstStyle>
+          <a:p>
+            <a:pPr lvl="0"/>
+            <a:r>
+              <a:rPr lang="en-US" dirty="0"/>
+              <a:t>Tempo de Páscoa </a:t>
+            </a:r>
+            <a:r>
+              <a:rPr lang="pt-PT" dirty="0"/>
+              <a:t>· </a:t>
+            </a:r>
+            <a:r>
+              <a:rPr lang="en-US" dirty="0"/>
+              <a:t>Ano A</a:t>
+            </a:r>
+            <a:endParaRPr lang="pt-PT" dirty="0"/>
           </a:p>
         </p:txBody>
       </p:sp>
     </p:spTree>
     <p:extLst>
       <p:ext uri="{BB962C8B-B14F-4D97-AF65-F5344CB8AC3E}">
-        <p14:creationId xmlns:p14="http://schemas.microsoft.com/office/powerpoint/2010/main" val="2195698647"/>
+        <p14:creationId xmlns:p14="http://schemas.microsoft.com/office/powerpoint/2010/main" val="3276494890"/>
       </p:ext>
     </p:extLst>
   </p:cSld>
@@ -3221,8 +3893,20 @@
 </file>
 
 <file path=ppt/slideLayouts/slideLayout9.xml><?xml version="1.0" encoding="utf-8"?>
-<p:sldLayout xmlns:a="http://schemas.openxmlformats.org/drawingml/2006/main" xmlns:r="http://schemas.openxmlformats.org/officeDocument/2006/relationships" xmlns:p="http://schemas.openxmlformats.org/presentationml/2006/main" type="obj" preserve="1">
-  <p:cSld name="Título e letra - Tempo Advento">
+<p:sldLayout xmlns:a="http://schemas.openxmlformats.org/drawingml/2006/main" xmlns:r="http://schemas.openxmlformats.org/officeDocument/2006/relationships" xmlns:p="http://schemas.openxmlformats.org/presentationml/2006/main" preserve="1" userDrawn="1">
+  <p:cSld name="Capa - Pentecostes">
+    <p:bg>
+      <p:bgPr>
+        <a:solidFill>
+          <a:schemeClr val="accent5">
+            <a:lumMod val="40000"/>
+            <a:lumOff val="60000"/>
+            <a:alpha val="25000"/>
+          </a:schemeClr>
+        </a:solidFill>
+        <a:effectLst/>
+      </p:bgPr>
+    </p:bg>
     <p:spTree>
       <p:nvGrpSpPr>
         <p:cNvPr id="1" name=""/>
@@ -3239,66 +3923,59 @@
       </p:grpSpPr>
       <p:sp>
         <p:nvSpPr>
-          <p:cNvPr id="7" name="Header">
-            <a:extLst>
-              <a:ext uri="{FF2B5EF4-FFF2-40B4-BE49-F238E27FC236}">
-                <a16:creationId xmlns:a16="http://schemas.microsoft.com/office/drawing/2014/main" id="{9C521DED-F031-73C8-3FE1-6EDC94DF1880}"/>
-              </a:ext>
-            </a:extLst>
-          </p:cNvPr>
-          <p:cNvSpPr/>
-          <p:nvPr userDrawn="1"/>
+          <p:cNvPr id="2" name="Domingo">
+            <a:extLst>
+              <a:ext uri="{FF2B5EF4-FFF2-40B4-BE49-F238E27FC236}">
+                <a16:creationId xmlns:a16="http://schemas.microsoft.com/office/drawing/2014/main" id="{AC6EEB27-5DD2-414A-A29B-10D30F19AC21}"/>
+              </a:ext>
+            </a:extLst>
+          </p:cNvPr>
+          <p:cNvSpPr>
+            <a:spLocks noGrp="1"/>
+          </p:cNvSpPr>
+          <p:nvPr>
+            <p:ph type="ctrTitle" hasCustomPrompt="1"/>
+          </p:nvPr>
         </p:nvSpPr>
         <p:spPr>
           <a:xfrm>
-            <a:off x="0" y="0"/>
-            <a:ext cx="9144000" cy="801278"/>
-          </a:xfrm>
-          <a:prstGeom prst="rect">
-            <a:avLst/>
-          </a:prstGeom>
-          <a:solidFill>
-            <a:schemeClr val="accent2">
-              <a:lumMod val="75000"/>
-            </a:schemeClr>
-          </a:solidFill>
-          <a:ln>
-            <a:noFill/>
-          </a:ln>
-        </p:spPr>
-        <p:style>
-          <a:lnRef idx="2">
-            <a:schemeClr val="accent1">
-              <a:shade val="15000"/>
-            </a:schemeClr>
-          </a:lnRef>
-          <a:fillRef idx="1">
-            <a:schemeClr val="accent1"/>
-          </a:fillRef>
-          <a:effectRef idx="0">
-            <a:schemeClr val="accent1"/>
-          </a:effectRef>
-          <a:fontRef idx="minor">
-            <a:schemeClr val="lt1"/>
-          </a:fontRef>
-        </p:style>
+            <a:off x="0" y="1129506"/>
+            <a:ext cx="9144000" cy="1106127"/>
+          </a:xfrm>
+        </p:spPr>
         <p:txBody>
-          <a:bodyPr wrap="none" rtlCol="0" anchor="ctr">
-            <a:normAutofit/>
+          <a:bodyPr anchor="b">
+            <a:noAutofit/>
           </a:bodyPr>
-          <a:lstStyle/>
-          <a:p>
-            <a:pPr algn="ctr"/>
-            <a:endParaRPr lang="pt-PT"/>
+          <a:lstStyle>
+            <a:lvl1pPr algn="ctr">
+              <a:defRPr sz="6000" b="1">
+                <a:solidFill>
+                  <a:schemeClr val="accent5"/>
+                </a:solidFill>
+                <a:latin typeface="Playfair Display" pitchFamily="2" charset="0"/>
+              </a:defRPr>
+            </a:lvl1pPr>
+          </a:lstStyle>
+          <a:p>
+            <a:r>
+              <a:rPr lang="en-US" dirty="0"/>
+              <a:t>Domingo de </a:t>
+            </a:r>
+            <a:r>
+              <a:rPr lang="en-US" dirty="0" err="1"/>
+              <a:t>Pentecostes</a:t>
+            </a:r>
+            <a:endParaRPr lang="pt-PT" dirty="0"/>
           </a:p>
         </p:txBody>
       </p:sp>
       <p:sp>
         <p:nvSpPr>
-          <p:cNvPr id="2" name="Título">
-            <a:extLst>
-              <a:ext uri="{FF2B5EF4-FFF2-40B4-BE49-F238E27FC236}">
-                <a16:creationId xmlns:a16="http://schemas.microsoft.com/office/drawing/2014/main" id="{29D85961-FC26-87D6-F7CF-D2E332EB5E80}"/>
+          <p:cNvPr id="3" name="Frase">
+            <a:extLst>
+              <a:ext uri="{FF2B5EF4-FFF2-40B4-BE49-F238E27FC236}">
+                <a16:creationId xmlns:a16="http://schemas.microsoft.com/office/drawing/2014/main" id="{F5DEF8E5-A6D3-FF16-3A4C-6762958F1B84}"/>
               </a:ext>
             </a:extLst>
           </p:cNvPr>
@@ -3306,56 +3983,82 @@
             <a:spLocks noGrp="1"/>
           </p:cNvSpPr>
           <p:nvPr>
-            <p:ph type="title" hasCustomPrompt="1"/>
+            <p:ph type="subTitle" idx="1" hasCustomPrompt="1"/>
           </p:nvPr>
         </p:nvSpPr>
         <p:spPr>
           <a:xfrm>
-            <a:off x="240890" y="245096"/>
-            <a:ext cx="8662220" cy="525262"/>
+            <a:off x="494907" y="2525677"/>
+            <a:ext cx="8154186" cy="914255"/>
           </a:xfrm>
         </p:spPr>
         <p:txBody>
-          <a:bodyPr wrap="square">
-            <a:normAutofit/>
+          <a:bodyPr>
+            <a:noAutofit/>
           </a:bodyPr>
           <a:lstStyle>
-            <a:lvl1pPr algn="ctr">
-              <a:defRPr sz="3400">
-                <a:solidFill>
-                  <a:schemeClr val="bg1"/>
-                </a:solidFill>
-                <a:latin typeface="Livvic SemiBold" pitchFamily="2" charset="0"/>
+            <a:lvl1pPr marL="0" indent="0" algn="ctr">
+              <a:buNone/>
+              <a:defRPr sz="2400">
+                <a:latin typeface="Shadows Into Light Two" panose="02000506000000020004" pitchFamily="2" charset="0"/>
               </a:defRPr>
             </a:lvl1pPr>
+            <a:lvl2pPr marL="342900" indent="0" algn="ctr">
+              <a:buNone/>
+              <a:defRPr sz="1500"/>
+            </a:lvl2pPr>
+            <a:lvl3pPr marL="685800" indent="0" algn="ctr">
+              <a:buNone/>
+              <a:defRPr sz="1350"/>
+            </a:lvl3pPr>
+            <a:lvl4pPr marL="1028700" indent="0" algn="ctr">
+              <a:buNone/>
+              <a:defRPr sz="1200"/>
+            </a:lvl4pPr>
+            <a:lvl5pPr marL="1371600" indent="0" algn="ctr">
+              <a:buNone/>
+              <a:defRPr sz="1200"/>
+            </a:lvl5pPr>
+            <a:lvl6pPr marL="1714500" indent="0" algn="ctr">
+              <a:buNone/>
+              <a:defRPr sz="1200"/>
+            </a:lvl6pPr>
+            <a:lvl7pPr marL="2057400" indent="0" algn="ctr">
+              <a:buNone/>
+              <a:defRPr sz="1200"/>
+            </a:lvl7pPr>
+            <a:lvl8pPr marL="2400300" indent="0" algn="ctr">
+              <a:buNone/>
+              <a:defRPr sz="1200"/>
+            </a:lvl8pPr>
+            <a:lvl9pPr marL="2743200" indent="0" algn="ctr">
+              <a:buNone/>
+              <a:defRPr sz="1200"/>
+            </a:lvl9pPr>
           </a:lstStyle>
           <a:p>
             <a:r>
-              <a:rPr lang="en-US" dirty="0"/>
-              <a:t>Cristo </a:t>
-            </a:r>
-            <a:r>
-              <a:rPr lang="en-US" dirty="0" err="1"/>
-              <a:t>em</a:t>
-            </a:r>
-            <a:r>
-              <a:rPr lang="en-US" dirty="0"/>
-              <a:t> </a:t>
-            </a:r>
-            <a:r>
-              <a:rPr lang="en-US" dirty="0" err="1"/>
-              <a:t>mim</a:t>
-            </a:r>
+              <a:rPr lang="pt-PT" dirty="0"/>
+              <a:t>«Foste fiel em coisas pequenas:</a:t>
+            </a:r>
+          </a:p>
+          <a:p>
+            <a:r>
+              <a:rPr lang="pt-PT" dirty="0"/>
+              <a:t>vem tomar parte na alegria do teu Senhor»</a:t>
+            </a:r>
+          </a:p>
+          <a:p>
             <a:endParaRPr lang="pt-PT" dirty="0"/>
           </a:p>
         </p:txBody>
       </p:sp>
       <p:sp>
         <p:nvSpPr>
-          <p:cNvPr id="3" name="Letra">
-            <a:extLst>
-              <a:ext uri="{FF2B5EF4-FFF2-40B4-BE49-F238E27FC236}">
-                <a16:creationId xmlns:a16="http://schemas.microsoft.com/office/drawing/2014/main" id="{7FBA5054-2BE0-6B52-7485-0B10968F39E5}"/>
+          <p:cNvPr id="10" name="Versiculo">
+            <a:extLst>
+              <a:ext uri="{FF2B5EF4-FFF2-40B4-BE49-F238E27FC236}">
+                <a16:creationId xmlns:a16="http://schemas.microsoft.com/office/drawing/2014/main" id="{5E840FDF-3863-C2D2-A15A-5646F8E54972}"/>
               </a:ext>
             </a:extLst>
           </p:cNvPr>
@@ -3363,177 +4066,164 @@
             <a:spLocks noGrp="1"/>
           </p:cNvSpPr>
           <p:nvPr>
-            <p:ph idx="1" hasCustomPrompt="1"/>
+            <p:ph type="body" sz="quarter" idx="11" hasCustomPrompt="1"/>
           </p:nvPr>
         </p:nvSpPr>
         <p:spPr>
           <a:xfrm>
-            <a:off x="549995" y="961533"/>
-            <a:ext cx="8044010" cy="5670225"/>
+            <a:off x="2597150" y="3439932"/>
+            <a:ext cx="3949700" cy="369838"/>
           </a:xfrm>
         </p:spPr>
         <p:txBody>
-          <a:bodyPr tIns="0" anchor="ctr" anchorCtr="1">
-            <a:normAutofit/>
+          <a:bodyPr>
+            <a:noAutofit/>
           </a:bodyPr>
           <a:lstStyle>
-            <a:lvl1pPr marL="0" marR="0" indent="0" algn="ctr" defTabSz="685800" rtl="0" eaLnBrk="1" fontAlgn="auto" latinLnBrk="0" hangingPunct="1">
-              <a:lnSpc>
-                <a:spcPct val="130000"/>
-              </a:lnSpc>
-              <a:spcBef>
-                <a:spcPts val="0"/>
-              </a:spcBef>
-              <a:spcAft>
-                <a:spcPts val="0"/>
-              </a:spcAft>
-              <a:buClrTx/>
-              <a:buSzTx/>
-              <a:buFont typeface="Arial" panose="020B0604020202020204" pitchFamily="34" charset="0"/>
-              <a:buNone/>
-              <a:tabLst/>
-              <a:defRPr sz="6000"/>
+            <a:lvl1pPr algn="ctr">
+              <a:defRPr lang="pt-PT" sz="1600" b="0" kern="1200" cap="small" spc="0" baseline="0" dirty="0">
+                <a:solidFill>
+                  <a:schemeClr val="tx1"/>
+                </a:solidFill>
+                <a:latin typeface="Livvic" pitchFamily="2" charset="0"/>
+                <a:ea typeface="+mn-ea"/>
+                <a:cs typeface="+mn-cs"/>
+              </a:defRPr>
             </a:lvl1pPr>
-            <a:lvl2pPr algn="ctr">
-              <a:defRPr/>
+            <a:lvl2pPr>
+              <a:defRPr sz="1800"/>
             </a:lvl2pPr>
-            <a:lvl3pPr algn="ctr">
-              <a:defRPr/>
+            <a:lvl3pPr>
+              <a:defRPr sz="1600"/>
             </a:lvl3pPr>
-            <a:lvl4pPr algn="ctr">
-              <a:defRPr/>
+            <a:lvl4pPr>
+              <a:defRPr sz="1600"/>
             </a:lvl4pPr>
-            <a:lvl5pPr algn="ctr">
-              <a:defRPr/>
+            <a:lvl5pPr>
+              <a:defRPr sz="1600"/>
             </a:lvl5pPr>
           </a:lstStyle>
           <a:p>
-            <a:pPr lvl="0"/>
-            <a:r>
-              <a:rPr lang="en-US" dirty="0"/>
-              <a:t>Música com </a:t>
-            </a:r>
-            <a:r>
-              <a:rPr lang="en-US" dirty="0" err="1"/>
-              <a:t>linha</a:t>
-            </a:r>
-            <a:r>
-              <a:rPr lang="en-US" dirty="0"/>
-              <a:t> 1</a:t>
-            </a:r>
-          </a:p>
-          <a:p>
-            <a:pPr marL="0" marR="0" lvl="0" indent="0" algn="ctr" defTabSz="685800" rtl="0" eaLnBrk="1" fontAlgn="auto" latinLnBrk="0" hangingPunct="1">
+            <a:pPr marL="0" lvl="0" indent="0" algn="ctr" defTabSz="685800" rtl="0" eaLnBrk="1" latinLnBrk="0" hangingPunct="1">
               <a:lnSpc>
                 <a:spcPct val="90000"/>
               </a:lnSpc>
               <a:spcBef>
                 <a:spcPts val="750"/>
               </a:spcBef>
-              <a:spcAft>
-                <a:spcPts val="0"/>
-              </a:spcAft>
-              <a:buClrTx/>
-              <a:buSzTx/>
               <a:buFont typeface="Arial" panose="020B0604020202020204" pitchFamily="34" charset="0"/>
               <a:buNone/>
-              <a:tabLst/>
-              <a:defRPr/>
             </a:pPr>
             <a:r>
               <a:rPr lang="en-US" dirty="0"/>
-              <a:t>Música com </a:t>
-            </a:r>
-            <a:r>
-              <a:rPr lang="en-US" dirty="0" err="1"/>
-              <a:t>linha</a:t>
-            </a:r>
-            <a:r>
-              <a:rPr lang="en-US" dirty="0"/>
-              <a:t> 2 e </a:t>
-            </a:r>
-            <a:r>
-              <a:rPr lang="en-US" dirty="0" err="1"/>
-              <a:t>mais</a:t>
-            </a:r>
-            <a:r>
-              <a:rPr lang="en-US" dirty="0"/>
-              <a:t> </a:t>
-            </a:r>
-          </a:p>
-          <a:p>
-            <a:pPr marL="0" marR="0" lvl="0" indent="0" algn="ctr" defTabSz="685800" rtl="0" eaLnBrk="1" fontAlgn="auto" latinLnBrk="0" hangingPunct="1">
-              <a:lnSpc>
-                <a:spcPct val="90000"/>
-              </a:lnSpc>
-              <a:spcBef>
-                <a:spcPts val="750"/>
-              </a:spcBef>
-              <a:spcAft>
-                <a:spcPts val="0"/>
-              </a:spcAft>
-              <a:buClrTx/>
-              <a:buSzTx/>
-              <a:buFont typeface="Arial" panose="020B0604020202020204" pitchFamily="34" charset="0"/>
-              <a:buNone/>
-              <a:tabLst/>
-              <a:defRPr/>
-            </a:pPr>
-            <a:r>
-              <a:rPr lang="en-US" dirty="0"/>
-              <a:t>Música com </a:t>
-            </a:r>
-            <a:r>
-              <a:rPr lang="en-US" dirty="0" err="1"/>
-              <a:t>linha</a:t>
-            </a:r>
-            <a:r>
-              <a:rPr lang="en-US" dirty="0"/>
-              <a:t> 3</a:t>
-            </a:r>
-          </a:p>
-          <a:p>
-            <a:pPr marL="0" marR="0" lvl="0" indent="0" algn="ctr" defTabSz="685800" rtl="0" eaLnBrk="1" fontAlgn="auto" latinLnBrk="0" hangingPunct="1">
-              <a:lnSpc>
-                <a:spcPct val="90000"/>
-              </a:lnSpc>
-              <a:spcBef>
-                <a:spcPts val="750"/>
-              </a:spcBef>
-              <a:spcAft>
-                <a:spcPts val="0"/>
-              </a:spcAft>
-              <a:buClrTx/>
-              <a:buSzTx/>
-              <a:buFont typeface="Arial" panose="020B0604020202020204" pitchFamily="34" charset="0"/>
-              <a:buNone/>
-              <a:tabLst/>
-              <a:defRPr/>
-            </a:pPr>
-            <a:r>
-              <a:rPr lang="en-US" dirty="0"/>
-              <a:t>Música com a </a:t>
-            </a:r>
-            <a:r>
-              <a:rPr lang="en-US" dirty="0" err="1"/>
-              <a:t>linha</a:t>
-            </a:r>
-            <a:r>
-              <a:rPr lang="en-US" dirty="0"/>
-              <a:t> final </a:t>
-            </a:r>
-            <a:r>
-              <a:rPr lang="en-US" dirty="0" err="1"/>
-              <a:t>aqui</a:t>
-            </a:r>
-            <a:endParaRPr lang="en-US" dirty="0"/>
+              <a:t>Mt 25, 14-30</a:t>
+            </a:r>
+            <a:endParaRPr lang="pt-PT" dirty="0"/>
+          </a:p>
+        </p:txBody>
+      </p:sp>
+      <p:pic>
+        <p:nvPicPr>
+          <p:cNvPr id="5" name="Picture 4">
+            <a:extLst>
+              <a:ext uri="{FF2B5EF4-FFF2-40B4-BE49-F238E27FC236}">
+                <a16:creationId xmlns:a16="http://schemas.microsoft.com/office/drawing/2014/main" id="{CFFB9FFB-187A-E58F-9BD3-81D67A3BC287}"/>
+              </a:ext>
+            </a:extLst>
+          </p:cNvPr>
+          <p:cNvPicPr>
+            <a:picLocks noChangeAspect="1"/>
+          </p:cNvPicPr>
+          <p:nvPr userDrawn="1"/>
+        </p:nvPicPr>
+        <p:blipFill>
+          <a:blip r:embed="rId2">
+            <a:extLst>
+              <a:ext uri="{28A0092B-C50C-407E-A947-70E740481C1C}">
+                <a14:useLocalDpi xmlns:a14="http://schemas.microsoft.com/office/drawing/2010/main" val="0"/>
+              </a:ext>
+            </a:extLst>
+          </a:blip>
+          <a:srcRect t="13134" b="13134"/>
+          <a:stretch/>
+        </p:blipFill>
+        <p:spPr>
+          <a:xfrm>
+            <a:off x="2597150" y="3940404"/>
+            <a:ext cx="3867487" cy="2851608"/>
+          </a:xfrm>
+          <a:prstGeom prst="rect">
+            <a:avLst/>
+          </a:prstGeom>
+        </p:spPr>
+      </p:pic>
+      <p:sp>
+        <p:nvSpPr>
+          <p:cNvPr id="4" name="Tempo">
+            <a:extLst>
+              <a:ext uri="{FF2B5EF4-FFF2-40B4-BE49-F238E27FC236}">
+                <a16:creationId xmlns:a16="http://schemas.microsoft.com/office/drawing/2014/main" id="{FC37DF36-BF80-AA4F-FD0F-95E21C3011EC}"/>
+              </a:ext>
+            </a:extLst>
+          </p:cNvPr>
+          <p:cNvSpPr>
+            <a:spLocks noGrp="1"/>
+          </p:cNvSpPr>
+          <p:nvPr>
+            <p:ph type="body" sz="quarter" idx="10" hasCustomPrompt="1"/>
+          </p:nvPr>
+        </p:nvSpPr>
+        <p:spPr>
+          <a:xfrm>
+            <a:off x="2074048" y="654543"/>
+            <a:ext cx="4913689" cy="369838"/>
+          </a:xfrm>
+        </p:spPr>
+        <p:txBody>
+          <a:bodyPr>
+            <a:noAutofit/>
+          </a:bodyPr>
+          <a:lstStyle>
+            <a:lvl1pPr algn="ctr">
+              <a:defRPr sz="1800" b="0" cap="small" spc="600" baseline="0">
+                <a:latin typeface="Livvic" pitchFamily="2" charset="0"/>
+              </a:defRPr>
+            </a:lvl1pPr>
+            <a:lvl2pPr>
+              <a:defRPr sz="1800"/>
+            </a:lvl2pPr>
+            <a:lvl3pPr>
+              <a:defRPr sz="1600"/>
+            </a:lvl3pPr>
+            <a:lvl4pPr>
+              <a:defRPr sz="1600"/>
+            </a:lvl4pPr>
+            <a:lvl5pPr>
+              <a:defRPr sz="1600"/>
+            </a:lvl5pPr>
+          </a:lstStyle>
+          <a:p>
+            <a:pPr lvl="0"/>
+            <a:r>
+              <a:rPr lang="en-US" dirty="0"/>
+              <a:t>Tempo de Páscoa </a:t>
+            </a:r>
+            <a:r>
+              <a:rPr lang="pt-PT" dirty="0"/>
+              <a:t>· </a:t>
+            </a:r>
+            <a:r>
+              <a:rPr lang="en-US" dirty="0"/>
+              <a:t>Ano A</a:t>
+            </a:r>
+            <a:endParaRPr lang="pt-PT" dirty="0"/>
           </a:p>
         </p:txBody>
       </p:sp>
     </p:spTree>
     <p:extLst>
       <p:ext uri="{BB962C8B-B14F-4D97-AF65-F5344CB8AC3E}">
-        <p14:creationId xmlns:p14="http://schemas.microsoft.com/office/powerpoint/2010/main" val="1096708260"/>
+        <p14:creationId xmlns:p14="http://schemas.microsoft.com/office/powerpoint/2010/main" val="447228626"/>
       </p:ext>
     </p:extLst>
   </p:cSld>
@@ -3824,10 +4514,12 @@
     <p:sldLayoutId id="2147483662" r:id="rId4"/>
     <p:sldLayoutId id="2147483663" r:id="rId5"/>
     <p:sldLayoutId id="2147483664" r:id="rId6"/>
-    <p:sldLayoutId id="2147483665" r:id="rId7"/>
-    <p:sldLayoutId id="2147483650" r:id="rId8"/>
-    <p:sldLayoutId id="2147483667" r:id="rId9"/>
-    <p:sldLayoutId id="2147483666" r:id="rId10"/>
+    <p:sldLayoutId id="2147483669" r:id="rId7"/>
+    <p:sldLayoutId id="2147483665" r:id="rId8"/>
+    <p:sldLayoutId id="2147483668" r:id="rId9"/>
+    <p:sldLayoutId id="2147483650" r:id="rId10"/>
+    <p:sldLayoutId id="2147483667" r:id="rId11"/>
+    <p:sldLayoutId id="2147483666" r:id="rId12"/>
   </p:sldLayoutIdLst>
   <p:txStyles>
     <p:titleStyle>
@@ -4126,19 +4818,19 @@
         <a:srgbClr val="44546A"/>
       </a:dk2>
       <a:lt2>
-        <a:srgbClr val="FB93A2"/>
+        <a:srgbClr val="FFEDB5"/>
       </a:lt2>
       <a:accent1>
-        <a:srgbClr val="285943"/>
+        <a:srgbClr val="377D49"/>
       </a:accent1>
       <a:accent2>
         <a:srgbClr val="A461AF"/>
       </a:accent2>
       <a:accent3>
-        <a:srgbClr val="DF5A1F"/>
+        <a:srgbClr val="F99595"/>
       </a:accent3>
       <a:accent4>
-        <a:srgbClr val="FFC000"/>
+        <a:srgbClr val="8C6A00"/>
       </a:accent4>
       <a:accent5>
         <a:srgbClr val="B92323"/>

</xml_diff>

<commit_message>
feature: add blank transition slides between songs and list songs in cover presenter notes
</commit_message>
<xml_diff>
--- a/backend/data/template_4x3.pptx
+++ b/backend/data/template_4x3.pptx
@@ -209,7 +209,7 @@
           <a:p>
             <a:fld id="{0C3A9764-8E67-4755-B19F-6AABFF615031}" type="datetimeFigureOut">
               <a:rPr lang="pt-PT" smtClean="0"/>
-              <a:t>14/10/2026</a:t>
+              <a:t>15/10/2026</a:t>
             </a:fld>
             <a:endParaRPr lang="pt-PT"/>
           </a:p>
@@ -1517,6 +1517,742 @@
 </p:sldLayout>
 </file>
 
+<file path=ppt/slideLayouts/slideLayout13.xml><?xml version="1.0" encoding="utf-8"?>
+<p:sldLayout xmlns:a="http://schemas.openxmlformats.org/drawingml/2006/main" xmlns:r="http://schemas.openxmlformats.org/officeDocument/2006/relationships" xmlns:p="http://schemas.openxmlformats.org/presentationml/2006/main" preserve="1" userDrawn="1">
+  <p:cSld name="Transição - Vazio">
+    <p:bg>
+      <p:bgRef idx="1001">
+        <a:schemeClr val="bg1"/>
+      </p:bgRef>
+    </p:bg>
+    <p:spTree>
+      <p:nvGrpSpPr>
+        <p:cNvPr id="1" name=""/>
+        <p:cNvGrpSpPr/>
+        <p:nvPr/>
+      </p:nvGrpSpPr>
+      <p:grpSpPr>
+        <a:xfrm>
+          <a:off x="0" y="0"/>
+          <a:ext cx="0" cy="0"/>
+          <a:chOff x="0" y="0"/>
+          <a:chExt cx="0" cy="0"/>
+        </a:xfrm>
+      </p:grpSpPr>
+    </p:spTree>
+    <p:extLst>
+      <p:ext uri="{BB962C8B-B14F-4D97-AF65-F5344CB8AC3E}">
+        <p14:creationId xmlns:p14="http://schemas.microsoft.com/office/powerpoint/2010/main" val="3656471839"/>
+      </p:ext>
+    </p:extLst>
+  </p:cSld>
+  <p:clrMapOvr>
+    <a:overrideClrMapping bg1="dk1" tx1="lt1" bg2="dk2" tx2="lt2" accent1="accent1" accent2="accent2" accent3="accent3" accent4="accent4" accent5="accent5" accent6="accent6" hlink="hlink" folHlink="folHlink"/>
+  </p:clrMapOvr>
+</p:sldLayout>
+</file>
+
+<file path=ppt/slideLayouts/slideLayout14.xml><?xml version="1.0" encoding="utf-8"?>
+<p:sldLayout xmlns:a="http://schemas.openxmlformats.org/drawingml/2006/main" xmlns:r="http://schemas.openxmlformats.org/officeDocument/2006/relationships" xmlns:p="http://schemas.openxmlformats.org/presentationml/2006/main" preserve="1" userDrawn="1">
+  <p:cSld name="Transição - Texto">
+    <p:bg>
+      <p:bgRef idx="1001">
+        <a:schemeClr val="bg1"/>
+      </p:bgRef>
+    </p:bg>
+    <p:spTree>
+      <p:nvGrpSpPr>
+        <p:cNvPr id="1" name=""/>
+        <p:cNvGrpSpPr/>
+        <p:nvPr/>
+      </p:nvGrpSpPr>
+      <p:grpSpPr>
+        <a:xfrm>
+          <a:off x="0" y="0"/>
+          <a:ext cx="0" cy="0"/>
+          <a:chOff x="0" y="0"/>
+          <a:chExt cx="0" cy="0"/>
+        </a:xfrm>
+      </p:grpSpPr>
+      <p:sp>
+        <p:nvSpPr>
+          <p:cNvPr id="3" name="Letra">
+            <a:extLst>
+              <a:ext uri="{FF2B5EF4-FFF2-40B4-BE49-F238E27FC236}">
+                <a16:creationId xmlns:a16="http://schemas.microsoft.com/office/drawing/2014/main" id="{7FBA5054-2BE0-6B52-7485-0B10968F39E5}"/>
+              </a:ext>
+            </a:extLst>
+          </p:cNvPr>
+          <p:cNvSpPr>
+            <a:spLocks noGrp="1"/>
+          </p:cNvSpPr>
+          <p:nvPr>
+            <p:ph idx="1" hasCustomPrompt="1"/>
+          </p:nvPr>
+        </p:nvSpPr>
+        <p:spPr>
+          <a:xfrm>
+            <a:off x="549995" y="103695"/>
+            <a:ext cx="8044010" cy="6532775"/>
+          </a:xfrm>
+        </p:spPr>
+        <p:txBody>
+          <a:bodyPr anchor="ctr" anchorCtr="0">
+            <a:normAutofit/>
+          </a:bodyPr>
+          <a:lstStyle>
+            <a:lvl1pPr marL="0" marR="0" indent="0" algn="ctr" defTabSz="685800" rtl="0" eaLnBrk="1" fontAlgn="auto" latinLnBrk="0" hangingPunct="1">
+              <a:lnSpc>
+                <a:spcPct val="130000"/>
+              </a:lnSpc>
+              <a:spcBef>
+                <a:spcPts val="0"/>
+              </a:spcBef>
+              <a:spcAft>
+                <a:spcPts val="0"/>
+              </a:spcAft>
+              <a:buClrTx/>
+              <a:buSzTx/>
+              <a:buFont typeface="Arial" panose="020B0604020202020204" pitchFamily="34" charset="0"/>
+              <a:buNone/>
+              <a:tabLst/>
+              <a:defRPr sz="6000">
+                <a:latin typeface="Livvic Thin" pitchFamily="2" charset="0"/>
+              </a:defRPr>
+            </a:lvl1pPr>
+            <a:lvl2pPr algn="ctr">
+              <a:defRPr/>
+            </a:lvl2pPr>
+            <a:lvl3pPr algn="ctr">
+              <a:defRPr/>
+            </a:lvl3pPr>
+            <a:lvl4pPr algn="ctr">
+              <a:defRPr/>
+            </a:lvl4pPr>
+            <a:lvl5pPr algn="ctr">
+              <a:defRPr/>
+            </a:lvl5pPr>
+          </a:lstStyle>
+          <a:p>
+            <a:pPr lvl="0"/>
+            <a:r>
+              <a:rPr lang="en-US" dirty="0" err="1"/>
+              <a:t>Texto</a:t>
+            </a:r>
+            <a:r>
+              <a:rPr lang="en-US" dirty="0"/>
+              <a:t> a </a:t>
+            </a:r>
+            <a:r>
+              <a:rPr lang="en-US" dirty="0" err="1"/>
+              <a:t>apresentar</a:t>
+            </a:r>
+            <a:r>
+              <a:rPr lang="en-US" dirty="0"/>
+              <a:t> entre slides</a:t>
+            </a:r>
+          </a:p>
+        </p:txBody>
+      </p:sp>
+    </p:spTree>
+    <p:extLst>
+      <p:ext uri="{BB962C8B-B14F-4D97-AF65-F5344CB8AC3E}">
+        <p14:creationId xmlns:p14="http://schemas.microsoft.com/office/powerpoint/2010/main" val="1788434461"/>
+      </p:ext>
+    </p:extLst>
+  </p:cSld>
+  <p:clrMapOvr>
+    <a:overrideClrMapping bg1="lt1" tx1="dk1" bg2="lt2" tx2="dk2" accent1="accent1" accent2="accent2" accent3="accent3" accent4="accent4" accent5="accent5" accent6="accent6" hlink="hlink" folHlink="folHlink"/>
+  </p:clrMapOvr>
+</p:sldLayout>
+</file>
+
+<file path=ppt/slideLayouts/slideLayout15.xml><?xml version="1.0" encoding="utf-8"?>
+<p:sldLayout xmlns:a="http://schemas.openxmlformats.org/drawingml/2006/main" xmlns:r="http://schemas.openxmlformats.org/officeDocument/2006/relationships" xmlns:p="http://schemas.openxmlformats.org/presentationml/2006/main" preserve="1" userDrawn="1">
+  <p:cSld name="Transição - Imagem">
+    <p:spTree>
+      <p:nvGrpSpPr>
+        <p:cNvPr id="1" name=""/>
+        <p:cNvGrpSpPr/>
+        <p:nvPr/>
+      </p:nvGrpSpPr>
+      <p:grpSpPr>
+        <a:xfrm>
+          <a:off x="0" y="0"/>
+          <a:ext cx="0" cy="0"/>
+          <a:chOff x="0" y="0"/>
+          <a:chExt cx="0" cy="0"/>
+        </a:xfrm>
+      </p:grpSpPr>
+      <p:sp>
+        <p:nvSpPr>
+          <p:cNvPr id="4" name="Picture Placeholder 3">
+            <a:extLst>
+              <a:ext uri="{FF2B5EF4-FFF2-40B4-BE49-F238E27FC236}">
+                <a16:creationId xmlns:a16="http://schemas.microsoft.com/office/drawing/2014/main" id="{D2844484-4E28-3CA2-5D12-528E93924332}"/>
+              </a:ext>
+            </a:extLst>
+          </p:cNvPr>
+          <p:cNvSpPr>
+            <a:spLocks noGrp="1"/>
+          </p:cNvSpPr>
+          <p:nvPr>
+            <p:ph type="pic" sz="quarter" idx="10"/>
+          </p:nvPr>
+        </p:nvSpPr>
+        <p:spPr>
+          <a:xfrm>
+            <a:off x="0" y="0"/>
+            <a:ext cx="9144000" cy="6858000"/>
+          </a:xfrm>
+        </p:spPr>
+        <p:txBody>
+          <a:bodyPr/>
+          <a:lstStyle/>
+          <a:p>
+            <a:endParaRPr lang="pt-PT"/>
+          </a:p>
+        </p:txBody>
+      </p:sp>
+    </p:spTree>
+    <p:extLst>
+      <p:ext uri="{BB962C8B-B14F-4D97-AF65-F5344CB8AC3E}">
+        <p14:creationId xmlns:p14="http://schemas.microsoft.com/office/powerpoint/2010/main" val="3538666441"/>
+      </p:ext>
+    </p:extLst>
+  </p:cSld>
+  <p:clrMapOvr>
+    <a:masterClrMapping/>
+  </p:clrMapOvr>
+</p:sldLayout>
+</file>
+
+<file path=ppt/slideLayouts/slideLayout16.xml><?xml version="1.0" encoding="utf-8"?>
+<p:sldLayout xmlns:a="http://schemas.openxmlformats.org/drawingml/2006/main" xmlns:r="http://schemas.openxmlformats.org/officeDocument/2006/relationships" xmlns:p="http://schemas.openxmlformats.org/presentationml/2006/main" preserve="1" userDrawn="1">
+  <p:cSld name="Transição - Texto + Imagem">
+    <p:spTree>
+      <p:nvGrpSpPr>
+        <p:cNvPr id="1" name=""/>
+        <p:cNvGrpSpPr/>
+        <p:nvPr/>
+      </p:nvGrpSpPr>
+      <p:grpSpPr>
+        <a:xfrm>
+          <a:off x="0" y="0"/>
+          <a:ext cx="0" cy="0"/>
+          <a:chOff x="0" y="0"/>
+          <a:chExt cx="0" cy="0"/>
+        </a:xfrm>
+      </p:grpSpPr>
+      <p:sp>
+        <p:nvSpPr>
+          <p:cNvPr id="3" name="Letra">
+            <a:extLst>
+              <a:ext uri="{FF2B5EF4-FFF2-40B4-BE49-F238E27FC236}">
+                <a16:creationId xmlns:a16="http://schemas.microsoft.com/office/drawing/2014/main" id="{7FBA5054-2BE0-6B52-7485-0B10968F39E5}"/>
+              </a:ext>
+            </a:extLst>
+          </p:cNvPr>
+          <p:cNvSpPr>
+            <a:spLocks noGrp="1"/>
+          </p:cNvSpPr>
+          <p:nvPr>
+            <p:ph idx="1" hasCustomPrompt="1"/>
+          </p:nvPr>
+        </p:nvSpPr>
+        <p:spPr>
+          <a:xfrm>
+            <a:off x="549995" y="5420412"/>
+            <a:ext cx="8044010" cy="1216058"/>
+          </a:xfrm>
+        </p:spPr>
+        <p:txBody>
+          <a:bodyPr anchor="ctr" anchorCtr="0">
+            <a:noAutofit/>
+          </a:bodyPr>
+          <a:lstStyle>
+            <a:lvl1pPr marL="0" marR="0" indent="0" algn="ctr" defTabSz="685800" rtl="0" eaLnBrk="1" fontAlgn="auto" latinLnBrk="0" hangingPunct="1">
+              <a:lnSpc>
+                <a:spcPct val="130000"/>
+              </a:lnSpc>
+              <a:spcBef>
+                <a:spcPts val="0"/>
+              </a:spcBef>
+              <a:spcAft>
+                <a:spcPts val="0"/>
+              </a:spcAft>
+              <a:buClrTx/>
+              <a:buSzTx/>
+              <a:buFont typeface="Arial" panose="020B0604020202020204" pitchFamily="34" charset="0"/>
+              <a:buNone/>
+              <a:tabLst/>
+              <a:defRPr sz="4400">
+                <a:latin typeface="Livvic Thin" pitchFamily="2" charset="0"/>
+              </a:defRPr>
+            </a:lvl1pPr>
+            <a:lvl2pPr algn="ctr">
+              <a:defRPr/>
+            </a:lvl2pPr>
+            <a:lvl3pPr algn="ctr">
+              <a:defRPr/>
+            </a:lvl3pPr>
+            <a:lvl4pPr algn="ctr">
+              <a:defRPr/>
+            </a:lvl4pPr>
+            <a:lvl5pPr algn="ctr">
+              <a:defRPr/>
+            </a:lvl5pPr>
+          </a:lstStyle>
+          <a:p>
+            <a:pPr lvl="0"/>
+            <a:r>
+              <a:rPr lang="en-US" dirty="0" err="1"/>
+              <a:t>Texto</a:t>
+            </a:r>
+            <a:r>
+              <a:rPr lang="en-US" dirty="0"/>
+              <a:t> a </a:t>
+            </a:r>
+            <a:r>
+              <a:rPr lang="en-US" dirty="0" err="1"/>
+              <a:t>apresentar</a:t>
+            </a:r>
+            <a:r>
+              <a:rPr lang="en-US" dirty="0"/>
+              <a:t> entre slides</a:t>
+            </a:r>
+          </a:p>
+        </p:txBody>
+      </p:sp>
+      <p:sp>
+        <p:nvSpPr>
+          <p:cNvPr id="4" name="Picture Placeholder 3">
+            <a:extLst>
+              <a:ext uri="{FF2B5EF4-FFF2-40B4-BE49-F238E27FC236}">
+                <a16:creationId xmlns:a16="http://schemas.microsoft.com/office/drawing/2014/main" id="{6821E55E-7402-9488-751D-96561C1FA26B}"/>
+              </a:ext>
+            </a:extLst>
+          </p:cNvPr>
+          <p:cNvSpPr>
+            <a:spLocks noGrp="1"/>
+          </p:cNvSpPr>
+          <p:nvPr>
+            <p:ph type="pic" sz="quarter" idx="10"/>
+          </p:nvPr>
+        </p:nvSpPr>
+        <p:spPr>
+          <a:xfrm>
+            <a:off x="544365" y="395288"/>
+            <a:ext cx="8044010" cy="4648052"/>
+          </a:xfrm>
+        </p:spPr>
+        <p:txBody>
+          <a:bodyPr/>
+          <a:lstStyle/>
+          <a:p>
+            <a:endParaRPr lang="pt-PT"/>
+          </a:p>
+        </p:txBody>
+      </p:sp>
+    </p:spTree>
+    <p:extLst>
+      <p:ext uri="{BB962C8B-B14F-4D97-AF65-F5344CB8AC3E}">
+        <p14:creationId xmlns:p14="http://schemas.microsoft.com/office/powerpoint/2010/main" val="3932383275"/>
+      </p:ext>
+    </p:extLst>
+  </p:cSld>
+  <p:clrMapOvr>
+    <a:masterClrMapping/>
+  </p:clrMapOvr>
+</p:sldLayout>
+</file>
+
+<file path=ppt/slideLayouts/slideLayout17.xml><?xml version="1.0" encoding="utf-8"?>
+<p:sldLayout xmlns:a="http://schemas.openxmlformats.org/drawingml/2006/main" xmlns:r="http://schemas.openxmlformats.org/officeDocument/2006/relationships" xmlns:p="http://schemas.openxmlformats.org/presentationml/2006/main" preserve="1" userDrawn="1">
+  <p:cSld name="Glória - 1">
+    <p:spTree>
+      <p:nvGrpSpPr>
+        <p:cNvPr id="1" name=""/>
+        <p:cNvGrpSpPr/>
+        <p:nvPr/>
+      </p:nvGrpSpPr>
+      <p:grpSpPr>
+        <a:xfrm>
+          <a:off x="0" y="0"/>
+          <a:ext cx="0" cy="0"/>
+          <a:chOff x="0" y="0"/>
+          <a:chExt cx="0" cy="0"/>
+        </a:xfrm>
+      </p:grpSpPr>
+      <p:sp>
+        <p:nvSpPr>
+          <p:cNvPr id="5" name="TextBox 4">
+            <a:extLst>
+              <a:ext uri="{FF2B5EF4-FFF2-40B4-BE49-F238E27FC236}">
+                <a16:creationId xmlns:a16="http://schemas.microsoft.com/office/drawing/2014/main" id="{F461CFFF-A66C-B4EF-69DF-1DD65AABD72A}"/>
+              </a:ext>
+            </a:extLst>
+          </p:cNvPr>
+          <p:cNvSpPr txBox="1"/>
+          <p:nvPr userDrawn="1"/>
+        </p:nvSpPr>
+        <p:spPr>
+          <a:xfrm>
+            <a:off x="0" y="302632"/>
+            <a:ext cx="9144000" cy="6252737"/>
+          </a:xfrm>
+          <a:prstGeom prst="rect">
+            <a:avLst/>
+          </a:prstGeom>
+          <a:noFill/>
+        </p:spPr>
+        <p:txBody>
+          <a:bodyPr wrap="square" rtlCol="0">
+            <a:spAutoFit/>
+          </a:bodyPr>
+          <a:lstStyle/>
+          <a:p>
+            <a:pPr lvl="0" algn="ctr">
+              <a:lnSpc>
+                <a:spcPct val="130000"/>
+              </a:lnSpc>
+              <a:spcAft>
+                <a:spcPts val="1800"/>
+              </a:spcAft>
+            </a:pPr>
+            <a:r>
+              <a:rPr lang="pt-PT" sz="3600" dirty="0">
+                <a:latin typeface="IBM Plex Sans SemiBold" panose="020B0703050203000203" pitchFamily="34" charset="0"/>
+              </a:rPr>
+              <a:t>Glória a Deus nas alturas e paz na terra aos homens por Ele amados.</a:t>
+            </a:r>
+          </a:p>
+          <a:p>
+            <a:pPr lvl="0" algn="ctr">
+              <a:lnSpc>
+                <a:spcPct val="130000"/>
+              </a:lnSpc>
+            </a:pPr>
+            <a:r>
+              <a:rPr lang="pt-PT" sz="3600" dirty="0"/>
+              <a:t>Senhor Deus, Rei dos céus, </a:t>
+            </a:r>
+          </a:p>
+          <a:p>
+            <a:pPr lvl="0" algn="ctr">
+              <a:lnSpc>
+                <a:spcPct val="130000"/>
+              </a:lnSpc>
+              <a:spcAft>
+                <a:spcPts val="1800"/>
+              </a:spcAft>
+            </a:pPr>
+            <a:r>
+              <a:rPr lang="pt-PT" sz="3600" dirty="0"/>
+              <a:t>Deus Pai todo-poderoso:</a:t>
+            </a:r>
+          </a:p>
+          <a:p>
+            <a:pPr lvl="0" algn="ctr">
+              <a:lnSpc>
+                <a:spcPct val="130000"/>
+              </a:lnSpc>
+            </a:pPr>
+            <a:r>
+              <a:rPr lang="pt-PT" sz="3600" dirty="0"/>
+              <a:t>nós Vos louvamos, nós Vos bendizemos, </a:t>
+            </a:r>
+          </a:p>
+          <a:p>
+            <a:pPr lvl="0" algn="ctr">
+              <a:lnSpc>
+                <a:spcPct val="130000"/>
+              </a:lnSpc>
+            </a:pPr>
+            <a:r>
+              <a:rPr lang="pt-PT" sz="3600" dirty="0"/>
+              <a:t>nós vos adoramos, nós Vos glorificamos, </a:t>
+            </a:r>
+          </a:p>
+          <a:p>
+            <a:pPr lvl="0" algn="ctr">
+              <a:lnSpc>
+                <a:spcPct val="130000"/>
+              </a:lnSpc>
+            </a:pPr>
+            <a:r>
+              <a:rPr lang="pt-PT" sz="3600" dirty="0"/>
+              <a:t>nós Vos damos graças, </a:t>
+            </a:r>
+          </a:p>
+          <a:p>
+            <a:pPr lvl="0" algn="ctr">
+              <a:lnSpc>
+                <a:spcPct val="130000"/>
+              </a:lnSpc>
+            </a:pPr>
+            <a:r>
+              <a:rPr lang="pt-PT" sz="3600" dirty="0"/>
+              <a:t>por vossa imensa glória.</a:t>
+            </a:r>
+          </a:p>
+        </p:txBody>
+      </p:sp>
+    </p:spTree>
+    <p:extLst>
+      <p:ext uri="{BB962C8B-B14F-4D97-AF65-F5344CB8AC3E}">
+        <p14:creationId xmlns:p14="http://schemas.microsoft.com/office/powerpoint/2010/main" val="1611675012"/>
+      </p:ext>
+    </p:extLst>
+  </p:cSld>
+  <p:clrMapOvr>
+    <a:masterClrMapping/>
+  </p:clrMapOvr>
+</p:sldLayout>
+</file>
+
+<file path=ppt/slideLayouts/slideLayout18.xml><?xml version="1.0" encoding="utf-8"?>
+<p:sldLayout xmlns:a="http://schemas.openxmlformats.org/drawingml/2006/main" xmlns:r="http://schemas.openxmlformats.org/officeDocument/2006/relationships" xmlns:p="http://schemas.openxmlformats.org/presentationml/2006/main" preserve="1" userDrawn="1">
+  <p:cSld name="Glória - 2">
+    <p:spTree>
+      <p:nvGrpSpPr>
+        <p:cNvPr id="1" name=""/>
+        <p:cNvGrpSpPr/>
+        <p:nvPr/>
+      </p:nvGrpSpPr>
+      <p:grpSpPr>
+        <a:xfrm>
+          <a:off x="0" y="0"/>
+          <a:ext cx="0" cy="0"/>
+          <a:chOff x="0" y="0"/>
+          <a:chExt cx="0" cy="0"/>
+        </a:xfrm>
+      </p:grpSpPr>
+      <p:sp>
+        <p:nvSpPr>
+          <p:cNvPr id="5" name="TextBox 4">
+            <a:extLst>
+              <a:ext uri="{FF2B5EF4-FFF2-40B4-BE49-F238E27FC236}">
+                <a16:creationId xmlns:a16="http://schemas.microsoft.com/office/drawing/2014/main" id="{F461CFFF-A66C-B4EF-69DF-1DD65AABD72A}"/>
+              </a:ext>
+            </a:extLst>
+          </p:cNvPr>
+          <p:cNvSpPr txBox="1"/>
+          <p:nvPr userDrawn="1"/>
+        </p:nvSpPr>
+        <p:spPr>
+          <a:xfrm>
+            <a:off x="791852" y="57949"/>
+            <a:ext cx="7701699" cy="6742102"/>
+          </a:xfrm>
+          <a:prstGeom prst="rect">
+            <a:avLst/>
+          </a:prstGeom>
+          <a:noFill/>
+        </p:spPr>
+        <p:txBody>
+          <a:bodyPr wrap="square" rtlCol="0">
+            <a:spAutoFit/>
+          </a:bodyPr>
+          <a:lstStyle/>
+          <a:p>
+            <a:pPr lvl="0" algn="ctr">
+              <a:lnSpc>
+                <a:spcPct val="130000"/>
+              </a:lnSpc>
+            </a:pPr>
+            <a:r>
+              <a:rPr lang="pt-PT" sz="3600" dirty="0"/>
+              <a:t>Senhor Jesus Cristo, Filho Unigénito, </a:t>
+            </a:r>
+          </a:p>
+          <a:p>
+            <a:pPr lvl="0" algn="ctr">
+              <a:lnSpc>
+                <a:spcPct val="130000"/>
+              </a:lnSpc>
+            </a:pPr>
+            <a:r>
+              <a:rPr lang="pt-PT" sz="3600" dirty="0"/>
+              <a:t>Senhor Deus, Cordeiro de Deus, </a:t>
+            </a:r>
+          </a:p>
+          <a:p>
+            <a:pPr lvl="0" algn="ctr">
+              <a:lnSpc>
+                <a:spcPct val="130000"/>
+              </a:lnSpc>
+              <a:spcAft>
+                <a:spcPts val="1800"/>
+              </a:spcAft>
+            </a:pPr>
+            <a:r>
+              <a:rPr lang="pt-PT" sz="3600" dirty="0"/>
+              <a:t>Filho de Deus Pai:</a:t>
+            </a:r>
+          </a:p>
+          <a:p>
+            <a:pPr lvl="0" algn="ctr">
+              <a:lnSpc>
+                <a:spcPct val="130000"/>
+              </a:lnSpc>
+            </a:pPr>
+            <a:r>
+              <a:rPr lang="pt-PT" sz="3600" dirty="0"/>
+              <a:t>Vós que tirais o pecado do mundo, tende piedade de nós;</a:t>
+            </a:r>
+          </a:p>
+          <a:p>
+            <a:pPr lvl="0" algn="ctr">
+              <a:lnSpc>
+                <a:spcPct val="130000"/>
+              </a:lnSpc>
+            </a:pPr>
+            <a:r>
+              <a:rPr lang="pt-PT" sz="3600" dirty="0"/>
+              <a:t>Vós que tirais o pecado do mundo, acolhei a nossa súplica;</a:t>
+            </a:r>
+          </a:p>
+          <a:p>
+            <a:pPr lvl="0" algn="ctr">
+              <a:lnSpc>
+                <a:spcPct val="130000"/>
+              </a:lnSpc>
+            </a:pPr>
+            <a:r>
+              <a:rPr lang="pt-PT" sz="3600" dirty="0"/>
+              <a:t>Vós que estais à direita do Pai, tende piedade de nós.</a:t>
+            </a:r>
+          </a:p>
+        </p:txBody>
+      </p:sp>
+    </p:spTree>
+    <p:extLst>
+      <p:ext uri="{BB962C8B-B14F-4D97-AF65-F5344CB8AC3E}">
+        <p14:creationId xmlns:p14="http://schemas.microsoft.com/office/powerpoint/2010/main" val="3535935584"/>
+      </p:ext>
+    </p:extLst>
+  </p:cSld>
+  <p:clrMapOvr>
+    <a:masterClrMapping/>
+  </p:clrMapOvr>
+</p:sldLayout>
+</file>
+
+<file path=ppt/slideLayouts/slideLayout19.xml><?xml version="1.0" encoding="utf-8"?>
+<p:sldLayout xmlns:a="http://schemas.openxmlformats.org/drawingml/2006/main" xmlns:r="http://schemas.openxmlformats.org/officeDocument/2006/relationships" xmlns:p="http://schemas.openxmlformats.org/presentationml/2006/main" preserve="1" userDrawn="1">
+  <p:cSld name="Glória - 3">
+    <p:spTree>
+      <p:nvGrpSpPr>
+        <p:cNvPr id="1" name=""/>
+        <p:cNvGrpSpPr/>
+        <p:nvPr/>
+      </p:nvGrpSpPr>
+      <p:grpSpPr>
+        <a:xfrm>
+          <a:off x="0" y="0"/>
+          <a:ext cx="0" cy="0"/>
+          <a:chOff x="0" y="0"/>
+          <a:chExt cx="0" cy="0"/>
+        </a:xfrm>
+      </p:grpSpPr>
+      <p:sp>
+        <p:nvSpPr>
+          <p:cNvPr id="5" name="TextBox 4">
+            <a:extLst>
+              <a:ext uri="{FF2B5EF4-FFF2-40B4-BE49-F238E27FC236}">
+                <a16:creationId xmlns:a16="http://schemas.microsoft.com/office/drawing/2014/main" id="{F461CFFF-A66C-B4EF-69DF-1DD65AABD72A}"/>
+              </a:ext>
+            </a:extLst>
+          </p:cNvPr>
+          <p:cNvSpPr txBox="1"/>
+          <p:nvPr userDrawn="1"/>
+        </p:nvSpPr>
+        <p:spPr>
+          <a:xfrm>
+            <a:off x="0" y="1124812"/>
+            <a:ext cx="9144000" cy="4608377"/>
+          </a:xfrm>
+          <a:prstGeom prst="rect">
+            <a:avLst/>
+          </a:prstGeom>
+          <a:noFill/>
+        </p:spPr>
+        <p:txBody>
+          <a:bodyPr wrap="square" rtlCol="0">
+            <a:spAutoFit/>
+          </a:bodyPr>
+          <a:lstStyle/>
+          <a:p>
+            <a:pPr lvl="0" algn="ctr">
+              <a:lnSpc>
+                <a:spcPct val="150000"/>
+              </a:lnSpc>
+            </a:pPr>
+            <a:r>
+              <a:rPr lang="pt-PT" sz="4000" dirty="0"/>
+              <a:t>Só Vós sois o Santo;</a:t>
+            </a:r>
+          </a:p>
+          <a:p>
+            <a:pPr lvl="0" algn="ctr">
+              <a:lnSpc>
+                <a:spcPct val="150000"/>
+              </a:lnSpc>
+            </a:pPr>
+            <a:r>
+              <a:rPr lang="pt-PT" sz="4000" dirty="0"/>
+              <a:t>só Vós, o Senhor;</a:t>
+            </a:r>
+          </a:p>
+          <a:p>
+            <a:pPr lvl="0" algn="ctr">
+              <a:lnSpc>
+                <a:spcPct val="150000"/>
+              </a:lnSpc>
+            </a:pPr>
+            <a:r>
+              <a:rPr lang="pt-PT" sz="4000" dirty="0"/>
+              <a:t>só Vós, o Altíssimo, Jesus Cristo.</a:t>
+            </a:r>
+          </a:p>
+          <a:p>
+            <a:pPr lvl="0" algn="ctr">
+              <a:lnSpc>
+                <a:spcPct val="150000"/>
+              </a:lnSpc>
+            </a:pPr>
+            <a:r>
+              <a:rPr lang="pt-PT" sz="4000" dirty="0"/>
+              <a:t>Com o Espírito Santo,</a:t>
+            </a:r>
+          </a:p>
+          <a:p>
+            <a:pPr lvl="0" algn="ctr">
+              <a:lnSpc>
+                <a:spcPct val="150000"/>
+              </a:lnSpc>
+            </a:pPr>
+            <a:r>
+              <a:rPr lang="pt-PT" sz="4000" dirty="0"/>
+              <a:t>na glória de Deus Pai.</a:t>
+            </a:r>
+          </a:p>
+        </p:txBody>
+      </p:sp>
+    </p:spTree>
+    <p:extLst>
+      <p:ext uri="{BB962C8B-B14F-4D97-AF65-F5344CB8AC3E}">
+        <p14:creationId xmlns:p14="http://schemas.microsoft.com/office/powerpoint/2010/main" val="3032261092"/>
+      </p:ext>
+    </p:extLst>
+  </p:cSld>
+  <p:clrMapOvr>
+    <a:masterClrMapping/>
+  </p:clrMapOvr>
+</p:sldLayout>
+</file>
+
 <file path=ppt/slideLayouts/slideLayout2.xml><?xml version="1.0" encoding="utf-8"?>
 <p:sldLayout xmlns:a="http://schemas.openxmlformats.org/drawingml/2006/main" xmlns:r="http://schemas.openxmlformats.org/officeDocument/2006/relationships" xmlns:p="http://schemas.openxmlformats.org/presentationml/2006/main" preserve="1" userDrawn="1">
   <p:cSld name="Capa - Advento">
@@ -1853,6 +2589,1353 @@
     <p:extLst>
       <p:ext uri="{BB962C8B-B14F-4D97-AF65-F5344CB8AC3E}">
         <p14:creationId xmlns:p14="http://schemas.microsoft.com/office/powerpoint/2010/main" val="2636666909"/>
+      </p:ext>
+    </p:extLst>
+  </p:cSld>
+  <p:clrMapOvr>
+    <a:masterClrMapping/>
+  </p:clrMapOvr>
+</p:sldLayout>
+</file>
+
+<file path=ppt/slideLayouts/slideLayout20.xml><?xml version="1.0" encoding="utf-8"?>
+<p:sldLayout xmlns:a="http://schemas.openxmlformats.org/drawingml/2006/main" xmlns:r="http://schemas.openxmlformats.org/officeDocument/2006/relationships" xmlns:p="http://schemas.openxmlformats.org/presentationml/2006/main" preserve="1" userDrawn="1">
+  <p:cSld name="Credo - Longo - 1">
+    <p:spTree>
+      <p:nvGrpSpPr>
+        <p:cNvPr id="1" name=""/>
+        <p:cNvGrpSpPr/>
+        <p:nvPr/>
+      </p:nvGrpSpPr>
+      <p:grpSpPr>
+        <a:xfrm>
+          <a:off x="0" y="0"/>
+          <a:ext cx="0" cy="0"/>
+          <a:chOff x="0" y="0"/>
+          <a:chExt cx="0" cy="0"/>
+        </a:xfrm>
+      </p:grpSpPr>
+      <p:sp>
+        <p:nvSpPr>
+          <p:cNvPr id="5" name="TextBox 4">
+            <a:extLst>
+              <a:ext uri="{FF2B5EF4-FFF2-40B4-BE49-F238E27FC236}">
+                <a16:creationId xmlns:a16="http://schemas.microsoft.com/office/drawing/2014/main" id="{F461CFFF-A66C-B4EF-69DF-1DD65AABD72A}"/>
+              </a:ext>
+            </a:extLst>
+          </p:cNvPr>
+          <p:cNvSpPr txBox="1"/>
+          <p:nvPr userDrawn="1"/>
+        </p:nvSpPr>
+        <p:spPr>
+          <a:xfrm>
+            <a:off x="0" y="1660760"/>
+            <a:ext cx="9144000" cy="3536481"/>
+          </a:xfrm>
+          <a:prstGeom prst="rect">
+            <a:avLst/>
+          </a:prstGeom>
+          <a:noFill/>
+        </p:spPr>
+        <p:txBody>
+          <a:bodyPr wrap="square" rtlCol="0">
+            <a:spAutoFit/>
+          </a:bodyPr>
+          <a:lstStyle/>
+          <a:p>
+            <a:pPr lvl="0" algn="ctr">
+              <a:lnSpc>
+                <a:spcPct val="130000"/>
+              </a:lnSpc>
+            </a:pPr>
+            <a:r>
+              <a:rPr lang="pt-PT" sz="4400" u="sng" dirty="0">
+                <a:latin typeface="IBM Plex Sans SemiBold" panose="020B0703050203000203" pitchFamily="34" charset="0"/>
+              </a:rPr>
+              <a:t>Creio em um só Deus,</a:t>
+            </a:r>
+            <a:r>
+              <a:rPr lang="pt-PT" sz="4400" dirty="0">
+                <a:latin typeface="IBM Plex Sans SemiBold" panose="020B0703050203000203" pitchFamily="34" charset="0"/>
+              </a:rPr>
+              <a:t> </a:t>
+            </a:r>
+          </a:p>
+          <a:p>
+            <a:pPr lvl="0" algn="ctr">
+              <a:lnSpc>
+                <a:spcPct val="130000"/>
+              </a:lnSpc>
+            </a:pPr>
+            <a:r>
+              <a:rPr lang="pt-PT" sz="4400" dirty="0"/>
+              <a:t>Pai todo-poderoso, Criador do céu e da terra, de todas as coisas visíveis e invisíveis. </a:t>
+            </a:r>
+          </a:p>
+        </p:txBody>
+      </p:sp>
+    </p:spTree>
+    <p:extLst>
+      <p:ext uri="{BB962C8B-B14F-4D97-AF65-F5344CB8AC3E}">
+        <p14:creationId xmlns:p14="http://schemas.microsoft.com/office/powerpoint/2010/main" val="1614050351"/>
+      </p:ext>
+    </p:extLst>
+  </p:cSld>
+  <p:clrMapOvr>
+    <a:masterClrMapping/>
+  </p:clrMapOvr>
+</p:sldLayout>
+</file>
+
+<file path=ppt/slideLayouts/slideLayout21.xml><?xml version="1.0" encoding="utf-8"?>
+<p:sldLayout xmlns:a="http://schemas.openxmlformats.org/drawingml/2006/main" xmlns:r="http://schemas.openxmlformats.org/officeDocument/2006/relationships" xmlns:p="http://schemas.openxmlformats.org/presentationml/2006/main" preserve="1" userDrawn="1">
+  <p:cSld name="Credo - Longo - 2">
+    <p:spTree>
+      <p:nvGrpSpPr>
+        <p:cNvPr id="1" name=""/>
+        <p:cNvGrpSpPr/>
+        <p:nvPr/>
+      </p:nvGrpSpPr>
+      <p:grpSpPr>
+        <a:xfrm>
+          <a:off x="0" y="0"/>
+          <a:ext cx="0" cy="0"/>
+          <a:chOff x="0" y="0"/>
+          <a:chExt cx="0" cy="0"/>
+        </a:xfrm>
+      </p:grpSpPr>
+      <p:sp>
+        <p:nvSpPr>
+          <p:cNvPr id="5" name="TextBox 4">
+            <a:extLst>
+              <a:ext uri="{FF2B5EF4-FFF2-40B4-BE49-F238E27FC236}">
+                <a16:creationId xmlns:a16="http://schemas.microsoft.com/office/drawing/2014/main" id="{F461CFFF-A66C-B4EF-69DF-1DD65AABD72A}"/>
+              </a:ext>
+            </a:extLst>
+          </p:cNvPr>
+          <p:cNvSpPr txBox="1"/>
+          <p:nvPr userDrawn="1"/>
+        </p:nvSpPr>
+        <p:spPr>
+          <a:xfrm>
+            <a:off x="0" y="893563"/>
+            <a:ext cx="9144000" cy="5070875"/>
+          </a:xfrm>
+          <a:prstGeom prst="rect">
+            <a:avLst/>
+          </a:prstGeom>
+          <a:noFill/>
+        </p:spPr>
+        <p:txBody>
+          <a:bodyPr wrap="square" rtlCol="0">
+            <a:spAutoFit/>
+          </a:bodyPr>
+          <a:lstStyle/>
+          <a:p>
+            <a:pPr lvl="0" algn="ctr">
+              <a:lnSpc>
+                <a:spcPct val="130000"/>
+              </a:lnSpc>
+            </a:pPr>
+            <a:r>
+              <a:rPr lang="pt-PT" sz="3600" u="sng" dirty="0">
+                <a:latin typeface="IBM Plex Sans SemiBold" panose="020B0703050203000203" pitchFamily="34" charset="0"/>
+              </a:rPr>
+              <a:t>Creio em um só Senhor, Jesus Cristo, </a:t>
+            </a:r>
+            <a:r>
+              <a:rPr lang="pt-PT" sz="3600" dirty="0">
+                <a:latin typeface="+mn-lt"/>
+              </a:rPr>
+              <a:t>Filho Unigénito de Deus, </a:t>
+            </a:r>
+          </a:p>
+          <a:p>
+            <a:pPr lvl="0" algn="ctr">
+              <a:lnSpc>
+                <a:spcPct val="130000"/>
+              </a:lnSpc>
+            </a:pPr>
+            <a:r>
+              <a:rPr lang="pt-PT" sz="3600" dirty="0">
+                <a:latin typeface="+mn-lt"/>
+              </a:rPr>
+              <a:t>nascido do Pai antes de todos os séculos: </a:t>
+            </a:r>
+          </a:p>
+          <a:p>
+            <a:pPr lvl="0" algn="ctr">
+              <a:lnSpc>
+                <a:spcPct val="130000"/>
+              </a:lnSpc>
+            </a:pPr>
+            <a:r>
+              <a:rPr lang="pt-PT" sz="3600" dirty="0">
+                <a:latin typeface="+mn-lt"/>
+              </a:rPr>
+              <a:t>Deus de Deus, Luz da Luz,</a:t>
+            </a:r>
+          </a:p>
+          <a:p>
+            <a:pPr lvl="0" algn="ctr">
+              <a:lnSpc>
+                <a:spcPct val="130000"/>
+              </a:lnSpc>
+            </a:pPr>
+            <a:r>
+              <a:rPr lang="pt-PT" sz="3600" dirty="0">
+                <a:latin typeface="+mn-lt"/>
+              </a:rPr>
+              <a:t>Deus verdadeiro de Deus verdadeiro; gerado, não criado, consubstancial ao Pai. Por Ele todas as coisas foram feitas. </a:t>
+            </a:r>
+          </a:p>
+        </p:txBody>
+      </p:sp>
+    </p:spTree>
+    <p:extLst>
+      <p:ext uri="{BB962C8B-B14F-4D97-AF65-F5344CB8AC3E}">
+        <p14:creationId xmlns:p14="http://schemas.microsoft.com/office/powerpoint/2010/main" val="696084085"/>
+      </p:ext>
+    </p:extLst>
+  </p:cSld>
+  <p:clrMapOvr>
+    <a:masterClrMapping/>
+  </p:clrMapOvr>
+</p:sldLayout>
+</file>
+
+<file path=ppt/slideLayouts/slideLayout22.xml><?xml version="1.0" encoding="utf-8"?>
+<p:sldLayout xmlns:a="http://schemas.openxmlformats.org/drawingml/2006/main" xmlns:r="http://schemas.openxmlformats.org/officeDocument/2006/relationships" xmlns:p="http://schemas.openxmlformats.org/presentationml/2006/main" preserve="1" userDrawn="1">
+  <p:cSld name="Credo - Longo - 3">
+    <p:spTree>
+      <p:nvGrpSpPr>
+        <p:cNvPr id="1" name=""/>
+        <p:cNvGrpSpPr/>
+        <p:nvPr/>
+      </p:nvGrpSpPr>
+      <p:grpSpPr>
+        <a:xfrm>
+          <a:off x="0" y="0"/>
+          <a:ext cx="0" cy="0"/>
+          <a:chOff x="0" y="0"/>
+          <a:chExt cx="0" cy="0"/>
+        </a:xfrm>
+      </p:grpSpPr>
+      <p:sp>
+        <p:nvSpPr>
+          <p:cNvPr id="5" name="TextBox 4">
+            <a:extLst>
+              <a:ext uri="{FF2B5EF4-FFF2-40B4-BE49-F238E27FC236}">
+                <a16:creationId xmlns:a16="http://schemas.microsoft.com/office/drawing/2014/main" id="{F461CFFF-A66C-B4EF-69DF-1DD65AABD72A}"/>
+              </a:ext>
+            </a:extLst>
+          </p:cNvPr>
+          <p:cNvSpPr txBox="1"/>
+          <p:nvPr userDrawn="1"/>
+        </p:nvSpPr>
+        <p:spPr>
+          <a:xfrm>
+            <a:off x="0" y="893563"/>
+            <a:ext cx="9144000" cy="5070875"/>
+          </a:xfrm>
+          <a:prstGeom prst="rect">
+            <a:avLst/>
+          </a:prstGeom>
+          <a:noFill/>
+        </p:spPr>
+        <p:txBody>
+          <a:bodyPr wrap="square" rtlCol="0">
+            <a:spAutoFit/>
+          </a:bodyPr>
+          <a:lstStyle/>
+          <a:p>
+            <a:pPr lvl="0" algn="ctr">
+              <a:lnSpc>
+                <a:spcPct val="130000"/>
+              </a:lnSpc>
+            </a:pPr>
+            <a:r>
+              <a:rPr lang="pt-PT" sz="3600" dirty="0">
+                <a:latin typeface="+mn-lt"/>
+              </a:rPr>
+              <a:t>E por nós, homens, e para nossa salvação desceu dos Céus. </a:t>
+            </a:r>
+          </a:p>
+          <a:p>
+            <a:pPr lvl="0" algn="ctr">
+              <a:lnSpc>
+                <a:spcPct val="130000"/>
+              </a:lnSpc>
+            </a:pPr>
+            <a:r>
+              <a:rPr lang="pt-PT" sz="3600" dirty="0">
+                <a:latin typeface="+mn-lt"/>
+              </a:rPr>
+              <a:t>E encarnou pelo Espírito Santo, </a:t>
+            </a:r>
+          </a:p>
+          <a:p>
+            <a:pPr lvl="0" algn="ctr">
+              <a:lnSpc>
+                <a:spcPct val="130000"/>
+              </a:lnSpc>
+            </a:pPr>
+            <a:r>
+              <a:rPr lang="pt-PT" sz="3600" dirty="0">
+                <a:latin typeface="+mn-lt"/>
+              </a:rPr>
+              <a:t>no seio da Virgem Maria, e Se fez Homem. </a:t>
+            </a:r>
+            <a:br>
+              <a:rPr lang="pt-PT" sz="3600" dirty="0">
+                <a:latin typeface="+mn-lt"/>
+              </a:rPr>
+            </a:br>
+            <a:r>
+              <a:rPr lang="pt-PT" sz="3600" dirty="0">
+                <a:latin typeface="+mn-lt"/>
+              </a:rPr>
+              <a:t>Também por nós foi crucificado </a:t>
+            </a:r>
+          </a:p>
+          <a:p>
+            <a:pPr lvl="0" algn="ctr">
+              <a:lnSpc>
+                <a:spcPct val="130000"/>
+              </a:lnSpc>
+            </a:pPr>
+            <a:r>
+              <a:rPr lang="pt-PT" sz="3600" dirty="0">
+                <a:latin typeface="+mn-lt"/>
+              </a:rPr>
+              <a:t>sob Pôncio Pilatos; </a:t>
+            </a:r>
+          </a:p>
+          <a:p>
+            <a:pPr lvl="0" algn="ctr">
+              <a:lnSpc>
+                <a:spcPct val="130000"/>
+              </a:lnSpc>
+            </a:pPr>
+            <a:r>
+              <a:rPr lang="pt-PT" sz="3600" dirty="0">
+                <a:latin typeface="+mn-lt"/>
+              </a:rPr>
+              <a:t>padeceu e foi sepultado. </a:t>
+            </a:r>
+          </a:p>
+        </p:txBody>
+      </p:sp>
+    </p:spTree>
+    <p:extLst>
+      <p:ext uri="{BB962C8B-B14F-4D97-AF65-F5344CB8AC3E}">
+        <p14:creationId xmlns:p14="http://schemas.microsoft.com/office/powerpoint/2010/main" val="4249338520"/>
+      </p:ext>
+    </p:extLst>
+  </p:cSld>
+  <p:clrMapOvr>
+    <a:masterClrMapping/>
+  </p:clrMapOvr>
+</p:sldLayout>
+</file>
+
+<file path=ppt/slideLayouts/slideLayout23.xml><?xml version="1.0" encoding="utf-8"?>
+<p:sldLayout xmlns:a="http://schemas.openxmlformats.org/drawingml/2006/main" xmlns:r="http://schemas.openxmlformats.org/officeDocument/2006/relationships" xmlns:p="http://schemas.openxmlformats.org/presentationml/2006/main" preserve="1" userDrawn="1">
+  <p:cSld name="Credo - Longo - 4">
+    <p:spTree>
+      <p:nvGrpSpPr>
+        <p:cNvPr id="1" name=""/>
+        <p:cNvGrpSpPr/>
+        <p:nvPr/>
+      </p:nvGrpSpPr>
+      <p:grpSpPr>
+        <a:xfrm>
+          <a:off x="0" y="0"/>
+          <a:ext cx="0" cy="0"/>
+          <a:chOff x="0" y="0"/>
+          <a:chExt cx="0" cy="0"/>
+        </a:xfrm>
+      </p:grpSpPr>
+      <p:sp>
+        <p:nvSpPr>
+          <p:cNvPr id="5" name="TextBox 4">
+            <a:extLst>
+              <a:ext uri="{FF2B5EF4-FFF2-40B4-BE49-F238E27FC236}">
+                <a16:creationId xmlns:a16="http://schemas.microsoft.com/office/drawing/2014/main" id="{F461CFFF-A66C-B4EF-69DF-1DD65AABD72A}"/>
+              </a:ext>
+            </a:extLst>
+          </p:cNvPr>
+          <p:cNvSpPr txBox="1"/>
+          <p:nvPr userDrawn="1"/>
+        </p:nvSpPr>
+        <p:spPr>
+          <a:xfrm>
+            <a:off x="0" y="616980"/>
+            <a:ext cx="9144000" cy="5624040"/>
+          </a:xfrm>
+          <a:prstGeom prst="rect">
+            <a:avLst/>
+          </a:prstGeom>
+          <a:noFill/>
+        </p:spPr>
+        <p:txBody>
+          <a:bodyPr wrap="square" rtlCol="0">
+            <a:spAutoFit/>
+          </a:bodyPr>
+          <a:lstStyle/>
+          <a:p>
+            <a:pPr lvl="0" algn="ctr">
+              <a:lnSpc>
+                <a:spcPct val="130000"/>
+              </a:lnSpc>
+            </a:pPr>
+            <a:r>
+              <a:rPr lang="pt-PT" sz="4000" dirty="0">
+                <a:latin typeface="+mn-lt"/>
+              </a:rPr>
+              <a:t>Ressuscitou ao terceiro dia, </a:t>
+            </a:r>
+          </a:p>
+          <a:p>
+            <a:pPr lvl="0" algn="ctr">
+              <a:lnSpc>
+                <a:spcPct val="130000"/>
+              </a:lnSpc>
+            </a:pPr>
+            <a:r>
+              <a:rPr lang="pt-PT" sz="4000" dirty="0">
+                <a:latin typeface="+mn-lt"/>
+              </a:rPr>
+              <a:t>conforme as Escrituras; </a:t>
+            </a:r>
+          </a:p>
+          <a:p>
+            <a:pPr lvl="0" algn="ctr">
+              <a:lnSpc>
+                <a:spcPct val="130000"/>
+              </a:lnSpc>
+            </a:pPr>
+            <a:r>
+              <a:rPr lang="pt-PT" sz="4000" dirty="0">
+                <a:latin typeface="+mn-lt"/>
+              </a:rPr>
+              <a:t>e subiu aos Céus, </a:t>
+            </a:r>
+          </a:p>
+          <a:p>
+            <a:pPr lvl="0" algn="ctr">
+              <a:lnSpc>
+                <a:spcPct val="130000"/>
+              </a:lnSpc>
+            </a:pPr>
+            <a:r>
+              <a:rPr lang="pt-PT" sz="4000" dirty="0">
+                <a:latin typeface="+mn-lt"/>
+              </a:rPr>
+              <a:t>onde está sentado à direita do Pai. </a:t>
+            </a:r>
+          </a:p>
+          <a:p>
+            <a:pPr lvl="0" algn="ctr">
+              <a:lnSpc>
+                <a:spcPct val="130000"/>
+              </a:lnSpc>
+            </a:pPr>
+            <a:r>
+              <a:rPr lang="pt-PT" sz="4000" dirty="0">
+                <a:latin typeface="+mn-lt"/>
+              </a:rPr>
+              <a:t>De novo há de vir em sua glória, </a:t>
+            </a:r>
+          </a:p>
+          <a:p>
+            <a:pPr lvl="0" algn="ctr">
+              <a:lnSpc>
+                <a:spcPct val="130000"/>
+              </a:lnSpc>
+            </a:pPr>
+            <a:r>
+              <a:rPr lang="pt-PT" sz="4000" dirty="0">
+                <a:latin typeface="+mn-lt"/>
+              </a:rPr>
+              <a:t>para julgar os vivos e os mortos; </a:t>
+            </a:r>
+          </a:p>
+          <a:p>
+            <a:pPr lvl="0" algn="ctr">
+              <a:lnSpc>
+                <a:spcPct val="130000"/>
+              </a:lnSpc>
+            </a:pPr>
+            <a:r>
+              <a:rPr lang="pt-PT" sz="4000" dirty="0">
+                <a:latin typeface="+mn-lt"/>
+              </a:rPr>
+              <a:t>e o Seu reino não terá fim. </a:t>
+            </a:r>
+          </a:p>
+        </p:txBody>
+      </p:sp>
+    </p:spTree>
+    <p:extLst>
+      <p:ext uri="{BB962C8B-B14F-4D97-AF65-F5344CB8AC3E}">
+        <p14:creationId xmlns:p14="http://schemas.microsoft.com/office/powerpoint/2010/main" val="2297356412"/>
+      </p:ext>
+    </p:extLst>
+  </p:cSld>
+  <p:clrMapOvr>
+    <a:masterClrMapping/>
+  </p:clrMapOvr>
+</p:sldLayout>
+</file>
+
+<file path=ppt/slideLayouts/slideLayout24.xml><?xml version="1.0" encoding="utf-8"?>
+<p:sldLayout xmlns:a="http://schemas.openxmlformats.org/drawingml/2006/main" xmlns:r="http://schemas.openxmlformats.org/officeDocument/2006/relationships" xmlns:p="http://schemas.openxmlformats.org/presentationml/2006/main" preserve="1" userDrawn="1">
+  <p:cSld name="Credo - Longo - 5">
+    <p:spTree>
+      <p:nvGrpSpPr>
+        <p:cNvPr id="1" name=""/>
+        <p:cNvGrpSpPr/>
+        <p:nvPr/>
+      </p:nvGrpSpPr>
+      <p:grpSpPr>
+        <a:xfrm>
+          <a:off x="0" y="0"/>
+          <a:ext cx="0" cy="0"/>
+          <a:chOff x="0" y="0"/>
+          <a:chExt cx="0" cy="0"/>
+        </a:xfrm>
+      </p:grpSpPr>
+      <p:sp>
+        <p:nvSpPr>
+          <p:cNvPr id="5" name="TextBox 4">
+            <a:extLst>
+              <a:ext uri="{FF2B5EF4-FFF2-40B4-BE49-F238E27FC236}">
+                <a16:creationId xmlns:a16="http://schemas.microsoft.com/office/drawing/2014/main" id="{F461CFFF-A66C-B4EF-69DF-1DD65AABD72A}"/>
+              </a:ext>
+            </a:extLst>
+          </p:cNvPr>
+          <p:cNvSpPr txBox="1"/>
+          <p:nvPr userDrawn="1"/>
+        </p:nvSpPr>
+        <p:spPr>
+          <a:xfrm>
+            <a:off x="0" y="780519"/>
+            <a:ext cx="9144000" cy="5296963"/>
+          </a:xfrm>
+          <a:prstGeom prst="rect">
+            <a:avLst/>
+          </a:prstGeom>
+          <a:noFill/>
+        </p:spPr>
+        <p:txBody>
+          <a:bodyPr wrap="square" rtlCol="0">
+            <a:spAutoFit/>
+          </a:bodyPr>
+          <a:lstStyle/>
+          <a:p>
+            <a:pPr lvl="0" algn="ctr">
+              <a:lnSpc>
+                <a:spcPct val="130000"/>
+              </a:lnSpc>
+            </a:pPr>
+            <a:r>
+              <a:rPr lang="pt-PT" sz="4400" u="sng" dirty="0">
+                <a:latin typeface="IBM Plex Sans SemiBold" panose="020B0703050203000203" pitchFamily="34" charset="0"/>
+              </a:rPr>
+              <a:t>Creio no Espírito Santo, </a:t>
+            </a:r>
+          </a:p>
+          <a:p>
+            <a:pPr lvl="0" algn="ctr">
+              <a:lnSpc>
+                <a:spcPct val="130000"/>
+              </a:lnSpc>
+            </a:pPr>
+            <a:r>
+              <a:rPr lang="pt-PT" sz="4400" dirty="0">
+                <a:latin typeface="+mn-lt"/>
+              </a:rPr>
+              <a:t>Senhor que dá Vida, </a:t>
+            </a:r>
+          </a:p>
+          <a:p>
+            <a:pPr lvl="0" algn="ctr">
+              <a:lnSpc>
+                <a:spcPct val="130000"/>
+              </a:lnSpc>
+            </a:pPr>
+            <a:r>
+              <a:rPr lang="pt-PT" sz="4400" dirty="0">
+                <a:latin typeface="+mn-lt"/>
+              </a:rPr>
+              <a:t>e que procede do Pai e do Filho; </a:t>
+            </a:r>
+          </a:p>
+          <a:p>
+            <a:pPr lvl="0" algn="ctr">
+              <a:lnSpc>
+                <a:spcPct val="130000"/>
+              </a:lnSpc>
+            </a:pPr>
+            <a:r>
+              <a:rPr lang="pt-PT" sz="4400" dirty="0">
+                <a:latin typeface="+mn-lt"/>
+              </a:rPr>
+              <a:t>e com o Pai e o Filho é adorado e glorificado: </a:t>
+            </a:r>
+          </a:p>
+          <a:p>
+            <a:pPr lvl="0" algn="ctr">
+              <a:lnSpc>
+                <a:spcPct val="130000"/>
+              </a:lnSpc>
+            </a:pPr>
+            <a:r>
+              <a:rPr lang="pt-PT" sz="4400" dirty="0">
+                <a:latin typeface="+mn-lt"/>
+              </a:rPr>
+              <a:t>Ele que falou pelos Profetas.</a:t>
+            </a:r>
+          </a:p>
+        </p:txBody>
+      </p:sp>
+    </p:spTree>
+    <p:extLst>
+      <p:ext uri="{BB962C8B-B14F-4D97-AF65-F5344CB8AC3E}">
+        <p14:creationId xmlns:p14="http://schemas.microsoft.com/office/powerpoint/2010/main" val="2797722090"/>
+      </p:ext>
+    </p:extLst>
+  </p:cSld>
+  <p:clrMapOvr>
+    <a:masterClrMapping/>
+  </p:clrMapOvr>
+</p:sldLayout>
+</file>
+
+<file path=ppt/slideLayouts/slideLayout25.xml><?xml version="1.0" encoding="utf-8"?>
+<p:sldLayout xmlns:a="http://schemas.openxmlformats.org/drawingml/2006/main" xmlns:r="http://schemas.openxmlformats.org/officeDocument/2006/relationships" xmlns:p="http://schemas.openxmlformats.org/presentationml/2006/main" preserve="1" userDrawn="1">
+  <p:cSld name="Credo - Longo - 6">
+    <p:spTree>
+      <p:nvGrpSpPr>
+        <p:cNvPr id="1" name=""/>
+        <p:cNvGrpSpPr/>
+        <p:nvPr/>
+      </p:nvGrpSpPr>
+      <p:grpSpPr>
+        <a:xfrm>
+          <a:off x="0" y="0"/>
+          <a:ext cx="0" cy="0"/>
+          <a:chOff x="0" y="0"/>
+          <a:chExt cx="0" cy="0"/>
+        </a:xfrm>
+      </p:grpSpPr>
+      <p:sp>
+        <p:nvSpPr>
+          <p:cNvPr id="5" name="TextBox 4">
+            <a:extLst>
+              <a:ext uri="{FF2B5EF4-FFF2-40B4-BE49-F238E27FC236}">
+                <a16:creationId xmlns:a16="http://schemas.microsoft.com/office/drawing/2014/main" id="{F461CFFF-A66C-B4EF-69DF-1DD65AABD72A}"/>
+              </a:ext>
+            </a:extLst>
+          </p:cNvPr>
+          <p:cNvSpPr txBox="1"/>
+          <p:nvPr userDrawn="1"/>
+        </p:nvSpPr>
+        <p:spPr>
+          <a:xfrm>
+            <a:off x="0" y="616980"/>
+            <a:ext cx="9144000" cy="5624040"/>
+          </a:xfrm>
+          <a:prstGeom prst="rect">
+            <a:avLst/>
+          </a:prstGeom>
+          <a:noFill/>
+        </p:spPr>
+        <p:txBody>
+          <a:bodyPr wrap="square" rtlCol="0">
+            <a:spAutoFit/>
+          </a:bodyPr>
+          <a:lstStyle/>
+          <a:p>
+            <a:pPr lvl="0" algn="ctr">
+              <a:lnSpc>
+                <a:spcPct val="130000"/>
+              </a:lnSpc>
+            </a:pPr>
+            <a:r>
+              <a:rPr lang="pt-PT" sz="4000" u="sng" dirty="0">
+                <a:latin typeface="IBM Plex Sans SemiBold" panose="020B0703050203000203" pitchFamily="34" charset="0"/>
+              </a:rPr>
+              <a:t>Creio na Igreja </a:t>
+            </a:r>
+          </a:p>
+          <a:p>
+            <a:pPr lvl="0" algn="ctr">
+              <a:lnSpc>
+                <a:spcPct val="130000"/>
+              </a:lnSpc>
+            </a:pPr>
+            <a:r>
+              <a:rPr lang="pt-PT" sz="4000" dirty="0">
+                <a:latin typeface="+mn-lt"/>
+              </a:rPr>
+              <a:t>una, santa, católica e apostólica. </a:t>
+            </a:r>
+            <a:br>
+              <a:rPr lang="pt-PT" sz="4000" dirty="0">
+                <a:latin typeface="+mn-lt"/>
+              </a:rPr>
+            </a:br>
+            <a:r>
+              <a:rPr lang="pt-PT" sz="4000" dirty="0">
+                <a:latin typeface="+mn-lt"/>
+              </a:rPr>
+              <a:t>Professo um só Batismo </a:t>
+            </a:r>
+          </a:p>
+          <a:p>
+            <a:pPr lvl="0" algn="ctr">
+              <a:lnSpc>
+                <a:spcPct val="130000"/>
+              </a:lnSpc>
+            </a:pPr>
+            <a:r>
+              <a:rPr lang="pt-PT" sz="4000" dirty="0">
+                <a:latin typeface="+mn-lt"/>
+              </a:rPr>
+              <a:t>para a remissão dos pecados. </a:t>
+            </a:r>
+          </a:p>
+          <a:p>
+            <a:pPr lvl="0" algn="ctr">
+              <a:lnSpc>
+                <a:spcPct val="130000"/>
+              </a:lnSpc>
+            </a:pPr>
+            <a:r>
+              <a:rPr lang="pt-PT" sz="4000" dirty="0">
+                <a:latin typeface="+mn-lt"/>
+              </a:rPr>
+              <a:t>E espero a ressurreição dos mortos,</a:t>
+            </a:r>
+          </a:p>
+          <a:p>
+            <a:pPr lvl="0" algn="ctr">
+              <a:lnSpc>
+                <a:spcPct val="130000"/>
+              </a:lnSpc>
+            </a:pPr>
+            <a:r>
+              <a:rPr lang="pt-PT" sz="4000" dirty="0">
+                <a:latin typeface="+mn-lt"/>
+              </a:rPr>
+              <a:t> e a vida do mundo que </a:t>
+            </a:r>
+            <a:r>
+              <a:rPr lang="pt-PT" sz="4000" dirty="0" err="1">
+                <a:latin typeface="+mn-lt"/>
+              </a:rPr>
+              <a:t>há-de</a:t>
+            </a:r>
+            <a:r>
+              <a:rPr lang="pt-PT" sz="4000" dirty="0">
+                <a:latin typeface="+mn-lt"/>
+              </a:rPr>
+              <a:t> vir. Ámen. </a:t>
+            </a:r>
+          </a:p>
+        </p:txBody>
+      </p:sp>
+    </p:spTree>
+    <p:extLst>
+      <p:ext uri="{BB962C8B-B14F-4D97-AF65-F5344CB8AC3E}">
+        <p14:creationId xmlns:p14="http://schemas.microsoft.com/office/powerpoint/2010/main" val="1595952212"/>
+      </p:ext>
+    </p:extLst>
+  </p:cSld>
+  <p:clrMapOvr>
+    <a:masterClrMapping/>
+  </p:clrMapOvr>
+</p:sldLayout>
+</file>
+
+<file path=ppt/slideLayouts/slideLayout26.xml><?xml version="1.0" encoding="utf-8"?>
+<p:sldLayout xmlns:a="http://schemas.openxmlformats.org/drawingml/2006/main" xmlns:r="http://schemas.openxmlformats.org/officeDocument/2006/relationships" xmlns:p="http://schemas.openxmlformats.org/presentationml/2006/main" preserve="1" userDrawn="1">
+  <p:cSld name="Credo - Breve - 1">
+    <p:spTree>
+      <p:nvGrpSpPr>
+        <p:cNvPr id="1" name=""/>
+        <p:cNvGrpSpPr/>
+        <p:nvPr/>
+      </p:nvGrpSpPr>
+      <p:grpSpPr>
+        <a:xfrm>
+          <a:off x="0" y="0"/>
+          <a:ext cx="0" cy="0"/>
+          <a:chOff x="0" y="0"/>
+          <a:chExt cx="0" cy="0"/>
+        </a:xfrm>
+      </p:grpSpPr>
+      <p:sp>
+        <p:nvSpPr>
+          <p:cNvPr id="5" name="TextBox 4">
+            <a:extLst>
+              <a:ext uri="{FF2B5EF4-FFF2-40B4-BE49-F238E27FC236}">
+                <a16:creationId xmlns:a16="http://schemas.microsoft.com/office/drawing/2014/main" id="{F461CFFF-A66C-B4EF-69DF-1DD65AABD72A}"/>
+              </a:ext>
+            </a:extLst>
+          </p:cNvPr>
+          <p:cNvSpPr txBox="1"/>
+          <p:nvPr userDrawn="1"/>
+        </p:nvSpPr>
+        <p:spPr>
+          <a:xfrm>
+            <a:off x="0" y="501564"/>
+            <a:ext cx="9144000" cy="5854873"/>
+          </a:xfrm>
+          <a:prstGeom prst="rect">
+            <a:avLst/>
+          </a:prstGeom>
+          <a:noFill/>
+        </p:spPr>
+        <p:txBody>
+          <a:bodyPr wrap="square" rtlCol="0">
+            <a:spAutoFit/>
+          </a:bodyPr>
+          <a:lstStyle/>
+          <a:p>
+            <a:pPr lvl="0" algn="ctr">
+              <a:lnSpc>
+                <a:spcPct val="130000"/>
+              </a:lnSpc>
+            </a:pPr>
+            <a:r>
+              <a:rPr lang="pt-PT" sz="4000" u="sng" dirty="0">
+                <a:latin typeface="IBM Plex Sans SemiBold" panose="020B0703050203000203" pitchFamily="34" charset="0"/>
+              </a:rPr>
+              <a:t>Creio em Deus,</a:t>
+            </a:r>
+          </a:p>
+          <a:p>
+            <a:pPr lvl="0" algn="ctr">
+              <a:lnSpc>
+                <a:spcPct val="130000"/>
+              </a:lnSpc>
+            </a:pPr>
+            <a:r>
+              <a:rPr lang="pt-PT" sz="4000" u="none" dirty="0">
+                <a:latin typeface="+mn-lt"/>
+              </a:rPr>
+              <a:t>Pai todo-poderoso, </a:t>
+            </a:r>
+          </a:p>
+          <a:p>
+            <a:pPr lvl="0" algn="ctr">
+              <a:lnSpc>
+                <a:spcPct val="130000"/>
+              </a:lnSpc>
+              <a:spcAft>
+                <a:spcPts val="1800"/>
+              </a:spcAft>
+            </a:pPr>
+            <a:r>
+              <a:rPr lang="pt-PT" sz="4000" u="none" dirty="0">
+                <a:latin typeface="+mn-lt"/>
+              </a:rPr>
+              <a:t>Criador do céu e da terra; </a:t>
+            </a:r>
+          </a:p>
+          <a:p>
+            <a:pPr lvl="0" algn="ctr">
+              <a:lnSpc>
+                <a:spcPct val="130000"/>
+              </a:lnSpc>
+            </a:pPr>
+            <a:r>
+              <a:rPr lang="pt-PT" sz="4000" u="sng" dirty="0">
+                <a:latin typeface="IBM Plex Sans SemiBold" panose="020B0703050203000203" pitchFamily="34" charset="0"/>
+              </a:rPr>
+              <a:t>e em Jesus Cristo</a:t>
+            </a:r>
+            <a:r>
+              <a:rPr lang="pt-PT" sz="4000" u="none" dirty="0">
+                <a:latin typeface="+mn-lt"/>
+              </a:rPr>
+              <a:t>, seu único Filho,</a:t>
+            </a:r>
+          </a:p>
+          <a:p>
+            <a:pPr lvl="0" algn="ctr">
+              <a:lnSpc>
+                <a:spcPct val="130000"/>
+              </a:lnSpc>
+            </a:pPr>
+            <a:r>
+              <a:rPr lang="pt-PT" sz="4000" u="none" dirty="0">
+                <a:latin typeface="+mn-lt"/>
+              </a:rPr>
+              <a:t> Nosso Senhor, </a:t>
+            </a:r>
+          </a:p>
+          <a:p>
+            <a:pPr lvl="0" algn="ctr">
+              <a:lnSpc>
+                <a:spcPct val="130000"/>
+              </a:lnSpc>
+            </a:pPr>
+            <a:r>
+              <a:rPr lang="pt-PT" sz="4000" u="none" dirty="0">
+                <a:latin typeface="+mn-lt"/>
+              </a:rPr>
+              <a:t>que foi concebido pelo poder do Espírito Santo;</a:t>
+            </a:r>
+          </a:p>
+        </p:txBody>
+      </p:sp>
+    </p:spTree>
+    <p:extLst>
+      <p:ext uri="{BB962C8B-B14F-4D97-AF65-F5344CB8AC3E}">
+        <p14:creationId xmlns:p14="http://schemas.microsoft.com/office/powerpoint/2010/main" val="518302046"/>
+      </p:ext>
+    </p:extLst>
+  </p:cSld>
+  <p:clrMapOvr>
+    <a:masterClrMapping/>
+  </p:clrMapOvr>
+</p:sldLayout>
+</file>
+
+<file path=ppt/slideLayouts/slideLayout27.xml><?xml version="1.0" encoding="utf-8"?>
+<p:sldLayout xmlns:a="http://schemas.openxmlformats.org/drawingml/2006/main" xmlns:r="http://schemas.openxmlformats.org/officeDocument/2006/relationships" xmlns:p="http://schemas.openxmlformats.org/presentationml/2006/main" preserve="1" userDrawn="1">
+  <p:cSld name="Credo - Breve - 2">
+    <p:spTree>
+      <p:nvGrpSpPr>
+        <p:cNvPr id="1" name=""/>
+        <p:cNvGrpSpPr/>
+        <p:nvPr/>
+      </p:nvGrpSpPr>
+      <p:grpSpPr>
+        <a:xfrm>
+          <a:off x="0" y="0"/>
+          <a:ext cx="0" cy="0"/>
+          <a:chOff x="0" y="0"/>
+          <a:chExt cx="0" cy="0"/>
+        </a:xfrm>
+      </p:grpSpPr>
+      <p:sp>
+        <p:nvSpPr>
+          <p:cNvPr id="5" name="TextBox 4">
+            <a:extLst>
+              <a:ext uri="{FF2B5EF4-FFF2-40B4-BE49-F238E27FC236}">
+                <a16:creationId xmlns:a16="http://schemas.microsoft.com/office/drawing/2014/main" id="{F461CFFF-A66C-B4EF-69DF-1DD65AABD72A}"/>
+              </a:ext>
+            </a:extLst>
+          </p:cNvPr>
+          <p:cNvSpPr txBox="1"/>
+          <p:nvPr userDrawn="1"/>
+        </p:nvSpPr>
+        <p:spPr>
+          <a:xfrm>
+            <a:off x="0" y="149513"/>
+            <a:ext cx="9144000" cy="6558975"/>
+          </a:xfrm>
+          <a:prstGeom prst="rect">
+            <a:avLst/>
+          </a:prstGeom>
+          <a:noFill/>
+        </p:spPr>
+        <p:txBody>
+          <a:bodyPr wrap="square" rtlCol="0">
+            <a:spAutoFit/>
+          </a:bodyPr>
+          <a:lstStyle/>
+          <a:p>
+            <a:pPr marL="0" indent="0" algn="ctr">
+              <a:lnSpc>
+                <a:spcPct val="120000"/>
+              </a:lnSpc>
+              <a:buNone/>
+            </a:pPr>
+            <a:r>
+              <a:rPr lang="pt-PT" sz="3400" dirty="0"/>
+              <a:t>Nasceu da Virgem Maria;</a:t>
+            </a:r>
+          </a:p>
+          <a:p>
+            <a:pPr marL="0" indent="0" algn="ctr">
+              <a:lnSpc>
+                <a:spcPct val="120000"/>
+              </a:lnSpc>
+              <a:buNone/>
+            </a:pPr>
+            <a:r>
+              <a:rPr lang="pt-PT" sz="3400" dirty="0"/>
+              <a:t>padeceu sob Pôncio Pilatos, </a:t>
+            </a:r>
+          </a:p>
+          <a:p>
+            <a:pPr marL="0" indent="0" algn="ctr">
+              <a:lnSpc>
+                <a:spcPct val="120000"/>
+              </a:lnSpc>
+              <a:buNone/>
+            </a:pPr>
+            <a:r>
+              <a:rPr lang="pt-PT" sz="3400" dirty="0"/>
+              <a:t>foi crucificado, morto e sepultado; </a:t>
+            </a:r>
+          </a:p>
+          <a:p>
+            <a:pPr marL="0" indent="0" algn="ctr">
+              <a:lnSpc>
+                <a:spcPct val="120000"/>
+              </a:lnSpc>
+              <a:spcAft>
+                <a:spcPts val="1800"/>
+              </a:spcAft>
+              <a:buNone/>
+            </a:pPr>
+            <a:r>
+              <a:rPr lang="pt-PT" sz="3400" dirty="0"/>
+              <a:t>desceu à mansão dos mortos;</a:t>
+            </a:r>
+          </a:p>
+          <a:p>
+            <a:pPr marL="0" indent="0" algn="ctr">
+              <a:lnSpc>
+                <a:spcPct val="120000"/>
+              </a:lnSpc>
+              <a:buNone/>
+            </a:pPr>
+            <a:r>
+              <a:rPr lang="pt-PT" sz="3400" dirty="0"/>
+              <a:t>Ressuscitou ao terceiro dia; </a:t>
+            </a:r>
+          </a:p>
+          <a:p>
+            <a:pPr marL="0" indent="0" algn="ctr">
+              <a:lnSpc>
+                <a:spcPct val="120000"/>
+              </a:lnSpc>
+              <a:buNone/>
+            </a:pPr>
+            <a:r>
+              <a:rPr lang="pt-PT" sz="3400" dirty="0"/>
+              <a:t>Subiu aos Céus, </a:t>
+            </a:r>
+          </a:p>
+          <a:p>
+            <a:pPr marL="0" indent="0" algn="ctr">
+              <a:lnSpc>
+                <a:spcPct val="120000"/>
+              </a:lnSpc>
+              <a:buNone/>
+            </a:pPr>
+            <a:r>
+              <a:rPr lang="pt-PT" sz="3400" dirty="0"/>
+              <a:t>está sentado à direita de Deus, </a:t>
+            </a:r>
+          </a:p>
+          <a:p>
+            <a:pPr marL="0" indent="0" algn="ctr">
+              <a:lnSpc>
+                <a:spcPct val="120000"/>
+              </a:lnSpc>
+              <a:buNone/>
+            </a:pPr>
+            <a:r>
+              <a:rPr lang="pt-PT" sz="3400" dirty="0"/>
+              <a:t>Pai todo-poderoso, </a:t>
+            </a:r>
+          </a:p>
+          <a:p>
+            <a:pPr marL="0" indent="0" algn="ctr">
+              <a:lnSpc>
+                <a:spcPct val="120000"/>
+              </a:lnSpc>
+              <a:buNone/>
+            </a:pPr>
+            <a:r>
+              <a:rPr lang="pt-PT" sz="3400" dirty="0"/>
+              <a:t>de onde há de vir a julgar</a:t>
+            </a:r>
+          </a:p>
+          <a:p>
+            <a:pPr marL="0" indent="0" algn="ctr">
+              <a:lnSpc>
+                <a:spcPct val="120000"/>
+              </a:lnSpc>
+              <a:buNone/>
+            </a:pPr>
+            <a:r>
+              <a:rPr lang="pt-PT" sz="3400" dirty="0"/>
+              <a:t> os vivos e os mortos.  </a:t>
+            </a:r>
+            <a:endParaRPr lang="pt-PT" sz="3400" dirty="0">
+              <a:solidFill>
+                <a:schemeClr val="bg1">
+                  <a:lumMod val="95000"/>
+                </a:schemeClr>
+              </a:solidFill>
+              <a:latin typeface="ø" panose="00000200000000000000" pitchFamily="2" charset="0"/>
+            </a:endParaRPr>
+          </a:p>
+        </p:txBody>
+      </p:sp>
+    </p:spTree>
+    <p:extLst>
+      <p:ext uri="{BB962C8B-B14F-4D97-AF65-F5344CB8AC3E}">
+        <p14:creationId xmlns:p14="http://schemas.microsoft.com/office/powerpoint/2010/main" val="1841311067"/>
+      </p:ext>
+    </p:extLst>
+  </p:cSld>
+  <p:clrMapOvr>
+    <a:masterClrMapping/>
+  </p:clrMapOvr>
+</p:sldLayout>
+</file>
+
+<file path=ppt/slideLayouts/slideLayout28.xml><?xml version="1.0" encoding="utf-8"?>
+<p:sldLayout xmlns:a="http://schemas.openxmlformats.org/drawingml/2006/main" xmlns:r="http://schemas.openxmlformats.org/officeDocument/2006/relationships" xmlns:p="http://schemas.openxmlformats.org/presentationml/2006/main" preserve="1" userDrawn="1">
+  <p:cSld name="Credo - Breve - 3">
+    <p:spTree>
+      <p:nvGrpSpPr>
+        <p:cNvPr id="1" name=""/>
+        <p:cNvGrpSpPr/>
+        <p:nvPr/>
+      </p:nvGrpSpPr>
+      <p:grpSpPr>
+        <a:xfrm>
+          <a:off x="0" y="0"/>
+          <a:ext cx="0" cy="0"/>
+          <a:chOff x="0" y="0"/>
+          <a:chExt cx="0" cy="0"/>
+        </a:xfrm>
+      </p:grpSpPr>
+      <p:sp>
+        <p:nvSpPr>
+          <p:cNvPr id="5" name="TextBox 4">
+            <a:extLst>
+              <a:ext uri="{FF2B5EF4-FFF2-40B4-BE49-F238E27FC236}">
+                <a16:creationId xmlns:a16="http://schemas.microsoft.com/office/drawing/2014/main" id="{F461CFFF-A66C-B4EF-69DF-1DD65AABD72A}"/>
+              </a:ext>
+            </a:extLst>
+          </p:cNvPr>
+          <p:cNvSpPr txBox="1"/>
+          <p:nvPr userDrawn="1"/>
+        </p:nvSpPr>
+        <p:spPr>
+          <a:xfrm>
+            <a:off x="0" y="824729"/>
+            <a:ext cx="9144000" cy="5208542"/>
+          </a:xfrm>
+          <a:prstGeom prst="rect">
+            <a:avLst/>
+          </a:prstGeom>
+          <a:noFill/>
+        </p:spPr>
+        <p:txBody>
+          <a:bodyPr wrap="square" rtlCol="0">
+            <a:spAutoFit/>
+          </a:bodyPr>
+          <a:lstStyle/>
+          <a:p>
+            <a:pPr marL="0" indent="0" algn="ctr">
+              <a:lnSpc>
+                <a:spcPct val="120000"/>
+              </a:lnSpc>
+              <a:buNone/>
+            </a:pPr>
+            <a:r>
+              <a:rPr lang="pt-PT" sz="4000" u="sng" dirty="0">
+                <a:latin typeface="IBM Plex Sans SemiBold" panose="020B0703050203000203" pitchFamily="34" charset="0"/>
+              </a:rPr>
+              <a:t>Creio no Espírito Santo; </a:t>
+            </a:r>
+          </a:p>
+          <a:p>
+            <a:pPr marL="0" indent="0" algn="ctr">
+              <a:lnSpc>
+                <a:spcPct val="120000"/>
+              </a:lnSpc>
+              <a:buNone/>
+            </a:pPr>
+            <a:r>
+              <a:rPr lang="pt-PT" sz="4000" u="sng" dirty="0">
+                <a:latin typeface="IBM Plex Sans SemiBold" panose="020B0703050203000203" pitchFamily="34" charset="0"/>
+              </a:rPr>
+              <a:t>na santa Igreja Católica; </a:t>
+            </a:r>
+          </a:p>
+          <a:p>
+            <a:pPr marL="0" indent="0" algn="ctr">
+              <a:lnSpc>
+                <a:spcPct val="120000"/>
+              </a:lnSpc>
+              <a:buNone/>
+            </a:pPr>
+            <a:r>
+              <a:rPr lang="pt-PT" sz="4000" dirty="0"/>
+              <a:t>na comunhão dos Santos; </a:t>
+            </a:r>
+          </a:p>
+          <a:p>
+            <a:pPr marL="0" indent="0" algn="ctr">
+              <a:lnSpc>
+                <a:spcPct val="120000"/>
+              </a:lnSpc>
+              <a:buNone/>
+            </a:pPr>
+            <a:r>
+              <a:rPr lang="pt-PT" sz="4000" dirty="0"/>
+              <a:t>na remissão dos pecados; </a:t>
+            </a:r>
+          </a:p>
+          <a:p>
+            <a:pPr marL="0" indent="0" algn="ctr">
+              <a:lnSpc>
+                <a:spcPct val="120000"/>
+              </a:lnSpc>
+              <a:buNone/>
+            </a:pPr>
+            <a:r>
+              <a:rPr lang="pt-PT" sz="4000" dirty="0"/>
+              <a:t>na ressurreição da carne; </a:t>
+            </a:r>
+          </a:p>
+          <a:p>
+            <a:pPr marL="0" indent="0" algn="ctr">
+              <a:lnSpc>
+                <a:spcPct val="120000"/>
+              </a:lnSpc>
+              <a:buNone/>
+            </a:pPr>
+            <a:r>
+              <a:rPr lang="pt-PT" sz="4000" dirty="0"/>
+              <a:t>na vida eterna.</a:t>
+            </a:r>
+          </a:p>
+          <a:p>
+            <a:pPr marL="0" indent="0" algn="ctr">
+              <a:lnSpc>
+                <a:spcPct val="120000"/>
+              </a:lnSpc>
+              <a:buNone/>
+            </a:pPr>
+            <a:r>
+              <a:rPr lang="pt-PT" sz="4000" dirty="0"/>
+              <a:t>Ámen.</a:t>
+            </a:r>
+          </a:p>
+        </p:txBody>
+      </p:sp>
+    </p:spTree>
+    <p:extLst>
+      <p:ext uri="{BB962C8B-B14F-4D97-AF65-F5344CB8AC3E}">
+        <p14:creationId xmlns:p14="http://schemas.microsoft.com/office/powerpoint/2010/main" val="4031632862"/>
+      </p:ext>
+    </p:extLst>
+  </p:cSld>
+  <p:clrMapOvr>
+    <a:masterClrMapping/>
+  </p:clrMapOvr>
+</p:sldLayout>
+</file>
+
+<file path=ppt/slideLayouts/slideLayout29.xml><?xml version="1.0" encoding="utf-8"?>
+<p:sldLayout xmlns:a="http://schemas.openxmlformats.org/drawingml/2006/main" xmlns:r="http://schemas.openxmlformats.org/officeDocument/2006/relationships" xmlns:p="http://schemas.openxmlformats.org/presentationml/2006/main" preserve="1" userDrawn="1">
+  <p:cSld name="Oração Universal">
+    <p:spTree>
+      <p:nvGrpSpPr>
+        <p:cNvPr id="1" name=""/>
+        <p:cNvGrpSpPr/>
+        <p:nvPr/>
+      </p:nvGrpSpPr>
+      <p:grpSpPr>
+        <a:xfrm>
+          <a:off x="0" y="0"/>
+          <a:ext cx="0" cy="0"/>
+          <a:chOff x="0" y="0"/>
+          <a:chExt cx="0" cy="0"/>
+        </a:xfrm>
+      </p:grpSpPr>
+      <p:sp>
+        <p:nvSpPr>
+          <p:cNvPr id="3" name="Letra">
+            <a:extLst>
+              <a:ext uri="{FF2B5EF4-FFF2-40B4-BE49-F238E27FC236}">
+                <a16:creationId xmlns:a16="http://schemas.microsoft.com/office/drawing/2014/main" id="{7FBA5054-2BE0-6B52-7485-0B10968F39E5}"/>
+              </a:ext>
+            </a:extLst>
+          </p:cNvPr>
+          <p:cNvSpPr>
+            <a:spLocks noGrp="1"/>
+          </p:cNvSpPr>
+          <p:nvPr>
+            <p:ph idx="1" hasCustomPrompt="1"/>
+          </p:nvPr>
+        </p:nvSpPr>
+        <p:spPr>
+          <a:xfrm>
+            <a:off x="549995" y="103695"/>
+            <a:ext cx="8044010" cy="6532775"/>
+          </a:xfrm>
+        </p:spPr>
+        <p:txBody>
+          <a:bodyPr anchor="ctr" anchorCtr="0">
+            <a:normAutofit/>
+          </a:bodyPr>
+          <a:lstStyle>
+            <a:lvl1pPr marL="0" marR="0" indent="0" algn="ctr" defTabSz="685800" rtl="0" eaLnBrk="1" fontAlgn="auto" latinLnBrk="0" hangingPunct="1">
+              <a:lnSpc>
+                <a:spcPct val="130000"/>
+              </a:lnSpc>
+              <a:spcBef>
+                <a:spcPts val="0"/>
+              </a:spcBef>
+              <a:spcAft>
+                <a:spcPts val="0"/>
+              </a:spcAft>
+              <a:buClrTx/>
+              <a:buSzTx/>
+              <a:buFont typeface="Arial" panose="020B0604020202020204" pitchFamily="34" charset="0"/>
+              <a:buNone/>
+              <a:tabLst/>
+              <a:defRPr sz="6000">
+                <a:latin typeface="+mj-lt"/>
+              </a:defRPr>
+            </a:lvl1pPr>
+            <a:lvl2pPr algn="ctr">
+              <a:defRPr/>
+            </a:lvl2pPr>
+            <a:lvl3pPr algn="ctr">
+              <a:defRPr/>
+            </a:lvl3pPr>
+            <a:lvl4pPr algn="ctr">
+              <a:defRPr/>
+            </a:lvl4pPr>
+            <a:lvl5pPr algn="ctr">
+              <a:defRPr/>
+            </a:lvl5pPr>
+          </a:lstStyle>
+          <a:p>
+            <a:pPr lvl="0"/>
+            <a:r>
+              <a:rPr lang="en-US" dirty="0" err="1"/>
+              <a:t>Ouvi-nos</a:t>
+            </a:r>
+            <a:r>
+              <a:rPr lang="en-US" dirty="0"/>
+              <a:t>, Senhor!</a:t>
+            </a:r>
+          </a:p>
+        </p:txBody>
+      </p:sp>
+    </p:spTree>
+    <p:extLst>
+      <p:ext uri="{BB962C8B-B14F-4D97-AF65-F5344CB8AC3E}">
+        <p14:creationId xmlns:p14="http://schemas.microsoft.com/office/powerpoint/2010/main" val="3280188006"/>
       </p:ext>
     </p:extLst>
   </p:cSld>
@@ -2198,6 +4281,507 @@
     <p:extLst>
       <p:ext uri="{BB962C8B-B14F-4D97-AF65-F5344CB8AC3E}">
         <p14:creationId xmlns:p14="http://schemas.microsoft.com/office/powerpoint/2010/main" val="1642785294"/>
+      </p:ext>
+    </p:extLst>
+  </p:cSld>
+  <p:clrMapOvr>
+    <a:masterClrMapping/>
+  </p:clrMapOvr>
+</p:sldLayout>
+</file>
+
+<file path=ppt/slideLayouts/slideLayout30.xml><?xml version="1.0" encoding="utf-8"?>
+<p:sldLayout xmlns:a="http://schemas.openxmlformats.org/drawingml/2006/main" xmlns:r="http://schemas.openxmlformats.org/officeDocument/2006/relationships" xmlns:p="http://schemas.openxmlformats.org/presentationml/2006/main" preserve="1" userDrawn="1">
+  <p:cSld name="Preparação das oferendas">
+    <p:spTree>
+      <p:nvGrpSpPr>
+        <p:cNvPr id="1" name=""/>
+        <p:cNvGrpSpPr/>
+        <p:nvPr/>
+      </p:nvGrpSpPr>
+      <p:grpSpPr>
+        <a:xfrm>
+          <a:off x="0" y="0"/>
+          <a:ext cx="0" cy="0"/>
+          <a:chOff x="0" y="0"/>
+          <a:chExt cx="0" cy="0"/>
+        </a:xfrm>
+      </p:grpSpPr>
+      <p:sp>
+        <p:nvSpPr>
+          <p:cNvPr id="5" name="TextBox 4">
+            <a:extLst>
+              <a:ext uri="{FF2B5EF4-FFF2-40B4-BE49-F238E27FC236}">
+                <a16:creationId xmlns:a16="http://schemas.microsoft.com/office/drawing/2014/main" id="{F461CFFF-A66C-B4EF-69DF-1DD65AABD72A}"/>
+              </a:ext>
+            </a:extLst>
+          </p:cNvPr>
+          <p:cNvSpPr txBox="1"/>
+          <p:nvPr userDrawn="1"/>
+        </p:nvSpPr>
+        <p:spPr>
+          <a:xfrm>
+            <a:off x="240384" y="713129"/>
+            <a:ext cx="8663233" cy="5431743"/>
+          </a:xfrm>
+          <a:prstGeom prst="rect">
+            <a:avLst/>
+          </a:prstGeom>
+          <a:noFill/>
+        </p:spPr>
+        <p:txBody>
+          <a:bodyPr wrap="square" rtlCol="0">
+            <a:spAutoFit/>
+          </a:bodyPr>
+          <a:lstStyle/>
+          <a:p>
+            <a:pPr marL="0" indent="0" algn="ctr">
+              <a:lnSpc>
+                <a:spcPct val="120000"/>
+              </a:lnSpc>
+              <a:spcAft>
+                <a:spcPts val="1800"/>
+              </a:spcAft>
+              <a:buNone/>
+            </a:pPr>
+            <a:r>
+              <a:rPr lang="pt-PT" sz="4000" dirty="0"/>
+              <a:t>V. Orai, irmãos, para que o meu e vosso sacrifício seja aceite por Deus Pai todo-poderoso.</a:t>
+            </a:r>
+          </a:p>
+          <a:p>
+            <a:pPr marL="0" indent="0" algn="ctr">
+              <a:lnSpc>
+                <a:spcPct val="120000"/>
+              </a:lnSpc>
+              <a:buNone/>
+            </a:pPr>
+            <a:r>
+              <a:rPr lang="pt-PT" sz="4000" dirty="0">
+                <a:latin typeface="+mj-lt"/>
+              </a:rPr>
+              <a:t>R. Receba o Senhor por tuas mãos este sacrifício, para glória do seu nome, para nosso bem e de toda a santa Igreja.</a:t>
+            </a:r>
+          </a:p>
+        </p:txBody>
+      </p:sp>
+    </p:spTree>
+    <p:extLst>
+      <p:ext uri="{BB962C8B-B14F-4D97-AF65-F5344CB8AC3E}">
+        <p14:creationId xmlns:p14="http://schemas.microsoft.com/office/powerpoint/2010/main" val="3340031225"/>
+      </p:ext>
+    </p:extLst>
+  </p:cSld>
+  <p:clrMapOvr>
+    <a:masterClrMapping/>
+  </p:clrMapOvr>
+</p:sldLayout>
+</file>
+
+<file path=ppt/slideLayouts/slideLayout31.xml><?xml version="1.0" encoding="utf-8"?>
+<p:sldLayout xmlns:a="http://schemas.openxmlformats.org/drawingml/2006/main" xmlns:r="http://schemas.openxmlformats.org/officeDocument/2006/relationships" xmlns:p="http://schemas.openxmlformats.org/presentationml/2006/main" preserve="1" userDrawn="1">
+  <p:cSld name="Diálogo Prefácio">
+    <p:spTree>
+      <p:nvGrpSpPr>
+        <p:cNvPr id="1" name=""/>
+        <p:cNvGrpSpPr/>
+        <p:nvPr/>
+      </p:nvGrpSpPr>
+      <p:grpSpPr>
+        <a:xfrm>
+          <a:off x="0" y="0"/>
+          <a:ext cx="0" cy="0"/>
+          <a:chOff x="0" y="0"/>
+          <a:chExt cx="0" cy="0"/>
+        </a:xfrm>
+      </p:grpSpPr>
+      <p:sp>
+        <p:nvSpPr>
+          <p:cNvPr id="5" name="TextBox 4">
+            <a:extLst>
+              <a:ext uri="{FF2B5EF4-FFF2-40B4-BE49-F238E27FC236}">
+                <a16:creationId xmlns:a16="http://schemas.microsoft.com/office/drawing/2014/main" id="{F461CFFF-A66C-B4EF-69DF-1DD65AABD72A}"/>
+              </a:ext>
+            </a:extLst>
+          </p:cNvPr>
+          <p:cNvSpPr txBox="1"/>
+          <p:nvPr userDrawn="1"/>
+        </p:nvSpPr>
+        <p:spPr>
+          <a:xfrm>
+            <a:off x="0" y="1108589"/>
+            <a:ext cx="9144000" cy="4640822"/>
+          </a:xfrm>
+          <a:prstGeom prst="rect">
+            <a:avLst/>
+          </a:prstGeom>
+          <a:noFill/>
+        </p:spPr>
+        <p:txBody>
+          <a:bodyPr wrap="square" rtlCol="0">
+            <a:spAutoFit/>
+          </a:bodyPr>
+          <a:lstStyle/>
+          <a:p>
+            <a:pPr marL="0" indent="0" algn="ctr">
+              <a:lnSpc>
+                <a:spcPct val="120000"/>
+              </a:lnSpc>
+              <a:buNone/>
+            </a:pPr>
+            <a:r>
+              <a:rPr lang="pt-PT" sz="3600" dirty="0"/>
+              <a:t>V. O Senhor esteja convosco.</a:t>
+            </a:r>
+          </a:p>
+          <a:p>
+            <a:pPr marL="0" indent="0" algn="ctr">
+              <a:lnSpc>
+                <a:spcPct val="120000"/>
+              </a:lnSpc>
+              <a:spcAft>
+                <a:spcPts val="2400"/>
+              </a:spcAft>
+              <a:buNone/>
+            </a:pPr>
+            <a:r>
+              <a:rPr lang="pt-PT" sz="3600" dirty="0">
+                <a:latin typeface="+mj-lt"/>
+              </a:rPr>
+              <a:t>R. Ele está no meio de nós.</a:t>
+            </a:r>
+          </a:p>
+          <a:p>
+            <a:pPr marL="0" indent="0" algn="ctr">
+              <a:lnSpc>
+                <a:spcPct val="120000"/>
+              </a:lnSpc>
+              <a:buNone/>
+            </a:pPr>
+            <a:r>
+              <a:rPr lang="pt-PT" sz="3600" dirty="0"/>
+              <a:t>V. Corações ao alto.</a:t>
+            </a:r>
+          </a:p>
+          <a:p>
+            <a:pPr marL="0" indent="0" algn="ctr">
+              <a:lnSpc>
+                <a:spcPct val="120000"/>
+              </a:lnSpc>
+              <a:spcAft>
+                <a:spcPts val="2400"/>
+              </a:spcAft>
+              <a:buNone/>
+            </a:pPr>
+            <a:r>
+              <a:rPr lang="pt-PT" sz="3600" dirty="0">
+                <a:latin typeface="+mj-lt"/>
+              </a:rPr>
+              <a:t>R. O nosso coração está em Deus.</a:t>
+            </a:r>
+          </a:p>
+          <a:p>
+            <a:pPr marL="0" indent="0" algn="ctr">
+              <a:lnSpc>
+                <a:spcPct val="120000"/>
+              </a:lnSpc>
+              <a:buNone/>
+            </a:pPr>
+            <a:r>
+              <a:rPr lang="pt-PT" sz="3600" dirty="0"/>
+              <a:t>V. Dêmos graças ao Senhor nosso Deus.</a:t>
+            </a:r>
+          </a:p>
+          <a:p>
+            <a:pPr marL="0" indent="0" algn="ctr">
+              <a:lnSpc>
+                <a:spcPct val="120000"/>
+              </a:lnSpc>
+              <a:buNone/>
+            </a:pPr>
+            <a:r>
+              <a:rPr lang="pt-PT" sz="3600" dirty="0">
+                <a:latin typeface="+mj-lt"/>
+              </a:rPr>
+              <a:t>R. É nosso dever, é nossa salvação.</a:t>
+            </a:r>
+          </a:p>
+        </p:txBody>
+      </p:sp>
+    </p:spTree>
+    <p:extLst>
+      <p:ext uri="{BB962C8B-B14F-4D97-AF65-F5344CB8AC3E}">
+        <p14:creationId xmlns:p14="http://schemas.microsoft.com/office/powerpoint/2010/main" val="4161769567"/>
+      </p:ext>
+    </p:extLst>
+  </p:cSld>
+  <p:clrMapOvr>
+    <a:masterClrMapping/>
+  </p:clrMapOvr>
+</p:sldLayout>
+</file>
+
+<file path=ppt/slideLayouts/slideLayout32.xml><?xml version="1.0" encoding="utf-8"?>
+<p:sldLayout xmlns:a="http://schemas.openxmlformats.org/drawingml/2006/main" xmlns:r="http://schemas.openxmlformats.org/officeDocument/2006/relationships" xmlns:p="http://schemas.openxmlformats.org/presentationml/2006/main" preserve="1" userDrawn="1">
+  <p:cSld name="Aclamação Memorial">
+    <p:spTree>
+      <p:nvGrpSpPr>
+        <p:cNvPr id="1" name=""/>
+        <p:cNvGrpSpPr/>
+        <p:nvPr/>
+      </p:nvGrpSpPr>
+      <p:grpSpPr>
+        <a:xfrm>
+          <a:off x="0" y="0"/>
+          <a:ext cx="0" cy="0"/>
+          <a:chOff x="0" y="0"/>
+          <a:chExt cx="0" cy="0"/>
+        </a:xfrm>
+      </p:grpSpPr>
+      <p:sp>
+        <p:nvSpPr>
+          <p:cNvPr id="5" name="TextBox 4">
+            <a:extLst>
+              <a:ext uri="{FF2B5EF4-FFF2-40B4-BE49-F238E27FC236}">
+                <a16:creationId xmlns:a16="http://schemas.microsoft.com/office/drawing/2014/main" id="{F461CFFF-A66C-B4EF-69DF-1DD65AABD72A}"/>
+              </a:ext>
+            </a:extLst>
+          </p:cNvPr>
+          <p:cNvSpPr txBox="1"/>
+          <p:nvPr userDrawn="1"/>
+        </p:nvSpPr>
+        <p:spPr>
+          <a:xfrm>
+            <a:off x="0" y="1859596"/>
+            <a:ext cx="9144000" cy="3138808"/>
+          </a:xfrm>
+          <a:prstGeom prst="rect">
+            <a:avLst/>
+          </a:prstGeom>
+          <a:noFill/>
+        </p:spPr>
+        <p:txBody>
+          <a:bodyPr wrap="square" rtlCol="0">
+            <a:spAutoFit/>
+          </a:bodyPr>
+          <a:lstStyle/>
+          <a:p>
+            <a:pPr marL="0" indent="0" algn="ctr">
+              <a:lnSpc>
+                <a:spcPct val="120000"/>
+              </a:lnSpc>
+              <a:spcAft>
+                <a:spcPts val="1200"/>
+              </a:spcAft>
+              <a:buNone/>
+            </a:pPr>
+            <a:r>
+              <a:rPr lang="pt-PT" sz="4000" dirty="0"/>
+              <a:t>V. Mistério da fé! </a:t>
+            </a:r>
+          </a:p>
+          <a:p>
+            <a:pPr marL="0" indent="0" algn="ctr">
+              <a:lnSpc>
+                <a:spcPct val="120000"/>
+              </a:lnSpc>
+              <a:buNone/>
+            </a:pPr>
+            <a:r>
+              <a:rPr lang="pt-PT" sz="4000" dirty="0">
+                <a:latin typeface="+mj-lt"/>
+              </a:rPr>
+              <a:t>R. Anunciamos, Senhor, a Vossa morte, proclamamos a Vossa ressurreição. Vinde, Senhor Jesus!</a:t>
+            </a:r>
+          </a:p>
+        </p:txBody>
+      </p:sp>
+    </p:spTree>
+    <p:extLst>
+      <p:ext uri="{BB962C8B-B14F-4D97-AF65-F5344CB8AC3E}">
+        <p14:creationId xmlns:p14="http://schemas.microsoft.com/office/powerpoint/2010/main" val="3268885157"/>
+      </p:ext>
+    </p:extLst>
+  </p:cSld>
+  <p:clrMapOvr>
+    <a:masterClrMapping/>
+  </p:clrMapOvr>
+</p:sldLayout>
+</file>
+
+<file path=ppt/slideLayouts/slideLayout33.xml><?xml version="1.0" encoding="utf-8"?>
+<p:sldLayout xmlns:a="http://schemas.openxmlformats.org/drawingml/2006/main" xmlns:r="http://schemas.openxmlformats.org/officeDocument/2006/relationships" xmlns:p="http://schemas.openxmlformats.org/presentationml/2006/main" preserve="1" userDrawn="1">
+  <p:cSld name="Aclamação">
+    <p:spTree>
+      <p:nvGrpSpPr>
+        <p:cNvPr id="1" name=""/>
+        <p:cNvGrpSpPr/>
+        <p:nvPr/>
+      </p:nvGrpSpPr>
+      <p:grpSpPr>
+        <a:xfrm>
+          <a:off x="0" y="0"/>
+          <a:ext cx="0" cy="0"/>
+          <a:chOff x="0" y="0"/>
+          <a:chExt cx="0" cy="0"/>
+        </a:xfrm>
+      </p:grpSpPr>
+      <p:sp>
+        <p:nvSpPr>
+          <p:cNvPr id="5" name="TextBox 4">
+            <a:extLst>
+              <a:ext uri="{FF2B5EF4-FFF2-40B4-BE49-F238E27FC236}">
+                <a16:creationId xmlns:a16="http://schemas.microsoft.com/office/drawing/2014/main" id="{F461CFFF-A66C-B4EF-69DF-1DD65AABD72A}"/>
+              </a:ext>
+            </a:extLst>
+          </p:cNvPr>
+          <p:cNvSpPr txBox="1"/>
+          <p:nvPr userDrawn="1"/>
+        </p:nvSpPr>
+        <p:spPr>
+          <a:xfrm>
+            <a:off x="325225" y="857751"/>
+            <a:ext cx="8493550" cy="5142498"/>
+          </a:xfrm>
+          <a:prstGeom prst="rect">
+            <a:avLst/>
+          </a:prstGeom>
+          <a:noFill/>
+        </p:spPr>
+        <p:txBody>
+          <a:bodyPr wrap="square" rtlCol="0">
+            <a:spAutoFit/>
+          </a:bodyPr>
+          <a:lstStyle/>
+          <a:p>
+            <a:pPr marL="0" indent="0" algn="ctr">
+              <a:lnSpc>
+                <a:spcPct val="120000"/>
+              </a:lnSpc>
+              <a:spcAft>
+                <a:spcPts val="1800"/>
+              </a:spcAft>
+              <a:buNone/>
+            </a:pPr>
+            <a:r>
+              <a:rPr lang="pt-PT" sz="3200" dirty="0"/>
+              <a:t>V. Livrai-nos de todo o mal, Senhor, e dai ao mundo a paz em nossos dias, para que, ajudados pela vossa misericórdia, sejamos sempre livres do pecado e de toda a perturbação, enquanto esperamos a vinda gloriosa de Jesus Cristo nosso Salvador.</a:t>
+            </a:r>
+          </a:p>
+          <a:p>
+            <a:pPr marL="0" indent="0" algn="ctr">
+              <a:lnSpc>
+                <a:spcPct val="120000"/>
+              </a:lnSpc>
+              <a:spcAft>
+                <a:spcPts val="1200"/>
+              </a:spcAft>
+              <a:buNone/>
+            </a:pPr>
+            <a:r>
+              <a:rPr lang="pt-PT" sz="3600" dirty="0">
+                <a:latin typeface="+mj-lt"/>
+              </a:rPr>
+              <a:t>R. Vosso é o reino e o poder e a glória para sempre.</a:t>
+            </a:r>
+          </a:p>
+        </p:txBody>
+      </p:sp>
+    </p:spTree>
+    <p:extLst>
+      <p:ext uri="{BB962C8B-B14F-4D97-AF65-F5344CB8AC3E}">
+        <p14:creationId xmlns:p14="http://schemas.microsoft.com/office/powerpoint/2010/main" val="2387806163"/>
+      </p:ext>
+    </p:extLst>
+  </p:cSld>
+  <p:clrMapOvr>
+    <a:masterClrMapping/>
+  </p:clrMapOvr>
+</p:sldLayout>
+</file>
+
+<file path=ppt/slideLayouts/slideLayout34.xml><?xml version="1.0" encoding="utf-8"?>
+<p:sldLayout xmlns:a="http://schemas.openxmlformats.org/drawingml/2006/main" xmlns:r="http://schemas.openxmlformats.org/officeDocument/2006/relationships" xmlns:p="http://schemas.openxmlformats.org/presentationml/2006/main" preserve="1" userDrawn="1">
+  <p:cSld name="Convite à Comunhão">
+    <p:spTree>
+      <p:nvGrpSpPr>
+        <p:cNvPr id="1" name=""/>
+        <p:cNvGrpSpPr/>
+        <p:nvPr/>
+      </p:nvGrpSpPr>
+      <p:grpSpPr>
+        <a:xfrm>
+          <a:off x="0" y="0"/>
+          <a:ext cx="0" cy="0"/>
+          <a:chOff x="0" y="0"/>
+          <a:chExt cx="0" cy="0"/>
+        </a:xfrm>
+      </p:grpSpPr>
+      <p:sp>
+        <p:nvSpPr>
+          <p:cNvPr id="5" name="TextBox 4">
+            <a:extLst>
+              <a:ext uri="{FF2B5EF4-FFF2-40B4-BE49-F238E27FC236}">
+                <a16:creationId xmlns:a16="http://schemas.microsoft.com/office/drawing/2014/main" id="{F461CFFF-A66C-B4EF-69DF-1DD65AABD72A}"/>
+              </a:ext>
+            </a:extLst>
+          </p:cNvPr>
+          <p:cNvSpPr txBox="1"/>
+          <p:nvPr userDrawn="1"/>
+        </p:nvSpPr>
+        <p:spPr>
+          <a:xfrm>
+            <a:off x="150829" y="1339422"/>
+            <a:ext cx="8842342" cy="4179157"/>
+          </a:xfrm>
+          <a:prstGeom prst="rect">
+            <a:avLst/>
+          </a:prstGeom>
+          <a:noFill/>
+        </p:spPr>
+        <p:txBody>
+          <a:bodyPr wrap="square" rtlCol="0">
+            <a:spAutoFit/>
+          </a:bodyPr>
+          <a:lstStyle/>
+          <a:p>
+            <a:pPr marL="0" indent="0" algn="ctr">
+              <a:lnSpc>
+                <a:spcPct val="120000"/>
+              </a:lnSpc>
+              <a:spcAft>
+                <a:spcPts val="1200"/>
+              </a:spcAft>
+              <a:buNone/>
+            </a:pPr>
+            <a:r>
+              <a:rPr lang="pt-PT" sz="3600" dirty="0"/>
+              <a:t>V. Felizes os convidados para a Ceia do Senhor. Eis o Cordeiro de Deus, que tira o pecado do mundo.</a:t>
+            </a:r>
+          </a:p>
+          <a:p>
+            <a:pPr marL="0" indent="0" algn="ctr">
+              <a:lnSpc>
+                <a:spcPct val="120000"/>
+              </a:lnSpc>
+              <a:spcAft>
+                <a:spcPts val="1200"/>
+              </a:spcAft>
+              <a:buNone/>
+            </a:pPr>
+            <a:r>
+              <a:rPr lang="pt-PT" sz="3600" dirty="0">
+                <a:latin typeface="+mj-lt"/>
+              </a:rPr>
+              <a:t>R. Senhor, eu não sou digno de que entreis em minha morada, mas dizei uma palavra e serei salvo.</a:t>
+            </a:r>
+          </a:p>
+        </p:txBody>
+      </p:sp>
+    </p:spTree>
+    <p:extLst>
+      <p:ext uri="{BB962C8B-B14F-4D97-AF65-F5344CB8AC3E}">
+        <p14:creationId xmlns:p14="http://schemas.microsoft.com/office/powerpoint/2010/main" val="2545085859"/>
       </p:ext>
     </p:extLst>
   </p:cSld>
@@ -4403,7 +6987,7 @@
           <a:p>
             <a:fld id="{9F2806AE-2D5A-4F99-BCA8-3392766A92A2}" type="datetimeFigureOut">
               <a:rPr lang="pt-PT" smtClean="0"/>
-              <a:t>14/10/2026</a:t>
+              <a:t>15/10/2026</a:t>
             </a:fld>
             <a:endParaRPr lang="pt-PT"/>
           </a:p>
@@ -4520,6 +7104,28 @@
     <p:sldLayoutId id="2147483650" r:id="rId10"/>
     <p:sldLayoutId id="2147483667" r:id="rId11"/>
     <p:sldLayoutId id="2147483666" r:id="rId12"/>
+    <p:sldLayoutId id="2147483670" r:id="rId13"/>
+    <p:sldLayoutId id="2147483672" r:id="rId14"/>
+    <p:sldLayoutId id="2147483673" r:id="rId15"/>
+    <p:sldLayoutId id="2147483674" r:id="rId16"/>
+    <p:sldLayoutId id="2147483675" r:id="rId17"/>
+    <p:sldLayoutId id="2147483677" r:id="rId18"/>
+    <p:sldLayoutId id="2147483678" r:id="rId19"/>
+    <p:sldLayoutId id="2147483679" r:id="rId20"/>
+    <p:sldLayoutId id="2147483680" r:id="rId21"/>
+    <p:sldLayoutId id="2147483681" r:id="rId22"/>
+    <p:sldLayoutId id="2147483682" r:id="rId23"/>
+    <p:sldLayoutId id="2147483683" r:id="rId24"/>
+    <p:sldLayoutId id="2147483684" r:id="rId25"/>
+    <p:sldLayoutId id="2147483685" r:id="rId26"/>
+    <p:sldLayoutId id="2147483686" r:id="rId27"/>
+    <p:sldLayoutId id="2147483687" r:id="rId28"/>
+    <p:sldLayoutId id="2147483688" r:id="rId29"/>
+    <p:sldLayoutId id="2147483693" r:id="rId30"/>
+    <p:sldLayoutId id="2147483689" r:id="rId31"/>
+    <p:sldLayoutId id="2147483690" r:id="rId32"/>
+    <p:sldLayoutId id="2147483692" r:id="rId33"/>
+    <p:sldLayoutId id="2147483691" r:id="rId34"/>
   </p:sldLayoutIdLst>
   <p:txStyles>
     <p:titleStyle>
@@ -5298,4 +7904,47 @@
     </a:ext>
   </a:extLst>
 </a:theme>
+</file>
+
+<file path=ppt/theme/themeOverride1.xml><?xml version="1.0" encoding="utf-8"?>
+<a:themeOverride xmlns:a="http://schemas.openxmlformats.org/drawingml/2006/main">
+  <a:clrScheme name="Liturgia">
+    <a:dk1>
+      <a:sysClr val="windowText" lastClr="000000"/>
+    </a:dk1>
+    <a:lt1>
+      <a:sysClr val="window" lastClr="FFFFFF"/>
+    </a:lt1>
+    <a:dk2>
+      <a:srgbClr val="44546A"/>
+    </a:dk2>
+    <a:lt2>
+      <a:srgbClr val="FFEDB5"/>
+    </a:lt2>
+    <a:accent1>
+      <a:srgbClr val="377D49"/>
+    </a:accent1>
+    <a:accent2>
+      <a:srgbClr val="A461AF"/>
+    </a:accent2>
+    <a:accent3>
+      <a:srgbClr val="F99595"/>
+    </a:accent3>
+    <a:accent4>
+      <a:srgbClr val="8C6A00"/>
+    </a:accent4>
+    <a:accent5>
+      <a:srgbClr val="B92323"/>
+    </a:accent5>
+    <a:accent6>
+      <a:srgbClr val="3470B2"/>
+    </a:accent6>
+    <a:hlink>
+      <a:srgbClr val="0563C1"/>
+    </a:hlink>
+    <a:folHlink>
+      <a:srgbClr val="954F72"/>
+    </a:folHlink>
+  </a:clrScheme>
+</a:themeOverride>
 </file>
</xml_diff>

<commit_message>
feature: allow defining different blank slide intervals
</commit_message>
<xml_diff>
--- a/backend/data/template_4x3.pptx
+++ b/backend/data/template_4x3.pptx
@@ -1686,10 +1686,10 @@
       </p:grpSpPr>
       <p:sp>
         <p:nvSpPr>
-          <p:cNvPr id="4" name="Picture Placeholder 3">
-            <a:extLst>
-              <a:ext uri="{FF2B5EF4-FFF2-40B4-BE49-F238E27FC236}">
-                <a16:creationId xmlns:a16="http://schemas.microsoft.com/office/drawing/2014/main" id="{D2844484-4E28-3CA2-5D12-528E93924332}"/>
+          <p:cNvPr id="5" name="Image Placeholder">
+            <a:extLst>
+              <a:ext uri="{FF2B5EF4-FFF2-40B4-BE49-F238E27FC236}">
+                <a16:creationId xmlns:a16="http://schemas.microsoft.com/office/drawing/2014/main" id="{AE07D419-6058-3F18-6256-550666078F95}"/>
               </a:ext>
             </a:extLst>
           </p:cNvPr>
@@ -1826,10 +1826,10 @@
       </p:sp>
       <p:sp>
         <p:nvSpPr>
-          <p:cNvPr id="4" name="Picture Placeholder 3">
-            <a:extLst>
-              <a:ext uri="{FF2B5EF4-FFF2-40B4-BE49-F238E27FC236}">
-                <a16:creationId xmlns:a16="http://schemas.microsoft.com/office/drawing/2014/main" id="{6821E55E-7402-9488-751D-96561C1FA26B}"/>
+          <p:cNvPr id="6" name="Image placeholder">
+            <a:extLst>
+              <a:ext uri="{FF2B5EF4-FFF2-40B4-BE49-F238E27FC236}">
+                <a16:creationId xmlns:a16="http://schemas.microsoft.com/office/drawing/2014/main" id="{EB16DF41-DA03-3463-7A2D-3D96D0034583}"/>
               </a:ext>
             </a:extLst>
           </p:cNvPr>
@@ -1842,8 +1842,8 @@
         </p:nvSpPr>
         <p:spPr>
           <a:xfrm>
-            <a:off x="544365" y="395288"/>
-            <a:ext cx="8044010" cy="4648052"/>
+            <a:off x="549995" y="471339"/>
+            <a:ext cx="8044729" cy="4817097"/>
           </a:xfrm>
         </p:spPr>
         <p:txBody>

</xml_diff>

<commit_message>
feature: fill a dated Mass from the Sunday calendar
</commit_message>
<xml_diff>
--- a/backend/data/template_4x3.pptx
+++ b/backend/data/template_4x3.pptx
@@ -401,7 +401,7 @@
           </a:xfrm>
         </p:spPr>
         <p:txBody>
-          <a:bodyPr>
+          <a:bodyPr anchor="ctr" anchorCtr="0">
             <a:noAutofit/>
           </a:bodyPr>
           <a:lstStyle>
@@ -455,9 +455,6 @@
               <a:rPr lang="pt-PT" dirty="0"/>
               <a:t>vem tomar parte na alegria do teu Senhor»</a:t>
             </a:r>
-          </a:p>
-          <a:p>
-            <a:endParaRPr lang="pt-PT" dirty="0"/>
           </a:p>
         </p:txBody>
       </p:sp>
@@ -552,10 +549,8 @@
               </a:ext>
             </a:extLst>
           </a:blip>
-          <a:srcRect l="2642" t="15589" r="2750" b="14655"/>
-          <a:stretch>
-            <a:fillRect/>
-          </a:stretch>
+          <a:srcRect t="47" b="47"/>
+          <a:stretch/>
         </p:blipFill>
         <p:spPr>
           <a:xfrm>
@@ -2329,89 +2324,6 @@
       </p:sp>
       <p:sp>
         <p:nvSpPr>
-          <p:cNvPr id="3" name="Frase">
-            <a:extLst>
-              <a:ext uri="{FF2B5EF4-FFF2-40B4-BE49-F238E27FC236}">
-                <a16:creationId xmlns:a16="http://schemas.microsoft.com/office/drawing/2014/main" id="{F5DEF8E5-A6D3-FF16-3A4C-6762958F1B84}"/>
-              </a:ext>
-            </a:extLst>
-          </p:cNvPr>
-          <p:cNvSpPr>
-            <a:spLocks noGrp="1"/>
-          </p:cNvSpPr>
-          <p:nvPr>
-            <p:ph type="subTitle" idx="1" hasCustomPrompt="1"/>
-          </p:nvPr>
-        </p:nvSpPr>
-        <p:spPr>
-          <a:xfrm>
-            <a:off x="494907" y="2525677"/>
-            <a:ext cx="8154186" cy="914255"/>
-          </a:xfrm>
-        </p:spPr>
-        <p:txBody>
-          <a:bodyPr>
-            <a:noAutofit/>
-          </a:bodyPr>
-          <a:lstStyle>
-            <a:lvl1pPr marL="0" indent="0" algn="ctr">
-              <a:buNone/>
-              <a:defRPr sz="2400">
-                <a:latin typeface="Shadows Into Light Two" panose="02000506000000020004" pitchFamily="2" charset="0"/>
-              </a:defRPr>
-            </a:lvl1pPr>
-            <a:lvl2pPr marL="342900" indent="0" algn="ctr">
-              <a:buNone/>
-              <a:defRPr sz="1500"/>
-            </a:lvl2pPr>
-            <a:lvl3pPr marL="685800" indent="0" algn="ctr">
-              <a:buNone/>
-              <a:defRPr sz="1350"/>
-            </a:lvl3pPr>
-            <a:lvl4pPr marL="1028700" indent="0" algn="ctr">
-              <a:buNone/>
-              <a:defRPr sz="1200"/>
-            </a:lvl4pPr>
-            <a:lvl5pPr marL="1371600" indent="0" algn="ctr">
-              <a:buNone/>
-              <a:defRPr sz="1200"/>
-            </a:lvl5pPr>
-            <a:lvl6pPr marL="1714500" indent="0" algn="ctr">
-              <a:buNone/>
-              <a:defRPr sz="1200"/>
-            </a:lvl6pPr>
-            <a:lvl7pPr marL="2057400" indent="0" algn="ctr">
-              <a:buNone/>
-              <a:defRPr sz="1200"/>
-            </a:lvl7pPr>
-            <a:lvl8pPr marL="2400300" indent="0" algn="ctr">
-              <a:buNone/>
-              <a:defRPr sz="1200"/>
-            </a:lvl8pPr>
-            <a:lvl9pPr marL="2743200" indent="0" algn="ctr">
-              <a:buNone/>
-              <a:defRPr sz="1200"/>
-            </a:lvl9pPr>
-          </a:lstStyle>
-          <a:p>
-            <a:r>
-              <a:rPr lang="pt-PT" dirty="0"/>
-              <a:t>«Foste fiel em coisas pequenas:</a:t>
-            </a:r>
-          </a:p>
-          <a:p>
-            <a:r>
-              <a:rPr lang="pt-PT" dirty="0"/>
-              <a:t>vem tomar parte na alegria do teu Senhor»</a:t>
-            </a:r>
-          </a:p>
-          <a:p>
-            <a:endParaRPr lang="pt-PT" dirty="0"/>
-          </a:p>
-        </p:txBody>
-      </p:sp>
-      <p:sp>
-        <p:nvSpPr>
           <p:cNvPr id="10" name="Versiculo">
             <a:extLst>
               <a:ext uri="{FF2B5EF4-FFF2-40B4-BE49-F238E27FC236}">
@@ -2501,7 +2413,7 @@
               </a:ext>
             </a:extLst>
           </a:blip>
-          <a:srcRect t="13134" b="13134"/>
+          <a:srcRect t="47" b="47"/>
           <a:stretch/>
         </p:blipFill>
         <p:spPr>
@@ -2582,6 +2494,86 @@
               <a:t>Ano A</a:t>
             </a:r>
             <a:endParaRPr lang="pt-PT" dirty="0"/>
+          </a:p>
+        </p:txBody>
+      </p:sp>
+      <p:sp>
+        <p:nvSpPr>
+          <p:cNvPr id="6" name="Frase">
+            <a:extLst>
+              <a:ext uri="{FF2B5EF4-FFF2-40B4-BE49-F238E27FC236}">
+                <a16:creationId xmlns:a16="http://schemas.microsoft.com/office/drawing/2014/main" id="{6F230E96-DA9A-242A-239B-91C6FC0D1E0D}"/>
+              </a:ext>
+            </a:extLst>
+          </p:cNvPr>
+          <p:cNvSpPr>
+            <a:spLocks noGrp="1"/>
+          </p:cNvSpPr>
+          <p:nvPr>
+            <p:ph type="subTitle" idx="1" hasCustomPrompt="1"/>
+          </p:nvPr>
+        </p:nvSpPr>
+        <p:spPr>
+          <a:xfrm>
+            <a:off x="494907" y="2525677"/>
+            <a:ext cx="8154186" cy="914255"/>
+          </a:xfrm>
+        </p:spPr>
+        <p:txBody>
+          <a:bodyPr anchor="ctr" anchorCtr="0">
+            <a:noAutofit/>
+          </a:bodyPr>
+          <a:lstStyle>
+            <a:lvl1pPr marL="0" indent="0" algn="ctr">
+              <a:buNone/>
+              <a:defRPr sz="2400">
+                <a:latin typeface="Shadows Into Light Two" panose="02000506000000020004" pitchFamily="2" charset="0"/>
+              </a:defRPr>
+            </a:lvl1pPr>
+            <a:lvl2pPr marL="342900" indent="0" algn="ctr">
+              <a:buNone/>
+              <a:defRPr sz="1500"/>
+            </a:lvl2pPr>
+            <a:lvl3pPr marL="685800" indent="0" algn="ctr">
+              <a:buNone/>
+              <a:defRPr sz="1350"/>
+            </a:lvl3pPr>
+            <a:lvl4pPr marL="1028700" indent="0" algn="ctr">
+              <a:buNone/>
+              <a:defRPr sz="1200"/>
+            </a:lvl4pPr>
+            <a:lvl5pPr marL="1371600" indent="0" algn="ctr">
+              <a:buNone/>
+              <a:defRPr sz="1200"/>
+            </a:lvl5pPr>
+            <a:lvl6pPr marL="1714500" indent="0" algn="ctr">
+              <a:buNone/>
+              <a:defRPr sz="1200"/>
+            </a:lvl6pPr>
+            <a:lvl7pPr marL="2057400" indent="0" algn="ctr">
+              <a:buNone/>
+              <a:defRPr sz="1200"/>
+            </a:lvl7pPr>
+            <a:lvl8pPr marL="2400300" indent="0" algn="ctr">
+              <a:buNone/>
+              <a:defRPr sz="1200"/>
+            </a:lvl8pPr>
+            <a:lvl9pPr marL="2743200" indent="0" algn="ctr">
+              <a:buNone/>
+              <a:defRPr sz="1200"/>
+            </a:lvl9pPr>
+          </a:lstStyle>
+          <a:p>
+            <a:r>
+              <a:rPr lang="pt-PT" dirty="0"/>
+              <a:t>«Foste fiel em coisas pequenas:</a:t>
+            </a:r>
+          </a:p>
+          <a:p>
+            <a:r>
+              <a:rPr lang="pt-PT" dirty="0"/>
+              <a:t>vem tomar parte na alegria do teu Senhor»</a:t>
+            </a:r>
           </a:p>
         </p:txBody>
       </p:sp>
@@ -4021,89 +4013,6 @@
       </p:sp>
       <p:sp>
         <p:nvSpPr>
-          <p:cNvPr id="3" name="Frase">
-            <a:extLst>
-              <a:ext uri="{FF2B5EF4-FFF2-40B4-BE49-F238E27FC236}">
-                <a16:creationId xmlns:a16="http://schemas.microsoft.com/office/drawing/2014/main" id="{F5DEF8E5-A6D3-FF16-3A4C-6762958F1B84}"/>
-              </a:ext>
-            </a:extLst>
-          </p:cNvPr>
-          <p:cNvSpPr>
-            <a:spLocks noGrp="1"/>
-          </p:cNvSpPr>
-          <p:nvPr>
-            <p:ph type="subTitle" idx="1" hasCustomPrompt="1"/>
-          </p:nvPr>
-        </p:nvSpPr>
-        <p:spPr>
-          <a:xfrm>
-            <a:off x="494907" y="2525677"/>
-            <a:ext cx="8154186" cy="914255"/>
-          </a:xfrm>
-        </p:spPr>
-        <p:txBody>
-          <a:bodyPr>
-            <a:noAutofit/>
-          </a:bodyPr>
-          <a:lstStyle>
-            <a:lvl1pPr marL="0" indent="0" algn="ctr">
-              <a:buNone/>
-              <a:defRPr sz="2400">
-                <a:latin typeface="Shadows Into Light Two" panose="02000506000000020004" pitchFamily="2" charset="0"/>
-              </a:defRPr>
-            </a:lvl1pPr>
-            <a:lvl2pPr marL="342900" indent="0" algn="ctr">
-              <a:buNone/>
-              <a:defRPr sz="1500"/>
-            </a:lvl2pPr>
-            <a:lvl3pPr marL="685800" indent="0" algn="ctr">
-              <a:buNone/>
-              <a:defRPr sz="1350"/>
-            </a:lvl3pPr>
-            <a:lvl4pPr marL="1028700" indent="0" algn="ctr">
-              <a:buNone/>
-              <a:defRPr sz="1200"/>
-            </a:lvl4pPr>
-            <a:lvl5pPr marL="1371600" indent="0" algn="ctr">
-              <a:buNone/>
-              <a:defRPr sz="1200"/>
-            </a:lvl5pPr>
-            <a:lvl6pPr marL="1714500" indent="0" algn="ctr">
-              <a:buNone/>
-              <a:defRPr sz="1200"/>
-            </a:lvl6pPr>
-            <a:lvl7pPr marL="2057400" indent="0" algn="ctr">
-              <a:buNone/>
-              <a:defRPr sz="1200"/>
-            </a:lvl7pPr>
-            <a:lvl8pPr marL="2400300" indent="0" algn="ctr">
-              <a:buNone/>
-              <a:defRPr sz="1200"/>
-            </a:lvl8pPr>
-            <a:lvl9pPr marL="2743200" indent="0" algn="ctr">
-              <a:buNone/>
-              <a:defRPr sz="1200"/>
-            </a:lvl9pPr>
-          </a:lstStyle>
-          <a:p>
-            <a:r>
-              <a:rPr lang="pt-PT" dirty="0"/>
-              <a:t>«Foste fiel em coisas pequenas:</a:t>
-            </a:r>
-          </a:p>
-          <a:p>
-            <a:r>
-              <a:rPr lang="pt-PT" dirty="0"/>
-              <a:t>vem tomar parte na alegria do teu Senhor»</a:t>
-            </a:r>
-          </a:p>
-          <a:p>
-            <a:endParaRPr lang="pt-PT" dirty="0"/>
-          </a:p>
-        </p:txBody>
-      </p:sp>
-      <p:sp>
-        <p:nvSpPr>
           <p:cNvPr id="10" name="Versiculo">
             <a:extLst>
               <a:ext uri="{FF2B5EF4-FFF2-40B4-BE49-F238E27FC236}">
@@ -4193,7 +4102,7 @@
               </a:ext>
             </a:extLst>
           </a:blip>
-          <a:srcRect t="13134" b="13134"/>
+          <a:srcRect t="47" b="47"/>
           <a:stretch/>
         </p:blipFill>
         <p:spPr>
@@ -4274,6 +4183,86 @@
               <a:t>Ano A</a:t>
             </a:r>
             <a:endParaRPr lang="pt-PT" dirty="0"/>
+          </a:p>
+        </p:txBody>
+      </p:sp>
+      <p:sp>
+        <p:nvSpPr>
+          <p:cNvPr id="6" name="Frase">
+            <a:extLst>
+              <a:ext uri="{FF2B5EF4-FFF2-40B4-BE49-F238E27FC236}">
+                <a16:creationId xmlns:a16="http://schemas.microsoft.com/office/drawing/2014/main" id="{FC7D14A6-6188-5DA5-548E-C9EB6ABA72AE}"/>
+              </a:ext>
+            </a:extLst>
+          </p:cNvPr>
+          <p:cNvSpPr>
+            <a:spLocks noGrp="1"/>
+          </p:cNvSpPr>
+          <p:nvPr>
+            <p:ph type="subTitle" idx="1" hasCustomPrompt="1"/>
+          </p:nvPr>
+        </p:nvSpPr>
+        <p:spPr>
+          <a:xfrm>
+            <a:off x="494907" y="2525677"/>
+            <a:ext cx="8154186" cy="914255"/>
+          </a:xfrm>
+        </p:spPr>
+        <p:txBody>
+          <a:bodyPr anchor="ctr" anchorCtr="0">
+            <a:noAutofit/>
+          </a:bodyPr>
+          <a:lstStyle>
+            <a:lvl1pPr marL="0" indent="0" algn="ctr">
+              <a:buNone/>
+              <a:defRPr sz="2400">
+                <a:latin typeface="Shadows Into Light Two" panose="02000506000000020004" pitchFamily="2" charset="0"/>
+              </a:defRPr>
+            </a:lvl1pPr>
+            <a:lvl2pPr marL="342900" indent="0" algn="ctr">
+              <a:buNone/>
+              <a:defRPr sz="1500"/>
+            </a:lvl2pPr>
+            <a:lvl3pPr marL="685800" indent="0" algn="ctr">
+              <a:buNone/>
+              <a:defRPr sz="1350"/>
+            </a:lvl3pPr>
+            <a:lvl4pPr marL="1028700" indent="0" algn="ctr">
+              <a:buNone/>
+              <a:defRPr sz="1200"/>
+            </a:lvl4pPr>
+            <a:lvl5pPr marL="1371600" indent="0" algn="ctr">
+              <a:buNone/>
+              <a:defRPr sz="1200"/>
+            </a:lvl5pPr>
+            <a:lvl6pPr marL="1714500" indent="0" algn="ctr">
+              <a:buNone/>
+              <a:defRPr sz="1200"/>
+            </a:lvl6pPr>
+            <a:lvl7pPr marL="2057400" indent="0" algn="ctr">
+              <a:buNone/>
+              <a:defRPr sz="1200"/>
+            </a:lvl7pPr>
+            <a:lvl8pPr marL="2400300" indent="0" algn="ctr">
+              <a:buNone/>
+              <a:defRPr sz="1200"/>
+            </a:lvl8pPr>
+            <a:lvl9pPr marL="2743200" indent="0" algn="ctr">
+              <a:buNone/>
+              <a:defRPr sz="1200"/>
+            </a:lvl9pPr>
+          </a:lstStyle>
+          <a:p>
+            <a:r>
+              <a:rPr lang="pt-PT" dirty="0"/>
+              <a:t>«Foste fiel em coisas pequenas:</a:t>
+            </a:r>
+          </a:p>
+          <a:p>
+            <a:r>
+              <a:rPr lang="pt-PT" dirty="0"/>
+              <a:t>vem tomar parte na alegria do teu Senhor»</a:t>
+            </a:r>
           </a:p>
         </p:txBody>
       </p:sp>
@@ -4782,6 +4771,1628 @@
     <p:extLst>
       <p:ext uri="{BB962C8B-B14F-4D97-AF65-F5344CB8AC3E}">
         <p14:creationId xmlns:p14="http://schemas.microsoft.com/office/powerpoint/2010/main" val="2545085859"/>
+      </p:ext>
+    </p:extLst>
+  </p:cSld>
+  <p:clrMapOvr>
+    <a:masterClrMapping/>
+  </p:clrMapOvr>
+</p:sldLayout>
+</file>
+
+<file path=ppt/slideLayouts/slideLayout35.xml><?xml version="1.0" encoding="utf-8"?>
+<p:sldLayout xmlns:a="http://schemas.openxmlformats.org/drawingml/2006/main" xmlns:r="http://schemas.openxmlformats.org/officeDocument/2006/relationships" xmlns:p="http://schemas.openxmlformats.org/presentationml/2006/main" preserve="1" userDrawn="1">
+  <p:cSld name="Leitura 1">
+    <p:bg>
+      <p:bgPr>
+        <a:blipFill dpi="0" rotWithShape="1">
+          <a:blip r:embed="rId2">
+            <a:lum/>
+          </a:blip>
+          <a:srcRect/>
+          <a:stretch>
+            <a:fillRect/>
+          </a:stretch>
+        </a:blipFill>
+        <a:effectLst/>
+      </p:bgPr>
+    </p:bg>
+    <p:spTree>
+      <p:nvGrpSpPr>
+        <p:cNvPr id="1" name=""/>
+        <p:cNvGrpSpPr/>
+        <p:nvPr/>
+      </p:nvGrpSpPr>
+      <p:grpSpPr>
+        <a:xfrm>
+          <a:off x="0" y="0"/>
+          <a:ext cx="0" cy="0"/>
+          <a:chOff x="0" y="0"/>
+          <a:chExt cx="0" cy="0"/>
+        </a:xfrm>
+      </p:grpSpPr>
+      <p:sp>
+        <p:nvSpPr>
+          <p:cNvPr id="2" name="Referência">
+            <a:extLst>
+              <a:ext uri="{FF2B5EF4-FFF2-40B4-BE49-F238E27FC236}">
+                <a16:creationId xmlns:a16="http://schemas.microsoft.com/office/drawing/2014/main" id="{29D85961-FC26-87D6-F7CF-D2E332EB5E80}"/>
+              </a:ext>
+            </a:extLst>
+          </p:cNvPr>
+          <p:cNvSpPr>
+            <a:spLocks noGrp="1"/>
+          </p:cNvSpPr>
+          <p:nvPr>
+            <p:ph type="title" hasCustomPrompt="1"/>
+          </p:nvPr>
+        </p:nvSpPr>
+        <p:spPr>
+          <a:xfrm>
+            <a:off x="444680" y="1225489"/>
+            <a:ext cx="8254640" cy="443054"/>
+          </a:xfrm>
+        </p:spPr>
+        <p:txBody>
+          <a:bodyPr wrap="square" anchor="t" anchorCtr="0">
+            <a:normAutofit/>
+          </a:bodyPr>
+          <a:lstStyle>
+            <a:lvl1pPr algn="ctr">
+              <a:defRPr lang="pt-PT" sz="2400" b="0" i="0" cap="small" spc="0" baseline="0" smtClean="0">
+                <a:solidFill>
+                  <a:schemeClr val="accent1">
+                    <a:lumMod val="75000"/>
+                  </a:schemeClr>
+                </a:solidFill>
+                <a:effectLst/>
+                <a:latin typeface="Livvic" pitchFamily="2" charset="0"/>
+                <a:cs typeface="Leelawadee UI Semilight" panose="020B0402040204020203" pitchFamily="34" charset="-34"/>
+              </a:defRPr>
+            </a:lvl1pPr>
+          </a:lstStyle>
+          <a:p>
+            <a:r>
+              <a:rPr lang="pt-PT" dirty="0"/>
+              <a:t>Is 45, 1.4-6</a:t>
+            </a:r>
+          </a:p>
+        </p:txBody>
+      </p:sp>
+      <p:sp>
+        <p:nvSpPr>
+          <p:cNvPr id="3" name="Citação">
+            <a:extLst>
+              <a:ext uri="{FF2B5EF4-FFF2-40B4-BE49-F238E27FC236}">
+                <a16:creationId xmlns:a16="http://schemas.microsoft.com/office/drawing/2014/main" id="{7FBA5054-2BE0-6B52-7485-0B10968F39E5}"/>
+              </a:ext>
+            </a:extLst>
+          </p:cNvPr>
+          <p:cNvSpPr>
+            <a:spLocks noGrp="1"/>
+          </p:cNvSpPr>
+          <p:nvPr>
+            <p:ph idx="1" hasCustomPrompt="1"/>
+          </p:nvPr>
+        </p:nvSpPr>
+        <p:spPr>
+          <a:xfrm>
+            <a:off x="444680" y="1800202"/>
+            <a:ext cx="8254639" cy="4638305"/>
+          </a:xfrm>
+        </p:spPr>
+        <p:txBody>
+          <a:bodyPr tIns="0" anchor="ctr" anchorCtr="1">
+            <a:normAutofit/>
+          </a:bodyPr>
+          <a:lstStyle>
+            <a:lvl1pPr marL="0" marR="0" indent="0" algn="ctr" defTabSz="685800" rtl="0" eaLnBrk="1" fontAlgn="auto" latinLnBrk="0" hangingPunct="1">
+              <a:lnSpc>
+                <a:spcPct val="130000"/>
+              </a:lnSpc>
+              <a:spcBef>
+                <a:spcPts val="0"/>
+              </a:spcBef>
+              <a:spcAft>
+                <a:spcPts val="0"/>
+              </a:spcAft>
+              <a:buClrTx/>
+              <a:buSzTx/>
+              <a:buFont typeface="Arial" panose="020B0604020202020204" pitchFamily="34" charset="0"/>
+              <a:buNone/>
+              <a:tabLst/>
+              <a:defRPr lang="pt-PT" sz="4000" b="0" i="0" smtClean="0">
+                <a:solidFill>
+                  <a:schemeClr val="accent1">
+                    <a:lumMod val="75000"/>
+                  </a:schemeClr>
+                </a:solidFill>
+                <a:effectLst/>
+                <a:latin typeface="Livvic" pitchFamily="2" charset="0"/>
+              </a:defRPr>
+            </a:lvl1pPr>
+            <a:lvl2pPr algn="ctr">
+              <a:defRPr/>
+            </a:lvl2pPr>
+            <a:lvl3pPr algn="ctr">
+              <a:defRPr/>
+            </a:lvl3pPr>
+            <a:lvl4pPr algn="ctr">
+              <a:defRPr/>
+            </a:lvl4pPr>
+            <a:lvl5pPr algn="ctr">
+              <a:defRPr/>
+            </a:lvl5pPr>
+          </a:lstStyle>
+          <a:p>
+            <a:pPr marL="0" marR="0" lvl="0" indent="0" algn="ctr" defTabSz="685800" rtl="0" eaLnBrk="1" fontAlgn="auto" latinLnBrk="0" hangingPunct="1">
+              <a:lnSpc>
+                <a:spcPct val="130000"/>
+              </a:lnSpc>
+              <a:spcBef>
+                <a:spcPts val="0"/>
+              </a:spcBef>
+              <a:spcAft>
+                <a:spcPts val="0"/>
+              </a:spcAft>
+              <a:buClrTx/>
+              <a:buSzTx/>
+              <a:buFont typeface="Arial" panose="020B0604020202020204" pitchFamily="34" charset="0"/>
+              <a:buNone/>
+              <a:tabLst/>
+              <a:defRPr/>
+            </a:pPr>
+            <a:r>
+              <a:rPr lang="pt-PT" dirty="0"/>
+              <a:t>«Tomei Ciro pela mão direita para subjugar diante dele as nações»</a:t>
+            </a:r>
+          </a:p>
+        </p:txBody>
+      </p:sp>
+      <p:sp>
+        <p:nvSpPr>
+          <p:cNvPr id="4" name="TextBox 3">
+            <a:extLst>
+              <a:ext uri="{FF2B5EF4-FFF2-40B4-BE49-F238E27FC236}">
+                <a16:creationId xmlns:a16="http://schemas.microsoft.com/office/drawing/2014/main" id="{1A16EFAF-C0B6-AE3C-0C51-0F0A4C760F06}"/>
+              </a:ext>
+            </a:extLst>
+          </p:cNvPr>
+          <p:cNvSpPr txBox="1"/>
+          <p:nvPr userDrawn="1"/>
+        </p:nvSpPr>
+        <p:spPr>
+          <a:xfrm>
+            <a:off x="2526384" y="282806"/>
+            <a:ext cx="4091233" cy="707886"/>
+          </a:xfrm>
+          <a:prstGeom prst="rect">
+            <a:avLst/>
+          </a:prstGeom>
+          <a:noFill/>
+        </p:spPr>
+        <p:txBody>
+          <a:bodyPr wrap="square" rtlCol="0">
+            <a:spAutoFit/>
+          </a:bodyPr>
+          <a:lstStyle/>
+          <a:p>
+            <a:pPr algn="ctr"/>
+            <a:r>
+              <a:rPr lang="pt-PT" sz="4000" b="0" i="0" u="none" cap="small" spc="600" baseline="0" dirty="0">
+                <a:solidFill>
+                  <a:schemeClr val="accent1">
+                    <a:lumMod val="50000"/>
+                  </a:schemeClr>
+                </a:solidFill>
+                <a:latin typeface="+mj-lt"/>
+              </a:rPr>
+              <a:t>1ª Leitura</a:t>
+            </a:r>
+          </a:p>
+        </p:txBody>
+      </p:sp>
+      <p:cxnSp>
+        <p:nvCxnSpPr>
+          <p:cNvPr id="8" name="Straight Connector 7">
+            <a:extLst>
+              <a:ext uri="{FF2B5EF4-FFF2-40B4-BE49-F238E27FC236}">
+                <a16:creationId xmlns:a16="http://schemas.microsoft.com/office/drawing/2014/main" id="{27959F69-8FA1-3D7A-1069-6CBFA7DEDAA9}"/>
+              </a:ext>
+            </a:extLst>
+          </p:cNvPr>
+          <p:cNvCxnSpPr>
+            <a:cxnSpLocks/>
+          </p:cNvCxnSpPr>
+          <p:nvPr userDrawn="1"/>
+        </p:nvCxnSpPr>
+        <p:spPr>
+          <a:xfrm flipH="1">
+            <a:off x="444680" y="1093829"/>
+            <a:ext cx="8254639" cy="0"/>
+          </a:xfrm>
+          <a:prstGeom prst="line">
+            <a:avLst/>
+          </a:prstGeom>
+          <a:ln w="19050">
+            <a:solidFill>
+              <a:schemeClr val="accent1">
+                <a:lumMod val="50000"/>
+              </a:schemeClr>
+            </a:solidFill>
+          </a:ln>
+        </p:spPr>
+        <p:style>
+          <a:lnRef idx="1">
+            <a:schemeClr val="accent1"/>
+          </a:lnRef>
+          <a:fillRef idx="0">
+            <a:schemeClr val="accent1"/>
+          </a:fillRef>
+          <a:effectRef idx="0">
+            <a:schemeClr val="accent1"/>
+          </a:effectRef>
+          <a:fontRef idx="minor">
+            <a:schemeClr val="tx1"/>
+          </a:fontRef>
+        </p:style>
+      </p:cxnSp>
+    </p:spTree>
+    <p:extLst>
+      <p:ext uri="{BB962C8B-B14F-4D97-AF65-F5344CB8AC3E}">
+        <p14:creationId xmlns:p14="http://schemas.microsoft.com/office/powerpoint/2010/main" val="4184228895"/>
+      </p:ext>
+    </p:extLst>
+  </p:cSld>
+  <p:clrMapOvr>
+    <a:masterClrMapping/>
+  </p:clrMapOvr>
+</p:sldLayout>
+</file>
+
+<file path=ppt/slideLayouts/slideLayout36.xml><?xml version="1.0" encoding="utf-8"?>
+<p:sldLayout xmlns:a="http://schemas.openxmlformats.org/drawingml/2006/main" xmlns:r="http://schemas.openxmlformats.org/officeDocument/2006/relationships" xmlns:p="http://schemas.openxmlformats.org/presentationml/2006/main" preserve="1" userDrawn="1">
+  <p:cSld name="Salmo">
+    <p:bg>
+      <p:bgPr>
+        <a:blipFill dpi="0" rotWithShape="1">
+          <a:blip r:embed="rId2">
+            <a:lum/>
+          </a:blip>
+          <a:srcRect/>
+          <a:stretch>
+            <a:fillRect/>
+          </a:stretch>
+        </a:blipFill>
+        <a:effectLst/>
+      </p:bgPr>
+    </p:bg>
+    <p:spTree>
+      <p:nvGrpSpPr>
+        <p:cNvPr id="1" name=""/>
+        <p:cNvGrpSpPr/>
+        <p:nvPr/>
+      </p:nvGrpSpPr>
+      <p:grpSpPr>
+        <a:xfrm>
+          <a:off x="0" y="0"/>
+          <a:ext cx="0" cy="0"/>
+          <a:chOff x="0" y="0"/>
+          <a:chExt cx="0" cy="0"/>
+        </a:xfrm>
+      </p:grpSpPr>
+      <p:sp>
+        <p:nvSpPr>
+          <p:cNvPr id="3" name="Citação">
+            <a:extLst>
+              <a:ext uri="{FF2B5EF4-FFF2-40B4-BE49-F238E27FC236}">
+                <a16:creationId xmlns:a16="http://schemas.microsoft.com/office/drawing/2014/main" id="{7FBA5054-2BE0-6B52-7485-0B10968F39E5}"/>
+              </a:ext>
+            </a:extLst>
+          </p:cNvPr>
+          <p:cNvSpPr>
+            <a:spLocks noGrp="1"/>
+          </p:cNvSpPr>
+          <p:nvPr>
+            <p:ph idx="1" hasCustomPrompt="1"/>
+          </p:nvPr>
+        </p:nvSpPr>
+        <p:spPr>
+          <a:xfrm>
+            <a:off x="444680" y="1517716"/>
+            <a:ext cx="8254639" cy="4826523"/>
+          </a:xfrm>
+        </p:spPr>
+        <p:txBody>
+          <a:bodyPr tIns="0" anchor="ctr" anchorCtr="1">
+            <a:normAutofit/>
+          </a:bodyPr>
+          <a:lstStyle>
+            <a:lvl1pPr marL="0" marR="0" indent="0" algn="ctr" defTabSz="685800" rtl="0" eaLnBrk="1" fontAlgn="auto" latinLnBrk="0" hangingPunct="1">
+              <a:lnSpc>
+                <a:spcPct val="130000"/>
+              </a:lnSpc>
+              <a:spcBef>
+                <a:spcPts val="0"/>
+              </a:spcBef>
+              <a:spcAft>
+                <a:spcPts val="0"/>
+              </a:spcAft>
+              <a:buClrTx/>
+              <a:buSzTx/>
+              <a:buFont typeface="Arial" panose="020B0604020202020204" pitchFamily="34" charset="0"/>
+              <a:buNone/>
+              <a:tabLst/>
+              <a:defRPr lang="pt-PT" sz="4000" b="0" i="0" smtClean="0">
+                <a:solidFill>
+                  <a:schemeClr val="accent1">
+                    <a:lumMod val="75000"/>
+                  </a:schemeClr>
+                </a:solidFill>
+                <a:effectLst/>
+                <a:latin typeface="Livvic" pitchFamily="2" charset="0"/>
+              </a:defRPr>
+            </a:lvl1pPr>
+            <a:lvl2pPr algn="ctr">
+              <a:defRPr/>
+            </a:lvl2pPr>
+            <a:lvl3pPr algn="ctr">
+              <a:defRPr/>
+            </a:lvl3pPr>
+            <a:lvl4pPr algn="ctr">
+              <a:defRPr/>
+            </a:lvl4pPr>
+            <a:lvl5pPr algn="ctr">
+              <a:defRPr/>
+            </a:lvl5pPr>
+          </a:lstStyle>
+          <a:p>
+            <a:pPr marL="0" marR="0" lvl="0" indent="0" algn="ctr" defTabSz="685800" rtl="0" eaLnBrk="1" fontAlgn="auto" latinLnBrk="0" hangingPunct="1">
+              <a:lnSpc>
+                <a:spcPct val="130000"/>
+              </a:lnSpc>
+              <a:spcBef>
+                <a:spcPts val="0"/>
+              </a:spcBef>
+              <a:spcAft>
+                <a:spcPts val="0"/>
+              </a:spcAft>
+              <a:buClrTx/>
+              <a:buSzTx/>
+              <a:buFont typeface="Arial" panose="020B0604020202020204" pitchFamily="34" charset="0"/>
+              <a:buNone/>
+              <a:tabLst/>
+              <a:defRPr/>
+            </a:pPr>
+            <a:r>
+              <a:rPr lang="en-US" dirty="0" err="1"/>
+              <a:t>Hoje</a:t>
+            </a:r>
+            <a:r>
+              <a:rPr lang="en-US" dirty="0"/>
+              <a:t> se </a:t>
+            </a:r>
+            <a:r>
+              <a:rPr lang="en-US" dirty="0" err="1"/>
+              <a:t>escutardes</a:t>
+            </a:r>
+            <a:r>
+              <a:rPr lang="en-US" dirty="0"/>
+              <a:t> a </a:t>
+            </a:r>
+            <a:r>
+              <a:rPr lang="en-US" dirty="0" err="1"/>
+              <a:t>voz</a:t>
+            </a:r>
+            <a:r>
+              <a:rPr lang="en-US" dirty="0"/>
+              <a:t> do Senhor, </a:t>
+            </a:r>
+            <a:r>
+              <a:rPr lang="en-US" dirty="0" err="1"/>
+              <a:t>não</a:t>
+            </a:r>
+            <a:r>
+              <a:rPr lang="en-US" dirty="0"/>
+              <a:t> </a:t>
+            </a:r>
+            <a:r>
+              <a:rPr lang="en-US" dirty="0" err="1"/>
+              <a:t>fecheis</a:t>
+            </a:r>
+            <a:r>
+              <a:rPr lang="en-US" dirty="0"/>
+              <a:t> </a:t>
+            </a:r>
+            <a:r>
+              <a:rPr lang="en-US" dirty="0" err="1"/>
+              <a:t>os</a:t>
+            </a:r>
+            <a:r>
+              <a:rPr lang="en-US" dirty="0"/>
+              <a:t> </a:t>
+            </a:r>
+            <a:r>
+              <a:rPr lang="en-US" dirty="0" err="1"/>
+              <a:t>vossos</a:t>
+            </a:r>
+            <a:r>
+              <a:rPr lang="en-US" dirty="0"/>
+              <a:t> </a:t>
+            </a:r>
+            <a:r>
+              <a:rPr lang="en-US" dirty="0" err="1"/>
+              <a:t>corações</a:t>
+            </a:r>
+            <a:r>
+              <a:rPr lang="en-US" dirty="0"/>
+              <a:t>, </a:t>
+            </a:r>
+            <a:r>
+              <a:rPr lang="en-US" dirty="0" err="1"/>
+              <a:t>não</a:t>
+            </a:r>
+            <a:r>
+              <a:rPr lang="en-US" dirty="0"/>
+              <a:t> </a:t>
+            </a:r>
+            <a:r>
+              <a:rPr lang="en-US" dirty="0" err="1"/>
+              <a:t>fecheis</a:t>
+            </a:r>
+            <a:r>
+              <a:rPr lang="en-US" dirty="0"/>
+              <a:t> </a:t>
+            </a:r>
+            <a:r>
+              <a:rPr lang="en-US" dirty="0" err="1"/>
+              <a:t>os</a:t>
+            </a:r>
+            <a:r>
+              <a:rPr lang="en-US" dirty="0"/>
+              <a:t> </a:t>
+            </a:r>
+            <a:r>
+              <a:rPr lang="en-US" dirty="0" err="1"/>
+              <a:t>vossos</a:t>
+            </a:r>
+            <a:r>
+              <a:rPr lang="en-US" dirty="0"/>
+              <a:t> </a:t>
+            </a:r>
+            <a:r>
+              <a:rPr lang="en-US" dirty="0" err="1"/>
+              <a:t>corações</a:t>
+            </a:r>
+            <a:r>
+              <a:rPr lang="en-US" dirty="0"/>
+              <a:t>.</a:t>
+            </a:r>
+            <a:endParaRPr lang="pt-PT" dirty="0"/>
+          </a:p>
+        </p:txBody>
+      </p:sp>
+      <p:sp>
+        <p:nvSpPr>
+          <p:cNvPr id="4" name="TextBox 3">
+            <a:extLst>
+              <a:ext uri="{FF2B5EF4-FFF2-40B4-BE49-F238E27FC236}">
+                <a16:creationId xmlns:a16="http://schemas.microsoft.com/office/drawing/2014/main" id="{1A16EFAF-C0B6-AE3C-0C51-0F0A4C760F06}"/>
+              </a:ext>
+            </a:extLst>
+          </p:cNvPr>
+          <p:cNvSpPr txBox="1"/>
+          <p:nvPr userDrawn="1"/>
+        </p:nvSpPr>
+        <p:spPr>
+          <a:xfrm>
+            <a:off x="2026763" y="282806"/>
+            <a:ext cx="5090474" cy="707886"/>
+          </a:xfrm>
+          <a:prstGeom prst="rect">
+            <a:avLst/>
+          </a:prstGeom>
+          <a:noFill/>
+        </p:spPr>
+        <p:txBody>
+          <a:bodyPr wrap="square" rtlCol="0">
+            <a:spAutoFit/>
+          </a:bodyPr>
+          <a:lstStyle/>
+          <a:p>
+            <a:pPr algn="ctr"/>
+            <a:r>
+              <a:rPr lang="en-US" sz="4000" b="0" i="0" u="none" cap="small" baseline="0" dirty="0">
+                <a:solidFill>
+                  <a:schemeClr val="accent1">
+                    <a:lumMod val="50000"/>
+                  </a:schemeClr>
+                </a:solidFill>
+                <a:latin typeface="+mj-lt"/>
+              </a:rPr>
+              <a:t>Salmo Responsorial</a:t>
+            </a:r>
+            <a:endParaRPr lang="pt-PT" sz="4000" b="0" i="0" u="none" cap="small" baseline="0" dirty="0">
+              <a:solidFill>
+                <a:schemeClr val="accent1">
+                  <a:lumMod val="50000"/>
+                </a:schemeClr>
+              </a:solidFill>
+              <a:latin typeface="+mj-lt"/>
+            </a:endParaRPr>
+          </a:p>
+        </p:txBody>
+      </p:sp>
+      <p:cxnSp>
+        <p:nvCxnSpPr>
+          <p:cNvPr id="6" name="Straight Connector 5">
+            <a:extLst>
+              <a:ext uri="{FF2B5EF4-FFF2-40B4-BE49-F238E27FC236}">
+                <a16:creationId xmlns:a16="http://schemas.microsoft.com/office/drawing/2014/main" id="{5F9CA452-C242-8E24-21E2-C455200B6F79}"/>
+              </a:ext>
+            </a:extLst>
+          </p:cNvPr>
+          <p:cNvCxnSpPr>
+            <a:cxnSpLocks/>
+          </p:cNvCxnSpPr>
+          <p:nvPr userDrawn="1"/>
+        </p:nvCxnSpPr>
+        <p:spPr>
+          <a:xfrm flipH="1">
+            <a:off x="444680" y="1093829"/>
+            <a:ext cx="8254639" cy="0"/>
+          </a:xfrm>
+          <a:prstGeom prst="line">
+            <a:avLst/>
+          </a:prstGeom>
+          <a:ln w="19050">
+            <a:solidFill>
+              <a:schemeClr val="accent1">
+                <a:lumMod val="50000"/>
+              </a:schemeClr>
+            </a:solidFill>
+          </a:ln>
+        </p:spPr>
+        <p:style>
+          <a:lnRef idx="1">
+            <a:schemeClr val="accent1"/>
+          </a:lnRef>
+          <a:fillRef idx="0">
+            <a:schemeClr val="accent1"/>
+          </a:fillRef>
+          <a:effectRef idx="0">
+            <a:schemeClr val="accent1"/>
+          </a:effectRef>
+          <a:fontRef idx="minor">
+            <a:schemeClr val="tx1"/>
+          </a:fontRef>
+        </p:style>
+      </p:cxnSp>
+    </p:spTree>
+    <p:extLst>
+      <p:ext uri="{BB962C8B-B14F-4D97-AF65-F5344CB8AC3E}">
+        <p14:creationId xmlns:p14="http://schemas.microsoft.com/office/powerpoint/2010/main" val="1743359995"/>
+      </p:ext>
+    </p:extLst>
+  </p:cSld>
+  <p:clrMapOvr>
+    <a:masterClrMapping/>
+  </p:clrMapOvr>
+</p:sldLayout>
+</file>
+
+<file path=ppt/slideLayouts/slideLayout37.xml><?xml version="1.0" encoding="utf-8"?>
+<p:sldLayout xmlns:a="http://schemas.openxmlformats.org/drawingml/2006/main" xmlns:r="http://schemas.openxmlformats.org/officeDocument/2006/relationships" xmlns:p="http://schemas.openxmlformats.org/presentationml/2006/main" preserve="1" userDrawn="1">
+  <p:cSld name="Leitura 2">
+    <p:bg>
+      <p:bgPr>
+        <a:blipFill dpi="0" rotWithShape="1">
+          <a:blip r:embed="rId2">
+            <a:lum/>
+          </a:blip>
+          <a:srcRect/>
+          <a:stretch>
+            <a:fillRect/>
+          </a:stretch>
+        </a:blipFill>
+        <a:effectLst/>
+      </p:bgPr>
+    </p:bg>
+    <p:spTree>
+      <p:nvGrpSpPr>
+        <p:cNvPr id="1" name=""/>
+        <p:cNvGrpSpPr/>
+        <p:nvPr/>
+      </p:nvGrpSpPr>
+      <p:grpSpPr>
+        <a:xfrm>
+          <a:off x="0" y="0"/>
+          <a:ext cx="0" cy="0"/>
+          <a:chOff x="0" y="0"/>
+          <a:chExt cx="0" cy="0"/>
+        </a:xfrm>
+      </p:grpSpPr>
+      <p:sp>
+        <p:nvSpPr>
+          <p:cNvPr id="2" name="Referência">
+            <a:extLst>
+              <a:ext uri="{FF2B5EF4-FFF2-40B4-BE49-F238E27FC236}">
+                <a16:creationId xmlns:a16="http://schemas.microsoft.com/office/drawing/2014/main" id="{29D85961-FC26-87D6-F7CF-D2E332EB5E80}"/>
+              </a:ext>
+            </a:extLst>
+          </p:cNvPr>
+          <p:cNvSpPr>
+            <a:spLocks noGrp="1"/>
+          </p:cNvSpPr>
+          <p:nvPr>
+            <p:ph type="title" hasCustomPrompt="1"/>
+          </p:nvPr>
+        </p:nvSpPr>
+        <p:spPr>
+          <a:xfrm>
+            <a:off x="444680" y="1225489"/>
+            <a:ext cx="8254640" cy="443054"/>
+          </a:xfrm>
+        </p:spPr>
+        <p:txBody>
+          <a:bodyPr wrap="square" anchor="t" anchorCtr="0">
+            <a:normAutofit/>
+          </a:bodyPr>
+          <a:lstStyle>
+            <a:lvl1pPr algn="ctr">
+              <a:defRPr lang="pt-PT" sz="2400" b="0" i="0" cap="small" spc="0" baseline="0" smtClean="0">
+                <a:solidFill>
+                  <a:schemeClr val="accent1">
+                    <a:lumMod val="75000"/>
+                  </a:schemeClr>
+                </a:solidFill>
+                <a:effectLst/>
+                <a:latin typeface="Livvic" pitchFamily="2" charset="0"/>
+                <a:cs typeface="Leelawadee UI Semilight" panose="020B0402040204020203" pitchFamily="34" charset="-34"/>
+              </a:defRPr>
+            </a:lvl1pPr>
+          </a:lstStyle>
+          <a:p>
+            <a:r>
+              <a:rPr lang="pt-PT" dirty="0"/>
+              <a:t>Is 45, 1.4-6</a:t>
+            </a:r>
+          </a:p>
+        </p:txBody>
+      </p:sp>
+      <p:sp>
+        <p:nvSpPr>
+          <p:cNvPr id="3" name="Citação">
+            <a:extLst>
+              <a:ext uri="{FF2B5EF4-FFF2-40B4-BE49-F238E27FC236}">
+                <a16:creationId xmlns:a16="http://schemas.microsoft.com/office/drawing/2014/main" id="{7FBA5054-2BE0-6B52-7485-0B10968F39E5}"/>
+              </a:ext>
+            </a:extLst>
+          </p:cNvPr>
+          <p:cNvSpPr>
+            <a:spLocks noGrp="1"/>
+          </p:cNvSpPr>
+          <p:nvPr>
+            <p:ph idx="1" hasCustomPrompt="1"/>
+          </p:nvPr>
+        </p:nvSpPr>
+        <p:spPr>
+          <a:xfrm>
+            <a:off x="444680" y="1800202"/>
+            <a:ext cx="8254639" cy="4638305"/>
+          </a:xfrm>
+        </p:spPr>
+        <p:txBody>
+          <a:bodyPr tIns="0" anchor="ctr" anchorCtr="1">
+            <a:normAutofit/>
+          </a:bodyPr>
+          <a:lstStyle>
+            <a:lvl1pPr marL="0" marR="0" indent="0" algn="ctr" defTabSz="685800" rtl="0" eaLnBrk="1" fontAlgn="auto" latinLnBrk="0" hangingPunct="1">
+              <a:lnSpc>
+                <a:spcPct val="130000"/>
+              </a:lnSpc>
+              <a:spcBef>
+                <a:spcPts val="0"/>
+              </a:spcBef>
+              <a:spcAft>
+                <a:spcPts val="0"/>
+              </a:spcAft>
+              <a:buClrTx/>
+              <a:buSzTx/>
+              <a:buFont typeface="Arial" panose="020B0604020202020204" pitchFamily="34" charset="0"/>
+              <a:buNone/>
+              <a:tabLst/>
+              <a:defRPr lang="pt-PT" sz="4000" b="0" i="0" smtClean="0">
+                <a:solidFill>
+                  <a:schemeClr val="accent1">
+                    <a:lumMod val="75000"/>
+                  </a:schemeClr>
+                </a:solidFill>
+                <a:effectLst/>
+                <a:latin typeface="Livvic" pitchFamily="2" charset="0"/>
+              </a:defRPr>
+            </a:lvl1pPr>
+            <a:lvl2pPr algn="ctr">
+              <a:defRPr/>
+            </a:lvl2pPr>
+            <a:lvl3pPr algn="ctr">
+              <a:defRPr/>
+            </a:lvl3pPr>
+            <a:lvl4pPr algn="ctr">
+              <a:defRPr/>
+            </a:lvl4pPr>
+            <a:lvl5pPr algn="ctr">
+              <a:defRPr/>
+            </a:lvl5pPr>
+          </a:lstStyle>
+          <a:p>
+            <a:pPr marL="0" marR="0" lvl="0" indent="0" algn="ctr" defTabSz="685800" rtl="0" eaLnBrk="1" fontAlgn="auto" latinLnBrk="0" hangingPunct="1">
+              <a:lnSpc>
+                <a:spcPct val="130000"/>
+              </a:lnSpc>
+              <a:spcBef>
+                <a:spcPts val="0"/>
+              </a:spcBef>
+              <a:spcAft>
+                <a:spcPts val="0"/>
+              </a:spcAft>
+              <a:buClrTx/>
+              <a:buSzTx/>
+              <a:buFont typeface="Arial" panose="020B0604020202020204" pitchFamily="34" charset="0"/>
+              <a:buNone/>
+              <a:tabLst/>
+              <a:defRPr/>
+            </a:pPr>
+            <a:r>
+              <a:rPr lang="pt-PT" dirty="0"/>
+              <a:t>«Tomei Ciro pela mão direita para subjugar diante dele as nações»</a:t>
+            </a:r>
+          </a:p>
+        </p:txBody>
+      </p:sp>
+      <p:sp>
+        <p:nvSpPr>
+          <p:cNvPr id="4" name="TextBox 3">
+            <a:extLst>
+              <a:ext uri="{FF2B5EF4-FFF2-40B4-BE49-F238E27FC236}">
+                <a16:creationId xmlns:a16="http://schemas.microsoft.com/office/drawing/2014/main" id="{1A16EFAF-C0B6-AE3C-0C51-0F0A4C760F06}"/>
+              </a:ext>
+            </a:extLst>
+          </p:cNvPr>
+          <p:cNvSpPr txBox="1"/>
+          <p:nvPr userDrawn="1"/>
+        </p:nvSpPr>
+        <p:spPr>
+          <a:xfrm>
+            <a:off x="2526384" y="282806"/>
+            <a:ext cx="4091233" cy="707886"/>
+          </a:xfrm>
+          <a:prstGeom prst="rect">
+            <a:avLst/>
+          </a:prstGeom>
+          <a:noFill/>
+        </p:spPr>
+        <p:txBody>
+          <a:bodyPr wrap="square" rtlCol="0">
+            <a:spAutoFit/>
+          </a:bodyPr>
+          <a:lstStyle/>
+          <a:p>
+            <a:pPr algn="ctr"/>
+            <a:r>
+              <a:rPr lang="pt-PT" sz="4000" b="0" i="0" u="none" cap="small" spc="600" baseline="0" dirty="0">
+                <a:solidFill>
+                  <a:schemeClr val="accent1">
+                    <a:lumMod val="50000"/>
+                  </a:schemeClr>
+                </a:solidFill>
+                <a:latin typeface="+mj-lt"/>
+              </a:rPr>
+              <a:t>2ª Leitura</a:t>
+            </a:r>
+          </a:p>
+        </p:txBody>
+      </p:sp>
+      <p:cxnSp>
+        <p:nvCxnSpPr>
+          <p:cNvPr id="8" name="Straight Connector 7">
+            <a:extLst>
+              <a:ext uri="{FF2B5EF4-FFF2-40B4-BE49-F238E27FC236}">
+                <a16:creationId xmlns:a16="http://schemas.microsoft.com/office/drawing/2014/main" id="{27959F69-8FA1-3D7A-1069-6CBFA7DEDAA9}"/>
+              </a:ext>
+            </a:extLst>
+          </p:cNvPr>
+          <p:cNvCxnSpPr>
+            <a:cxnSpLocks/>
+          </p:cNvCxnSpPr>
+          <p:nvPr userDrawn="1"/>
+        </p:nvCxnSpPr>
+        <p:spPr>
+          <a:xfrm flipH="1">
+            <a:off x="444680" y="1093829"/>
+            <a:ext cx="8254639" cy="0"/>
+          </a:xfrm>
+          <a:prstGeom prst="line">
+            <a:avLst/>
+          </a:prstGeom>
+          <a:ln w="19050">
+            <a:solidFill>
+              <a:schemeClr val="accent1">
+                <a:lumMod val="50000"/>
+              </a:schemeClr>
+            </a:solidFill>
+          </a:ln>
+        </p:spPr>
+        <p:style>
+          <a:lnRef idx="1">
+            <a:schemeClr val="accent1"/>
+          </a:lnRef>
+          <a:fillRef idx="0">
+            <a:schemeClr val="accent1"/>
+          </a:fillRef>
+          <a:effectRef idx="0">
+            <a:schemeClr val="accent1"/>
+          </a:effectRef>
+          <a:fontRef idx="minor">
+            <a:schemeClr val="tx1"/>
+          </a:fontRef>
+        </p:style>
+      </p:cxnSp>
+    </p:spTree>
+    <p:extLst>
+      <p:ext uri="{BB962C8B-B14F-4D97-AF65-F5344CB8AC3E}">
+        <p14:creationId xmlns:p14="http://schemas.microsoft.com/office/powerpoint/2010/main" val="929720417"/>
+      </p:ext>
+    </p:extLst>
+  </p:cSld>
+  <p:clrMapOvr>
+    <a:masterClrMapping/>
+  </p:clrMapOvr>
+</p:sldLayout>
+</file>
+
+<file path=ppt/slideLayouts/slideLayout38.xml><?xml version="1.0" encoding="utf-8"?>
+<p:sldLayout xmlns:a="http://schemas.openxmlformats.org/drawingml/2006/main" xmlns:r="http://schemas.openxmlformats.org/officeDocument/2006/relationships" xmlns:p="http://schemas.openxmlformats.org/presentationml/2006/main" preserve="1" userDrawn="1">
+  <p:cSld name="Louvor a vós">
+    <p:bg>
+      <p:bgPr>
+        <a:blipFill dpi="0" rotWithShape="1">
+          <a:blip r:embed="rId2">
+            <a:lum/>
+          </a:blip>
+          <a:srcRect/>
+          <a:stretch>
+            <a:fillRect/>
+          </a:stretch>
+        </a:blipFill>
+        <a:effectLst/>
+      </p:bgPr>
+    </p:bg>
+    <p:spTree>
+      <p:nvGrpSpPr>
+        <p:cNvPr id="1" name=""/>
+        <p:cNvGrpSpPr/>
+        <p:nvPr/>
+      </p:nvGrpSpPr>
+      <p:grpSpPr>
+        <a:xfrm>
+          <a:off x="0" y="0"/>
+          <a:ext cx="0" cy="0"/>
+          <a:chOff x="0" y="0"/>
+          <a:chExt cx="0" cy="0"/>
+        </a:xfrm>
+      </p:grpSpPr>
+      <p:sp>
+        <p:nvSpPr>
+          <p:cNvPr id="3" name="Verso">
+            <a:extLst>
+              <a:ext uri="{FF2B5EF4-FFF2-40B4-BE49-F238E27FC236}">
+                <a16:creationId xmlns:a16="http://schemas.microsoft.com/office/drawing/2014/main" id="{7FBA5054-2BE0-6B52-7485-0B10968F39E5}"/>
+              </a:ext>
+            </a:extLst>
+          </p:cNvPr>
+          <p:cNvSpPr>
+            <a:spLocks noGrp="1"/>
+          </p:cNvSpPr>
+          <p:nvPr>
+            <p:ph idx="1" hasCustomPrompt="1"/>
+          </p:nvPr>
+        </p:nvSpPr>
+        <p:spPr>
+          <a:xfrm>
+            <a:off x="655974" y="3162144"/>
+            <a:ext cx="7832053" cy="3413050"/>
+          </a:xfrm>
+        </p:spPr>
+        <p:txBody>
+          <a:bodyPr tIns="0" anchor="ctr" anchorCtr="1">
+            <a:noAutofit/>
+          </a:bodyPr>
+          <a:lstStyle>
+            <a:lvl1pPr marL="0" marR="0" indent="0" algn="ctr" defTabSz="685800" rtl="0" eaLnBrk="1" fontAlgn="auto" latinLnBrk="0" hangingPunct="1">
+              <a:lnSpc>
+                <a:spcPct val="130000"/>
+              </a:lnSpc>
+              <a:spcBef>
+                <a:spcPts val="0"/>
+              </a:spcBef>
+              <a:spcAft>
+                <a:spcPts val="0"/>
+              </a:spcAft>
+              <a:buClrTx/>
+              <a:buSzTx/>
+              <a:buFont typeface="Arial" panose="020B0604020202020204" pitchFamily="34" charset="0"/>
+              <a:buNone/>
+              <a:tabLst/>
+              <a:defRPr lang="pt-PT" sz="3200" b="0" i="0" smtClean="0">
+                <a:solidFill>
+                  <a:schemeClr val="accent2">
+                    <a:lumMod val="75000"/>
+                  </a:schemeClr>
+                </a:solidFill>
+                <a:effectLst/>
+                <a:latin typeface="Livvic" pitchFamily="2" charset="0"/>
+              </a:defRPr>
+            </a:lvl1pPr>
+            <a:lvl2pPr algn="ctr">
+              <a:defRPr/>
+            </a:lvl2pPr>
+            <a:lvl3pPr algn="ctr">
+              <a:defRPr/>
+            </a:lvl3pPr>
+            <a:lvl4pPr algn="ctr">
+              <a:defRPr/>
+            </a:lvl4pPr>
+            <a:lvl5pPr algn="ctr">
+              <a:defRPr/>
+            </a:lvl5pPr>
+          </a:lstStyle>
+          <a:p>
+            <a:pPr marL="0" marR="0" lvl="0" indent="0" algn="ctr" defTabSz="685800" rtl="0" eaLnBrk="1" fontAlgn="auto" latinLnBrk="0" hangingPunct="1">
+              <a:lnSpc>
+                <a:spcPct val="130000"/>
+              </a:lnSpc>
+              <a:spcBef>
+                <a:spcPts val="0"/>
+              </a:spcBef>
+              <a:spcAft>
+                <a:spcPts val="0"/>
+              </a:spcAft>
+              <a:buClrTx/>
+              <a:buSzTx/>
+              <a:buFont typeface="Arial" panose="020B0604020202020204" pitchFamily="34" charset="0"/>
+              <a:buNone/>
+              <a:tabLst/>
+              <a:defRPr/>
+            </a:pPr>
+            <a:r>
+              <a:rPr lang="pt-PT" dirty="0"/>
+              <a:t>Cristo obedeceu até à morte e morte de cruz.</a:t>
+            </a:r>
+          </a:p>
+          <a:p>
+            <a:pPr marL="0" marR="0" lvl="0" indent="0" algn="ctr" defTabSz="685800" rtl="0" eaLnBrk="1" fontAlgn="auto" latinLnBrk="0" hangingPunct="1">
+              <a:lnSpc>
+                <a:spcPct val="130000"/>
+              </a:lnSpc>
+              <a:spcBef>
+                <a:spcPts val="0"/>
+              </a:spcBef>
+              <a:spcAft>
+                <a:spcPts val="0"/>
+              </a:spcAft>
+              <a:buClrTx/>
+              <a:buSzTx/>
+              <a:buFont typeface="Arial" panose="020B0604020202020204" pitchFamily="34" charset="0"/>
+              <a:buNone/>
+              <a:tabLst/>
+              <a:defRPr/>
+            </a:pPr>
+            <a:r>
+              <a:rPr lang="pt-PT" dirty="0"/>
+              <a:t>Por isso Deus O exaltou</a:t>
+            </a:r>
+          </a:p>
+          <a:p>
+            <a:pPr marL="0" marR="0" lvl="0" indent="0" algn="ctr" defTabSz="685800" rtl="0" eaLnBrk="1" fontAlgn="auto" latinLnBrk="0" hangingPunct="1">
+              <a:lnSpc>
+                <a:spcPct val="130000"/>
+              </a:lnSpc>
+              <a:spcBef>
+                <a:spcPts val="0"/>
+              </a:spcBef>
+              <a:spcAft>
+                <a:spcPts val="0"/>
+              </a:spcAft>
+              <a:buClrTx/>
+              <a:buSzTx/>
+              <a:buFont typeface="Arial" panose="020B0604020202020204" pitchFamily="34" charset="0"/>
+              <a:buNone/>
+              <a:tabLst/>
+              <a:defRPr/>
+            </a:pPr>
+            <a:r>
+              <a:rPr lang="pt-PT" dirty="0"/>
+              <a:t>e Lhe deu um nome que está acima de todos os nomes.</a:t>
+            </a:r>
+          </a:p>
+        </p:txBody>
+      </p:sp>
+      <p:sp>
+        <p:nvSpPr>
+          <p:cNvPr id="4" name="TextBox 3">
+            <a:extLst>
+              <a:ext uri="{FF2B5EF4-FFF2-40B4-BE49-F238E27FC236}">
+                <a16:creationId xmlns:a16="http://schemas.microsoft.com/office/drawing/2014/main" id="{1A16EFAF-C0B6-AE3C-0C51-0F0A4C760F06}"/>
+              </a:ext>
+            </a:extLst>
+          </p:cNvPr>
+          <p:cNvSpPr txBox="1"/>
+          <p:nvPr userDrawn="1"/>
+        </p:nvSpPr>
+        <p:spPr>
+          <a:xfrm>
+            <a:off x="1310326" y="282806"/>
+            <a:ext cx="6523348" cy="707886"/>
+          </a:xfrm>
+          <a:prstGeom prst="rect">
+            <a:avLst/>
+          </a:prstGeom>
+          <a:noFill/>
+        </p:spPr>
+        <p:txBody>
+          <a:bodyPr wrap="square" rtlCol="0">
+            <a:spAutoFit/>
+          </a:bodyPr>
+          <a:lstStyle/>
+          <a:p>
+            <a:pPr algn="ctr"/>
+            <a:r>
+              <a:rPr lang="en-US" sz="4000" b="0" i="0" u="none" cap="small" baseline="0" dirty="0" err="1">
+                <a:solidFill>
+                  <a:schemeClr val="accent2">
+                    <a:lumMod val="50000"/>
+                  </a:schemeClr>
+                </a:solidFill>
+                <a:latin typeface="+mj-lt"/>
+              </a:rPr>
+              <a:t>Aclamação</a:t>
+            </a:r>
+            <a:r>
+              <a:rPr lang="en-US" sz="4000" b="0" i="0" u="none" cap="small" baseline="0" dirty="0">
+                <a:solidFill>
+                  <a:schemeClr val="accent2">
+                    <a:lumMod val="50000"/>
+                  </a:schemeClr>
+                </a:solidFill>
+                <a:latin typeface="+mj-lt"/>
+              </a:rPr>
+              <a:t> </a:t>
+            </a:r>
+            <a:r>
+              <a:rPr lang="en-US" sz="4000" b="0" i="0" u="none" cap="small" baseline="0" dirty="0" err="1">
+                <a:solidFill>
+                  <a:schemeClr val="accent2">
+                    <a:lumMod val="50000"/>
+                  </a:schemeClr>
+                </a:solidFill>
+                <a:latin typeface="+mj-lt"/>
+              </a:rPr>
+              <a:t>ao</a:t>
+            </a:r>
+            <a:r>
+              <a:rPr lang="en-US" sz="4000" b="0" i="0" u="none" cap="small" baseline="0" dirty="0">
+                <a:solidFill>
+                  <a:schemeClr val="accent2">
+                    <a:lumMod val="50000"/>
+                  </a:schemeClr>
+                </a:solidFill>
+                <a:latin typeface="+mj-lt"/>
+              </a:rPr>
+              <a:t> Evangelho</a:t>
+            </a:r>
+            <a:endParaRPr lang="pt-PT" sz="4000" b="0" i="0" u="none" cap="small" baseline="0" dirty="0">
+              <a:solidFill>
+                <a:schemeClr val="accent2">
+                  <a:lumMod val="50000"/>
+                </a:schemeClr>
+              </a:solidFill>
+              <a:latin typeface="+mj-lt"/>
+            </a:endParaRPr>
+          </a:p>
+        </p:txBody>
+      </p:sp>
+      <p:cxnSp>
+        <p:nvCxnSpPr>
+          <p:cNvPr id="6" name="Straight Connector 5">
+            <a:extLst>
+              <a:ext uri="{FF2B5EF4-FFF2-40B4-BE49-F238E27FC236}">
+                <a16:creationId xmlns:a16="http://schemas.microsoft.com/office/drawing/2014/main" id="{5F9CA452-C242-8E24-21E2-C455200B6F79}"/>
+              </a:ext>
+            </a:extLst>
+          </p:cNvPr>
+          <p:cNvCxnSpPr>
+            <a:cxnSpLocks/>
+          </p:cNvCxnSpPr>
+          <p:nvPr userDrawn="1"/>
+        </p:nvCxnSpPr>
+        <p:spPr>
+          <a:xfrm flipH="1">
+            <a:off x="444680" y="1093829"/>
+            <a:ext cx="8254639" cy="0"/>
+          </a:xfrm>
+          <a:prstGeom prst="line">
+            <a:avLst/>
+          </a:prstGeom>
+          <a:ln w="19050">
+            <a:solidFill>
+              <a:schemeClr val="accent2">
+                <a:lumMod val="50000"/>
+              </a:schemeClr>
+            </a:solidFill>
+          </a:ln>
+        </p:spPr>
+        <p:style>
+          <a:lnRef idx="1">
+            <a:schemeClr val="accent1"/>
+          </a:lnRef>
+          <a:fillRef idx="0">
+            <a:schemeClr val="accent1"/>
+          </a:fillRef>
+          <a:effectRef idx="0">
+            <a:schemeClr val="accent1"/>
+          </a:effectRef>
+          <a:fontRef idx="minor">
+            <a:schemeClr val="tx1"/>
+          </a:fontRef>
+        </p:style>
+      </p:cxnSp>
+      <p:sp>
+        <p:nvSpPr>
+          <p:cNvPr id="5" name="TextBox 4">
+            <a:extLst>
+              <a:ext uri="{FF2B5EF4-FFF2-40B4-BE49-F238E27FC236}">
+                <a16:creationId xmlns:a16="http://schemas.microsoft.com/office/drawing/2014/main" id="{63DBA0E2-F88B-D280-38B9-7C776713B47B}"/>
+              </a:ext>
+            </a:extLst>
+          </p:cNvPr>
+          <p:cNvSpPr txBox="1"/>
+          <p:nvPr userDrawn="1"/>
+        </p:nvSpPr>
+        <p:spPr>
+          <a:xfrm>
+            <a:off x="655974" y="1343157"/>
+            <a:ext cx="7832053" cy="1569660"/>
+          </a:xfrm>
+          <a:prstGeom prst="rect">
+            <a:avLst/>
+          </a:prstGeom>
+          <a:noFill/>
+        </p:spPr>
+        <p:txBody>
+          <a:bodyPr wrap="square" rtlCol="0">
+            <a:spAutoFit/>
+          </a:bodyPr>
+          <a:lstStyle/>
+          <a:p>
+            <a:pPr algn="ctr"/>
+            <a:r>
+              <a:rPr lang="en-US" sz="4800" b="0" i="0" u="none" cap="small" baseline="0" dirty="0" err="1">
+                <a:solidFill>
+                  <a:schemeClr val="accent2">
+                    <a:lumMod val="50000"/>
+                  </a:schemeClr>
+                </a:solidFill>
+                <a:latin typeface="+mj-lt"/>
+              </a:rPr>
+              <a:t>Louvor</a:t>
+            </a:r>
+            <a:r>
+              <a:rPr lang="en-US" sz="4800" b="0" i="0" u="none" cap="small" baseline="0" dirty="0">
+                <a:solidFill>
+                  <a:schemeClr val="accent2">
+                    <a:lumMod val="50000"/>
+                  </a:schemeClr>
+                </a:solidFill>
+                <a:latin typeface="+mj-lt"/>
+              </a:rPr>
+              <a:t> a </a:t>
+            </a:r>
+            <a:r>
+              <a:rPr lang="en-US" sz="4800" b="0" i="0" u="none" cap="small" baseline="0" dirty="0" err="1">
+                <a:solidFill>
+                  <a:schemeClr val="accent2">
+                    <a:lumMod val="50000"/>
+                  </a:schemeClr>
+                </a:solidFill>
+                <a:latin typeface="+mj-lt"/>
+              </a:rPr>
+              <a:t>Vós</a:t>
+            </a:r>
+            <a:r>
+              <a:rPr lang="en-US" sz="4800" b="0" i="0" u="none" cap="small" baseline="0" dirty="0">
+                <a:solidFill>
+                  <a:schemeClr val="accent2">
+                    <a:lumMod val="50000"/>
+                  </a:schemeClr>
+                </a:solidFill>
+                <a:latin typeface="+mj-lt"/>
+              </a:rPr>
+              <a:t>, Rei da </a:t>
+            </a:r>
+            <a:r>
+              <a:rPr lang="en-US" sz="4800" b="0" i="0" u="none" cap="small" baseline="0" dirty="0" err="1">
+                <a:solidFill>
+                  <a:schemeClr val="accent2">
+                    <a:lumMod val="50000"/>
+                  </a:schemeClr>
+                </a:solidFill>
+                <a:latin typeface="+mj-lt"/>
+              </a:rPr>
+              <a:t>eterna</a:t>
+            </a:r>
+            <a:r>
+              <a:rPr lang="en-US" sz="4800" b="0" i="0" u="none" cap="small" baseline="0" dirty="0">
+                <a:solidFill>
+                  <a:schemeClr val="accent2">
+                    <a:lumMod val="50000"/>
+                  </a:schemeClr>
+                </a:solidFill>
+                <a:latin typeface="+mj-lt"/>
+              </a:rPr>
+              <a:t> </a:t>
+            </a:r>
+            <a:r>
+              <a:rPr lang="en-US" sz="4800" b="0" i="0" u="none" cap="small" baseline="0" dirty="0" err="1">
+                <a:solidFill>
+                  <a:schemeClr val="accent2">
+                    <a:lumMod val="50000"/>
+                  </a:schemeClr>
+                </a:solidFill>
+                <a:latin typeface="+mj-lt"/>
+              </a:rPr>
+              <a:t>glória</a:t>
+            </a:r>
+            <a:r>
+              <a:rPr lang="en-US" sz="4800" b="0" i="0" u="none" cap="small" baseline="0" dirty="0">
+                <a:solidFill>
+                  <a:schemeClr val="accent2">
+                    <a:lumMod val="50000"/>
+                  </a:schemeClr>
+                </a:solidFill>
+                <a:latin typeface="+mj-lt"/>
+              </a:rPr>
+              <a:t>, </a:t>
+            </a:r>
+            <a:r>
+              <a:rPr lang="en-US" sz="4800" b="0" i="0" u="none" cap="small" baseline="0" dirty="0" err="1">
+                <a:solidFill>
+                  <a:schemeClr val="accent2">
+                    <a:lumMod val="50000"/>
+                  </a:schemeClr>
+                </a:solidFill>
+                <a:latin typeface="+mj-lt"/>
+              </a:rPr>
+              <a:t>louvor</a:t>
+            </a:r>
+            <a:r>
+              <a:rPr lang="en-US" sz="4800" b="0" i="0" u="none" cap="small" baseline="0" dirty="0">
+                <a:solidFill>
+                  <a:schemeClr val="accent2">
+                    <a:lumMod val="50000"/>
+                  </a:schemeClr>
+                </a:solidFill>
+                <a:latin typeface="+mj-lt"/>
+              </a:rPr>
+              <a:t> a </a:t>
+            </a:r>
+            <a:r>
+              <a:rPr lang="en-US" sz="4800" b="0" i="0" u="none" cap="small" baseline="0" dirty="0" err="1">
+                <a:solidFill>
+                  <a:schemeClr val="accent2">
+                    <a:lumMod val="50000"/>
+                  </a:schemeClr>
+                </a:solidFill>
+                <a:latin typeface="+mj-lt"/>
+              </a:rPr>
+              <a:t>Vós</a:t>
+            </a:r>
+            <a:r>
+              <a:rPr lang="en-US" sz="4800" b="0" i="0" u="none" cap="small" baseline="0" dirty="0">
+                <a:solidFill>
+                  <a:schemeClr val="accent2">
+                    <a:lumMod val="50000"/>
+                  </a:schemeClr>
+                </a:solidFill>
+                <a:latin typeface="+mj-lt"/>
+              </a:rPr>
+              <a:t>!</a:t>
+            </a:r>
+            <a:endParaRPr lang="pt-PT" sz="4800" b="0" i="0" u="none" cap="small" baseline="0" dirty="0">
+              <a:solidFill>
+                <a:schemeClr val="accent2">
+                  <a:lumMod val="50000"/>
+                </a:schemeClr>
+              </a:solidFill>
+              <a:latin typeface="+mj-lt"/>
+            </a:endParaRPr>
+          </a:p>
+        </p:txBody>
+      </p:sp>
+    </p:spTree>
+    <p:extLst>
+      <p:ext uri="{BB962C8B-B14F-4D97-AF65-F5344CB8AC3E}">
+        <p14:creationId xmlns:p14="http://schemas.microsoft.com/office/powerpoint/2010/main" val="1421212563"/>
+      </p:ext>
+    </p:extLst>
+  </p:cSld>
+  <p:clrMapOvr>
+    <a:masterClrMapping/>
+  </p:clrMapOvr>
+</p:sldLayout>
+</file>
+
+<file path=ppt/slideLayouts/slideLayout39.xml><?xml version="1.0" encoding="utf-8"?>
+<p:sldLayout xmlns:a="http://schemas.openxmlformats.org/drawingml/2006/main" xmlns:r="http://schemas.openxmlformats.org/officeDocument/2006/relationships" xmlns:p="http://schemas.openxmlformats.org/presentationml/2006/main" preserve="1" userDrawn="1">
+  <p:cSld name="Evangelho">
+    <p:bg>
+      <p:bgPr>
+        <a:blipFill dpi="0" rotWithShape="1">
+          <a:blip r:embed="rId2">
+            <a:lum/>
+          </a:blip>
+          <a:srcRect/>
+          <a:stretch>
+            <a:fillRect/>
+          </a:stretch>
+        </a:blipFill>
+        <a:effectLst/>
+      </p:bgPr>
+    </p:bg>
+    <p:spTree>
+      <p:nvGrpSpPr>
+        <p:cNvPr id="1" name=""/>
+        <p:cNvGrpSpPr/>
+        <p:nvPr/>
+      </p:nvGrpSpPr>
+      <p:grpSpPr>
+        <a:xfrm>
+          <a:off x="0" y="0"/>
+          <a:ext cx="0" cy="0"/>
+          <a:chOff x="0" y="0"/>
+          <a:chExt cx="0" cy="0"/>
+        </a:xfrm>
+      </p:grpSpPr>
+      <p:sp>
+        <p:nvSpPr>
+          <p:cNvPr id="2" name="Referência">
+            <a:extLst>
+              <a:ext uri="{FF2B5EF4-FFF2-40B4-BE49-F238E27FC236}">
+                <a16:creationId xmlns:a16="http://schemas.microsoft.com/office/drawing/2014/main" id="{29D85961-FC26-87D6-F7CF-D2E332EB5E80}"/>
+              </a:ext>
+            </a:extLst>
+          </p:cNvPr>
+          <p:cNvSpPr>
+            <a:spLocks noGrp="1"/>
+          </p:cNvSpPr>
+          <p:nvPr>
+            <p:ph type="title" hasCustomPrompt="1"/>
+          </p:nvPr>
+        </p:nvSpPr>
+        <p:spPr>
+          <a:xfrm>
+            <a:off x="444680" y="1225489"/>
+            <a:ext cx="8254640" cy="443054"/>
+          </a:xfrm>
+        </p:spPr>
+        <p:txBody>
+          <a:bodyPr wrap="square" anchor="t" anchorCtr="0">
+            <a:normAutofit/>
+          </a:bodyPr>
+          <a:lstStyle>
+            <a:lvl1pPr algn="ctr">
+              <a:defRPr lang="pt-PT" sz="2400" b="0" i="0" cap="small" spc="0" baseline="0" smtClean="0">
+                <a:solidFill>
+                  <a:schemeClr val="accent1">
+                    <a:lumMod val="75000"/>
+                  </a:schemeClr>
+                </a:solidFill>
+                <a:effectLst/>
+                <a:latin typeface="Livvic" pitchFamily="2" charset="0"/>
+                <a:cs typeface="Leelawadee UI Semilight" panose="020B0402040204020203" pitchFamily="34" charset="-34"/>
+              </a:defRPr>
+            </a:lvl1pPr>
+          </a:lstStyle>
+          <a:p>
+            <a:r>
+              <a:rPr lang="pt-PT" dirty="0"/>
+              <a:t>Is 45, 1.4-6</a:t>
+            </a:r>
+          </a:p>
+        </p:txBody>
+      </p:sp>
+      <p:sp>
+        <p:nvSpPr>
+          <p:cNvPr id="3" name="Citação">
+            <a:extLst>
+              <a:ext uri="{FF2B5EF4-FFF2-40B4-BE49-F238E27FC236}">
+                <a16:creationId xmlns:a16="http://schemas.microsoft.com/office/drawing/2014/main" id="{7FBA5054-2BE0-6B52-7485-0B10968F39E5}"/>
+              </a:ext>
+            </a:extLst>
+          </p:cNvPr>
+          <p:cNvSpPr>
+            <a:spLocks noGrp="1"/>
+          </p:cNvSpPr>
+          <p:nvPr>
+            <p:ph idx="1" hasCustomPrompt="1"/>
+          </p:nvPr>
+        </p:nvSpPr>
+        <p:spPr>
+          <a:xfrm>
+            <a:off x="444680" y="1800202"/>
+            <a:ext cx="8254639" cy="4638305"/>
+          </a:xfrm>
+        </p:spPr>
+        <p:txBody>
+          <a:bodyPr tIns="0" anchor="ctr" anchorCtr="1">
+            <a:normAutofit/>
+          </a:bodyPr>
+          <a:lstStyle>
+            <a:lvl1pPr marL="0" marR="0" indent="0" algn="ctr" defTabSz="685800" rtl="0" eaLnBrk="1" fontAlgn="auto" latinLnBrk="0" hangingPunct="1">
+              <a:lnSpc>
+                <a:spcPct val="130000"/>
+              </a:lnSpc>
+              <a:spcBef>
+                <a:spcPts val="0"/>
+              </a:spcBef>
+              <a:spcAft>
+                <a:spcPts val="0"/>
+              </a:spcAft>
+              <a:buClrTx/>
+              <a:buSzTx/>
+              <a:buFont typeface="Arial" panose="020B0604020202020204" pitchFamily="34" charset="0"/>
+              <a:buNone/>
+              <a:tabLst/>
+              <a:defRPr lang="pt-PT" sz="4000" b="0" i="0" smtClean="0">
+                <a:solidFill>
+                  <a:schemeClr val="accent1">
+                    <a:lumMod val="75000"/>
+                  </a:schemeClr>
+                </a:solidFill>
+                <a:effectLst/>
+                <a:latin typeface="Livvic" pitchFamily="2" charset="0"/>
+              </a:defRPr>
+            </a:lvl1pPr>
+            <a:lvl2pPr algn="ctr">
+              <a:defRPr/>
+            </a:lvl2pPr>
+            <a:lvl3pPr algn="ctr">
+              <a:defRPr/>
+            </a:lvl3pPr>
+            <a:lvl4pPr algn="ctr">
+              <a:defRPr/>
+            </a:lvl4pPr>
+            <a:lvl5pPr algn="ctr">
+              <a:defRPr/>
+            </a:lvl5pPr>
+          </a:lstStyle>
+          <a:p>
+            <a:pPr marL="0" marR="0" lvl="0" indent="0" algn="ctr" defTabSz="685800" rtl="0" eaLnBrk="1" fontAlgn="auto" latinLnBrk="0" hangingPunct="1">
+              <a:lnSpc>
+                <a:spcPct val="130000"/>
+              </a:lnSpc>
+              <a:spcBef>
+                <a:spcPts val="0"/>
+              </a:spcBef>
+              <a:spcAft>
+                <a:spcPts val="0"/>
+              </a:spcAft>
+              <a:buClrTx/>
+              <a:buSzTx/>
+              <a:buFont typeface="Arial" panose="020B0604020202020204" pitchFamily="34" charset="0"/>
+              <a:buNone/>
+              <a:tabLst/>
+              <a:defRPr/>
+            </a:pPr>
+            <a:r>
+              <a:rPr lang="pt-PT" dirty="0"/>
+              <a:t>«Tomei Ciro pela mão direita para subjugar diante dele as nações»</a:t>
+            </a:r>
+          </a:p>
+        </p:txBody>
+      </p:sp>
+      <p:sp>
+        <p:nvSpPr>
+          <p:cNvPr id="4" name="TextBox 3">
+            <a:extLst>
+              <a:ext uri="{FF2B5EF4-FFF2-40B4-BE49-F238E27FC236}">
+                <a16:creationId xmlns:a16="http://schemas.microsoft.com/office/drawing/2014/main" id="{1A16EFAF-C0B6-AE3C-0C51-0F0A4C760F06}"/>
+              </a:ext>
+            </a:extLst>
+          </p:cNvPr>
+          <p:cNvSpPr txBox="1"/>
+          <p:nvPr userDrawn="1"/>
+        </p:nvSpPr>
+        <p:spPr>
+          <a:xfrm>
+            <a:off x="2526384" y="282806"/>
+            <a:ext cx="4091233" cy="707886"/>
+          </a:xfrm>
+          <a:prstGeom prst="rect">
+            <a:avLst/>
+          </a:prstGeom>
+          <a:noFill/>
+        </p:spPr>
+        <p:txBody>
+          <a:bodyPr wrap="square" rtlCol="0">
+            <a:spAutoFit/>
+          </a:bodyPr>
+          <a:lstStyle/>
+          <a:p>
+            <a:pPr algn="ctr"/>
+            <a:r>
+              <a:rPr lang="pt-PT" sz="4000" b="0" i="0" u="none" cap="small" spc="600" baseline="0" dirty="0">
+                <a:solidFill>
+                  <a:schemeClr val="accent1">
+                    <a:lumMod val="50000"/>
+                  </a:schemeClr>
+                </a:solidFill>
+                <a:latin typeface="+mj-lt"/>
+              </a:rPr>
+              <a:t>Evangelho</a:t>
+            </a:r>
+          </a:p>
+        </p:txBody>
+      </p:sp>
+      <p:cxnSp>
+        <p:nvCxnSpPr>
+          <p:cNvPr id="8" name="Straight Connector 7">
+            <a:extLst>
+              <a:ext uri="{FF2B5EF4-FFF2-40B4-BE49-F238E27FC236}">
+                <a16:creationId xmlns:a16="http://schemas.microsoft.com/office/drawing/2014/main" id="{27959F69-8FA1-3D7A-1069-6CBFA7DEDAA9}"/>
+              </a:ext>
+            </a:extLst>
+          </p:cNvPr>
+          <p:cNvCxnSpPr>
+            <a:cxnSpLocks/>
+          </p:cNvCxnSpPr>
+          <p:nvPr userDrawn="1"/>
+        </p:nvCxnSpPr>
+        <p:spPr>
+          <a:xfrm flipH="1">
+            <a:off x="444680" y="1093829"/>
+            <a:ext cx="8254639" cy="0"/>
+          </a:xfrm>
+          <a:prstGeom prst="line">
+            <a:avLst/>
+          </a:prstGeom>
+          <a:ln w="19050">
+            <a:solidFill>
+              <a:schemeClr val="accent1">
+                <a:lumMod val="50000"/>
+              </a:schemeClr>
+            </a:solidFill>
+          </a:ln>
+        </p:spPr>
+        <p:style>
+          <a:lnRef idx="1">
+            <a:schemeClr val="accent1"/>
+          </a:lnRef>
+          <a:fillRef idx="0">
+            <a:schemeClr val="accent1"/>
+          </a:fillRef>
+          <a:effectRef idx="0">
+            <a:schemeClr val="accent1"/>
+          </a:effectRef>
+          <a:fontRef idx="minor">
+            <a:schemeClr val="tx1"/>
+          </a:fontRef>
+        </p:style>
+      </p:cxnSp>
+    </p:spTree>
+    <p:extLst>
+      <p:ext uri="{BB962C8B-B14F-4D97-AF65-F5344CB8AC3E}">
+        <p14:creationId xmlns:p14="http://schemas.microsoft.com/office/powerpoint/2010/main" val="1280624248"/>
       </p:ext>
     </p:extLst>
   </p:cSld>
@@ -4867,89 +6478,6 @@
       </p:sp>
       <p:sp>
         <p:nvSpPr>
-          <p:cNvPr id="3" name="Frase">
-            <a:extLst>
-              <a:ext uri="{FF2B5EF4-FFF2-40B4-BE49-F238E27FC236}">
-                <a16:creationId xmlns:a16="http://schemas.microsoft.com/office/drawing/2014/main" id="{F5DEF8E5-A6D3-FF16-3A4C-6762958F1B84}"/>
-              </a:ext>
-            </a:extLst>
-          </p:cNvPr>
-          <p:cNvSpPr>
-            <a:spLocks noGrp="1"/>
-          </p:cNvSpPr>
-          <p:nvPr>
-            <p:ph type="subTitle" idx="1" hasCustomPrompt="1"/>
-          </p:nvPr>
-        </p:nvSpPr>
-        <p:spPr>
-          <a:xfrm>
-            <a:off x="494907" y="2525677"/>
-            <a:ext cx="8154186" cy="914255"/>
-          </a:xfrm>
-        </p:spPr>
-        <p:txBody>
-          <a:bodyPr>
-            <a:noAutofit/>
-          </a:bodyPr>
-          <a:lstStyle>
-            <a:lvl1pPr marL="0" indent="0" algn="ctr">
-              <a:buNone/>
-              <a:defRPr sz="2400">
-                <a:latin typeface="Shadows Into Light Two" panose="02000506000000020004" pitchFamily="2" charset="0"/>
-              </a:defRPr>
-            </a:lvl1pPr>
-            <a:lvl2pPr marL="342900" indent="0" algn="ctr">
-              <a:buNone/>
-              <a:defRPr sz="1500"/>
-            </a:lvl2pPr>
-            <a:lvl3pPr marL="685800" indent="0" algn="ctr">
-              <a:buNone/>
-              <a:defRPr sz="1350"/>
-            </a:lvl3pPr>
-            <a:lvl4pPr marL="1028700" indent="0" algn="ctr">
-              <a:buNone/>
-              <a:defRPr sz="1200"/>
-            </a:lvl4pPr>
-            <a:lvl5pPr marL="1371600" indent="0" algn="ctr">
-              <a:buNone/>
-              <a:defRPr sz="1200"/>
-            </a:lvl5pPr>
-            <a:lvl6pPr marL="1714500" indent="0" algn="ctr">
-              <a:buNone/>
-              <a:defRPr sz="1200"/>
-            </a:lvl6pPr>
-            <a:lvl7pPr marL="2057400" indent="0" algn="ctr">
-              <a:buNone/>
-              <a:defRPr sz="1200"/>
-            </a:lvl7pPr>
-            <a:lvl8pPr marL="2400300" indent="0" algn="ctr">
-              <a:buNone/>
-              <a:defRPr sz="1200"/>
-            </a:lvl8pPr>
-            <a:lvl9pPr marL="2743200" indent="0" algn="ctr">
-              <a:buNone/>
-              <a:defRPr sz="1200"/>
-            </a:lvl9pPr>
-          </a:lstStyle>
-          <a:p>
-            <a:r>
-              <a:rPr lang="pt-PT" dirty="0"/>
-              <a:t>«Foste fiel em coisas pequenas:</a:t>
-            </a:r>
-          </a:p>
-          <a:p>
-            <a:r>
-              <a:rPr lang="pt-PT" dirty="0"/>
-              <a:t>vem tomar parte na alegria do teu Senhor»</a:t>
-            </a:r>
-          </a:p>
-          <a:p>
-            <a:endParaRPr lang="pt-PT" dirty="0"/>
-          </a:p>
-        </p:txBody>
-      </p:sp>
-      <p:sp>
-        <p:nvSpPr>
           <p:cNvPr id="10" name="Versiculo">
             <a:extLst>
               <a:ext uri="{FF2B5EF4-FFF2-40B4-BE49-F238E27FC236}">
@@ -5039,7 +6567,7 @@
               </a:ext>
             </a:extLst>
           </a:blip>
-          <a:srcRect t="13134" b="13134"/>
+          <a:srcRect t="47" b="47"/>
           <a:stretch/>
         </p:blipFill>
         <p:spPr>
@@ -5112,6 +6640,86 @@
               <a:t>Ano A</a:t>
             </a:r>
             <a:endParaRPr lang="pt-PT" dirty="0"/>
+          </a:p>
+        </p:txBody>
+      </p:sp>
+      <p:sp>
+        <p:nvSpPr>
+          <p:cNvPr id="6" name="Frase">
+            <a:extLst>
+              <a:ext uri="{FF2B5EF4-FFF2-40B4-BE49-F238E27FC236}">
+                <a16:creationId xmlns:a16="http://schemas.microsoft.com/office/drawing/2014/main" id="{D276088C-87E5-6E42-8C13-2DE7D9DFB226}"/>
+              </a:ext>
+            </a:extLst>
+          </p:cNvPr>
+          <p:cNvSpPr>
+            <a:spLocks noGrp="1"/>
+          </p:cNvSpPr>
+          <p:nvPr>
+            <p:ph type="subTitle" idx="1" hasCustomPrompt="1"/>
+          </p:nvPr>
+        </p:nvSpPr>
+        <p:spPr>
+          <a:xfrm>
+            <a:off x="494907" y="2525677"/>
+            <a:ext cx="8154186" cy="914255"/>
+          </a:xfrm>
+        </p:spPr>
+        <p:txBody>
+          <a:bodyPr anchor="ctr" anchorCtr="0">
+            <a:noAutofit/>
+          </a:bodyPr>
+          <a:lstStyle>
+            <a:lvl1pPr marL="0" indent="0" algn="ctr">
+              <a:buNone/>
+              <a:defRPr sz="2400">
+                <a:latin typeface="Shadows Into Light Two" panose="02000506000000020004" pitchFamily="2" charset="0"/>
+              </a:defRPr>
+            </a:lvl1pPr>
+            <a:lvl2pPr marL="342900" indent="0" algn="ctr">
+              <a:buNone/>
+              <a:defRPr sz="1500"/>
+            </a:lvl2pPr>
+            <a:lvl3pPr marL="685800" indent="0" algn="ctr">
+              <a:buNone/>
+              <a:defRPr sz="1350"/>
+            </a:lvl3pPr>
+            <a:lvl4pPr marL="1028700" indent="0" algn="ctr">
+              <a:buNone/>
+              <a:defRPr sz="1200"/>
+            </a:lvl4pPr>
+            <a:lvl5pPr marL="1371600" indent="0" algn="ctr">
+              <a:buNone/>
+              <a:defRPr sz="1200"/>
+            </a:lvl5pPr>
+            <a:lvl6pPr marL="1714500" indent="0" algn="ctr">
+              <a:buNone/>
+              <a:defRPr sz="1200"/>
+            </a:lvl6pPr>
+            <a:lvl7pPr marL="2057400" indent="0" algn="ctr">
+              <a:buNone/>
+              <a:defRPr sz="1200"/>
+            </a:lvl7pPr>
+            <a:lvl8pPr marL="2400300" indent="0" algn="ctr">
+              <a:buNone/>
+              <a:defRPr sz="1200"/>
+            </a:lvl8pPr>
+            <a:lvl9pPr marL="2743200" indent="0" algn="ctr">
+              <a:buNone/>
+              <a:defRPr sz="1200"/>
+            </a:lvl9pPr>
+          </a:lstStyle>
+          <a:p>
+            <a:r>
+              <a:rPr lang="pt-PT" dirty="0"/>
+              <a:t>«Foste fiel em coisas pequenas:</a:t>
+            </a:r>
+          </a:p>
+          <a:p>
+            <a:r>
+              <a:rPr lang="pt-PT" dirty="0"/>
+              <a:t>vem tomar parte na alegria do teu Senhor»</a:t>
+            </a:r>
           </a:p>
         </p:txBody>
       </p:sp>
@@ -5204,89 +6812,6 @@
       </p:sp>
       <p:sp>
         <p:nvSpPr>
-          <p:cNvPr id="3" name="Frase">
-            <a:extLst>
-              <a:ext uri="{FF2B5EF4-FFF2-40B4-BE49-F238E27FC236}">
-                <a16:creationId xmlns:a16="http://schemas.microsoft.com/office/drawing/2014/main" id="{F5DEF8E5-A6D3-FF16-3A4C-6762958F1B84}"/>
-              </a:ext>
-            </a:extLst>
-          </p:cNvPr>
-          <p:cNvSpPr>
-            <a:spLocks noGrp="1"/>
-          </p:cNvSpPr>
-          <p:nvPr>
-            <p:ph type="subTitle" idx="1" hasCustomPrompt="1"/>
-          </p:nvPr>
-        </p:nvSpPr>
-        <p:spPr>
-          <a:xfrm>
-            <a:off x="494907" y="2525677"/>
-            <a:ext cx="8154186" cy="914255"/>
-          </a:xfrm>
-        </p:spPr>
-        <p:txBody>
-          <a:bodyPr>
-            <a:noAutofit/>
-          </a:bodyPr>
-          <a:lstStyle>
-            <a:lvl1pPr marL="0" indent="0" algn="ctr">
-              <a:buNone/>
-              <a:defRPr sz="2400">
-                <a:latin typeface="Shadows Into Light Two" panose="02000506000000020004" pitchFamily="2" charset="0"/>
-              </a:defRPr>
-            </a:lvl1pPr>
-            <a:lvl2pPr marL="342900" indent="0" algn="ctr">
-              <a:buNone/>
-              <a:defRPr sz="1500"/>
-            </a:lvl2pPr>
-            <a:lvl3pPr marL="685800" indent="0" algn="ctr">
-              <a:buNone/>
-              <a:defRPr sz="1350"/>
-            </a:lvl3pPr>
-            <a:lvl4pPr marL="1028700" indent="0" algn="ctr">
-              <a:buNone/>
-              <a:defRPr sz="1200"/>
-            </a:lvl4pPr>
-            <a:lvl5pPr marL="1371600" indent="0" algn="ctr">
-              <a:buNone/>
-              <a:defRPr sz="1200"/>
-            </a:lvl5pPr>
-            <a:lvl6pPr marL="1714500" indent="0" algn="ctr">
-              <a:buNone/>
-              <a:defRPr sz="1200"/>
-            </a:lvl6pPr>
-            <a:lvl7pPr marL="2057400" indent="0" algn="ctr">
-              <a:buNone/>
-              <a:defRPr sz="1200"/>
-            </a:lvl7pPr>
-            <a:lvl8pPr marL="2400300" indent="0" algn="ctr">
-              <a:buNone/>
-              <a:defRPr sz="1200"/>
-            </a:lvl8pPr>
-            <a:lvl9pPr marL="2743200" indent="0" algn="ctr">
-              <a:buNone/>
-              <a:defRPr sz="1200"/>
-            </a:lvl9pPr>
-          </a:lstStyle>
-          <a:p>
-            <a:r>
-              <a:rPr lang="pt-PT" dirty="0"/>
-              <a:t>«Foste fiel em coisas pequenas:</a:t>
-            </a:r>
-          </a:p>
-          <a:p>
-            <a:r>
-              <a:rPr lang="pt-PT" dirty="0"/>
-              <a:t>vem tomar parte na alegria do teu Senhor»</a:t>
-            </a:r>
-          </a:p>
-          <a:p>
-            <a:endParaRPr lang="pt-PT" dirty="0"/>
-          </a:p>
-        </p:txBody>
-      </p:sp>
-      <p:sp>
-        <p:nvSpPr>
           <p:cNvPr id="10" name="Versiculo">
             <a:extLst>
               <a:ext uri="{FF2B5EF4-FFF2-40B4-BE49-F238E27FC236}">
@@ -5376,7 +6901,7 @@
               </a:ext>
             </a:extLst>
           </a:blip>
-          <a:srcRect t="13134" b="13134"/>
+          <a:srcRect t="47" b="47"/>
           <a:stretch/>
         </p:blipFill>
         <p:spPr>
@@ -5449,6 +6974,86 @@
               <a:t>Ano A</a:t>
             </a:r>
             <a:endParaRPr lang="pt-PT" dirty="0"/>
+          </a:p>
+        </p:txBody>
+      </p:sp>
+      <p:sp>
+        <p:nvSpPr>
+          <p:cNvPr id="6" name="Frase">
+            <a:extLst>
+              <a:ext uri="{FF2B5EF4-FFF2-40B4-BE49-F238E27FC236}">
+                <a16:creationId xmlns:a16="http://schemas.microsoft.com/office/drawing/2014/main" id="{D9BA9940-0272-DFDB-FEE3-701B28484642}"/>
+              </a:ext>
+            </a:extLst>
+          </p:cNvPr>
+          <p:cNvSpPr>
+            <a:spLocks noGrp="1"/>
+          </p:cNvSpPr>
+          <p:nvPr>
+            <p:ph type="subTitle" idx="1" hasCustomPrompt="1"/>
+          </p:nvPr>
+        </p:nvSpPr>
+        <p:spPr>
+          <a:xfrm>
+            <a:off x="494907" y="2525677"/>
+            <a:ext cx="8154186" cy="914255"/>
+          </a:xfrm>
+        </p:spPr>
+        <p:txBody>
+          <a:bodyPr anchor="ctr" anchorCtr="0">
+            <a:noAutofit/>
+          </a:bodyPr>
+          <a:lstStyle>
+            <a:lvl1pPr marL="0" indent="0" algn="ctr">
+              <a:buNone/>
+              <a:defRPr sz="2400">
+                <a:latin typeface="Shadows Into Light Two" panose="02000506000000020004" pitchFamily="2" charset="0"/>
+              </a:defRPr>
+            </a:lvl1pPr>
+            <a:lvl2pPr marL="342900" indent="0" algn="ctr">
+              <a:buNone/>
+              <a:defRPr sz="1500"/>
+            </a:lvl2pPr>
+            <a:lvl3pPr marL="685800" indent="0" algn="ctr">
+              <a:buNone/>
+              <a:defRPr sz="1350"/>
+            </a:lvl3pPr>
+            <a:lvl4pPr marL="1028700" indent="0" algn="ctr">
+              <a:buNone/>
+              <a:defRPr sz="1200"/>
+            </a:lvl4pPr>
+            <a:lvl5pPr marL="1371600" indent="0" algn="ctr">
+              <a:buNone/>
+              <a:defRPr sz="1200"/>
+            </a:lvl5pPr>
+            <a:lvl6pPr marL="1714500" indent="0" algn="ctr">
+              <a:buNone/>
+              <a:defRPr sz="1200"/>
+            </a:lvl6pPr>
+            <a:lvl7pPr marL="2057400" indent="0" algn="ctr">
+              <a:buNone/>
+              <a:defRPr sz="1200"/>
+            </a:lvl7pPr>
+            <a:lvl8pPr marL="2400300" indent="0" algn="ctr">
+              <a:buNone/>
+              <a:defRPr sz="1200"/>
+            </a:lvl8pPr>
+            <a:lvl9pPr marL="2743200" indent="0" algn="ctr">
+              <a:buNone/>
+              <a:defRPr sz="1200"/>
+            </a:lvl9pPr>
+          </a:lstStyle>
+          <a:p>
+            <a:r>
+              <a:rPr lang="pt-PT" dirty="0"/>
+              <a:t>«Foste fiel em coisas pequenas:</a:t>
+            </a:r>
+          </a:p>
+          <a:p>
+            <a:r>
+              <a:rPr lang="pt-PT" dirty="0"/>
+              <a:t>vem tomar parte na alegria do teu Senhor»</a:t>
+            </a:r>
           </a:p>
         </p:txBody>
       </p:sp>
@@ -5541,89 +7146,6 @@
       </p:sp>
       <p:sp>
         <p:nvSpPr>
-          <p:cNvPr id="3" name="Frase">
-            <a:extLst>
-              <a:ext uri="{FF2B5EF4-FFF2-40B4-BE49-F238E27FC236}">
-                <a16:creationId xmlns:a16="http://schemas.microsoft.com/office/drawing/2014/main" id="{F5DEF8E5-A6D3-FF16-3A4C-6762958F1B84}"/>
-              </a:ext>
-            </a:extLst>
-          </p:cNvPr>
-          <p:cNvSpPr>
-            <a:spLocks noGrp="1"/>
-          </p:cNvSpPr>
-          <p:nvPr>
-            <p:ph type="subTitle" idx="1" hasCustomPrompt="1"/>
-          </p:nvPr>
-        </p:nvSpPr>
-        <p:spPr>
-          <a:xfrm>
-            <a:off x="494907" y="2525677"/>
-            <a:ext cx="8154186" cy="914255"/>
-          </a:xfrm>
-        </p:spPr>
-        <p:txBody>
-          <a:bodyPr>
-            <a:noAutofit/>
-          </a:bodyPr>
-          <a:lstStyle>
-            <a:lvl1pPr marL="0" indent="0" algn="ctr">
-              <a:buNone/>
-              <a:defRPr sz="2400">
-                <a:latin typeface="Shadows Into Light Two" panose="02000506000000020004" pitchFamily="2" charset="0"/>
-              </a:defRPr>
-            </a:lvl1pPr>
-            <a:lvl2pPr marL="342900" indent="0" algn="ctr">
-              <a:buNone/>
-              <a:defRPr sz="1500"/>
-            </a:lvl2pPr>
-            <a:lvl3pPr marL="685800" indent="0" algn="ctr">
-              <a:buNone/>
-              <a:defRPr sz="1350"/>
-            </a:lvl3pPr>
-            <a:lvl4pPr marL="1028700" indent="0" algn="ctr">
-              <a:buNone/>
-              <a:defRPr sz="1200"/>
-            </a:lvl4pPr>
-            <a:lvl5pPr marL="1371600" indent="0" algn="ctr">
-              <a:buNone/>
-              <a:defRPr sz="1200"/>
-            </a:lvl5pPr>
-            <a:lvl6pPr marL="1714500" indent="0" algn="ctr">
-              <a:buNone/>
-              <a:defRPr sz="1200"/>
-            </a:lvl6pPr>
-            <a:lvl7pPr marL="2057400" indent="0" algn="ctr">
-              <a:buNone/>
-              <a:defRPr sz="1200"/>
-            </a:lvl7pPr>
-            <a:lvl8pPr marL="2400300" indent="0" algn="ctr">
-              <a:buNone/>
-              <a:defRPr sz="1200"/>
-            </a:lvl8pPr>
-            <a:lvl9pPr marL="2743200" indent="0" algn="ctr">
-              <a:buNone/>
-              <a:defRPr sz="1200"/>
-            </a:lvl9pPr>
-          </a:lstStyle>
-          <a:p>
-            <a:r>
-              <a:rPr lang="pt-PT" dirty="0"/>
-              <a:t>«Foste fiel em coisas pequenas:</a:t>
-            </a:r>
-          </a:p>
-          <a:p>
-            <a:r>
-              <a:rPr lang="pt-PT" dirty="0"/>
-              <a:t>vem tomar parte na alegria do teu Senhor»</a:t>
-            </a:r>
-          </a:p>
-          <a:p>
-            <a:endParaRPr lang="pt-PT" dirty="0"/>
-          </a:p>
-        </p:txBody>
-      </p:sp>
-      <p:sp>
-        <p:nvSpPr>
           <p:cNvPr id="10" name="Versiculo">
             <a:extLst>
               <a:ext uri="{FF2B5EF4-FFF2-40B4-BE49-F238E27FC236}">
@@ -5713,7 +7235,7 @@
               </a:ext>
             </a:extLst>
           </a:blip>
-          <a:srcRect t="13134" b="13134"/>
+          <a:srcRect t="47" b="47"/>
           <a:stretch/>
         </p:blipFill>
         <p:spPr>
@@ -5786,6 +7308,86 @@
               <a:t>Ano A</a:t>
             </a:r>
             <a:endParaRPr lang="pt-PT" dirty="0"/>
+          </a:p>
+        </p:txBody>
+      </p:sp>
+      <p:sp>
+        <p:nvSpPr>
+          <p:cNvPr id="6" name="Frase">
+            <a:extLst>
+              <a:ext uri="{FF2B5EF4-FFF2-40B4-BE49-F238E27FC236}">
+                <a16:creationId xmlns:a16="http://schemas.microsoft.com/office/drawing/2014/main" id="{09C9B4EA-71D8-000A-DA49-713D0A05DF3A}"/>
+              </a:ext>
+            </a:extLst>
+          </p:cNvPr>
+          <p:cNvSpPr>
+            <a:spLocks noGrp="1"/>
+          </p:cNvSpPr>
+          <p:nvPr>
+            <p:ph type="subTitle" idx="1" hasCustomPrompt="1"/>
+          </p:nvPr>
+        </p:nvSpPr>
+        <p:spPr>
+          <a:xfrm>
+            <a:off x="494907" y="2525677"/>
+            <a:ext cx="8154186" cy="914255"/>
+          </a:xfrm>
+        </p:spPr>
+        <p:txBody>
+          <a:bodyPr anchor="ctr" anchorCtr="0">
+            <a:noAutofit/>
+          </a:bodyPr>
+          <a:lstStyle>
+            <a:lvl1pPr marL="0" indent="0" algn="ctr">
+              <a:buNone/>
+              <a:defRPr sz="2400">
+                <a:latin typeface="Shadows Into Light Two" panose="02000506000000020004" pitchFamily="2" charset="0"/>
+              </a:defRPr>
+            </a:lvl1pPr>
+            <a:lvl2pPr marL="342900" indent="0" algn="ctr">
+              <a:buNone/>
+              <a:defRPr sz="1500"/>
+            </a:lvl2pPr>
+            <a:lvl3pPr marL="685800" indent="0" algn="ctr">
+              <a:buNone/>
+              <a:defRPr sz="1350"/>
+            </a:lvl3pPr>
+            <a:lvl4pPr marL="1028700" indent="0" algn="ctr">
+              <a:buNone/>
+              <a:defRPr sz="1200"/>
+            </a:lvl4pPr>
+            <a:lvl5pPr marL="1371600" indent="0" algn="ctr">
+              <a:buNone/>
+              <a:defRPr sz="1200"/>
+            </a:lvl5pPr>
+            <a:lvl6pPr marL="1714500" indent="0" algn="ctr">
+              <a:buNone/>
+              <a:defRPr sz="1200"/>
+            </a:lvl6pPr>
+            <a:lvl7pPr marL="2057400" indent="0" algn="ctr">
+              <a:buNone/>
+              <a:defRPr sz="1200"/>
+            </a:lvl7pPr>
+            <a:lvl8pPr marL="2400300" indent="0" algn="ctr">
+              <a:buNone/>
+              <a:defRPr sz="1200"/>
+            </a:lvl8pPr>
+            <a:lvl9pPr marL="2743200" indent="0" algn="ctr">
+              <a:buNone/>
+              <a:defRPr sz="1200"/>
+            </a:lvl9pPr>
+          </a:lstStyle>
+          <a:p>
+            <a:r>
+              <a:rPr lang="pt-PT" dirty="0"/>
+              <a:t>«Foste fiel em coisas pequenas:</a:t>
+            </a:r>
+          </a:p>
+          <a:p>
+            <a:r>
+              <a:rPr lang="pt-PT" dirty="0"/>
+              <a:t>vem tomar parte na alegria do teu Senhor»</a:t>
+            </a:r>
           </a:p>
         </p:txBody>
       </p:sp>
@@ -5878,89 +7480,6 @@
       </p:sp>
       <p:sp>
         <p:nvSpPr>
-          <p:cNvPr id="3" name="Frase">
-            <a:extLst>
-              <a:ext uri="{FF2B5EF4-FFF2-40B4-BE49-F238E27FC236}">
-                <a16:creationId xmlns:a16="http://schemas.microsoft.com/office/drawing/2014/main" id="{F5DEF8E5-A6D3-FF16-3A4C-6762958F1B84}"/>
-              </a:ext>
-            </a:extLst>
-          </p:cNvPr>
-          <p:cNvSpPr>
-            <a:spLocks noGrp="1"/>
-          </p:cNvSpPr>
-          <p:nvPr>
-            <p:ph type="subTitle" idx="1" hasCustomPrompt="1"/>
-          </p:nvPr>
-        </p:nvSpPr>
-        <p:spPr>
-          <a:xfrm>
-            <a:off x="494907" y="2525677"/>
-            <a:ext cx="8154186" cy="914255"/>
-          </a:xfrm>
-        </p:spPr>
-        <p:txBody>
-          <a:bodyPr>
-            <a:noAutofit/>
-          </a:bodyPr>
-          <a:lstStyle>
-            <a:lvl1pPr marL="0" indent="0" algn="ctr">
-              <a:buNone/>
-              <a:defRPr sz="2400">
-                <a:latin typeface="Shadows Into Light Two" panose="02000506000000020004" pitchFamily="2" charset="0"/>
-              </a:defRPr>
-            </a:lvl1pPr>
-            <a:lvl2pPr marL="342900" indent="0" algn="ctr">
-              <a:buNone/>
-              <a:defRPr sz="1500"/>
-            </a:lvl2pPr>
-            <a:lvl3pPr marL="685800" indent="0" algn="ctr">
-              <a:buNone/>
-              <a:defRPr sz="1350"/>
-            </a:lvl3pPr>
-            <a:lvl4pPr marL="1028700" indent="0" algn="ctr">
-              <a:buNone/>
-              <a:defRPr sz="1200"/>
-            </a:lvl4pPr>
-            <a:lvl5pPr marL="1371600" indent="0" algn="ctr">
-              <a:buNone/>
-              <a:defRPr sz="1200"/>
-            </a:lvl5pPr>
-            <a:lvl6pPr marL="1714500" indent="0" algn="ctr">
-              <a:buNone/>
-              <a:defRPr sz="1200"/>
-            </a:lvl6pPr>
-            <a:lvl7pPr marL="2057400" indent="0" algn="ctr">
-              <a:buNone/>
-              <a:defRPr sz="1200"/>
-            </a:lvl7pPr>
-            <a:lvl8pPr marL="2400300" indent="0" algn="ctr">
-              <a:buNone/>
-              <a:defRPr sz="1200"/>
-            </a:lvl8pPr>
-            <a:lvl9pPr marL="2743200" indent="0" algn="ctr">
-              <a:buNone/>
-              <a:defRPr sz="1200"/>
-            </a:lvl9pPr>
-          </a:lstStyle>
-          <a:p>
-            <a:r>
-              <a:rPr lang="pt-PT" dirty="0"/>
-              <a:t>«Foste fiel em coisas pequenas:</a:t>
-            </a:r>
-          </a:p>
-          <a:p>
-            <a:r>
-              <a:rPr lang="pt-PT" dirty="0"/>
-              <a:t>vem tomar parte na alegria do teu Senhor»</a:t>
-            </a:r>
-          </a:p>
-          <a:p>
-            <a:endParaRPr lang="pt-PT" dirty="0"/>
-          </a:p>
-        </p:txBody>
-      </p:sp>
-      <p:sp>
-        <p:nvSpPr>
           <p:cNvPr id="10" name="Versiculo">
             <a:extLst>
               <a:ext uri="{FF2B5EF4-FFF2-40B4-BE49-F238E27FC236}">
@@ -6123,6 +7642,86 @@
               <a:t>Ano A</a:t>
             </a:r>
             <a:endParaRPr lang="pt-PT" dirty="0"/>
+          </a:p>
+        </p:txBody>
+      </p:sp>
+      <p:sp>
+        <p:nvSpPr>
+          <p:cNvPr id="6" name="Frase">
+            <a:extLst>
+              <a:ext uri="{FF2B5EF4-FFF2-40B4-BE49-F238E27FC236}">
+                <a16:creationId xmlns:a16="http://schemas.microsoft.com/office/drawing/2014/main" id="{266F4FDB-B979-745C-320D-6CEA04390DD9}"/>
+              </a:ext>
+            </a:extLst>
+          </p:cNvPr>
+          <p:cNvSpPr>
+            <a:spLocks noGrp="1"/>
+          </p:cNvSpPr>
+          <p:nvPr>
+            <p:ph type="subTitle" idx="1" hasCustomPrompt="1"/>
+          </p:nvPr>
+        </p:nvSpPr>
+        <p:spPr>
+          <a:xfrm>
+            <a:off x="494907" y="2525677"/>
+            <a:ext cx="8154186" cy="914255"/>
+          </a:xfrm>
+        </p:spPr>
+        <p:txBody>
+          <a:bodyPr anchor="ctr" anchorCtr="0">
+            <a:noAutofit/>
+          </a:bodyPr>
+          <a:lstStyle>
+            <a:lvl1pPr marL="0" indent="0" algn="ctr">
+              <a:buNone/>
+              <a:defRPr sz="2400">
+                <a:latin typeface="Shadows Into Light Two" panose="02000506000000020004" pitchFamily="2" charset="0"/>
+              </a:defRPr>
+            </a:lvl1pPr>
+            <a:lvl2pPr marL="342900" indent="0" algn="ctr">
+              <a:buNone/>
+              <a:defRPr sz="1500"/>
+            </a:lvl2pPr>
+            <a:lvl3pPr marL="685800" indent="0" algn="ctr">
+              <a:buNone/>
+              <a:defRPr sz="1350"/>
+            </a:lvl3pPr>
+            <a:lvl4pPr marL="1028700" indent="0" algn="ctr">
+              <a:buNone/>
+              <a:defRPr sz="1200"/>
+            </a:lvl4pPr>
+            <a:lvl5pPr marL="1371600" indent="0" algn="ctr">
+              <a:buNone/>
+              <a:defRPr sz="1200"/>
+            </a:lvl5pPr>
+            <a:lvl6pPr marL="1714500" indent="0" algn="ctr">
+              <a:buNone/>
+              <a:defRPr sz="1200"/>
+            </a:lvl6pPr>
+            <a:lvl7pPr marL="2057400" indent="0" algn="ctr">
+              <a:buNone/>
+              <a:defRPr sz="1200"/>
+            </a:lvl7pPr>
+            <a:lvl8pPr marL="2400300" indent="0" algn="ctr">
+              <a:buNone/>
+              <a:defRPr sz="1200"/>
+            </a:lvl8pPr>
+            <a:lvl9pPr marL="2743200" indent="0" algn="ctr">
+              <a:buNone/>
+              <a:defRPr sz="1200"/>
+            </a:lvl9pPr>
+          </a:lstStyle>
+          <a:p>
+            <a:r>
+              <a:rPr lang="pt-PT" dirty="0"/>
+              <a:t>«Foste fiel em coisas pequenas:</a:t>
+            </a:r>
+          </a:p>
+          <a:p>
+            <a:r>
+              <a:rPr lang="pt-PT" dirty="0"/>
+              <a:t>vem tomar parte na alegria do teu Senhor»</a:t>
+            </a:r>
           </a:p>
         </p:txBody>
       </p:sp>
@@ -6215,89 +7814,6 @@
       </p:sp>
       <p:sp>
         <p:nvSpPr>
-          <p:cNvPr id="3" name="Frase">
-            <a:extLst>
-              <a:ext uri="{FF2B5EF4-FFF2-40B4-BE49-F238E27FC236}">
-                <a16:creationId xmlns:a16="http://schemas.microsoft.com/office/drawing/2014/main" id="{F5DEF8E5-A6D3-FF16-3A4C-6762958F1B84}"/>
-              </a:ext>
-            </a:extLst>
-          </p:cNvPr>
-          <p:cNvSpPr>
-            <a:spLocks noGrp="1"/>
-          </p:cNvSpPr>
-          <p:nvPr>
-            <p:ph type="subTitle" idx="1" hasCustomPrompt="1"/>
-          </p:nvPr>
-        </p:nvSpPr>
-        <p:spPr>
-          <a:xfrm>
-            <a:off x="494907" y="2525677"/>
-            <a:ext cx="8154186" cy="914255"/>
-          </a:xfrm>
-        </p:spPr>
-        <p:txBody>
-          <a:bodyPr>
-            <a:noAutofit/>
-          </a:bodyPr>
-          <a:lstStyle>
-            <a:lvl1pPr marL="0" indent="0" algn="ctr">
-              <a:buNone/>
-              <a:defRPr sz="2400">
-                <a:latin typeface="Shadows Into Light Two" panose="02000506000000020004" pitchFamily="2" charset="0"/>
-              </a:defRPr>
-            </a:lvl1pPr>
-            <a:lvl2pPr marL="342900" indent="0" algn="ctr">
-              <a:buNone/>
-              <a:defRPr sz="1500"/>
-            </a:lvl2pPr>
-            <a:lvl3pPr marL="685800" indent="0" algn="ctr">
-              <a:buNone/>
-              <a:defRPr sz="1350"/>
-            </a:lvl3pPr>
-            <a:lvl4pPr marL="1028700" indent="0" algn="ctr">
-              <a:buNone/>
-              <a:defRPr sz="1200"/>
-            </a:lvl4pPr>
-            <a:lvl5pPr marL="1371600" indent="0" algn="ctr">
-              <a:buNone/>
-              <a:defRPr sz="1200"/>
-            </a:lvl5pPr>
-            <a:lvl6pPr marL="1714500" indent="0" algn="ctr">
-              <a:buNone/>
-              <a:defRPr sz="1200"/>
-            </a:lvl6pPr>
-            <a:lvl7pPr marL="2057400" indent="0" algn="ctr">
-              <a:buNone/>
-              <a:defRPr sz="1200"/>
-            </a:lvl7pPr>
-            <a:lvl8pPr marL="2400300" indent="0" algn="ctr">
-              <a:buNone/>
-              <a:defRPr sz="1200"/>
-            </a:lvl8pPr>
-            <a:lvl9pPr marL="2743200" indent="0" algn="ctr">
-              <a:buNone/>
-              <a:defRPr sz="1200"/>
-            </a:lvl9pPr>
-          </a:lstStyle>
-          <a:p>
-            <a:r>
-              <a:rPr lang="pt-PT" dirty="0"/>
-              <a:t>«Foste fiel em coisas pequenas:</a:t>
-            </a:r>
-          </a:p>
-          <a:p>
-            <a:r>
-              <a:rPr lang="pt-PT" dirty="0"/>
-              <a:t>vem tomar parte na alegria do teu Senhor»</a:t>
-            </a:r>
-          </a:p>
-          <a:p>
-            <a:endParaRPr lang="pt-PT" dirty="0"/>
-          </a:p>
-        </p:txBody>
-      </p:sp>
-      <p:sp>
-        <p:nvSpPr>
           <p:cNvPr id="10" name="Versiculo">
             <a:extLst>
               <a:ext uri="{FF2B5EF4-FFF2-40B4-BE49-F238E27FC236}">
@@ -6460,6 +7976,86 @@
               <a:t>Ano A</a:t>
             </a:r>
             <a:endParaRPr lang="pt-PT" dirty="0"/>
+          </a:p>
+        </p:txBody>
+      </p:sp>
+      <p:sp>
+        <p:nvSpPr>
+          <p:cNvPr id="6" name="Frase">
+            <a:extLst>
+              <a:ext uri="{FF2B5EF4-FFF2-40B4-BE49-F238E27FC236}">
+                <a16:creationId xmlns:a16="http://schemas.microsoft.com/office/drawing/2014/main" id="{D08124FD-CC6B-7059-0C41-242782CD53AF}"/>
+              </a:ext>
+            </a:extLst>
+          </p:cNvPr>
+          <p:cNvSpPr>
+            <a:spLocks noGrp="1"/>
+          </p:cNvSpPr>
+          <p:nvPr>
+            <p:ph type="subTitle" idx="1" hasCustomPrompt="1"/>
+          </p:nvPr>
+        </p:nvSpPr>
+        <p:spPr>
+          <a:xfrm>
+            <a:off x="494907" y="2525677"/>
+            <a:ext cx="8154186" cy="914255"/>
+          </a:xfrm>
+        </p:spPr>
+        <p:txBody>
+          <a:bodyPr anchor="ctr" anchorCtr="0">
+            <a:noAutofit/>
+          </a:bodyPr>
+          <a:lstStyle>
+            <a:lvl1pPr marL="0" indent="0" algn="ctr">
+              <a:buNone/>
+              <a:defRPr sz="2400">
+                <a:latin typeface="Shadows Into Light Two" panose="02000506000000020004" pitchFamily="2" charset="0"/>
+              </a:defRPr>
+            </a:lvl1pPr>
+            <a:lvl2pPr marL="342900" indent="0" algn="ctr">
+              <a:buNone/>
+              <a:defRPr sz="1500"/>
+            </a:lvl2pPr>
+            <a:lvl3pPr marL="685800" indent="0" algn="ctr">
+              <a:buNone/>
+              <a:defRPr sz="1350"/>
+            </a:lvl3pPr>
+            <a:lvl4pPr marL="1028700" indent="0" algn="ctr">
+              <a:buNone/>
+              <a:defRPr sz="1200"/>
+            </a:lvl4pPr>
+            <a:lvl5pPr marL="1371600" indent="0" algn="ctr">
+              <a:buNone/>
+              <a:defRPr sz="1200"/>
+            </a:lvl5pPr>
+            <a:lvl6pPr marL="1714500" indent="0" algn="ctr">
+              <a:buNone/>
+              <a:defRPr sz="1200"/>
+            </a:lvl6pPr>
+            <a:lvl7pPr marL="2057400" indent="0" algn="ctr">
+              <a:buNone/>
+              <a:defRPr sz="1200"/>
+            </a:lvl7pPr>
+            <a:lvl8pPr marL="2400300" indent="0" algn="ctr">
+              <a:buNone/>
+              <a:defRPr sz="1200"/>
+            </a:lvl8pPr>
+            <a:lvl9pPr marL="2743200" indent="0" algn="ctr">
+              <a:buNone/>
+              <a:defRPr sz="1200"/>
+            </a:lvl9pPr>
+          </a:lstStyle>
+          <a:p>
+            <a:r>
+              <a:rPr lang="pt-PT" dirty="0"/>
+              <a:t>«Foste fiel em coisas pequenas:</a:t>
+            </a:r>
+          </a:p>
+          <a:p>
+            <a:r>
+              <a:rPr lang="pt-PT" dirty="0"/>
+              <a:t>vem tomar parte na alegria do teu Senhor»</a:t>
+            </a:r>
           </a:p>
         </p:txBody>
       </p:sp>
@@ -6556,89 +8152,6 @@
       </p:sp>
       <p:sp>
         <p:nvSpPr>
-          <p:cNvPr id="3" name="Frase">
-            <a:extLst>
-              <a:ext uri="{FF2B5EF4-FFF2-40B4-BE49-F238E27FC236}">
-                <a16:creationId xmlns:a16="http://schemas.microsoft.com/office/drawing/2014/main" id="{F5DEF8E5-A6D3-FF16-3A4C-6762958F1B84}"/>
-              </a:ext>
-            </a:extLst>
-          </p:cNvPr>
-          <p:cNvSpPr>
-            <a:spLocks noGrp="1"/>
-          </p:cNvSpPr>
-          <p:nvPr>
-            <p:ph type="subTitle" idx="1" hasCustomPrompt="1"/>
-          </p:nvPr>
-        </p:nvSpPr>
-        <p:spPr>
-          <a:xfrm>
-            <a:off x="494907" y="2525677"/>
-            <a:ext cx="8154186" cy="914255"/>
-          </a:xfrm>
-        </p:spPr>
-        <p:txBody>
-          <a:bodyPr>
-            <a:noAutofit/>
-          </a:bodyPr>
-          <a:lstStyle>
-            <a:lvl1pPr marL="0" indent="0" algn="ctr">
-              <a:buNone/>
-              <a:defRPr sz="2400">
-                <a:latin typeface="Shadows Into Light Two" panose="02000506000000020004" pitchFamily="2" charset="0"/>
-              </a:defRPr>
-            </a:lvl1pPr>
-            <a:lvl2pPr marL="342900" indent="0" algn="ctr">
-              <a:buNone/>
-              <a:defRPr sz="1500"/>
-            </a:lvl2pPr>
-            <a:lvl3pPr marL="685800" indent="0" algn="ctr">
-              <a:buNone/>
-              <a:defRPr sz="1350"/>
-            </a:lvl3pPr>
-            <a:lvl4pPr marL="1028700" indent="0" algn="ctr">
-              <a:buNone/>
-              <a:defRPr sz="1200"/>
-            </a:lvl4pPr>
-            <a:lvl5pPr marL="1371600" indent="0" algn="ctr">
-              <a:buNone/>
-              <a:defRPr sz="1200"/>
-            </a:lvl5pPr>
-            <a:lvl6pPr marL="1714500" indent="0" algn="ctr">
-              <a:buNone/>
-              <a:defRPr sz="1200"/>
-            </a:lvl6pPr>
-            <a:lvl7pPr marL="2057400" indent="0" algn="ctr">
-              <a:buNone/>
-              <a:defRPr sz="1200"/>
-            </a:lvl7pPr>
-            <a:lvl8pPr marL="2400300" indent="0" algn="ctr">
-              <a:buNone/>
-              <a:defRPr sz="1200"/>
-            </a:lvl8pPr>
-            <a:lvl9pPr marL="2743200" indent="0" algn="ctr">
-              <a:buNone/>
-              <a:defRPr sz="1200"/>
-            </a:lvl9pPr>
-          </a:lstStyle>
-          <a:p>
-            <a:r>
-              <a:rPr lang="pt-PT" dirty="0"/>
-              <a:t>«Foste fiel em coisas pequenas:</a:t>
-            </a:r>
-          </a:p>
-          <a:p>
-            <a:r>
-              <a:rPr lang="pt-PT" dirty="0"/>
-              <a:t>vem tomar parte na alegria do teu Senhor»</a:t>
-            </a:r>
-          </a:p>
-          <a:p>
-            <a:endParaRPr lang="pt-PT" dirty="0"/>
-          </a:p>
-        </p:txBody>
-      </p:sp>
-      <p:sp>
-        <p:nvSpPr>
           <p:cNvPr id="10" name="Versiculo">
             <a:extLst>
               <a:ext uri="{FF2B5EF4-FFF2-40B4-BE49-F238E27FC236}">
@@ -6801,6 +8314,86 @@
               <a:t>Ano A</a:t>
             </a:r>
             <a:endParaRPr lang="pt-PT" dirty="0"/>
+          </a:p>
+        </p:txBody>
+      </p:sp>
+      <p:sp>
+        <p:nvSpPr>
+          <p:cNvPr id="6" name="Frase">
+            <a:extLst>
+              <a:ext uri="{FF2B5EF4-FFF2-40B4-BE49-F238E27FC236}">
+                <a16:creationId xmlns:a16="http://schemas.microsoft.com/office/drawing/2014/main" id="{0E697FAB-DEF7-E708-A0BC-88BF5E9C774F}"/>
+              </a:ext>
+            </a:extLst>
+          </p:cNvPr>
+          <p:cNvSpPr>
+            <a:spLocks noGrp="1"/>
+          </p:cNvSpPr>
+          <p:nvPr>
+            <p:ph type="subTitle" idx="1" hasCustomPrompt="1"/>
+          </p:nvPr>
+        </p:nvSpPr>
+        <p:spPr>
+          <a:xfrm>
+            <a:off x="494907" y="2525677"/>
+            <a:ext cx="8154186" cy="914255"/>
+          </a:xfrm>
+        </p:spPr>
+        <p:txBody>
+          <a:bodyPr anchor="ctr" anchorCtr="0">
+            <a:noAutofit/>
+          </a:bodyPr>
+          <a:lstStyle>
+            <a:lvl1pPr marL="0" indent="0" algn="ctr">
+              <a:buNone/>
+              <a:defRPr sz="2400">
+                <a:latin typeface="Shadows Into Light Two" panose="02000506000000020004" pitchFamily="2" charset="0"/>
+              </a:defRPr>
+            </a:lvl1pPr>
+            <a:lvl2pPr marL="342900" indent="0" algn="ctr">
+              <a:buNone/>
+              <a:defRPr sz="1500"/>
+            </a:lvl2pPr>
+            <a:lvl3pPr marL="685800" indent="0" algn="ctr">
+              <a:buNone/>
+              <a:defRPr sz="1350"/>
+            </a:lvl3pPr>
+            <a:lvl4pPr marL="1028700" indent="0" algn="ctr">
+              <a:buNone/>
+              <a:defRPr sz="1200"/>
+            </a:lvl4pPr>
+            <a:lvl5pPr marL="1371600" indent="0" algn="ctr">
+              <a:buNone/>
+              <a:defRPr sz="1200"/>
+            </a:lvl5pPr>
+            <a:lvl6pPr marL="1714500" indent="0" algn="ctr">
+              <a:buNone/>
+              <a:defRPr sz="1200"/>
+            </a:lvl6pPr>
+            <a:lvl7pPr marL="2057400" indent="0" algn="ctr">
+              <a:buNone/>
+              <a:defRPr sz="1200"/>
+            </a:lvl7pPr>
+            <a:lvl8pPr marL="2400300" indent="0" algn="ctr">
+              <a:buNone/>
+              <a:defRPr sz="1200"/>
+            </a:lvl8pPr>
+            <a:lvl9pPr marL="2743200" indent="0" algn="ctr">
+              <a:buNone/>
+              <a:defRPr sz="1200"/>
+            </a:lvl9pPr>
+          </a:lstStyle>
+          <a:p>
+            <a:r>
+              <a:rPr lang="pt-PT" dirty="0"/>
+              <a:t>«Foste fiel em coisas pequenas:</a:t>
+            </a:r>
+          </a:p>
+          <a:p>
+            <a:r>
+              <a:rPr lang="pt-PT" dirty="0"/>
+              <a:t>vem tomar parte na alegria do teu Senhor»</a:t>
+            </a:r>
           </a:p>
         </p:txBody>
       </p:sp>
@@ -7126,6 +8719,11 @@
     <p:sldLayoutId id="2147483690" r:id="rId32"/>
     <p:sldLayoutId id="2147483692" r:id="rId33"/>
     <p:sldLayoutId id="2147483691" r:id="rId34"/>
+    <p:sldLayoutId id="2147483694" r:id="rId35"/>
+    <p:sldLayoutId id="2147483700" r:id="rId36"/>
+    <p:sldLayoutId id="2147483701" r:id="rId37"/>
+    <p:sldLayoutId id="2147483703" r:id="rId38"/>
+    <p:sldLayoutId id="2147483702" r:id="rId39"/>
   </p:sldLayoutIdLst>
   <p:txStyles>
     <p:titleStyle>
@@ -7427,7 +9025,7 @@
         <a:srgbClr val="FFEDB5"/>
       </a:lt2>
       <a:accent1>
-        <a:srgbClr val="377D49"/>
+        <a:srgbClr val="46715C"/>
       </a:accent1>
       <a:accent2>
         <a:srgbClr val="A461AF"/>
@@ -7904,47 +9502,4 @@
     </a:ext>
   </a:extLst>
 </a:theme>
-</file>
-
-<file path=ppt/theme/themeOverride1.xml><?xml version="1.0" encoding="utf-8"?>
-<a:themeOverride xmlns:a="http://schemas.openxmlformats.org/drawingml/2006/main">
-  <a:clrScheme name="Liturgia">
-    <a:dk1>
-      <a:sysClr val="windowText" lastClr="000000"/>
-    </a:dk1>
-    <a:lt1>
-      <a:sysClr val="window" lastClr="FFFFFF"/>
-    </a:lt1>
-    <a:dk2>
-      <a:srgbClr val="44546A"/>
-    </a:dk2>
-    <a:lt2>
-      <a:srgbClr val="FFEDB5"/>
-    </a:lt2>
-    <a:accent1>
-      <a:srgbClr val="377D49"/>
-    </a:accent1>
-    <a:accent2>
-      <a:srgbClr val="A461AF"/>
-    </a:accent2>
-    <a:accent3>
-      <a:srgbClr val="F99595"/>
-    </a:accent3>
-    <a:accent4>
-      <a:srgbClr val="8C6A00"/>
-    </a:accent4>
-    <a:accent5>
-      <a:srgbClr val="B92323"/>
-    </a:accent5>
-    <a:accent6>
-      <a:srgbClr val="3470B2"/>
-    </a:accent6>
-    <a:hlink>
-      <a:srgbClr val="0563C1"/>
-    </a:hlink>
-    <a:folHlink>
-      <a:srgbClr val="954F72"/>
-    </a:folHlink>
-  </a:clrScheme>
-</a:themeOverride>
 </file>
</xml_diff>

<commit_message>
feature: generate a weekday or fixed solemnity from its date
</commit_message>
<xml_diff>
--- a/backend/data/template_4x3.pptx
+++ b/backend/data/template_4x3.pptx
@@ -648,6 +648,678 @@
 
 <file path=ppt/slideLayouts/slideLayout10.xml><?xml version="1.0" encoding="utf-8"?>
 <p:sldLayout xmlns:a="http://schemas.openxmlformats.org/drawingml/2006/main" xmlns:r="http://schemas.openxmlformats.org/officeDocument/2006/relationships" xmlns:p="http://schemas.openxmlformats.org/presentationml/2006/main" preserve="1" userDrawn="1">
+  <p:cSld name="Capa - Páscoa">
+    <p:bg>
+      <p:bgPr>
+        <a:solidFill>
+          <a:schemeClr val="accent4">
+            <a:lumMod val="20000"/>
+            <a:lumOff val="80000"/>
+            <a:alpha val="20000"/>
+          </a:schemeClr>
+        </a:solidFill>
+        <a:effectLst/>
+      </p:bgPr>
+    </p:bg>
+    <p:spTree>
+      <p:nvGrpSpPr>
+        <p:cNvPr id="1" name=""/>
+        <p:cNvGrpSpPr/>
+        <p:nvPr/>
+      </p:nvGrpSpPr>
+      <p:grpSpPr>
+        <a:xfrm>
+          <a:off x="0" y="0"/>
+          <a:ext cx="0" cy="0"/>
+          <a:chOff x="0" y="0"/>
+          <a:chExt cx="0" cy="0"/>
+        </a:xfrm>
+      </p:grpSpPr>
+      <p:sp>
+        <p:nvSpPr>
+          <p:cNvPr id="2" name="Domingo">
+            <a:extLst>
+              <a:ext uri="{FF2B5EF4-FFF2-40B4-BE49-F238E27FC236}">
+                <a16:creationId xmlns:a16="http://schemas.microsoft.com/office/drawing/2014/main" id="{AC6EEB27-5DD2-414A-A29B-10D30F19AC21}"/>
+              </a:ext>
+            </a:extLst>
+          </p:cNvPr>
+          <p:cNvSpPr>
+            <a:spLocks noGrp="1"/>
+          </p:cNvSpPr>
+          <p:nvPr>
+            <p:ph type="ctrTitle" hasCustomPrompt="1"/>
+          </p:nvPr>
+        </p:nvSpPr>
+        <p:spPr>
+          <a:xfrm>
+            <a:off x="1143000" y="1129506"/>
+            <a:ext cx="6858000" cy="1106127"/>
+          </a:xfrm>
+        </p:spPr>
+        <p:txBody>
+          <a:bodyPr anchor="b">
+            <a:normAutofit/>
+          </a:bodyPr>
+          <a:lstStyle>
+            <a:lvl1pPr algn="ctr">
+              <a:defRPr sz="6600" b="1">
+                <a:solidFill>
+                  <a:schemeClr val="accent4"/>
+                </a:solidFill>
+                <a:latin typeface="Playfair Display" pitchFamily="2" charset="0"/>
+              </a:defRPr>
+            </a:lvl1pPr>
+          </a:lstStyle>
+          <a:p>
+            <a:r>
+              <a:rPr lang="en-US" dirty="0"/>
+              <a:t>Domingo VIII</a:t>
+            </a:r>
+            <a:endParaRPr lang="pt-PT" dirty="0"/>
+          </a:p>
+        </p:txBody>
+      </p:sp>
+      <p:sp>
+        <p:nvSpPr>
+          <p:cNvPr id="10" name="Versiculo">
+            <a:extLst>
+              <a:ext uri="{FF2B5EF4-FFF2-40B4-BE49-F238E27FC236}">
+                <a16:creationId xmlns:a16="http://schemas.microsoft.com/office/drawing/2014/main" id="{5E840FDF-3863-C2D2-A15A-5646F8E54972}"/>
+              </a:ext>
+            </a:extLst>
+          </p:cNvPr>
+          <p:cNvSpPr>
+            <a:spLocks noGrp="1"/>
+          </p:cNvSpPr>
+          <p:nvPr>
+            <p:ph type="body" sz="quarter" idx="11" hasCustomPrompt="1"/>
+          </p:nvPr>
+        </p:nvSpPr>
+        <p:spPr>
+          <a:xfrm>
+            <a:off x="2597150" y="3439932"/>
+            <a:ext cx="3949700" cy="369838"/>
+          </a:xfrm>
+        </p:spPr>
+        <p:txBody>
+          <a:bodyPr>
+            <a:noAutofit/>
+          </a:bodyPr>
+          <a:lstStyle>
+            <a:lvl1pPr algn="ctr">
+              <a:defRPr lang="pt-PT" sz="1600" b="0" kern="1200" cap="small" spc="0" baseline="0" dirty="0">
+                <a:solidFill>
+                  <a:schemeClr val="tx1"/>
+                </a:solidFill>
+                <a:latin typeface="Livvic" pitchFamily="2" charset="0"/>
+                <a:ea typeface="+mn-ea"/>
+                <a:cs typeface="+mn-cs"/>
+              </a:defRPr>
+            </a:lvl1pPr>
+            <a:lvl2pPr>
+              <a:defRPr sz="1800"/>
+            </a:lvl2pPr>
+            <a:lvl3pPr>
+              <a:defRPr sz="1600"/>
+            </a:lvl3pPr>
+            <a:lvl4pPr>
+              <a:defRPr sz="1600"/>
+            </a:lvl4pPr>
+            <a:lvl5pPr>
+              <a:defRPr sz="1600"/>
+            </a:lvl5pPr>
+          </a:lstStyle>
+          <a:p>
+            <a:pPr marL="0" lvl="0" indent="0" algn="ctr" defTabSz="685800" rtl="0" eaLnBrk="1" latinLnBrk="0" hangingPunct="1">
+              <a:lnSpc>
+                <a:spcPct val="90000"/>
+              </a:lnSpc>
+              <a:spcBef>
+                <a:spcPts val="750"/>
+              </a:spcBef>
+              <a:buFont typeface="Arial" panose="020B0604020202020204" pitchFamily="34" charset="0"/>
+              <a:buNone/>
+            </a:pPr>
+            <a:r>
+              <a:rPr lang="en-US" dirty="0"/>
+              <a:t>Mt 25, 14-30</a:t>
+            </a:r>
+            <a:endParaRPr lang="pt-PT" dirty="0"/>
+          </a:p>
+        </p:txBody>
+      </p:sp>
+      <p:pic>
+        <p:nvPicPr>
+          <p:cNvPr id="5" name="Picture 4">
+            <a:extLst>
+              <a:ext uri="{FF2B5EF4-FFF2-40B4-BE49-F238E27FC236}">
+                <a16:creationId xmlns:a16="http://schemas.microsoft.com/office/drawing/2014/main" id="{CFFB9FFB-187A-E58F-9BD3-81D67A3BC287}"/>
+              </a:ext>
+            </a:extLst>
+          </p:cNvPr>
+          <p:cNvPicPr>
+            <a:picLocks noChangeAspect="1"/>
+          </p:cNvPicPr>
+          <p:nvPr userDrawn="1"/>
+        </p:nvPicPr>
+        <p:blipFill>
+          <a:blip r:embed="rId2">
+            <a:extLst>
+              <a:ext uri="{28A0092B-C50C-407E-A947-70E740481C1C}">
+                <a14:useLocalDpi xmlns:a14="http://schemas.microsoft.com/office/drawing/2010/main" val="0"/>
+              </a:ext>
+            </a:extLst>
+          </a:blip>
+          <a:srcRect t="13134" b="13134"/>
+          <a:stretch/>
+        </p:blipFill>
+        <p:spPr>
+          <a:xfrm>
+            <a:off x="2597150" y="3940404"/>
+            <a:ext cx="3867487" cy="2851608"/>
+          </a:xfrm>
+          <a:prstGeom prst="rect">
+            <a:avLst/>
+          </a:prstGeom>
+        </p:spPr>
+      </p:pic>
+      <p:sp>
+        <p:nvSpPr>
+          <p:cNvPr id="4" name="Tempo">
+            <a:extLst>
+              <a:ext uri="{FF2B5EF4-FFF2-40B4-BE49-F238E27FC236}">
+                <a16:creationId xmlns:a16="http://schemas.microsoft.com/office/drawing/2014/main" id="{FC37DF36-BF80-AA4F-FD0F-95E21C3011EC}"/>
+              </a:ext>
+            </a:extLst>
+          </p:cNvPr>
+          <p:cNvSpPr>
+            <a:spLocks noGrp="1"/>
+          </p:cNvSpPr>
+          <p:nvPr>
+            <p:ph type="body" sz="quarter" idx="10" hasCustomPrompt="1"/>
+          </p:nvPr>
+        </p:nvSpPr>
+        <p:spPr>
+          <a:xfrm>
+            <a:off x="2074048" y="654543"/>
+            <a:ext cx="4913689" cy="369838"/>
+          </a:xfrm>
+        </p:spPr>
+        <p:txBody>
+          <a:bodyPr>
+            <a:noAutofit/>
+          </a:bodyPr>
+          <a:lstStyle>
+            <a:lvl1pPr algn="ctr">
+              <a:defRPr sz="1800" b="0" cap="small" spc="600" baseline="0">
+                <a:latin typeface="Livvic" pitchFamily="2" charset="0"/>
+              </a:defRPr>
+            </a:lvl1pPr>
+            <a:lvl2pPr>
+              <a:defRPr sz="1800"/>
+            </a:lvl2pPr>
+            <a:lvl3pPr>
+              <a:defRPr sz="1600"/>
+            </a:lvl3pPr>
+            <a:lvl4pPr>
+              <a:defRPr sz="1600"/>
+            </a:lvl4pPr>
+            <a:lvl5pPr>
+              <a:defRPr sz="1600"/>
+            </a:lvl5pPr>
+          </a:lstStyle>
+          <a:p>
+            <a:pPr lvl="0"/>
+            <a:r>
+              <a:rPr lang="en-US" dirty="0"/>
+              <a:t>Tempo de Páscoa </a:t>
+            </a:r>
+            <a:r>
+              <a:rPr lang="pt-PT" dirty="0"/>
+              <a:t>· </a:t>
+            </a:r>
+            <a:r>
+              <a:rPr lang="en-US" dirty="0"/>
+              <a:t>Ano A</a:t>
+            </a:r>
+            <a:endParaRPr lang="pt-PT" dirty="0"/>
+          </a:p>
+        </p:txBody>
+      </p:sp>
+      <p:sp>
+        <p:nvSpPr>
+          <p:cNvPr id="6" name="Frase">
+            <a:extLst>
+              <a:ext uri="{FF2B5EF4-FFF2-40B4-BE49-F238E27FC236}">
+                <a16:creationId xmlns:a16="http://schemas.microsoft.com/office/drawing/2014/main" id="{D08124FD-CC6B-7059-0C41-242782CD53AF}"/>
+              </a:ext>
+            </a:extLst>
+          </p:cNvPr>
+          <p:cNvSpPr>
+            <a:spLocks noGrp="1"/>
+          </p:cNvSpPr>
+          <p:nvPr>
+            <p:ph type="subTitle" idx="1" hasCustomPrompt="1"/>
+          </p:nvPr>
+        </p:nvSpPr>
+        <p:spPr>
+          <a:xfrm>
+            <a:off x="494907" y="2525677"/>
+            <a:ext cx="8154186" cy="914255"/>
+          </a:xfrm>
+        </p:spPr>
+        <p:txBody>
+          <a:bodyPr anchor="ctr" anchorCtr="0">
+            <a:noAutofit/>
+          </a:bodyPr>
+          <a:lstStyle>
+            <a:lvl1pPr marL="0" indent="0" algn="ctr">
+              <a:buNone/>
+              <a:defRPr sz="2400">
+                <a:latin typeface="Shadows Into Light Two" panose="02000506000000020004" pitchFamily="2" charset="0"/>
+              </a:defRPr>
+            </a:lvl1pPr>
+            <a:lvl2pPr marL="342900" indent="0" algn="ctr">
+              <a:buNone/>
+              <a:defRPr sz="1500"/>
+            </a:lvl2pPr>
+            <a:lvl3pPr marL="685800" indent="0" algn="ctr">
+              <a:buNone/>
+              <a:defRPr sz="1350"/>
+            </a:lvl3pPr>
+            <a:lvl4pPr marL="1028700" indent="0" algn="ctr">
+              <a:buNone/>
+              <a:defRPr sz="1200"/>
+            </a:lvl4pPr>
+            <a:lvl5pPr marL="1371600" indent="0" algn="ctr">
+              <a:buNone/>
+              <a:defRPr sz="1200"/>
+            </a:lvl5pPr>
+            <a:lvl6pPr marL="1714500" indent="0" algn="ctr">
+              <a:buNone/>
+              <a:defRPr sz="1200"/>
+            </a:lvl6pPr>
+            <a:lvl7pPr marL="2057400" indent="0" algn="ctr">
+              <a:buNone/>
+              <a:defRPr sz="1200"/>
+            </a:lvl7pPr>
+            <a:lvl8pPr marL="2400300" indent="0" algn="ctr">
+              <a:buNone/>
+              <a:defRPr sz="1200"/>
+            </a:lvl8pPr>
+            <a:lvl9pPr marL="2743200" indent="0" algn="ctr">
+              <a:buNone/>
+              <a:defRPr sz="1200"/>
+            </a:lvl9pPr>
+          </a:lstStyle>
+          <a:p>
+            <a:r>
+              <a:rPr lang="pt-PT" dirty="0"/>
+              <a:t>«Foste fiel em coisas pequenas:</a:t>
+            </a:r>
+          </a:p>
+          <a:p>
+            <a:r>
+              <a:rPr lang="pt-PT" dirty="0"/>
+              <a:t>vem tomar parte na alegria do teu Senhor»</a:t>
+            </a:r>
+          </a:p>
+        </p:txBody>
+      </p:sp>
+    </p:spTree>
+    <p:extLst>
+      <p:ext uri="{BB962C8B-B14F-4D97-AF65-F5344CB8AC3E}">
+        <p14:creationId xmlns:p14="http://schemas.microsoft.com/office/powerpoint/2010/main" val="3276494890"/>
+      </p:ext>
+    </p:extLst>
+  </p:cSld>
+  <p:clrMapOvr>
+    <a:masterClrMapping/>
+  </p:clrMapOvr>
+</p:sldLayout>
+</file>
+
+<file path=ppt/slideLayouts/slideLayout11.xml><?xml version="1.0" encoding="utf-8"?>
+<p:sldLayout xmlns:a="http://schemas.openxmlformats.org/drawingml/2006/main" xmlns:r="http://schemas.openxmlformats.org/officeDocument/2006/relationships" xmlns:p="http://schemas.openxmlformats.org/presentationml/2006/main" preserve="1" userDrawn="1">
+  <p:cSld name="Capa - Pentecostes">
+    <p:bg>
+      <p:bgPr>
+        <a:solidFill>
+          <a:schemeClr val="accent5">
+            <a:lumMod val="60000"/>
+            <a:lumOff val="40000"/>
+            <a:alpha val="20000"/>
+          </a:schemeClr>
+        </a:solidFill>
+        <a:effectLst/>
+      </p:bgPr>
+    </p:bg>
+    <p:spTree>
+      <p:nvGrpSpPr>
+        <p:cNvPr id="1" name=""/>
+        <p:cNvGrpSpPr/>
+        <p:nvPr/>
+      </p:nvGrpSpPr>
+      <p:grpSpPr>
+        <a:xfrm>
+          <a:off x="0" y="0"/>
+          <a:ext cx="0" cy="0"/>
+          <a:chOff x="0" y="0"/>
+          <a:chExt cx="0" cy="0"/>
+        </a:xfrm>
+      </p:grpSpPr>
+      <p:sp>
+        <p:nvSpPr>
+          <p:cNvPr id="2" name="Domingo">
+            <a:extLst>
+              <a:ext uri="{FF2B5EF4-FFF2-40B4-BE49-F238E27FC236}">
+                <a16:creationId xmlns:a16="http://schemas.microsoft.com/office/drawing/2014/main" id="{AC6EEB27-5DD2-414A-A29B-10D30F19AC21}"/>
+              </a:ext>
+            </a:extLst>
+          </p:cNvPr>
+          <p:cNvSpPr>
+            <a:spLocks noGrp="1"/>
+          </p:cNvSpPr>
+          <p:nvPr>
+            <p:ph type="ctrTitle" hasCustomPrompt="1"/>
+          </p:nvPr>
+        </p:nvSpPr>
+        <p:spPr>
+          <a:xfrm>
+            <a:off x="0" y="1129506"/>
+            <a:ext cx="9144000" cy="1106127"/>
+          </a:xfrm>
+        </p:spPr>
+        <p:txBody>
+          <a:bodyPr anchor="b">
+            <a:noAutofit/>
+          </a:bodyPr>
+          <a:lstStyle>
+            <a:lvl1pPr algn="ctr">
+              <a:defRPr sz="6000" b="1">
+                <a:solidFill>
+                  <a:schemeClr val="accent5"/>
+                </a:solidFill>
+                <a:latin typeface="Playfair Display" pitchFamily="2" charset="0"/>
+              </a:defRPr>
+            </a:lvl1pPr>
+          </a:lstStyle>
+          <a:p>
+            <a:r>
+              <a:rPr lang="en-US" dirty="0"/>
+              <a:t>Domingo de </a:t>
+            </a:r>
+            <a:r>
+              <a:rPr lang="en-US" dirty="0" err="1"/>
+              <a:t>Pentecostes</a:t>
+            </a:r>
+            <a:endParaRPr lang="pt-PT" dirty="0"/>
+          </a:p>
+        </p:txBody>
+      </p:sp>
+      <p:sp>
+        <p:nvSpPr>
+          <p:cNvPr id="10" name="Versiculo">
+            <a:extLst>
+              <a:ext uri="{FF2B5EF4-FFF2-40B4-BE49-F238E27FC236}">
+                <a16:creationId xmlns:a16="http://schemas.microsoft.com/office/drawing/2014/main" id="{5E840FDF-3863-C2D2-A15A-5646F8E54972}"/>
+              </a:ext>
+            </a:extLst>
+          </p:cNvPr>
+          <p:cNvSpPr>
+            <a:spLocks noGrp="1"/>
+          </p:cNvSpPr>
+          <p:nvPr>
+            <p:ph type="body" sz="quarter" idx="11" hasCustomPrompt="1"/>
+          </p:nvPr>
+        </p:nvSpPr>
+        <p:spPr>
+          <a:xfrm>
+            <a:off x="2597150" y="3439932"/>
+            <a:ext cx="3949700" cy="369838"/>
+          </a:xfrm>
+        </p:spPr>
+        <p:txBody>
+          <a:bodyPr>
+            <a:noAutofit/>
+          </a:bodyPr>
+          <a:lstStyle>
+            <a:lvl1pPr algn="ctr">
+              <a:defRPr lang="pt-PT" sz="1600" b="0" kern="1200" cap="small" spc="0" baseline="0" dirty="0">
+                <a:solidFill>
+                  <a:schemeClr val="tx1"/>
+                </a:solidFill>
+                <a:latin typeface="Livvic" pitchFamily="2" charset="0"/>
+                <a:ea typeface="+mn-ea"/>
+                <a:cs typeface="+mn-cs"/>
+              </a:defRPr>
+            </a:lvl1pPr>
+            <a:lvl2pPr>
+              <a:defRPr sz="1800"/>
+            </a:lvl2pPr>
+            <a:lvl3pPr>
+              <a:defRPr sz="1600"/>
+            </a:lvl3pPr>
+            <a:lvl4pPr>
+              <a:defRPr sz="1600"/>
+            </a:lvl4pPr>
+            <a:lvl5pPr>
+              <a:defRPr sz="1600"/>
+            </a:lvl5pPr>
+          </a:lstStyle>
+          <a:p>
+            <a:pPr marL="0" lvl="0" indent="0" algn="ctr" defTabSz="685800" rtl="0" eaLnBrk="1" latinLnBrk="0" hangingPunct="1">
+              <a:lnSpc>
+                <a:spcPct val="90000"/>
+              </a:lnSpc>
+              <a:spcBef>
+                <a:spcPts val="750"/>
+              </a:spcBef>
+              <a:buFont typeface="Arial" panose="020B0604020202020204" pitchFamily="34" charset="0"/>
+              <a:buNone/>
+            </a:pPr>
+            <a:r>
+              <a:rPr lang="en-US" dirty="0"/>
+              <a:t>Mt 25, 14-30</a:t>
+            </a:r>
+            <a:endParaRPr lang="pt-PT" dirty="0"/>
+          </a:p>
+        </p:txBody>
+      </p:sp>
+      <p:pic>
+        <p:nvPicPr>
+          <p:cNvPr id="5" name="Picture 4">
+            <a:extLst>
+              <a:ext uri="{FF2B5EF4-FFF2-40B4-BE49-F238E27FC236}">
+                <a16:creationId xmlns:a16="http://schemas.microsoft.com/office/drawing/2014/main" id="{CFFB9FFB-187A-E58F-9BD3-81D67A3BC287}"/>
+              </a:ext>
+            </a:extLst>
+          </p:cNvPr>
+          <p:cNvPicPr>
+            <a:picLocks noChangeAspect="1"/>
+          </p:cNvPicPr>
+          <p:nvPr userDrawn="1"/>
+        </p:nvPicPr>
+        <p:blipFill>
+          <a:blip r:embed="rId2">
+            <a:extLst>
+              <a:ext uri="{28A0092B-C50C-407E-A947-70E740481C1C}">
+                <a14:useLocalDpi xmlns:a14="http://schemas.microsoft.com/office/drawing/2010/main" val="0"/>
+              </a:ext>
+            </a:extLst>
+          </a:blip>
+          <a:srcRect t="47" b="47"/>
+          <a:stretch/>
+        </p:blipFill>
+        <p:spPr>
+          <a:xfrm>
+            <a:off x="2597150" y="3940404"/>
+            <a:ext cx="3867487" cy="2851608"/>
+          </a:xfrm>
+          <a:prstGeom prst="rect">
+            <a:avLst/>
+          </a:prstGeom>
+        </p:spPr>
+      </p:pic>
+      <p:sp>
+        <p:nvSpPr>
+          <p:cNvPr id="4" name="Tempo">
+            <a:extLst>
+              <a:ext uri="{FF2B5EF4-FFF2-40B4-BE49-F238E27FC236}">
+                <a16:creationId xmlns:a16="http://schemas.microsoft.com/office/drawing/2014/main" id="{FC37DF36-BF80-AA4F-FD0F-95E21C3011EC}"/>
+              </a:ext>
+            </a:extLst>
+          </p:cNvPr>
+          <p:cNvSpPr>
+            <a:spLocks noGrp="1"/>
+          </p:cNvSpPr>
+          <p:nvPr>
+            <p:ph type="body" sz="quarter" idx="10" hasCustomPrompt="1"/>
+          </p:nvPr>
+        </p:nvSpPr>
+        <p:spPr>
+          <a:xfrm>
+            <a:off x="2074048" y="654543"/>
+            <a:ext cx="4913689" cy="369838"/>
+          </a:xfrm>
+        </p:spPr>
+        <p:txBody>
+          <a:bodyPr>
+            <a:noAutofit/>
+          </a:bodyPr>
+          <a:lstStyle>
+            <a:lvl1pPr algn="ctr">
+              <a:defRPr sz="1800" b="0" cap="small" spc="600" baseline="0">
+                <a:latin typeface="Livvic" pitchFamily="2" charset="0"/>
+              </a:defRPr>
+            </a:lvl1pPr>
+            <a:lvl2pPr>
+              <a:defRPr sz="1800"/>
+            </a:lvl2pPr>
+            <a:lvl3pPr>
+              <a:defRPr sz="1600"/>
+            </a:lvl3pPr>
+            <a:lvl4pPr>
+              <a:defRPr sz="1600"/>
+            </a:lvl4pPr>
+            <a:lvl5pPr>
+              <a:defRPr sz="1600"/>
+            </a:lvl5pPr>
+          </a:lstStyle>
+          <a:p>
+            <a:pPr lvl="0"/>
+            <a:r>
+              <a:rPr lang="en-US" dirty="0"/>
+              <a:t>Tempo de Páscoa </a:t>
+            </a:r>
+            <a:r>
+              <a:rPr lang="pt-PT" dirty="0"/>
+              <a:t>· </a:t>
+            </a:r>
+            <a:r>
+              <a:rPr lang="en-US" dirty="0"/>
+              <a:t>Ano A</a:t>
+            </a:r>
+            <a:endParaRPr lang="pt-PT" dirty="0"/>
+          </a:p>
+        </p:txBody>
+      </p:sp>
+      <p:sp>
+        <p:nvSpPr>
+          <p:cNvPr id="6" name="Frase">
+            <a:extLst>
+              <a:ext uri="{FF2B5EF4-FFF2-40B4-BE49-F238E27FC236}">
+                <a16:creationId xmlns:a16="http://schemas.microsoft.com/office/drawing/2014/main" id="{0E697FAB-DEF7-E708-A0BC-88BF5E9C774F}"/>
+              </a:ext>
+            </a:extLst>
+          </p:cNvPr>
+          <p:cNvSpPr>
+            <a:spLocks noGrp="1"/>
+          </p:cNvSpPr>
+          <p:nvPr>
+            <p:ph type="subTitle" idx="1" hasCustomPrompt="1"/>
+          </p:nvPr>
+        </p:nvSpPr>
+        <p:spPr>
+          <a:xfrm>
+            <a:off x="494907" y="2525677"/>
+            <a:ext cx="8154186" cy="914255"/>
+          </a:xfrm>
+        </p:spPr>
+        <p:txBody>
+          <a:bodyPr anchor="ctr" anchorCtr="0">
+            <a:noAutofit/>
+          </a:bodyPr>
+          <a:lstStyle>
+            <a:lvl1pPr marL="0" indent="0" algn="ctr">
+              <a:buNone/>
+              <a:defRPr sz="2400">
+                <a:latin typeface="Shadows Into Light Two" panose="02000506000000020004" pitchFamily="2" charset="0"/>
+              </a:defRPr>
+            </a:lvl1pPr>
+            <a:lvl2pPr marL="342900" indent="0" algn="ctr">
+              <a:buNone/>
+              <a:defRPr sz="1500"/>
+            </a:lvl2pPr>
+            <a:lvl3pPr marL="685800" indent="0" algn="ctr">
+              <a:buNone/>
+              <a:defRPr sz="1350"/>
+            </a:lvl3pPr>
+            <a:lvl4pPr marL="1028700" indent="0" algn="ctr">
+              <a:buNone/>
+              <a:defRPr sz="1200"/>
+            </a:lvl4pPr>
+            <a:lvl5pPr marL="1371600" indent="0" algn="ctr">
+              <a:buNone/>
+              <a:defRPr sz="1200"/>
+            </a:lvl5pPr>
+            <a:lvl6pPr marL="1714500" indent="0" algn="ctr">
+              <a:buNone/>
+              <a:defRPr sz="1200"/>
+            </a:lvl6pPr>
+            <a:lvl7pPr marL="2057400" indent="0" algn="ctr">
+              <a:buNone/>
+              <a:defRPr sz="1200"/>
+            </a:lvl7pPr>
+            <a:lvl8pPr marL="2400300" indent="0" algn="ctr">
+              <a:buNone/>
+              <a:defRPr sz="1200"/>
+            </a:lvl8pPr>
+            <a:lvl9pPr marL="2743200" indent="0" algn="ctr">
+              <a:buNone/>
+              <a:defRPr sz="1200"/>
+            </a:lvl9pPr>
+          </a:lstStyle>
+          <a:p>
+            <a:r>
+              <a:rPr lang="pt-PT" dirty="0"/>
+              <a:t>«Foste fiel em coisas pequenas:</a:t>
+            </a:r>
+          </a:p>
+          <a:p>
+            <a:r>
+              <a:rPr lang="pt-PT" dirty="0"/>
+              <a:t>vem tomar parte na alegria do teu Senhor»</a:t>
+            </a:r>
+          </a:p>
+        </p:txBody>
+      </p:sp>
+    </p:spTree>
+    <p:extLst>
+      <p:ext uri="{BB962C8B-B14F-4D97-AF65-F5344CB8AC3E}">
+        <p14:creationId xmlns:p14="http://schemas.microsoft.com/office/powerpoint/2010/main" val="447228626"/>
+      </p:ext>
+    </p:extLst>
+  </p:cSld>
+  <p:clrMapOvr>
+    <a:masterClrMapping/>
+  </p:clrMapOvr>
+</p:sldLayout>
+</file>
+
+<file path=ppt/slideLayouts/slideLayout12.xml><?xml version="1.0" encoding="utf-8"?>
+<p:sldLayout xmlns:a="http://schemas.openxmlformats.org/drawingml/2006/main" xmlns:r="http://schemas.openxmlformats.org/officeDocument/2006/relationships" xmlns:p="http://schemas.openxmlformats.org/presentationml/2006/main" preserve="1" userDrawn="1">
   <p:cSld name="Título e letra">
     <p:spTree>
       <p:nvGrpSpPr>
@@ -719,66 +1391,6 @@
       </p:sp>
       <p:sp>
         <p:nvSpPr>
-          <p:cNvPr id="2" name="Título">
-            <a:extLst>
-              <a:ext uri="{FF2B5EF4-FFF2-40B4-BE49-F238E27FC236}">
-                <a16:creationId xmlns:a16="http://schemas.microsoft.com/office/drawing/2014/main" id="{29D85961-FC26-87D6-F7CF-D2E332EB5E80}"/>
-              </a:ext>
-            </a:extLst>
-          </p:cNvPr>
-          <p:cNvSpPr>
-            <a:spLocks noGrp="1"/>
-          </p:cNvSpPr>
-          <p:nvPr>
-            <p:ph type="title" hasCustomPrompt="1"/>
-          </p:nvPr>
-        </p:nvSpPr>
-        <p:spPr>
-          <a:xfrm>
-            <a:off x="240890" y="245096"/>
-            <a:ext cx="8662220" cy="525262"/>
-          </a:xfrm>
-        </p:spPr>
-        <p:txBody>
-          <a:bodyPr wrap="square">
-            <a:normAutofit/>
-          </a:bodyPr>
-          <a:lstStyle>
-            <a:lvl1pPr algn="ctr">
-              <a:defRPr sz="3400" cap="small" baseline="0">
-                <a:solidFill>
-                  <a:schemeClr val="accent1">
-                    <a:lumMod val="20000"/>
-                    <a:lumOff val="80000"/>
-                  </a:schemeClr>
-                </a:solidFill>
-                <a:latin typeface="Livvic SemiBold" pitchFamily="2" charset="0"/>
-              </a:defRPr>
-            </a:lvl1pPr>
-          </a:lstStyle>
-          <a:p>
-            <a:r>
-              <a:rPr lang="en-US" dirty="0"/>
-              <a:t>Cristo </a:t>
-            </a:r>
-            <a:r>
-              <a:rPr lang="en-US" dirty="0" err="1"/>
-              <a:t>em</a:t>
-            </a:r>
-            <a:r>
-              <a:rPr lang="en-US" dirty="0"/>
-              <a:t> </a:t>
-            </a:r>
-            <a:r>
-              <a:rPr lang="en-US" dirty="0" err="1"/>
-              <a:t>mim</a:t>
-            </a:r>
-            <a:endParaRPr lang="pt-PT" dirty="0"/>
-          </a:p>
-        </p:txBody>
-      </p:sp>
-      <p:sp>
-        <p:nvSpPr>
           <p:cNvPr id="3" name="Letra">
             <a:extLst>
               <a:ext uri="{FF2B5EF4-FFF2-40B4-BE49-F238E27FC236}">
@@ -957,6 +1569,112 @@
           </a:p>
         </p:txBody>
       </p:sp>
+      <p:sp>
+        <p:nvSpPr>
+          <p:cNvPr id="10" name="Título">
+            <a:extLst>
+              <a:ext uri="{FF2B5EF4-FFF2-40B4-BE49-F238E27FC236}">
+                <a16:creationId xmlns:a16="http://schemas.microsoft.com/office/drawing/2014/main" id="{29D85961-FC26-87D6-F7CF-D2E332EB5E80}"/>
+              </a:ext>
+            </a:extLst>
+          </p:cNvPr>
+          <p:cNvSpPr>
+            <a:spLocks noGrp="1"/>
+          </p:cNvSpPr>
+          <p:nvPr>
+            <p:ph type="title" hasCustomPrompt="1"/>
+          </p:nvPr>
+        </p:nvSpPr>
+        <p:spPr>
+          <a:xfrm>
+            <a:off x="240890" y="94268"/>
+            <a:ext cx="8662220" cy="619528"/>
+          </a:xfrm>
+        </p:spPr>
+        <p:txBody>
+          <a:bodyPr wrap="square" anchor="ctr" anchorCtr="0">
+            <a:normAutofit/>
+          </a:bodyPr>
+          <a:lstStyle>
+            <a:lvl1pPr algn="ctr">
+              <a:defRPr sz="3400" cap="small" baseline="0">
+                <a:solidFill>
+                  <a:schemeClr val="accent1">
+                    <a:lumMod val="20000"/>
+                    <a:lumOff val="80000"/>
+                  </a:schemeClr>
+                </a:solidFill>
+                <a:latin typeface="Livvic SemiBold" pitchFamily="2" charset="0"/>
+              </a:defRPr>
+            </a:lvl1pPr>
+          </a:lstStyle>
+          <a:p>
+            <a:r>
+              <a:rPr lang="en-US" dirty="0"/>
+              <a:t>Cristo </a:t>
+            </a:r>
+            <a:r>
+              <a:rPr lang="en-US" dirty="0" err="1"/>
+              <a:t>em</a:t>
+            </a:r>
+            <a:r>
+              <a:rPr lang="en-US" dirty="0"/>
+              <a:t> </a:t>
+            </a:r>
+            <a:r>
+              <a:rPr lang="en-US" dirty="0" err="1"/>
+              <a:t>mim</a:t>
+            </a:r>
+            <a:endParaRPr lang="pt-PT" dirty="0"/>
+          </a:p>
+        </p:txBody>
+      </p:sp>
+      <p:cxnSp>
+        <p:nvCxnSpPr>
+          <p:cNvPr id="11" name="Straight Connector 10">
+            <a:extLst>
+              <a:ext uri="{FF2B5EF4-FFF2-40B4-BE49-F238E27FC236}">
+                <a16:creationId xmlns:a16="http://schemas.microsoft.com/office/drawing/2014/main" id="{442DA94A-925F-57FE-22F1-D65B1983C9A9}"/>
+              </a:ext>
+            </a:extLst>
+          </p:cNvPr>
+          <p:cNvCxnSpPr>
+            <a:cxnSpLocks/>
+          </p:cNvCxnSpPr>
+          <p:nvPr userDrawn="1"/>
+        </p:nvCxnSpPr>
+        <p:spPr>
+          <a:xfrm flipH="1">
+            <a:off x="549995" y="687235"/>
+            <a:ext cx="8254639" cy="0"/>
+          </a:xfrm>
+          <a:prstGeom prst="line">
+            <a:avLst/>
+          </a:prstGeom>
+          <a:ln w="19050">
+            <a:solidFill>
+              <a:schemeClr val="accent1">
+                <a:lumMod val="20000"/>
+                <a:lumOff val="80000"/>
+              </a:schemeClr>
+            </a:solidFill>
+          </a:ln>
+        </p:spPr>
+        <p:style>
+          <a:lnRef idx="1">
+            <a:schemeClr val="accent1"/>
+          </a:lnRef>
+          <a:fillRef idx="0">
+            <a:schemeClr val="accent1"/>
+          </a:fillRef>
+          <a:effectRef idx="0">
+            <a:schemeClr val="accent1"/>
+          </a:effectRef>
+          <a:fontRef idx="minor">
+            <a:schemeClr val="tx1"/>
+          </a:fontRef>
+        </p:style>
+      </p:cxnSp>
     </p:spTree>
     <p:extLst>
       <p:ext uri="{BB962C8B-B14F-4D97-AF65-F5344CB8AC3E}">
@@ -970,7 +1688,7 @@
 </p:sldLayout>
 </file>
 
-<file path=ppt/slideLayouts/slideLayout11.xml><?xml version="1.0" encoding="utf-8"?>
+<file path=ppt/slideLayouts/slideLayout13.xml><?xml version="1.0" encoding="utf-8"?>
 <p:sldLayout xmlns:a="http://schemas.openxmlformats.org/drawingml/2006/main" xmlns:r="http://schemas.openxmlformats.org/officeDocument/2006/relationships" xmlns:p="http://schemas.openxmlformats.org/presentationml/2006/main" preserve="1" userDrawn="1">
   <p:cSld name="Título e letra - Natal e Páscoa">
     <p:spTree>
@@ -1057,63 +1775,6 @@
       </p:sp>
       <p:sp>
         <p:nvSpPr>
-          <p:cNvPr id="2" name="Título">
-            <a:extLst>
-              <a:ext uri="{FF2B5EF4-FFF2-40B4-BE49-F238E27FC236}">
-                <a16:creationId xmlns:a16="http://schemas.microsoft.com/office/drawing/2014/main" id="{29D85961-FC26-87D6-F7CF-D2E332EB5E80}"/>
-              </a:ext>
-            </a:extLst>
-          </p:cNvPr>
-          <p:cNvSpPr>
-            <a:spLocks noGrp="1"/>
-          </p:cNvSpPr>
-          <p:nvPr>
-            <p:ph type="title" hasCustomPrompt="1"/>
-          </p:nvPr>
-        </p:nvSpPr>
-        <p:spPr>
-          <a:xfrm>
-            <a:off x="240890" y="245096"/>
-            <a:ext cx="8662220" cy="525262"/>
-          </a:xfrm>
-        </p:spPr>
-        <p:txBody>
-          <a:bodyPr wrap="square">
-            <a:normAutofit/>
-          </a:bodyPr>
-          <a:lstStyle>
-            <a:lvl1pPr algn="ctr">
-              <a:defRPr sz="3400" cap="small" baseline="0">
-                <a:solidFill>
-                  <a:schemeClr val="accent4"/>
-                </a:solidFill>
-                <a:latin typeface="Livvic SemiBold" pitchFamily="2" charset="0"/>
-              </a:defRPr>
-            </a:lvl1pPr>
-          </a:lstStyle>
-          <a:p>
-            <a:r>
-              <a:rPr lang="en-US" dirty="0"/>
-              <a:t>Cristo </a:t>
-            </a:r>
-            <a:r>
-              <a:rPr lang="en-US" dirty="0" err="1"/>
-              <a:t>em</a:t>
-            </a:r>
-            <a:r>
-              <a:rPr lang="en-US" dirty="0"/>
-              <a:t> </a:t>
-            </a:r>
-            <a:r>
-              <a:rPr lang="en-US" dirty="0" err="1"/>
-              <a:t>mim</a:t>
-            </a:r>
-            <a:endParaRPr lang="pt-PT" dirty="0"/>
-          </a:p>
-        </p:txBody>
-      </p:sp>
-      <p:sp>
-        <p:nvSpPr>
           <p:cNvPr id="3" name="Letra">
             <a:extLst>
               <a:ext uri="{FF2B5EF4-FFF2-40B4-BE49-F238E27FC236}">
@@ -1292,6 +1953,106 @@
           </a:p>
         </p:txBody>
       </p:sp>
+      <p:cxnSp>
+        <p:nvCxnSpPr>
+          <p:cNvPr id="4" name="Straight Connector 3" hidden="1">
+            <a:extLst>
+              <a:ext uri="{FF2B5EF4-FFF2-40B4-BE49-F238E27FC236}">
+                <a16:creationId xmlns:a16="http://schemas.microsoft.com/office/drawing/2014/main" id="{084205EB-DDFD-93C0-9E00-F56C5FD691B1}"/>
+              </a:ext>
+            </a:extLst>
+          </p:cNvPr>
+          <p:cNvCxnSpPr>
+            <a:cxnSpLocks/>
+          </p:cNvCxnSpPr>
+          <p:nvPr userDrawn="1"/>
+        </p:nvCxnSpPr>
+        <p:spPr>
+          <a:xfrm flipH="1">
+            <a:off x="549995" y="687235"/>
+            <a:ext cx="8254639" cy="0"/>
+          </a:xfrm>
+          <a:prstGeom prst="line">
+            <a:avLst/>
+          </a:prstGeom>
+          <a:ln w="19050">
+            <a:solidFill>
+              <a:schemeClr val="accent4"/>
+            </a:solidFill>
+          </a:ln>
+        </p:spPr>
+        <p:style>
+          <a:lnRef idx="1">
+            <a:schemeClr val="accent1"/>
+          </a:lnRef>
+          <a:fillRef idx="0">
+            <a:schemeClr val="accent1"/>
+          </a:fillRef>
+          <a:effectRef idx="0">
+            <a:schemeClr val="accent1"/>
+          </a:effectRef>
+          <a:fontRef idx="minor">
+            <a:schemeClr val="tx1"/>
+          </a:fontRef>
+        </p:style>
+      </p:cxnSp>
+      <p:sp>
+        <p:nvSpPr>
+          <p:cNvPr id="8" name="Título">
+            <a:extLst>
+              <a:ext uri="{FF2B5EF4-FFF2-40B4-BE49-F238E27FC236}">
+                <a16:creationId xmlns:a16="http://schemas.microsoft.com/office/drawing/2014/main" id="{9114A82A-8183-D1F2-F08E-5A012AE868D0}"/>
+              </a:ext>
+            </a:extLst>
+          </p:cNvPr>
+          <p:cNvSpPr>
+            <a:spLocks noGrp="1"/>
+          </p:cNvSpPr>
+          <p:nvPr>
+            <p:ph type="title" hasCustomPrompt="1"/>
+          </p:nvPr>
+        </p:nvSpPr>
+        <p:spPr>
+          <a:xfrm>
+            <a:off x="240890" y="103695"/>
+            <a:ext cx="8662220" cy="610101"/>
+          </a:xfrm>
+        </p:spPr>
+        <p:txBody>
+          <a:bodyPr wrap="square">
+            <a:normAutofit/>
+          </a:bodyPr>
+          <a:lstStyle>
+            <a:lvl1pPr algn="ctr">
+              <a:defRPr sz="3400" cap="small" baseline="0">
+                <a:solidFill>
+                  <a:schemeClr val="accent4"/>
+                </a:solidFill>
+                <a:latin typeface="Livvic SemiBold" pitchFamily="2" charset="0"/>
+              </a:defRPr>
+            </a:lvl1pPr>
+          </a:lstStyle>
+          <a:p>
+            <a:r>
+              <a:rPr lang="en-US" dirty="0"/>
+              <a:t>Cristo </a:t>
+            </a:r>
+            <a:r>
+              <a:rPr lang="en-US" dirty="0" err="1"/>
+              <a:t>em</a:t>
+            </a:r>
+            <a:r>
+              <a:rPr lang="en-US" dirty="0"/>
+              <a:t> </a:t>
+            </a:r>
+            <a:r>
+              <a:rPr lang="en-US" dirty="0" err="1"/>
+              <a:t>mim</a:t>
+            </a:r>
+            <a:endParaRPr lang="pt-PT" dirty="0"/>
+          </a:p>
+        </p:txBody>
+      </p:sp>
     </p:spTree>
     <p:extLst>
       <p:ext uri="{BB962C8B-B14F-4D97-AF65-F5344CB8AC3E}">
@@ -1305,7 +2066,7 @@
 </p:sldLayout>
 </file>
 
-<file path=ppt/slideLayouts/slideLayout12.xml><?xml version="1.0" encoding="utf-8"?>
+<file path=ppt/slideLayouts/slideLayout14.xml><?xml version="1.0" encoding="utf-8"?>
 <p:sldLayout xmlns:a="http://schemas.openxmlformats.org/drawingml/2006/main" xmlns:r="http://schemas.openxmlformats.org/officeDocument/2006/relationships" xmlns:p="http://schemas.openxmlformats.org/presentationml/2006/main" preserve="1" userDrawn="1">
   <p:cSld name="Letra">
     <p:spTree>
@@ -1571,7 +2332,7 @@
 </p:sldLayout>
 </file>
 
-<file path=ppt/slideLayouts/slideLayout13.xml><?xml version="1.0" encoding="utf-8"?>
+<file path=ppt/slideLayouts/slideLayout15.xml><?xml version="1.0" encoding="utf-8"?>
 <p:sldLayout xmlns:a="http://schemas.openxmlformats.org/drawingml/2006/main" xmlns:r="http://schemas.openxmlformats.org/officeDocument/2006/relationships" xmlns:p="http://schemas.openxmlformats.org/presentationml/2006/main" preserve="1" userDrawn="1">
   <p:cSld name="Transição - Vazio">
     <p:bg>
@@ -1606,7 +2367,7 @@
 </p:sldLayout>
 </file>
 
-<file path=ppt/slideLayouts/slideLayout14.xml><?xml version="1.0" encoding="utf-8"?>
+<file path=ppt/slideLayouts/slideLayout16.xml><?xml version="1.0" encoding="utf-8"?>
 <p:sldLayout xmlns:a="http://schemas.openxmlformats.org/drawingml/2006/main" xmlns:r="http://schemas.openxmlformats.org/officeDocument/2006/relationships" xmlns:p="http://schemas.openxmlformats.org/presentationml/2006/main" preserve="1" userDrawn="1">
   <p:cSld name="Transição - Texto">
     <p:bg>
@@ -1721,7 +2482,7 @@
 </p:sldLayout>
 </file>
 
-<file path=ppt/slideLayouts/slideLayout15.xml><?xml version="1.0" encoding="utf-8"?>
+<file path=ppt/slideLayouts/slideLayout17.xml><?xml version="1.0" encoding="utf-8"?>
 <p:sldLayout xmlns:a="http://schemas.openxmlformats.org/drawingml/2006/main" xmlns:r="http://schemas.openxmlformats.org/officeDocument/2006/relationships" xmlns:p="http://schemas.openxmlformats.org/presentationml/2006/main" preserve="1" userDrawn="1">
   <p:cSld name="Transição - Imagem">
     <p:spTree>
@@ -1781,7 +2542,7 @@
 </p:sldLayout>
 </file>
 
-<file path=ppt/slideLayouts/slideLayout16.xml><?xml version="1.0" encoding="utf-8"?>
+<file path=ppt/slideLayouts/slideLayout18.xml><?xml version="1.0" encoding="utf-8"?>
 <p:sldLayout xmlns:a="http://schemas.openxmlformats.org/drawingml/2006/main" xmlns:r="http://schemas.openxmlformats.org/officeDocument/2006/relationships" xmlns:p="http://schemas.openxmlformats.org/presentationml/2006/main" preserve="1" userDrawn="1">
   <p:cSld name="Transição - Texto + Imagem">
     <p:spTree>
@@ -1921,7 +2682,7 @@
 </p:sldLayout>
 </file>
 
-<file path=ppt/slideLayouts/slideLayout17.xml><?xml version="1.0" encoding="utf-8"?>
+<file path=ppt/slideLayouts/slideLayout19.xml><?xml version="1.0" encoding="utf-8"?>
 <p:sldLayout xmlns:a="http://schemas.openxmlformats.org/drawingml/2006/main" xmlns:r="http://schemas.openxmlformats.org/officeDocument/2006/relationships" xmlns:p="http://schemas.openxmlformats.org/presentationml/2006/main" preserve="1" userDrawn="1">
   <p:cSld name="Glória - 1">
     <p:spTree>
@@ -2065,258 +2826,16 @@
 </p:sldLayout>
 </file>
 
-<file path=ppt/slideLayouts/slideLayout18.xml><?xml version="1.0" encoding="utf-8"?>
-<p:sldLayout xmlns:a="http://schemas.openxmlformats.org/drawingml/2006/main" xmlns:r="http://schemas.openxmlformats.org/officeDocument/2006/relationships" xmlns:p="http://schemas.openxmlformats.org/presentationml/2006/main" preserve="1" userDrawn="1">
-  <p:cSld name="Glória - 2">
-    <p:spTree>
-      <p:nvGrpSpPr>
-        <p:cNvPr id="1" name=""/>
-        <p:cNvGrpSpPr/>
-        <p:nvPr/>
-      </p:nvGrpSpPr>
-      <p:grpSpPr>
-        <a:xfrm>
-          <a:off x="0" y="0"/>
-          <a:ext cx="0" cy="0"/>
-          <a:chOff x="0" y="0"/>
-          <a:chExt cx="0" cy="0"/>
-        </a:xfrm>
-      </p:grpSpPr>
-      <p:sp>
-        <p:nvSpPr>
-          <p:cNvPr id="5" name="TextBox 4">
-            <a:extLst>
-              <a:ext uri="{FF2B5EF4-FFF2-40B4-BE49-F238E27FC236}">
-                <a16:creationId xmlns:a16="http://schemas.microsoft.com/office/drawing/2014/main" id="{F461CFFF-A66C-B4EF-69DF-1DD65AABD72A}"/>
-              </a:ext>
-            </a:extLst>
-          </p:cNvPr>
-          <p:cNvSpPr txBox="1"/>
-          <p:nvPr userDrawn="1"/>
-        </p:nvSpPr>
-        <p:spPr>
-          <a:xfrm>
-            <a:off x="791852" y="57949"/>
-            <a:ext cx="7701699" cy="6742102"/>
-          </a:xfrm>
-          <a:prstGeom prst="rect">
-            <a:avLst/>
-          </a:prstGeom>
-          <a:noFill/>
-        </p:spPr>
-        <p:txBody>
-          <a:bodyPr wrap="square" rtlCol="0">
-            <a:spAutoFit/>
-          </a:bodyPr>
-          <a:lstStyle/>
-          <a:p>
-            <a:pPr lvl="0" algn="ctr">
-              <a:lnSpc>
-                <a:spcPct val="130000"/>
-              </a:lnSpc>
-            </a:pPr>
-            <a:r>
-              <a:rPr lang="pt-PT" sz="3600" dirty="0"/>
-              <a:t>Senhor Jesus Cristo, Filho Unigénito, </a:t>
-            </a:r>
-          </a:p>
-          <a:p>
-            <a:pPr lvl="0" algn="ctr">
-              <a:lnSpc>
-                <a:spcPct val="130000"/>
-              </a:lnSpc>
-            </a:pPr>
-            <a:r>
-              <a:rPr lang="pt-PT" sz="3600" dirty="0"/>
-              <a:t>Senhor Deus, Cordeiro de Deus, </a:t>
-            </a:r>
-          </a:p>
-          <a:p>
-            <a:pPr lvl="0" algn="ctr">
-              <a:lnSpc>
-                <a:spcPct val="130000"/>
-              </a:lnSpc>
-              <a:spcAft>
-                <a:spcPts val="1800"/>
-              </a:spcAft>
-            </a:pPr>
-            <a:r>
-              <a:rPr lang="pt-PT" sz="3600" dirty="0"/>
-              <a:t>Filho de Deus Pai:</a:t>
-            </a:r>
-          </a:p>
-          <a:p>
-            <a:pPr lvl="0" algn="ctr">
-              <a:lnSpc>
-                <a:spcPct val="130000"/>
-              </a:lnSpc>
-            </a:pPr>
-            <a:r>
-              <a:rPr lang="pt-PT" sz="3600" dirty="0"/>
-              <a:t>Vós que tirais o pecado do mundo, tende piedade de nós;</a:t>
-            </a:r>
-          </a:p>
-          <a:p>
-            <a:pPr lvl="0" algn="ctr">
-              <a:lnSpc>
-                <a:spcPct val="130000"/>
-              </a:lnSpc>
-            </a:pPr>
-            <a:r>
-              <a:rPr lang="pt-PT" sz="3600" dirty="0"/>
-              <a:t>Vós que tirais o pecado do mundo, acolhei a nossa súplica;</a:t>
-            </a:r>
-          </a:p>
-          <a:p>
-            <a:pPr lvl="0" algn="ctr">
-              <a:lnSpc>
-                <a:spcPct val="130000"/>
-              </a:lnSpc>
-            </a:pPr>
-            <a:r>
-              <a:rPr lang="pt-PT" sz="3600" dirty="0"/>
-              <a:t>Vós que estais à direita do Pai, tende piedade de nós.</a:t>
-            </a:r>
-          </a:p>
-        </p:txBody>
-      </p:sp>
-    </p:spTree>
-    <p:extLst>
-      <p:ext uri="{BB962C8B-B14F-4D97-AF65-F5344CB8AC3E}">
-        <p14:creationId xmlns:p14="http://schemas.microsoft.com/office/powerpoint/2010/main" val="3535935584"/>
-      </p:ext>
-    </p:extLst>
-  </p:cSld>
-  <p:clrMapOvr>
-    <a:masterClrMapping/>
-  </p:clrMapOvr>
-</p:sldLayout>
-</file>
-
-<file path=ppt/slideLayouts/slideLayout19.xml><?xml version="1.0" encoding="utf-8"?>
-<p:sldLayout xmlns:a="http://schemas.openxmlformats.org/drawingml/2006/main" xmlns:r="http://schemas.openxmlformats.org/officeDocument/2006/relationships" xmlns:p="http://schemas.openxmlformats.org/presentationml/2006/main" preserve="1" userDrawn="1">
-  <p:cSld name="Glória - 3">
-    <p:spTree>
-      <p:nvGrpSpPr>
-        <p:cNvPr id="1" name=""/>
-        <p:cNvGrpSpPr/>
-        <p:nvPr/>
-      </p:nvGrpSpPr>
-      <p:grpSpPr>
-        <a:xfrm>
-          <a:off x="0" y="0"/>
-          <a:ext cx="0" cy="0"/>
-          <a:chOff x="0" y="0"/>
-          <a:chExt cx="0" cy="0"/>
-        </a:xfrm>
-      </p:grpSpPr>
-      <p:sp>
-        <p:nvSpPr>
-          <p:cNvPr id="5" name="TextBox 4">
-            <a:extLst>
-              <a:ext uri="{FF2B5EF4-FFF2-40B4-BE49-F238E27FC236}">
-                <a16:creationId xmlns:a16="http://schemas.microsoft.com/office/drawing/2014/main" id="{F461CFFF-A66C-B4EF-69DF-1DD65AABD72A}"/>
-              </a:ext>
-            </a:extLst>
-          </p:cNvPr>
-          <p:cNvSpPr txBox="1"/>
-          <p:nvPr userDrawn="1"/>
-        </p:nvSpPr>
-        <p:spPr>
-          <a:xfrm>
-            <a:off x="0" y="1124812"/>
-            <a:ext cx="9144000" cy="4608377"/>
-          </a:xfrm>
-          <a:prstGeom prst="rect">
-            <a:avLst/>
-          </a:prstGeom>
-          <a:noFill/>
-        </p:spPr>
-        <p:txBody>
-          <a:bodyPr wrap="square" rtlCol="0">
-            <a:spAutoFit/>
-          </a:bodyPr>
-          <a:lstStyle/>
-          <a:p>
-            <a:pPr lvl="0" algn="ctr">
-              <a:lnSpc>
-                <a:spcPct val="150000"/>
-              </a:lnSpc>
-            </a:pPr>
-            <a:r>
-              <a:rPr lang="pt-PT" sz="4000" dirty="0"/>
-              <a:t>Só Vós sois o Santo;</a:t>
-            </a:r>
-          </a:p>
-          <a:p>
-            <a:pPr lvl="0" algn="ctr">
-              <a:lnSpc>
-                <a:spcPct val="150000"/>
-              </a:lnSpc>
-            </a:pPr>
-            <a:r>
-              <a:rPr lang="pt-PT" sz="4000" dirty="0"/>
-              <a:t>só Vós, o Senhor;</a:t>
-            </a:r>
-          </a:p>
-          <a:p>
-            <a:pPr lvl="0" algn="ctr">
-              <a:lnSpc>
-                <a:spcPct val="150000"/>
-              </a:lnSpc>
-            </a:pPr>
-            <a:r>
-              <a:rPr lang="pt-PT" sz="4000" dirty="0"/>
-              <a:t>só Vós, o Altíssimo, Jesus Cristo.</a:t>
-            </a:r>
-          </a:p>
-          <a:p>
-            <a:pPr lvl="0" algn="ctr">
-              <a:lnSpc>
-                <a:spcPct val="150000"/>
-              </a:lnSpc>
-            </a:pPr>
-            <a:r>
-              <a:rPr lang="pt-PT" sz="4000" dirty="0"/>
-              <a:t>Com o Espírito Santo,</a:t>
-            </a:r>
-          </a:p>
-          <a:p>
-            <a:pPr lvl="0" algn="ctr">
-              <a:lnSpc>
-                <a:spcPct val="150000"/>
-              </a:lnSpc>
-            </a:pPr>
-            <a:r>
-              <a:rPr lang="pt-PT" sz="4000" dirty="0"/>
-              <a:t>na glória de Deus Pai.</a:t>
-            </a:r>
-          </a:p>
-        </p:txBody>
-      </p:sp>
-    </p:spTree>
-    <p:extLst>
-      <p:ext uri="{BB962C8B-B14F-4D97-AF65-F5344CB8AC3E}">
-        <p14:creationId xmlns:p14="http://schemas.microsoft.com/office/powerpoint/2010/main" val="3032261092"/>
-      </p:ext>
-    </p:extLst>
-  </p:cSld>
-  <p:clrMapOvr>
-    <a:masterClrMapping/>
-  </p:clrMapOvr>
-</p:sldLayout>
-</file>
-
 <file path=ppt/slideLayouts/slideLayout2.xml><?xml version="1.0" encoding="utf-8"?>
 <p:sldLayout xmlns:a="http://schemas.openxmlformats.org/drawingml/2006/main" xmlns:r="http://schemas.openxmlformats.org/officeDocument/2006/relationships" xmlns:p="http://schemas.openxmlformats.org/presentationml/2006/main" preserve="1" userDrawn="1">
-  <p:cSld name="Capa - Advento">
+  <p:cSld name="Capa - Solenidade">
     <p:bg>
       <p:bgPr>
         <a:solidFill>
-          <a:schemeClr val="accent2">
+          <a:schemeClr val="accent4">
             <a:lumMod val="20000"/>
             <a:lumOff val="80000"/>
-            <a:alpha val="40000"/>
+            <a:alpha val="20000"/>
           </a:schemeClr>
         </a:solidFill>
         <a:effectLst/>
@@ -2360,13 +2879,13 @@
         </p:spPr>
         <p:txBody>
           <a:bodyPr anchor="b">
-            <a:normAutofit/>
+            <a:noAutofit/>
           </a:bodyPr>
           <a:lstStyle>
             <a:lvl1pPr algn="ctr">
-              <a:defRPr sz="6600" b="1">
+              <a:defRPr sz="4000" b="1">
                 <a:solidFill>
-                  <a:schemeClr val="accent2"/>
+                  <a:schemeClr val="accent4"/>
                 </a:solidFill>
                 <a:latin typeface="Playfair Display" pitchFamily="2" charset="0"/>
               </a:defRPr>
@@ -2374,10 +2893,17 @@
           </a:lstStyle>
           <a:p>
             <a:r>
-              <a:rPr lang="en-US" dirty="0"/>
-              <a:t>Domingo IV</a:t>
-            </a:r>
-            <a:endParaRPr lang="pt-PT" dirty="0"/>
+              <a:rPr lang="en-US" dirty="0" err="1"/>
+              <a:t>Solenidade</a:t>
+            </a:r>
+            <a:r>
+              <a:rPr lang="en-US" dirty="0"/>
+              <a:t> do </a:t>
+            </a:r>
+            <a:r>
+              <a:rPr lang="pt-PT" dirty="0"/>
+              <a:t>Sagrado Coração de Jesus</a:t>
+            </a:r>
           </a:p>
         </p:txBody>
       </p:sp>
@@ -2472,7 +2998,7 @@
               </a:ext>
             </a:extLst>
           </a:blip>
-          <a:srcRect t="47" b="47"/>
+          <a:srcRect t="13134" b="13134"/>
           <a:stretch/>
         </p:blipFill>
         <p:spPr>
@@ -2534,11 +3060,11 @@
             <a:pPr lvl="0"/>
             <a:r>
               <a:rPr lang="en-US" dirty="0"/>
-              <a:t>Tempo de </a:t>
+              <a:t>Tempo </a:t>
             </a:r>
             <a:r>
               <a:rPr lang="en-US" dirty="0" err="1"/>
-              <a:t>Advento</a:t>
+              <a:t>Comum</a:t>
             </a:r>
             <a:r>
               <a:rPr lang="en-US" dirty="0"/>
@@ -2561,7 +3087,7 @@
           <p:cNvPr id="6" name="Frase">
             <a:extLst>
               <a:ext uri="{FF2B5EF4-FFF2-40B4-BE49-F238E27FC236}">
-                <a16:creationId xmlns:a16="http://schemas.microsoft.com/office/drawing/2014/main" id="{6F230E96-DA9A-242A-239B-91C6FC0D1E0D}"/>
+                <a16:creationId xmlns:a16="http://schemas.microsoft.com/office/drawing/2014/main" id="{D08124FD-CC6B-7059-0C41-242782CD53AF}"/>
               </a:ext>
             </a:extLst>
           </p:cNvPr>
@@ -2639,7 +3165,7 @@
     </p:spTree>
     <p:extLst>
       <p:ext uri="{BB962C8B-B14F-4D97-AF65-F5344CB8AC3E}">
-        <p14:creationId xmlns:p14="http://schemas.microsoft.com/office/powerpoint/2010/main" val="2636666909"/>
+        <p14:creationId xmlns:p14="http://schemas.microsoft.com/office/powerpoint/2010/main" val="4170717751"/>
       </p:ext>
     </p:extLst>
   </p:cSld>
@@ -2650,6 +3176,248 @@
 </file>
 
 <file path=ppt/slideLayouts/slideLayout20.xml><?xml version="1.0" encoding="utf-8"?>
+<p:sldLayout xmlns:a="http://schemas.openxmlformats.org/drawingml/2006/main" xmlns:r="http://schemas.openxmlformats.org/officeDocument/2006/relationships" xmlns:p="http://schemas.openxmlformats.org/presentationml/2006/main" preserve="1" userDrawn="1">
+  <p:cSld name="Glória - 2">
+    <p:spTree>
+      <p:nvGrpSpPr>
+        <p:cNvPr id="1" name=""/>
+        <p:cNvGrpSpPr/>
+        <p:nvPr/>
+      </p:nvGrpSpPr>
+      <p:grpSpPr>
+        <a:xfrm>
+          <a:off x="0" y="0"/>
+          <a:ext cx="0" cy="0"/>
+          <a:chOff x="0" y="0"/>
+          <a:chExt cx="0" cy="0"/>
+        </a:xfrm>
+      </p:grpSpPr>
+      <p:sp>
+        <p:nvSpPr>
+          <p:cNvPr id="5" name="TextBox 4">
+            <a:extLst>
+              <a:ext uri="{FF2B5EF4-FFF2-40B4-BE49-F238E27FC236}">
+                <a16:creationId xmlns:a16="http://schemas.microsoft.com/office/drawing/2014/main" id="{F461CFFF-A66C-B4EF-69DF-1DD65AABD72A}"/>
+              </a:ext>
+            </a:extLst>
+          </p:cNvPr>
+          <p:cNvSpPr txBox="1"/>
+          <p:nvPr userDrawn="1"/>
+        </p:nvSpPr>
+        <p:spPr>
+          <a:xfrm>
+            <a:off x="791852" y="57949"/>
+            <a:ext cx="7701699" cy="6742102"/>
+          </a:xfrm>
+          <a:prstGeom prst="rect">
+            <a:avLst/>
+          </a:prstGeom>
+          <a:noFill/>
+        </p:spPr>
+        <p:txBody>
+          <a:bodyPr wrap="square" rtlCol="0">
+            <a:spAutoFit/>
+          </a:bodyPr>
+          <a:lstStyle/>
+          <a:p>
+            <a:pPr lvl="0" algn="ctr">
+              <a:lnSpc>
+                <a:spcPct val="130000"/>
+              </a:lnSpc>
+            </a:pPr>
+            <a:r>
+              <a:rPr lang="pt-PT" sz="3600" dirty="0"/>
+              <a:t>Senhor Jesus Cristo, Filho Unigénito, </a:t>
+            </a:r>
+          </a:p>
+          <a:p>
+            <a:pPr lvl="0" algn="ctr">
+              <a:lnSpc>
+                <a:spcPct val="130000"/>
+              </a:lnSpc>
+            </a:pPr>
+            <a:r>
+              <a:rPr lang="pt-PT" sz="3600" dirty="0"/>
+              <a:t>Senhor Deus, Cordeiro de Deus, </a:t>
+            </a:r>
+          </a:p>
+          <a:p>
+            <a:pPr lvl="0" algn="ctr">
+              <a:lnSpc>
+                <a:spcPct val="130000"/>
+              </a:lnSpc>
+              <a:spcAft>
+                <a:spcPts val="1800"/>
+              </a:spcAft>
+            </a:pPr>
+            <a:r>
+              <a:rPr lang="pt-PT" sz="3600" dirty="0"/>
+              <a:t>Filho de Deus Pai:</a:t>
+            </a:r>
+          </a:p>
+          <a:p>
+            <a:pPr lvl="0" algn="ctr">
+              <a:lnSpc>
+                <a:spcPct val="130000"/>
+              </a:lnSpc>
+            </a:pPr>
+            <a:r>
+              <a:rPr lang="pt-PT" sz="3600" dirty="0"/>
+              <a:t>Vós que tirais o pecado do mundo, tende piedade de nós;</a:t>
+            </a:r>
+          </a:p>
+          <a:p>
+            <a:pPr lvl="0" algn="ctr">
+              <a:lnSpc>
+                <a:spcPct val="130000"/>
+              </a:lnSpc>
+            </a:pPr>
+            <a:r>
+              <a:rPr lang="pt-PT" sz="3600" dirty="0"/>
+              <a:t>Vós que tirais o pecado do mundo, acolhei a nossa súplica;</a:t>
+            </a:r>
+          </a:p>
+          <a:p>
+            <a:pPr lvl="0" algn="ctr">
+              <a:lnSpc>
+                <a:spcPct val="130000"/>
+              </a:lnSpc>
+            </a:pPr>
+            <a:r>
+              <a:rPr lang="pt-PT" sz="3600" dirty="0"/>
+              <a:t>Vós que estais à direita do Pai, tende piedade de nós.</a:t>
+            </a:r>
+          </a:p>
+        </p:txBody>
+      </p:sp>
+    </p:spTree>
+    <p:extLst>
+      <p:ext uri="{BB962C8B-B14F-4D97-AF65-F5344CB8AC3E}">
+        <p14:creationId xmlns:p14="http://schemas.microsoft.com/office/powerpoint/2010/main" val="3535935584"/>
+      </p:ext>
+    </p:extLst>
+  </p:cSld>
+  <p:clrMapOvr>
+    <a:masterClrMapping/>
+  </p:clrMapOvr>
+</p:sldLayout>
+</file>
+
+<file path=ppt/slideLayouts/slideLayout21.xml><?xml version="1.0" encoding="utf-8"?>
+<p:sldLayout xmlns:a="http://schemas.openxmlformats.org/drawingml/2006/main" xmlns:r="http://schemas.openxmlformats.org/officeDocument/2006/relationships" xmlns:p="http://schemas.openxmlformats.org/presentationml/2006/main" preserve="1" userDrawn="1">
+  <p:cSld name="Glória - 3">
+    <p:spTree>
+      <p:nvGrpSpPr>
+        <p:cNvPr id="1" name=""/>
+        <p:cNvGrpSpPr/>
+        <p:nvPr/>
+      </p:nvGrpSpPr>
+      <p:grpSpPr>
+        <a:xfrm>
+          <a:off x="0" y="0"/>
+          <a:ext cx="0" cy="0"/>
+          <a:chOff x="0" y="0"/>
+          <a:chExt cx="0" cy="0"/>
+        </a:xfrm>
+      </p:grpSpPr>
+      <p:sp>
+        <p:nvSpPr>
+          <p:cNvPr id="5" name="TextBox 4">
+            <a:extLst>
+              <a:ext uri="{FF2B5EF4-FFF2-40B4-BE49-F238E27FC236}">
+                <a16:creationId xmlns:a16="http://schemas.microsoft.com/office/drawing/2014/main" id="{F461CFFF-A66C-B4EF-69DF-1DD65AABD72A}"/>
+              </a:ext>
+            </a:extLst>
+          </p:cNvPr>
+          <p:cNvSpPr txBox="1"/>
+          <p:nvPr userDrawn="1"/>
+        </p:nvSpPr>
+        <p:spPr>
+          <a:xfrm>
+            <a:off x="0" y="1124812"/>
+            <a:ext cx="9144000" cy="4608377"/>
+          </a:xfrm>
+          <a:prstGeom prst="rect">
+            <a:avLst/>
+          </a:prstGeom>
+          <a:noFill/>
+        </p:spPr>
+        <p:txBody>
+          <a:bodyPr wrap="square" rtlCol="0">
+            <a:spAutoFit/>
+          </a:bodyPr>
+          <a:lstStyle/>
+          <a:p>
+            <a:pPr lvl="0" algn="ctr">
+              <a:lnSpc>
+                <a:spcPct val="150000"/>
+              </a:lnSpc>
+            </a:pPr>
+            <a:r>
+              <a:rPr lang="pt-PT" sz="4000" dirty="0"/>
+              <a:t>Só Vós sois o Santo;</a:t>
+            </a:r>
+          </a:p>
+          <a:p>
+            <a:pPr lvl="0" algn="ctr">
+              <a:lnSpc>
+                <a:spcPct val="150000"/>
+              </a:lnSpc>
+            </a:pPr>
+            <a:r>
+              <a:rPr lang="pt-PT" sz="4000" dirty="0"/>
+              <a:t>só Vós, o Senhor;</a:t>
+            </a:r>
+          </a:p>
+          <a:p>
+            <a:pPr lvl="0" algn="ctr">
+              <a:lnSpc>
+                <a:spcPct val="150000"/>
+              </a:lnSpc>
+            </a:pPr>
+            <a:r>
+              <a:rPr lang="pt-PT" sz="4000" dirty="0"/>
+              <a:t>só Vós, o Altíssimo, Jesus Cristo.</a:t>
+            </a:r>
+          </a:p>
+          <a:p>
+            <a:pPr lvl="0" algn="ctr">
+              <a:lnSpc>
+                <a:spcPct val="150000"/>
+              </a:lnSpc>
+            </a:pPr>
+            <a:r>
+              <a:rPr lang="pt-PT" sz="4000" dirty="0"/>
+              <a:t>Com o Espírito Santo,</a:t>
+            </a:r>
+          </a:p>
+          <a:p>
+            <a:pPr lvl="0" algn="ctr">
+              <a:lnSpc>
+                <a:spcPct val="150000"/>
+              </a:lnSpc>
+            </a:pPr>
+            <a:r>
+              <a:rPr lang="pt-PT" sz="4000" dirty="0"/>
+              <a:t>na glória de Deus Pai.</a:t>
+            </a:r>
+          </a:p>
+        </p:txBody>
+      </p:sp>
+    </p:spTree>
+    <p:extLst>
+      <p:ext uri="{BB962C8B-B14F-4D97-AF65-F5344CB8AC3E}">
+        <p14:creationId xmlns:p14="http://schemas.microsoft.com/office/powerpoint/2010/main" val="3032261092"/>
+      </p:ext>
+    </p:extLst>
+  </p:cSld>
+  <p:clrMapOvr>
+    <a:masterClrMapping/>
+  </p:clrMapOvr>
+</p:sldLayout>
+</file>
+
+<file path=ppt/slideLayouts/slideLayout22.xml><?xml version="1.0" encoding="utf-8"?>
 <p:sldLayout xmlns:a="http://schemas.openxmlformats.org/drawingml/2006/main" xmlns:r="http://schemas.openxmlformats.org/officeDocument/2006/relationships" xmlns:p="http://schemas.openxmlformats.org/presentationml/2006/main" preserve="1" userDrawn="1">
   <p:cSld name="Credo - Longo - 1">
     <p:spTree>
@@ -2738,7 +3506,7 @@
 </p:sldLayout>
 </file>
 
-<file path=ppt/slideLayouts/slideLayout21.xml><?xml version="1.0" encoding="utf-8"?>
+<file path=ppt/slideLayouts/slideLayout23.xml><?xml version="1.0" encoding="utf-8"?>
 <p:sldLayout xmlns:a="http://schemas.openxmlformats.org/drawingml/2006/main" xmlns:r="http://schemas.openxmlformats.org/officeDocument/2006/relationships" xmlns:p="http://schemas.openxmlformats.org/presentationml/2006/main" preserve="1" userDrawn="1">
   <p:cSld name="Credo - Longo - 2">
     <p:spTree>
@@ -2855,7 +3623,7 @@
 </p:sldLayout>
 </file>
 
-<file path=ppt/slideLayouts/slideLayout22.xml><?xml version="1.0" encoding="utf-8"?>
+<file path=ppt/slideLayouts/slideLayout24.xml><?xml version="1.0" encoding="utf-8"?>
 <p:sldLayout xmlns:a="http://schemas.openxmlformats.org/drawingml/2006/main" xmlns:r="http://schemas.openxmlformats.org/officeDocument/2006/relationships" xmlns:p="http://schemas.openxmlformats.org/presentationml/2006/main" preserve="1" userDrawn="1">
   <p:cSld name="Credo - Longo - 3">
     <p:spTree>
@@ -2990,7 +3758,7 @@
 </p:sldLayout>
 </file>
 
-<file path=ppt/slideLayouts/slideLayout23.xml><?xml version="1.0" encoding="utf-8"?>
+<file path=ppt/slideLayouts/slideLayout25.xml><?xml version="1.0" encoding="utf-8"?>
 <p:sldLayout xmlns:a="http://schemas.openxmlformats.org/drawingml/2006/main" xmlns:r="http://schemas.openxmlformats.org/officeDocument/2006/relationships" xmlns:p="http://schemas.openxmlformats.org/presentationml/2006/main" preserve="1" userDrawn="1">
   <p:cSld name="Credo - Longo - 4">
     <p:spTree>
@@ -3140,7 +3908,7 @@
 </p:sldLayout>
 </file>
 
-<file path=ppt/slideLayouts/slideLayout24.xml><?xml version="1.0" encoding="utf-8"?>
+<file path=ppt/slideLayouts/slideLayout26.xml><?xml version="1.0" encoding="utf-8"?>
 <p:sldLayout xmlns:a="http://schemas.openxmlformats.org/drawingml/2006/main" xmlns:r="http://schemas.openxmlformats.org/officeDocument/2006/relationships" xmlns:p="http://schemas.openxmlformats.org/presentationml/2006/main" preserve="1" userDrawn="1">
   <p:cSld name="Credo - Longo - 5">
     <p:spTree>
@@ -3264,7 +4032,7 @@
 </p:sldLayout>
 </file>
 
-<file path=ppt/slideLayouts/slideLayout25.xml><?xml version="1.0" encoding="utf-8"?>
+<file path=ppt/slideLayouts/slideLayout27.xml><?xml version="1.0" encoding="utf-8"?>
 <p:sldLayout xmlns:a="http://schemas.openxmlformats.org/drawingml/2006/main" xmlns:r="http://schemas.openxmlformats.org/officeDocument/2006/relationships" xmlns:p="http://schemas.openxmlformats.org/presentationml/2006/main" preserve="1" userDrawn="1">
   <p:cSld name="Credo - Longo - 6">
     <p:spTree>
@@ -3411,7 +4179,7 @@
 </p:sldLayout>
 </file>
 
-<file path=ppt/slideLayouts/slideLayout26.xml><?xml version="1.0" encoding="utf-8"?>
+<file path=ppt/slideLayouts/slideLayout28.xml><?xml version="1.0" encoding="utf-8"?>
 <p:sldLayout xmlns:a="http://schemas.openxmlformats.org/drawingml/2006/main" xmlns:r="http://schemas.openxmlformats.org/officeDocument/2006/relationships" xmlns:p="http://schemas.openxmlformats.org/presentationml/2006/main" preserve="1" userDrawn="1">
   <p:cSld name="Credo - Breve - 1">
     <p:spTree>
@@ -3557,7 +4325,7 @@
 </p:sldLayout>
 </file>
 
-<file path=ppt/slideLayouts/slideLayout27.xml><?xml version="1.0" encoding="utf-8"?>
+<file path=ppt/slideLayouts/slideLayout29.xml><?xml version="1.0" encoding="utf-8"?>
 <p:sldLayout xmlns:a="http://schemas.openxmlformats.org/drawingml/2006/main" xmlns:r="http://schemas.openxmlformats.org/officeDocument/2006/relationships" xmlns:p="http://schemas.openxmlformats.org/presentationml/2006/main" preserve="1" userDrawn="1">
   <p:cSld name="Credo - Breve - 2">
     <p:spTree>
@@ -3747,265 +4515,16 @@
 </p:sldLayout>
 </file>
 
-<file path=ppt/slideLayouts/slideLayout28.xml><?xml version="1.0" encoding="utf-8"?>
-<p:sldLayout xmlns:a="http://schemas.openxmlformats.org/drawingml/2006/main" xmlns:r="http://schemas.openxmlformats.org/officeDocument/2006/relationships" xmlns:p="http://schemas.openxmlformats.org/presentationml/2006/main" preserve="1" userDrawn="1">
-  <p:cSld name="Credo - Breve - 3">
-    <p:spTree>
-      <p:nvGrpSpPr>
-        <p:cNvPr id="1" name=""/>
-        <p:cNvGrpSpPr/>
-        <p:nvPr/>
-      </p:nvGrpSpPr>
-      <p:grpSpPr>
-        <a:xfrm>
-          <a:off x="0" y="0"/>
-          <a:ext cx="0" cy="0"/>
-          <a:chOff x="0" y="0"/>
-          <a:chExt cx="0" cy="0"/>
-        </a:xfrm>
-      </p:grpSpPr>
-      <p:sp>
-        <p:nvSpPr>
-          <p:cNvPr id="5" name="TextBox 4">
-            <a:extLst>
-              <a:ext uri="{FF2B5EF4-FFF2-40B4-BE49-F238E27FC236}">
-                <a16:creationId xmlns:a16="http://schemas.microsoft.com/office/drawing/2014/main" id="{F461CFFF-A66C-B4EF-69DF-1DD65AABD72A}"/>
-              </a:ext>
-            </a:extLst>
-          </p:cNvPr>
-          <p:cNvSpPr txBox="1"/>
-          <p:nvPr userDrawn="1"/>
-        </p:nvSpPr>
-        <p:spPr>
-          <a:xfrm>
-            <a:off x="0" y="824729"/>
-            <a:ext cx="9144000" cy="5208542"/>
-          </a:xfrm>
-          <a:prstGeom prst="rect">
-            <a:avLst/>
-          </a:prstGeom>
-          <a:noFill/>
-        </p:spPr>
-        <p:txBody>
-          <a:bodyPr wrap="square" rtlCol="0">
-            <a:spAutoFit/>
-          </a:bodyPr>
-          <a:lstStyle/>
-          <a:p>
-            <a:pPr marL="0" indent="0" algn="ctr">
-              <a:lnSpc>
-                <a:spcPct val="120000"/>
-              </a:lnSpc>
-              <a:buNone/>
-            </a:pPr>
-            <a:r>
-              <a:rPr lang="pt-PT" sz="4000" u="sng" dirty="0">
-                <a:latin typeface="IBM Plex Sans SemiBold" panose="020B0703050203000203" pitchFamily="34" charset="0"/>
-              </a:rPr>
-              <a:t>Creio no Espírito Santo; </a:t>
-            </a:r>
-          </a:p>
-          <a:p>
-            <a:pPr marL="0" indent="0" algn="ctr">
-              <a:lnSpc>
-                <a:spcPct val="120000"/>
-              </a:lnSpc>
-              <a:buNone/>
-            </a:pPr>
-            <a:r>
-              <a:rPr lang="pt-PT" sz="4000" u="sng" dirty="0">
-                <a:latin typeface="IBM Plex Sans SemiBold" panose="020B0703050203000203" pitchFamily="34" charset="0"/>
-              </a:rPr>
-              <a:t>na santa Igreja Católica; </a:t>
-            </a:r>
-          </a:p>
-          <a:p>
-            <a:pPr marL="0" indent="0" algn="ctr">
-              <a:lnSpc>
-                <a:spcPct val="120000"/>
-              </a:lnSpc>
-              <a:buNone/>
-            </a:pPr>
-            <a:r>
-              <a:rPr lang="pt-PT" sz="4000" dirty="0"/>
-              <a:t>na comunhão dos Santos; </a:t>
-            </a:r>
-          </a:p>
-          <a:p>
-            <a:pPr marL="0" indent="0" algn="ctr">
-              <a:lnSpc>
-                <a:spcPct val="120000"/>
-              </a:lnSpc>
-              <a:buNone/>
-            </a:pPr>
-            <a:r>
-              <a:rPr lang="pt-PT" sz="4000" dirty="0"/>
-              <a:t>na remissão dos pecados; </a:t>
-            </a:r>
-          </a:p>
-          <a:p>
-            <a:pPr marL="0" indent="0" algn="ctr">
-              <a:lnSpc>
-                <a:spcPct val="120000"/>
-              </a:lnSpc>
-              <a:buNone/>
-            </a:pPr>
-            <a:r>
-              <a:rPr lang="pt-PT" sz="4000" dirty="0"/>
-              <a:t>na ressurreição da carne; </a:t>
-            </a:r>
-          </a:p>
-          <a:p>
-            <a:pPr marL="0" indent="0" algn="ctr">
-              <a:lnSpc>
-                <a:spcPct val="120000"/>
-              </a:lnSpc>
-              <a:buNone/>
-            </a:pPr>
-            <a:r>
-              <a:rPr lang="pt-PT" sz="4000" dirty="0"/>
-              <a:t>na vida eterna.</a:t>
-            </a:r>
-          </a:p>
-          <a:p>
-            <a:pPr marL="0" indent="0" algn="ctr">
-              <a:lnSpc>
-                <a:spcPct val="120000"/>
-              </a:lnSpc>
-              <a:buNone/>
-            </a:pPr>
-            <a:r>
-              <a:rPr lang="pt-PT" sz="4000" dirty="0"/>
-              <a:t>Ámen.</a:t>
-            </a:r>
-          </a:p>
-        </p:txBody>
-      </p:sp>
-    </p:spTree>
-    <p:extLst>
-      <p:ext uri="{BB962C8B-B14F-4D97-AF65-F5344CB8AC3E}">
-        <p14:creationId xmlns:p14="http://schemas.microsoft.com/office/powerpoint/2010/main" val="4031632862"/>
-      </p:ext>
-    </p:extLst>
-  </p:cSld>
-  <p:clrMapOvr>
-    <a:masterClrMapping/>
-  </p:clrMapOvr>
-</p:sldLayout>
-</file>
-
-<file path=ppt/slideLayouts/slideLayout29.xml><?xml version="1.0" encoding="utf-8"?>
-<p:sldLayout xmlns:a="http://schemas.openxmlformats.org/drawingml/2006/main" xmlns:r="http://schemas.openxmlformats.org/officeDocument/2006/relationships" xmlns:p="http://schemas.openxmlformats.org/presentationml/2006/main" preserve="1" userDrawn="1">
-  <p:cSld name="Oração Universal">
-    <p:spTree>
-      <p:nvGrpSpPr>
-        <p:cNvPr id="1" name=""/>
-        <p:cNvGrpSpPr/>
-        <p:nvPr/>
-      </p:nvGrpSpPr>
-      <p:grpSpPr>
-        <a:xfrm>
-          <a:off x="0" y="0"/>
-          <a:ext cx="0" cy="0"/>
-          <a:chOff x="0" y="0"/>
-          <a:chExt cx="0" cy="0"/>
-        </a:xfrm>
-      </p:grpSpPr>
-      <p:sp>
-        <p:nvSpPr>
-          <p:cNvPr id="3" name="Letra">
-            <a:extLst>
-              <a:ext uri="{FF2B5EF4-FFF2-40B4-BE49-F238E27FC236}">
-                <a16:creationId xmlns:a16="http://schemas.microsoft.com/office/drawing/2014/main" id="{7FBA5054-2BE0-6B52-7485-0B10968F39E5}"/>
-              </a:ext>
-            </a:extLst>
-          </p:cNvPr>
-          <p:cNvSpPr>
-            <a:spLocks noGrp="1"/>
-          </p:cNvSpPr>
-          <p:nvPr>
-            <p:ph idx="1" hasCustomPrompt="1"/>
-          </p:nvPr>
-        </p:nvSpPr>
-        <p:spPr>
-          <a:xfrm>
-            <a:off x="549995" y="103695"/>
-            <a:ext cx="8044010" cy="6532775"/>
-          </a:xfrm>
-        </p:spPr>
-        <p:txBody>
-          <a:bodyPr anchor="ctr" anchorCtr="0">
-            <a:normAutofit/>
-          </a:bodyPr>
-          <a:lstStyle>
-            <a:lvl1pPr marL="0" marR="0" indent="0" algn="ctr" defTabSz="685800" rtl="0" eaLnBrk="1" fontAlgn="auto" latinLnBrk="0" hangingPunct="1">
-              <a:lnSpc>
-                <a:spcPct val="130000"/>
-              </a:lnSpc>
-              <a:spcBef>
-                <a:spcPts val="0"/>
-              </a:spcBef>
-              <a:spcAft>
-                <a:spcPts val="0"/>
-              </a:spcAft>
-              <a:buClrTx/>
-              <a:buSzTx/>
-              <a:buFont typeface="Arial" panose="020B0604020202020204" pitchFamily="34" charset="0"/>
-              <a:buNone/>
-              <a:tabLst/>
-              <a:defRPr sz="6000">
-                <a:latin typeface="+mj-lt"/>
-              </a:defRPr>
-            </a:lvl1pPr>
-            <a:lvl2pPr algn="ctr">
-              <a:defRPr/>
-            </a:lvl2pPr>
-            <a:lvl3pPr algn="ctr">
-              <a:defRPr/>
-            </a:lvl3pPr>
-            <a:lvl4pPr algn="ctr">
-              <a:defRPr/>
-            </a:lvl4pPr>
-            <a:lvl5pPr algn="ctr">
-              <a:defRPr/>
-            </a:lvl5pPr>
-          </a:lstStyle>
-          <a:p>
-            <a:pPr lvl="0"/>
-            <a:r>
-              <a:rPr lang="en-US" dirty="0" err="1"/>
-              <a:t>Ouvi-nos</a:t>
-            </a:r>
-            <a:r>
-              <a:rPr lang="en-US" dirty="0"/>
-              <a:t>, Senhor!</a:t>
-            </a:r>
-          </a:p>
-        </p:txBody>
-      </p:sp>
-    </p:spTree>
-    <p:extLst>
-      <p:ext uri="{BB962C8B-B14F-4D97-AF65-F5344CB8AC3E}">
-        <p14:creationId xmlns:p14="http://schemas.microsoft.com/office/powerpoint/2010/main" val="3280188006"/>
-      </p:ext>
-    </p:extLst>
-  </p:cSld>
-  <p:clrMapOvr>
-    <a:masterClrMapping/>
-  </p:clrMapOvr>
-</p:sldLayout>
-</file>
-
 <file path=ppt/slideLayouts/slideLayout3.xml><?xml version="1.0" encoding="utf-8"?>
 <p:sldLayout xmlns:a="http://schemas.openxmlformats.org/drawingml/2006/main" xmlns:r="http://schemas.openxmlformats.org/officeDocument/2006/relationships" xmlns:p="http://schemas.openxmlformats.org/presentationml/2006/main" preserve="1" userDrawn="1">
-  <p:cSld name="Capa - Domingo III Advento">
+  <p:cSld name="Capa - Solenidade Pedro Paulo">
     <p:bg>
       <p:bgPr>
         <a:solidFill>
-          <a:schemeClr val="accent3">
-            <a:lumMod val="40000"/>
-            <a:lumOff val="60000"/>
-            <a:alpha val="25000"/>
+          <a:schemeClr val="accent5">
+            <a:lumMod val="60000"/>
+            <a:lumOff val="40000"/>
+            <a:alpha val="20000"/>
           </a:schemeClr>
         </a:solidFill>
         <a:effectLst/>
@@ -4043,19 +4562,19 @@
         </p:nvSpPr>
         <p:spPr>
           <a:xfrm>
-            <a:off x="1143000" y="1129506"/>
-            <a:ext cx="6858000" cy="1106127"/>
+            <a:off x="0" y="1129506"/>
+            <a:ext cx="9144000" cy="1265537"/>
           </a:xfrm>
         </p:spPr>
         <p:txBody>
           <a:bodyPr anchor="b">
-            <a:normAutofit/>
+            <a:noAutofit/>
           </a:bodyPr>
           <a:lstStyle>
             <a:lvl1pPr algn="ctr">
-              <a:defRPr sz="6600" b="1">
+              <a:defRPr sz="4400" b="1">
                 <a:solidFill>
-                  <a:schemeClr val="accent3"/>
+                  <a:schemeClr val="accent5"/>
                 </a:solidFill>
                 <a:latin typeface="Playfair Display" pitchFamily="2" charset="0"/>
               </a:defRPr>
@@ -4063,8 +4582,27 @@
           </a:lstStyle>
           <a:p>
             <a:r>
-              <a:rPr lang="en-US" dirty="0"/>
-              <a:t>Domingo III</a:t>
+              <a:rPr lang="en-US" dirty="0" err="1"/>
+              <a:t>Solenidade</a:t>
+            </a:r>
+            <a:r>
+              <a:rPr lang="en-US" dirty="0"/>
+              <a:t> dos </a:t>
+            </a:r>
+            <a:r>
+              <a:rPr lang="en-US" dirty="0" err="1"/>
+              <a:t>Apóstolos</a:t>
+            </a:r>
+            <a:r>
+              <a:rPr lang="en-US" dirty="0"/>
+              <a:t> </a:t>
+            </a:r>
+            <a:br>
+              <a:rPr lang="en-US" dirty="0"/>
+            </a:br>
+            <a:r>
+              <a:rPr lang="en-US" dirty="0"/>
+              <a:t>São Pedro e São Paulo</a:t>
             </a:r>
             <a:endParaRPr lang="pt-PT" dirty="0"/>
           </a:p>
@@ -4161,7 +4699,7 @@
               </a:ext>
             </a:extLst>
           </a:blip>
-          <a:srcRect t="47" b="47"/>
+          <a:srcRect t="13134" b="13134"/>
           <a:stretch/>
         </p:blipFill>
         <p:spPr>
@@ -4223,15 +4761,7 @@
             <a:pPr lvl="0"/>
             <a:r>
               <a:rPr lang="en-US" dirty="0"/>
-              <a:t>Tempo de </a:t>
-            </a:r>
-            <a:r>
-              <a:rPr lang="en-US" dirty="0" err="1"/>
-              <a:t>Advento</a:t>
-            </a:r>
-            <a:r>
-              <a:rPr lang="en-US" dirty="0"/>
-              <a:t> </a:t>
+              <a:t>Tempo de Quaresma </a:t>
             </a:r>
             <a:r>
               <a:rPr lang="pt-PT" dirty="0"/>
@@ -4250,7 +4780,7 @@
           <p:cNvPr id="6" name="Frase">
             <a:extLst>
               <a:ext uri="{FF2B5EF4-FFF2-40B4-BE49-F238E27FC236}">
-                <a16:creationId xmlns:a16="http://schemas.microsoft.com/office/drawing/2014/main" id="{FC7D14A6-6188-5DA5-548E-C9EB6ABA72AE}"/>
+                <a16:creationId xmlns:a16="http://schemas.microsoft.com/office/drawing/2014/main" id="{266F4FDB-B979-745C-320D-6CEA04390DD9}"/>
               </a:ext>
             </a:extLst>
           </p:cNvPr>
@@ -4328,7 +4858,7 @@
     </p:spTree>
     <p:extLst>
       <p:ext uri="{BB962C8B-B14F-4D97-AF65-F5344CB8AC3E}">
-        <p14:creationId xmlns:p14="http://schemas.microsoft.com/office/powerpoint/2010/main" val="1642785294"/>
+        <p14:creationId xmlns:p14="http://schemas.microsoft.com/office/powerpoint/2010/main" val="3818133528"/>
       </p:ext>
     </p:extLst>
   </p:cSld>
@@ -4339,6 +4869,255 @@
 </file>
 
 <file path=ppt/slideLayouts/slideLayout30.xml><?xml version="1.0" encoding="utf-8"?>
+<p:sldLayout xmlns:a="http://schemas.openxmlformats.org/drawingml/2006/main" xmlns:r="http://schemas.openxmlformats.org/officeDocument/2006/relationships" xmlns:p="http://schemas.openxmlformats.org/presentationml/2006/main" preserve="1" userDrawn="1">
+  <p:cSld name="Credo - Breve - 3">
+    <p:spTree>
+      <p:nvGrpSpPr>
+        <p:cNvPr id="1" name=""/>
+        <p:cNvGrpSpPr/>
+        <p:nvPr/>
+      </p:nvGrpSpPr>
+      <p:grpSpPr>
+        <a:xfrm>
+          <a:off x="0" y="0"/>
+          <a:ext cx="0" cy="0"/>
+          <a:chOff x="0" y="0"/>
+          <a:chExt cx="0" cy="0"/>
+        </a:xfrm>
+      </p:grpSpPr>
+      <p:sp>
+        <p:nvSpPr>
+          <p:cNvPr id="5" name="TextBox 4">
+            <a:extLst>
+              <a:ext uri="{FF2B5EF4-FFF2-40B4-BE49-F238E27FC236}">
+                <a16:creationId xmlns:a16="http://schemas.microsoft.com/office/drawing/2014/main" id="{F461CFFF-A66C-B4EF-69DF-1DD65AABD72A}"/>
+              </a:ext>
+            </a:extLst>
+          </p:cNvPr>
+          <p:cNvSpPr txBox="1"/>
+          <p:nvPr userDrawn="1"/>
+        </p:nvSpPr>
+        <p:spPr>
+          <a:xfrm>
+            <a:off x="0" y="824729"/>
+            <a:ext cx="9144000" cy="5208542"/>
+          </a:xfrm>
+          <a:prstGeom prst="rect">
+            <a:avLst/>
+          </a:prstGeom>
+          <a:noFill/>
+        </p:spPr>
+        <p:txBody>
+          <a:bodyPr wrap="square" rtlCol="0">
+            <a:spAutoFit/>
+          </a:bodyPr>
+          <a:lstStyle/>
+          <a:p>
+            <a:pPr marL="0" indent="0" algn="ctr">
+              <a:lnSpc>
+                <a:spcPct val="120000"/>
+              </a:lnSpc>
+              <a:buNone/>
+            </a:pPr>
+            <a:r>
+              <a:rPr lang="pt-PT" sz="4000" u="sng" dirty="0">
+                <a:latin typeface="IBM Plex Sans SemiBold" panose="020B0703050203000203" pitchFamily="34" charset="0"/>
+              </a:rPr>
+              <a:t>Creio no Espírito Santo; </a:t>
+            </a:r>
+          </a:p>
+          <a:p>
+            <a:pPr marL="0" indent="0" algn="ctr">
+              <a:lnSpc>
+                <a:spcPct val="120000"/>
+              </a:lnSpc>
+              <a:buNone/>
+            </a:pPr>
+            <a:r>
+              <a:rPr lang="pt-PT" sz="4000" u="sng" dirty="0">
+                <a:latin typeface="IBM Plex Sans SemiBold" panose="020B0703050203000203" pitchFamily="34" charset="0"/>
+              </a:rPr>
+              <a:t>na santa Igreja Católica; </a:t>
+            </a:r>
+          </a:p>
+          <a:p>
+            <a:pPr marL="0" indent="0" algn="ctr">
+              <a:lnSpc>
+                <a:spcPct val="120000"/>
+              </a:lnSpc>
+              <a:buNone/>
+            </a:pPr>
+            <a:r>
+              <a:rPr lang="pt-PT" sz="4000" dirty="0"/>
+              <a:t>na comunhão dos Santos; </a:t>
+            </a:r>
+          </a:p>
+          <a:p>
+            <a:pPr marL="0" indent="0" algn="ctr">
+              <a:lnSpc>
+                <a:spcPct val="120000"/>
+              </a:lnSpc>
+              <a:buNone/>
+            </a:pPr>
+            <a:r>
+              <a:rPr lang="pt-PT" sz="4000" dirty="0"/>
+              <a:t>na remissão dos pecados; </a:t>
+            </a:r>
+          </a:p>
+          <a:p>
+            <a:pPr marL="0" indent="0" algn="ctr">
+              <a:lnSpc>
+                <a:spcPct val="120000"/>
+              </a:lnSpc>
+              <a:buNone/>
+            </a:pPr>
+            <a:r>
+              <a:rPr lang="pt-PT" sz="4000" dirty="0"/>
+              <a:t>na ressurreição da carne; </a:t>
+            </a:r>
+          </a:p>
+          <a:p>
+            <a:pPr marL="0" indent="0" algn="ctr">
+              <a:lnSpc>
+                <a:spcPct val="120000"/>
+              </a:lnSpc>
+              <a:buNone/>
+            </a:pPr>
+            <a:r>
+              <a:rPr lang="pt-PT" sz="4000" dirty="0"/>
+              <a:t>na vida eterna.</a:t>
+            </a:r>
+          </a:p>
+          <a:p>
+            <a:pPr marL="0" indent="0" algn="ctr">
+              <a:lnSpc>
+                <a:spcPct val="120000"/>
+              </a:lnSpc>
+              <a:buNone/>
+            </a:pPr>
+            <a:r>
+              <a:rPr lang="pt-PT" sz="4000" dirty="0"/>
+              <a:t>Ámen.</a:t>
+            </a:r>
+          </a:p>
+        </p:txBody>
+      </p:sp>
+    </p:spTree>
+    <p:extLst>
+      <p:ext uri="{BB962C8B-B14F-4D97-AF65-F5344CB8AC3E}">
+        <p14:creationId xmlns:p14="http://schemas.microsoft.com/office/powerpoint/2010/main" val="4031632862"/>
+      </p:ext>
+    </p:extLst>
+  </p:cSld>
+  <p:clrMapOvr>
+    <a:masterClrMapping/>
+  </p:clrMapOvr>
+</p:sldLayout>
+</file>
+
+<file path=ppt/slideLayouts/slideLayout31.xml><?xml version="1.0" encoding="utf-8"?>
+<p:sldLayout xmlns:a="http://schemas.openxmlformats.org/drawingml/2006/main" xmlns:r="http://schemas.openxmlformats.org/officeDocument/2006/relationships" xmlns:p="http://schemas.openxmlformats.org/presentationml/2006/main" preserve="1" userDrawn="1">
+  <p:cSld name="Oração Universal">
+    <p:spTree>
+      <p:nvGrpSpPr>
+        <p:cNvPr id="1" name=""/>
+        <p:cNvGrpSpPr/>
+        <p:nvPr/>
+      </p:nvGrpSpPr>
+      <p:grpSpPr>
+        <a:xfrm>
+          <a:off x="0" y="0"/>
+          <a:ext cx="0" cy="0"/>
+          <a:chOff x="0" y="0"/>
+          <a:chExt cx="0" cy="0"/>
+        </a:xfrm>
+      </p:grpSpPr>
+      <p:sp>
+        <p:nvSpPr>
+          <p:cNvPr id="3" name="Letra">
+            <a:extLst>
+              <a:ext uri="{FF2B5EF4-FFF2-40B4-BE49-F238E27FC236}">
+                <a16:creationId xmlns:a16="http://schemas.microsoft.com/office/drawing/2014/main" id="{7FBA5054-2BE0-6B52-7485-0B10968F39E5}"/>
+              </a:ext>
+            </a:extLst>
+          </p:cNvPr>
+          <p:cNvSpPr>
+            <a:spLocks noGrp="1"/>
+          </p:cNvSpPr>
+          <p:nvPr>
+            <p:ph idx="1" hasCustomPrompt="1"/>
+          </p:nvPr>
+        </p:nvSpPr>
+        <p:spPr>
+          <a:xfrm>
+            <a:off x="549995" y="103695"/>
+            <a:ext cx="8044010" cy="6532775"/>
+          </a:xfrm>
+        </p:spPr>
+        <p:txBody>
+          <a:bodyPr anchor="ctr" anchorCtr="0">
+            <a:normAutofit/>
+          </a:bodyPr>
+          <a:lstStyle>
+            <a:lvl1pPr marL="0" marR="0" indent="0" algn="ctr" defTabSz="685800" rtl="0" eaLnBrk="1" fontAlgn="auto" latinLnBrk="0" hangingPunct="1">
+              <a:lnSpc>
+                <a:spcPct val="130000"/>
+              </a:lnSpc>
+              <a:spcBef>
+                <a:spcPts val="0"/>
+              </a:spcBef>
+              <a:spcAft>
+                <a:spcPts val="0"/>
+              </a:spcAft>
+              <a:buClrTx/>
+              <a:buSzTx/>
+              <a:buFont typeface="Arial" panose="020B0604020202020204" pitchFamily="34" charset="0"/>
+              <a:buNone/>
+              <a:tabLst/>
+              <a:defRPr sz="6000">
+                <a:latin typeface="+mj-lt"/>
+              </a:defRPr>
+            </a:lvl1pPr>
+            <a:lvl2pPr algn="ctr">
+              <a:defRPr/>
+            </a:lvl2pPr>
+            <a:lvl3pPr algn="ctr">
+              <a:defRPr/>
+            </a:lvl3pPr>
+            <a:lvl4pPr algn="ctr">
+              <a:defRPr/>
+            </a:lvl4pPr>
+            <a:lvl5pPr algn="ctr">
+              <a:defRPr/>
+            </a:lvl5pPr>
+          </a:lstStyle>
+          <a:p>
+            <a:pPr lvl="0"/>
+            <a:r>
+              <a:rPr lang="en-US" dirty="0" err="1"/>
+              <a:t>Ouvi-nos</a:t>
+            </a:r>
+            <a:r>
+              <a:rPr lang="en-US" dirty="0"/>
+              <a:t>, Senhor!</a:t>
+            </a:r>
+          </a:p>
+        </p:txBody>
+      </p:sp>
+    </p:spTree>
+    <p:extLst>
+      <p:ext uri="{BB962C8B-B14F-4D97-AF65-F5344CB8AC3E}">
+        <p14:creationId xmlns:p14="http://schemas.microsoft.com/office/powerpoint/2010/main" val="3280188006"/>
+      </p:ext>
+    </p:extLst>
+  </p:cSld>
+  <p:clrMapOvr>
+    <a:masterClrMapping/>
+  </p:clrMapOvr>
+</p:sldLayout>
+</file>
+
+<file path=ppt/slideLayouts/slideLayout32.xml><?xml version="1.0" encoding="utf-8"?>
 <p:sldLayout xmlns:a="http://schemas.openxmlformats.org/drawingml/2006/main" xmlns:r="http://schemas.openxmlformats.org/officeDocument/2006/relationships" xmlns:p="http://schemas.openxmlformats.org/presentationml/2006/main" preserve="1" userDrawn="1">
   <p:cSld name="Preparação das oferendas">
     <p:spTree>
@@ -4426,7 +5205,7 @@
 </p:sldLayout>
 </file>
 
-<file path=ppt/slideLayouts/slideLayout31.xml><?xml version="1.0" encoding="utf-8"?>
+<file path=ppt/slideLayouts/slideLayout33.xml><?xml version="1.0" encoding="utf-8"?>
 <p:sldLayout xmlns:a="http://schemas.openxmlformats.org/drawingml/2006/main" xmlns:r="http://schemas.openxmlformats.org/officeDocument/2006/relationships" xmlns:p="http://schemas.openxmlformats.org/presentationml/2006/main" preserve="1" userDrawn="1">
   <p:cSld name="Diálogo Prefácio">
     <p:spTree>
@@ -4569,7 +5348,7 @@
 </p:sldLayout>
 </file>
 
-<file path=ppt/slideLayouts/slideLayout32.xml><?xml version="1.0" encoding="utf-8"?>
+<file path=ppt/slideLayouts/slideLayout34.xml><?xml version="1.0" encoding="utf-8"?>
 <p:sldLayout xmlns:a="http://schemas.openxmlformats.org/drawingml/2006/main" xmlns:r="http://schemas.openxmlformats.org/officeDocument/2006/relationships" xmlns:p="http://schemas.openxmlformats.org/presentationml/2006/main" preserve="1" userDrawn="1">
   <p:cSld name="Aclamação Memorial">
     <p:spTree>
@@ -4657,7 +5436,7 @@
 </p:sldLayout>
 </file>
 
-<file path=ppt/slideLayouts/slideLayout33.xml><?xml version="1.0" encoding="utf-8"?>
+<file path=ppt/slideLayouts/slideLayout35.xml><?xml version="1.0" encoding="utf-8"?>
 <p:sldLayout xmlns:a="http://schemas.openxmlformats.org/drawingml/2006/main" xmlns:r="http://schemas.openxmlformats.org/officeDocument/2006/relationships" xmlns:p="http://schemas.openxmlformats.org/presentationml/2006/main" preserve="1" userDrawn="1">
   <p:cSld name="Aclamação">
     <p:spTree>
@@ -4748,7 +5527,7 @@
 </p:sldLayout>
 </file>
 
-<file path=ppt/slideLayouts/slideLayout34.xml><?xml version="1.0" encoding="utf-8"?>
+<file path=ppt/slideLayouts/slideLayout36.xml><?xml version="1.0" encoding="utf-8"?>
 <p:sldLayout xmlns:a="http://schemas.openxmlformats.org/drawingml/2006/main" xmlns:r="http://schemas.openxmlformats.org/officeDocument/2006/relationships" xmlns:p="http://schemas.openxmlformats.org/presentationml/2006/main" preserve="1" userDrawn="1">
   <p:cSld name="Convite à Comunhão">
     <p:spTree>
@@ -4839,7 +5618,7 @@
 </p:sldLayout>
 </file>
 
-<file path=ppt/slideLayouts/slideLayout35.xml><?xml version="1.0" encoding="utf-8"?>
+<file path=ppt/slideLayouts/slideLayout37.xml><?xml version="1.0" encoding="utf-8"?>
 <p:sldLayout xmlns:a="http://schemas.openxmlformats.org/drawingml/2006/main" xmlns:r="http://schemas.openxmlformats.org/officeDocument/2006/relationships" xmlns:p="http://schemas.openxmlformats.org/presentationml/2006/main" preserve="1" userDrawn="1">
   <p:cSld name="Leitura 1">
     <p:bg>
@@ -5109,7 +5888,7 @@
 </p:sldLayout>
 </file>
 
-<file path=ppt/slideLayouts/slideLayout36.xml><?xml version="1.0" encoding="utf-8"?>
+<file path=ppt/slideLayouts/slideLayout38.xml><?xml version="1.0" encoding="utf-8"?>
 <p:sldLayout xmlns:a="http://schemas.openxmlformats.org/drawingml/2006/main" xmlns:r="http://schemas.openxmlformats.org/officeDocument/2006/relationships" xmlns:p="http://schemas.openxmlformats.org/presentationml/2006/main" preserve="1" userDrawn="1">
   <p:cSld name="Salmo">
     <p:bg>
@@ -5440,7 +6219,7 @@
 </p:sldLayout>
 </file>
 
-<file path=ppt/slideLayouts/slideLayout37.xml><?xml version="1.0" encoding="utf-8"?>
+<file path=ppt/slideLayouts/slideLayout39.xml><?xml version="1.0" encoding="utf-8"?>
 <p:sldLayout xmlns:a="http://schemas.openxmlformats.org/drawingml/2006/main" xmlns:r="http://schemas.openxmlformats.org/officeDocument/2006/relationships" xmlns:p="http://schemas.openxmlformats.org/presentationml/2006/main" preserve="1" userDrawn="1">
   <p:cSld name="Leitura 2">
     <p:bg>
@@ -5710,7 +6489,349 @@
 </p:sldLayout>
 </file>
 
-<file path=ppt/slideLayouts/slideLayout38.xml><?xml version="1.0" encoding="utf-8"?>
+<file path=ppt/slideLayouts/slideLayout4.xml><?xml version="1.0" encoding="utf-8"?>
+<p:sldLayout xmlns:a="http://schemas.openxmlformats.org/drawingml/2006/main" xmlns:r="http://schemas.openxmlformats.org/officeDocument/2006/relationships" xmlns:p="http://schemas.openxmlformats.org/presentationml/2006/main" preserve="1" userDrawn="1">
+  <p:cSld name="Capa - Advento">
+    <p:bg>
+      <p:bgPr>
+        <a:solidFill>
+          <a:schemeClr val="accent2">
+            <a:lumMod val="20000"/>
+            <a:lumOff val="80000"/>
+            <a:alpha val="40000"/>
+          </a:schemeClr>
+        </a:solidFill>
+        <a:effectLst/>
+      </p:bgPr>
+    </p:bg>
+    <p:spTree>
+      <p:nvGrpSpPr>
+        <p:cNvPr id="1" name=""/>
+        <p:cNvGrpSpPr/>
+        <p:nvPr/>
+      </p:nvGrpSpPr>
+      <p:grpSpPr>
+        <a:xfrm>
+          <a:off x="0" y="0"/>
+          <a:ext cx="0" cy="0"/>
+          <a:chOff x="0" y="0"/>
+          <a:chExt cx="0" cy="0"/>
+        </a:xfrm>
+      </p:grpSpPr>
+      <p:sp>
+        <p:nvSpPr>
+          <p:cNvPr id="2" name="Domingo">
+            <a:extLst>
+              <a:ext uri="{FF2B5EF4-FFF2-40B4-BE49-F238E27FC236}">
+                <a16:creationId xmlns:a16="http://schemas.microsoft.com/office/drawing/2014/main" id="{AC6EEB27-5DD2-414A-A29B-10D30F19AC21}"/>
+              </a:ext>
+            </a:extLst>
+          </p:cNvPr>
+          <p:cNvSpPr>
+            <a:spLocks noGrp="1"/>
+          </p:cNvSpPr>
+          <p:nvPr>
+            <p:ph type="ctrTitle" hasCustomPrompt="1"/>
+          </p:nvPr>
+        </p:nvSpPr>
+        <p:spPr>
+          <a:xfrm>
+            <a:off x="1143000" y="1129506"/>
+            <a:ext cx="6858000" cy="1106127"/>
+          </a:xfrm>
+        </p:spPr>
+        <p:txBody>
+          <a:bodyPr anchor="b">
+            <a:normAutofit/>
+          </a:bodyPr>
+          <a:lstStyle>
+            <a:lvl1pPr algn="ctr">
+              <a:defRPr sz="6600" b="1">
+                <a:solidFill>
+                  <a:schemeClr val="accent2"/>
+                </a:solidFill>
+                <a:latin typeface="Playfair Display" pitchFamily="2" charset="0"/>
+              </a:defRPr>
+            </a:lvl1pPr>
+          </a:lstStyle>
+          <a:p>
+            <a:r>
+              <a:rPr lang="en-US" dirty="0"/>
+              <a:t>Domingo IV</a:t>
+            </a:r>
+            <a:endParaRPr lang="pt-PT" dirty="0"/>
+          </a:p>
+        </p:txBody>
+      </p:sp>
+      <p:sp>
+        <p:nvSpPr>
+          <p:cNvPr id="10" name="Versiculo">
+            <a:extLst>
+              <a:ext uri="{FF2B5EF4-FFF2-40B4-BE49-F238E27FC236}">
+                <a16:creationId xmlns:a16="http://schemas.microsoft.com/office/drawing/2014/main" id="{5E840FDF-3863-C2D2-A15A-5646F8E54972}"/>
+              </a:ext>
+            </a:extLst>
+          </p:cNvPr>
+          <p:cNvSpPr>
+            <a:spLocks noGrp="1"/>
+          </p:cNvSpPr>
+          <p:nvPr>
+            <p:ph type="body" sz="quarter" idx="11" hasCustomPrompt="1"/>
+          </p:nvPr>
+        </p:nvSpPr>
+        <p:spPr>
+          <a:xfrm>
+            <a:off x="2597150" y="3439932"/>
+            <a:ext cx="3949700" cy="369838"/>
+          </a:xfrm>
+        </p:spPr>
+        <p:txBody>
+          <a:bodyPr>
+            <a:noAutofit/>
+          </a:bodyPr>
+          <a:lstStyle>
+            <a:lvl1pPr algn="ctr">
+              <a:defRPr lang="pt-PT" sz="1600" b="0" kern="1200" cap="small" spc="0" baseline="0" dirty="0">
+                <a:solidFill>
+                  <a:schemeClr val="tx1"/>
+                </a:solidFill>
+                <a:latin typeface="Livvic" pitchFamily="2" charset="0"/>
+                <a:ea typeface="+mn-ea"/>
+                <a:cs typeface="+mn-cs"/>
+              </a:defRPr>
+            </a:lvl1pPr>
+            <a:lvl2pPr>
+              <a:defRPr sz="1800"/>
+            </a:lvl2pPr>
+            <a:lvl3pPr>
+              <a:defRPr sz="1600"/>
+            </a:lvl3pPr>
+            <a:lvl4pPr>
+              <a:defRPr sz="1600"/>
+            </a:lvl4pPr>
+            <a:lvl5pPr>
+              <a:defRPr sz="1600"/>
+            </a:lvl5pPr>
+          </a:lstStyle>
+          <a:p>
+            <a:pPr marL="0" lvl="0" indent="0" algn="ctr" defTabSz="685800" rtl="0" eaLnBrk="1" latinLnBrk="0" hangingPunct="1">
+              <a:lnSpc>
+                <a:spcPct val="90000"/>
+              </a:lnSpc>
+              <a:spcBef>
+                <a:spcPts val="750"/>
+              </a:spcBef>
+              <a:buFont typeface="Arial" panose="020B0604020202020204" pitchFamily="34" charset="0"/>
+              <a:buNone/>
+            </a:pPr>
+            <a:r>
+              <a:rPr lang="en-US" dirty="0"/>
+              <a:t>Mt 25, 14-30</a:t>
+            </a:r>
+            <a:endParaRPr lang="pt-PT" dirty="0"/>
+          </a:p>
+        </p:txBody>
+      </p:sp>
+      <p:pic>
+        <p:nvPicPr>
+          <p:cNvPr id="5" name="Picture 4">
+            <a:extLst>
+              <a:ext uri="{FF2B5EF4-FFF2-40B4-BE49-F238E27FC236}">
+                <a16:creationId xmlns:a16="http://schemas.microsoft.com/office/drawing/2014/main" id="{CFFB9FFB-187A-E58F-9BD3-81D67A3BC287}"/>
+              </a:ext>
+            </a:extLst>
+          </p:cNvPr>
+          <p:cNvPicPr>
+            <a:picLocks noChangeAspect="1"/>
+          </p:cNvPicPr>
+          <p:nvPr userDrawn="1"/>
+        </p:nvPicPr>
+        <p:blipFill>
+          <a:blip r:embed="rId2">
+            <a:extLst>
+              <a:ext uri="{28A0092B-C50C-407E-A947-70E740481C1C}">
+                <a14:useLocalDpi xmlns:a14="http://schemas.microsoft.com/office/drawing/2010/main" val="0"/>
+              </a:ext>
+            </a:extLst>
+          </a:blip>
+          <a:srcRect t="47" b="47"/>
+          <a:stretch/>
+        </p:blipFill>
+        <p:spPr>
+          <a:xfrm>
+            <a:off x="2597150" y="3940404"/>
+            <a:ext cx="3867487" cy="2851608"/>
+          </a:xfrm>
+          <a:prstGeom prst="rect">
+            <a:avLst/>
+          </a:prstGeom>
+        </p:spPr>
+      </p:pic>
+      <p:sp>
+        <p:nvSpPr>
+          <p:cNvPr id="4" name="Tempo">
+            <a:extLst>
+              <a:ext uri="{FF2B5EF4-FFF2-40B4-BE49-F238E27FC236}">
+                <a16:creationId xmlns:a16="http://schemas.microsoft.com/office/drawing/2014/main" id="{FC37DF36-BF80-AA4F-FD0F-95E21C3011EC}"/>
+              </a:ext>
+            </a:extLst>
+          </p:cNvPr>
+          <p:cNvSpPr>
+            <a:spLocks noGrp="1"/>
+          </p:cNvSpPr>
+          <p:nvPr>
+            <p:ph type="body" sz="quarter" idx="10" hasCustomPrompt="1"/>
+          </p:nvPr>
+        </p:nvSpPr>
+        <p:spPr>
+          <a:xfrm>
+            <a:off x="2074048" y="654543"/>
+            <a:ext cx="4913689" cy="369838"/>
+          </a:xfrm>
+        </p:spPr>
+        <p:txBody>
+          <a:bodyPr>
+            <a:noAutofit/>
+          </a:bodyPr>
+          <a:lstStyle>
+            <a:lvl1pPr algn="ctr">
+              <a:defRPr sz="1800" b="0" cap="small" spc="600" baseline="0">
+                <a:latin typeface="Livvic" pitchFamily="2" charset="0"/>
+              </a:defRPr>
+            </a:lvl1pPr>
+            <a:lvl2pPr>
+              <a:defRPr sz="1800"/>
+            </a:lvl2pPr>
+            <a:lvl3pPr>
+              <a:defRPr sz="1600"/>
+            </a:lvl3pPr>
+            <a:lvl4pPr>
+              <a:defRPr sz="1600"/>
+            </a:lvl4pPr>
+            <a:lvl5pPr>
+              <a:defRPr sz="1600"/>
+            </a:lvl5pPr>
+          </a:lstStyle>
+          <a:p>
+            <a:pPr lvl="0"/>
+            <a:r>
+              <a:rPr lang="en-US" dirty="0"/>
+              <a:t>Tempo de </a:t>
+            </a:r>
+            <a:r>
+              <a:rPr lang="en-US" dirty="0" err="1"/>
+              <a:t>Advento</a:t>
+            </a:r>
+            <a:r>
+              <a:rPr lang="en-US" dirty="0"/>
+              <a:t> </a:t>
+            </a:r>
+            <a:r>
+              <a:rPr lang="pt-PT" dirty="0"/>
+              <a:t>· </a:t>
+            </a:r>
+            <a:r>
+              <a:rPr lang="en-US" dirty="0"/>
+              <a:t>Ano A</a:t>
+            </a:r>
+            <a:endParaRPr lang="pt-PT" dirty="0"/>
+          </a:p>
+        </p:txBody>
+      </p:sp>
+      <p:sp>
+        <p:nvSpPr>
+          <p:cNvPr id="6" name="Frase">
+            <a:extLst>
+              <a:ext uri="{FF2B5EF4-FFF2-40B4-BE49-F238E27FC236}">
+                <a16:creationId xmlns:a16="http://schemas.microsoft.com/office/drawing/2014/main" id="{6F230E96-DA9A-242A-239B-91C6FC0D1E0D}"/>
+              </a:ext>
+            </a:extLst>
+          </p:cNvPr>
+          <p:cNvSpPr>
+            <a:spLocks noGrp="1"/>
+          </p:cNvSpPr>
+          <p:nvPr>
+            <p:ph type="subTitle" idx="1" hasCustomPrompt="1"/>
+          </p:nvPr>
+        </p:nvSpPr>
+        <p:spPr>
+          <a:xfrm>
+            <a:off x="494907" y="2525677"/>
+            <a:ext cx="8154186" cy="914255"/>
+          </a:xfrm>
+        </p:spPr>
+        <p:txBody>
+          <a:bodyPr anchor="ctr" anchorCtr="0">
+            <a:noAutofit/>
+          </a:bodyPr>
+          <a:lstStyle>
+            <a:lvl1pPr marL="0" indent="0" algn="ctr">
+              <a:buNone/>
+              <a:defRPr sz="2400">
+                <a:latin typeface="Shadows Into Light Two" panose="02000506000000020004" pitchFamily="2" charset="0"/>
+              </a:defRPr>
+            </a:lvl1pPr>
+            <a:lvl2pPr marL="342900" indent="0" algn="ctr">
+              <a:buNone/>
+              <a:defRPr sz="1500"/>
+            </a:lvl2pPr>
+            <a:lvl3pPr marL="685800" indent="0" algn="ctr">
+              <a:buNone/>
+              <a:defRPr sz="1350"/>
+            </a:lvl3pPr>
+            <a:lvl4pPr marL="1028700" indent="0" algn="ctr">
+              <a:buNone/>
+              <a:defRPr sz="1200"/>
+            </a:lvl4pPr>
+            <a:lvl5pPr marL="1371600" indent="0" algn="ctr">
+              <a:buNone/>
+              <a:defRPr sz="1200"/>
+            </a:lvl5pPr>
+            <a:lvl6pPr marL="1714500" indent="0" algn="ctr">
+              <a:buNone/>
+              <a:defRPr sz="1200"/>
+            </a:lvl6pPr>
+            <a:lvl7pPr marL="2057400" indent="0" algn="ctr">
+              <a:buNone/>
+              <a:defRPr sz="1200"/>
+            </a:lvl7pPr>
+            <a:lvl8pPr marL="2400300" indent="0" algn="ctr">
+              <a:buNone/>
+              <a:defRPr sz="1200"/>
+            </a:lvl8pPr>
+            <a:lvl9pPr marL="2743200" indent="0" algn="ctr">
+              <a:buNone/>
+              <a:defRPr sz="1200"/>
+            </a:lvl9pPr>
+          </a:lstStyle>
+          <a:p>
+            <a:r>
+              <a:rPr lang="pt-PT" dirty="0"/>
+              <a:t>«Foste fiel em coisas pequenas:</a:t>
+            </a:r>
+          </a:p>
+          <a:p>
+            <a:r>
+              <a:rPr lang="pt-PT" dirty="0"/>
+              <a:t>vem tomar parte na alegria do teu Senhor»</a:t>
+            </a:r>
+          </a:p>
+        </p:txBody>
+      </p:sp>
+    </p:spTree>
+    <p:extLst>
+      <p:ext uri="{BB962C8B-B14F-4D97-AF65-F5344CB8AC3E}">
+        <p14:creationId xmlns:p14="http://schemas.microsoft.com/office/powerpoint/2010/main" val="2636666909"/>
+      </p:ext>
+    </p:extLst>
+  </p:cSld>
+  <p:clrMapOvr>
+    <a:masterClrMapping/>
+  </p:clrMapOvr>
+</p:sldLayout>
+</file>
+
+<file path=ppt/slideLayouts/slideLayout40.xml><?xml version="1.0" encoding="utf-8"?>
 <p:sldLayout xmlns:a="http://schemas.openxmlformats.org/drawingml/2006/main" xmlns:r="http://schemas.openxmlformats.org/officeDocument/2006/relationships" xmlns:p="http://schemas.openxmlformats.org/presentationml/2006/main" preserve="1" userDrawn="1">
   <p:cSld name="Louvor a vós">
     <p:bg>
@@ -6191,7 +7312,7 @@
 </p:sldLayout>
 </file>
 
-<file path=ppt/slideLayouts/slideLayout39.xml><?xml version="1.0" encoding="utf-8"?>
+<file path=ppt/slideLayouts/slideLayout41.xml><?xml version="1.0" encoding="utf-8"?>
 <p:sldLayout xmlns:a="http://schemas.openxmlformats.org/drawingml/2006/main" xmlns:r="http://schemas.openxmlformats.org/officeDocument/2006/relationships" xmlns:p="http://schemas.openxmlformats.org/presentationml/2006/main" preserve="1" userDrawn="1">
   <p:cSld name="Evangelho">
     <p:bg>
@@ -6461,7 +7582,349 @@
 </p:sldLayout>
 </file>
 
-<file path=ppt/slideLayouts/slideLayout4.xml><?xml version="1.0" encoding="utf-8"?>
+<file path=ppt/slideLayouts/slideLayout5.xml><?xml version="1.0" encoding="utf-8"?>
+<p:sldLayout xmlns:a="http://schemas.openxmlformats.org/drawingml/2006/main" xmlns:r="http://schemas.openxmlformats.org/officeDocument/2006/relationships" xmlns:p="http://schemas.openxmlformats.org/presentationml/2006/main" preserve="1" userDrawn="1">
+  <p:cSld name="Capa - Domingo III Advento">
+    <p:bg>
+      <p:bgPr>
+        <a:solidFill>
+          <a:schemeClr val="accent3">
+            <a:lumMod val="40000"/>
+            <a:lumOff val="60000"/>
+            <a:alpha val="25000"/>
+          </a:schemeClr>
+        </a:solidFill>
+        <a:effectLst/>
+      </p:bgPr>
+    </p:bg>
+    <p:spTree>
+      <p:nvGrpSpPr>
+        <p:cNvPr id="1" name=""/>
+        <p:cNvGrpSpPr/>
+        <p:nvPr/>
+      </p:nvGrpSpPr>
+      <p:grpSpPr>
+        <a:xfrm>
+          <a:off x="0" y="0"/>
+          <a:ext cx="0" cy="0"/>
+          <a:chOff x="0" y="0"/>
+          <a:chExt cx="0" cy="0"/>
+        </a:xfrm>
+      </p:grpSpPr>
+      <p:sp>
+        <p:nvSpPr>
+          <p:cNvPr id="2" name="Domingo">
+            <a:extLst>
+              <a:ext uri="{FF2B5EF4-FFF2-40B4-BE49-F238E27FC236}">
+                <a16:creationId xmlns:a16="http://schemas.microsoft.com/office/drawing/2014/main" id="{AC6EEB27-5DD2-414A-A29B-10D30F19AC21}"/>
+              </a:ext>
+            </a:extLst>
+          </p:cNvPr>
+          <p:cNvSpPr>
+            <a:spLocks noGrp="1"/>
+          </p:cNvSpPr>
+          <p:nvPr>
+            <p:ph type="ctrTitle" hasCustomPrompt="1"/>
+          </p:nvPr>
+        </p:nvSpPr>
+        <p:spPr>
+          <a:xfrm>
+            <a:off x="1143000" y="1129506"/>
+            <a:ext cx="6858000" cy="1106127"/>
+          </a:xfrm>
+        </p:spPr>
+        <p:txBody>
+          <a:bodyPr anchor="b">
+            <a:normAutofit/>
+          </a:bodyPr>
+          <a:lstStyle>
+            <a:lvl1pPr algn="ctr">
+              <a:defRPr sz="6600" b="1">
+                <a:solidFill>
+                  <a:schemeClr val="accent3"/>
+                </a:solidFill>
+                <a:latin typeface="Playfair Display" pitchFamily="2" charset="0"/>
+              </a:defRPr>
+            </a:lvl1pPr>
+          </a:lstStyle>
+          <a:p>
+            <a:r>
+              <a:rPr lang="en-US" dirty="0"/>
+              <a:t>Domingo III</a:t>
+            </a:r>
+            <a:endParaRPr lang="pt-PT" dirty="0"/>
+          </a:p>
+        </p:txBody>
+      </p:sp>
+      <p:sp>
+        <p:nvSpPr>
+          <p:cNvPr id="10" name="Versiculo">
+            <a:extLst>
+              <a:ext uri="{FF2B5EF4-FFF2-40B4-BE49-F238E27FC236}">
+                <a16:creationId xmlns:a16="http://schemas.microsoft.com/office/drawing/2014/main" id="{5E840FDF-3863-C2D2-A15A-5646F8E54972}"/>
+              </a:ext>
+            </a:extLst>
+          </p:cNvPr>
+          <p:cNvSpPr>
+            <a:spLocks noGrp="1"/>
+          </p:cNvSpPr>
+          <p:nvPr>
+            <p:ph type="body" sz="quarter" idx="11" hasCustomPrompt="1"/>
+          </p:nvPr>
+        </p:nvSpPr>
+        <p:spPr>
+          <a:xfrm>
+            <a:off x="2597150" y="3439932"/>
+            <a:ext cx="3949700" cy="369838"/>
+          </a:xfrm>
+        </p:spPr>
+        <p:txBody>
+          <a:bodyPr>
+            <a:noAutofit/>
+          </a:bodyPr>
+          <a:lstStyle>
+            <a:lvl1pPr algn="ctr">
+              <a:defRPr lang="pt-PT" sz="1600" b="0" kern="1200" cap="small" spc="0" baseline="0" dirty="0">
+                <a:solidFill>
+                  <a:schemeClr val="tx1"/>
+                </a:solidFill>
+                <a:latin typeface="Livvic" pitchFamily="2" charset="0"/>
+                <a:ea typeface="+mn-ea"/>
+                <a:cs typeface="+mn-cs"/>
+              </a:defRPr>
+            </a:lvl1pPr>
+            <a:lvl2pPr>
+              <a:defRPr sz="1800"/>
+            </a:lvl2pPr>
+            <a:lvl3pPr>
+              <a:defRPr sz="1600"/>
+            </a:lvl3pPr>
+            <a:lvl4pPr>
+              <a:defRPr sz="1600"/>
+            </a:lvl4pPr>
+            <a:lvl5pPr>
+              <a:defRPr sz="1600"/>
+            </a:lvl5pPr>
+          </a:lstStyle>
+          <a:p>
+            <a:pPr marL="0" lvl="0" indent="0" algn="ctr" defTabSz="685800" rtl="0" eaLnBrk="1" latinLnBrk="0" hangingPunct="1">
+              <a:lnSpc>
+                <a:spcPct val="90000"/>
+              </a:lnSpc>
+              <a:spcBef>
+                <a:spcPts val="750"/>
+              </a:spcBef>
+              <a:buFont typeface="Arial" panose="020B0604020202020204" pitchFamily="34" charset="0"/>
+              <a:buNone/>
+            </a:pPr>
+            <a:r>
+              <a:rPr lang="en-US" dirty="0"/>
+              <a:t>Mt 25, 14-30</a:t>
+            </a:r>
+            <a:endParaRPr lang="pt-PT" dirty="0"/>
+          </a:p>
+        </p:txBody>
+      </p:sp>
+      <p:pic>
+        <p:nvPicPr>
+          <p:cNvPr id="5" name="Picture 4">
+            <a:extLst>
+              <a:ext uri="{FF2B5EF4-FFF2-40B4-BE49-F238E27FC236}">
+                <a16:creationId xmlns:a16="http://schemas.microsoft.com/office/drawing/2014/main" id="{CFFB9FFB-187A-E58F-9BD3-81D67A3BC287}"/>
+              </a:ext>
+            </a:extLst>
+          </p:cNvPr>
+          <p:cNvPicPr>
+            <a:picLocks noChangeAspect="1"/>
+          </p:cNvPicPr>
+          <p:nvPr userDrawn="1"/>
+        </p:nvPicPr>
+        <p:blipFill>
+          <a:blip r:embed="rId2">
+            <a:extLst>
+              <a:ext uri="{28A0092B-C50C-407E-A947-70E740481C1C}">
+                <a14:useLocalDpi xmlns:a14="http://schemas.microsoft.com/office/drawing/2010/main" val="0"/>
+              </a:ext>
+            </a:extLst>
+          </a:blip>
+          <a:srcRect t="47" b="47"/>
+          <a:stretch/>
+        </p:blipFill>
+        <p:spPr>
+          <a:xfrm>
+            <a:off x="2597150" y="3940404"/>
+            <a:ext cx="3867487" cy="2851608"/>
+          </a:xfrm>
+          <a:prstGeom prst="rect">
+            <a:avLst/>
+          </a:prstGeom>
+        </p:spPr>
+      </p:pic>
+      <p:sp>
+        <p:nvSpPr>
+          <p:cNvPr id="4" name="Tempo">
+            <a:extLst>
+              <a:ext uri="{FF2B5EF4-FFF2-40B4-BE49-F238E27FC236}">
+                <a16:creationId xmlns:a16="http://schemas.microsoft.com/office/drawing/2014/main" id="{FC37DF36-BF80-AA4F-FD0F-95E21C3011EC}"/>
+              </a:ext>
+            </a:extLst>
+          </p:cNvPr>
+          <p:cNvSpPr>
+            <a:spLocks noGrp="1"/>
+          </p:cNvSpPr>
+          <p:nvPr>
+            <p:ph type="body" sz="quarter" idx="10" hasCustomPrompt="1"/>
+          </p:nvPr>
+        </p:nvSpPr>
+        <p:spPr>
+          <a:xfrm>
+            <a:off x="2074048" y="654543"/>
+            <a:ext cx="4913689" cy="369838"/>
+          </a:xfrm>
+        </p:spPr>
+        <p:txBody>
+          <a:bodyPr>
+            <a:noAutofit/>
+          </a:bodyPr>
+          <a:lstStyle>
+            <a:lvl1pPr algn="ctr">
+              <a:defRPr sz="1800" b="0" cap="small" spc="600" baseline="0">
+                <a:latin typeface="Livvic" pitchFamily="2" charset="0"/>
+              </a:defRPr>
+            </a:lvl1pPr>
+            <a:lvl2pPr>
+              <a:defRPr sz="1800"/>
+            </a:lvl2pPr>
+            <a:lvl3pPr>
+              <a:defRPr sz="1600"/>
+            </a:lvl3pPr>
+            <a:lvl4pPr>
+              <a:defRPr sz="1600"/>
+            </a:lvl4pPr>
+            <a:lvl5pPr>
+              <a:defRPr sz="1600"/>
+            </a:lvl5pPr>
+          </a:lstStyle>
+          <a:p>
+            <a:pPr lvl="0"/>
+            <a:r>
+              <a:rPr lang="en-US" dirty="0"/>
+              <a:t>Tempo de </a:t>
+            </a:r>
+            <a:r>
+              <a:rPr lang="en-US" dirty="0" err="1"/>
+              <a:t>Advento</a:t>
+            </a:r>
+            <a:r>
+              <a:rPr lang="en-US" dirty="0"/>
+              <a:t> </a:t>
+            </a:r>
+            <a:r>
+              <a:rPr lang="pt-PT" dirty="0"/>
+              <a:t>· </a:t>
+            </a:r>
+            <a:r>
+              <a:rPr lang="en-US" dirty="0"/>
+              <a:t>Ano A</a:t>
+            </a:r>
+            <a:endParaRPr lang="pt-PT" dirty="0"/>
+          </a:p>
+        </p:txBody>
+      </p:sp>
+      <p:sp>
+        <p:nvSpPr>
+          <p:cNvPr id="6" name="Frase">
+            <a:extLst>
+              <a:ext uri="{FF2B5EF4-FFF2-40B4-BE49-F238E27FC236}">
+                <a16:creationId xmlns:a16="http://schemas.microsoft.com/office/drawing/2014/main" id="{FC7D14A6-6188-5DA5-548E-C9EB6ABA72AE}"/>
+              </a:ext>
+            </a:extLst>
+          </p:cNvPr>
+          <p:cNvSpPr>
+            <a:spLocks noGrp="1"/>
+          </p:cNvSpPr>
+          <p:nvPr>
+            <p:ph type="subTitle" idx="1" hasCustomPrompt="1"/>
+          </p:nvPr>
+        </p:nvSpPr>
+        <p:spPr>
+          <a:xfrm>
+            <a:off x="494907" y="2525677"/>
+            <a:ext cx="8154186" cy="914255"/>
+          </a:xfrm>
+        </p:spPr>
+        <p:txBody>
+          <a:bodyPr anchor="ctr" anchorCtr="0">
+            <a:noAutofit/>
+          </a:bodyPr>
+          <a:lstStyle>
+            <a:lvl1pPr marL="0" indent="0" algn="ctr">
+              <a:buNone/>
+              <a:defRPr sz="2400">
+                <a:latin typeface="Shadows Into Light Two" panose="02000506000000020004" pitchFamily="2" charset="0"/>
+              </a:defRPr>
+            </a:lvl1pPr>
+            <a:lvl2pPr marL="342900" indent="0" algn="ctr">
+              <a:buNone/>
+              <a:defRPr sz="1500"/>
+            </a:lvl2pPr>
+            <a:lvl3pPr marL="685800" indent="0" algn="ctr">
+              <a:buNone/>
+              <a:defRPr sz="1350"/>
+            </a:lvl3pPr>
+            <a:lvl4pPr marL="1028700" indent="0" algn="ctr">
+              <a:buNone/>
+              <a:defRPr sz="1200"/>
+            </a:lvl4pPr>
+            <a:lvl5pPr marL="1371600" indent="0" algn="ctr">
+              <a:buNone/>
+              <a:defRPr sz="1200"/>
+            </a:lvl5pPr>
+            <a:lvl6pPr marL="1714500" indent="0" algn="ctr">
+              <a:buNone/>
+              <a:defRPr sz="1200"/>
+            </a:lvl6pPr>
+            <a:lvl7pPr marL="2057400" indent="0" algn="ctr">
+              <a:buNone/>
+              <a:defRPr sz="1200"/>
+            </a:lvl7pPr>
+            <a:lvl8pPr marL="2400300" indent="0" algn="ctr">
+              <a:buNone/>
+              <a:defRPr sz="1200"/>
+            </a:lvl8pPr>
+            <a:lvl9pPr marL="2743200" indent="0" algn="ctr">
+              <a:buNone/>
+              <a:defRPr sz="1200"/>
+            </a:lvl9pPr>
+          </a:lstStyle>
+          <a:p>
+            <a:r>
+              <a:rPr lang="pt-PT" dirty="0"/>
+              <a:t>«Foste fiel em coisas pequenas:</a:t>
+            </a:r>
+          </a:p>
+          <a:p>
+            <a:r>
+              <a:rPr lang="pt-PT" dirty="0"/>
+              <a:t>vem tomar parte na alegria do teu Senhor»</a:t>
+            </a:r>
+          </a:p>
+        </p:txBody>
+      </p:sp>
+    </p:spTree>
+    <p:extLst>
+      <p:ext uri="{BB962C8B-B14F-4D97-AF65-F5344CB8AC3E}">
+        <p14:creationId xmlns:p14="http://schemas.microsoft.com/office/powerpoint/2010/main" val="1642785294"/>
+      </p:ext>
+    </p:extLst>
+  </p:cSld>
+  <p:clrMapOvr>
+    <a:masterClrMapping/>
+  </p:clrMapOvr>
+</p:sldLayout>
+</file>
+
+<file path=ppt/slideLayouts/slideLayout6.xml><?xml version="1.0" encoding="utf-8"?>
 <p:sldLayout xmlns:a="http://schemas.openxmlformats.org/drawingml/2006/main" xmlns:r="http://schemas.openxmlformats.org/officeDocument/2006/relationships" xmlns:p="http://schemas.openxmlformats.org/presentationml/2006/main" preserve="1" userDrawn="1">
   <p:cSld name="Capa - Natal">
     <p:bg>
@@ -6795,7 +8258,7 @@
 </p:sldLayout>
 </file>
 
-<file path=ppt/slideLayouts/slideLayout5.xml><?xml version="1.0" encoding="utf-8"?>
+<file path=ppt/slideLayouts/slideLayout7.xml><?xml version="1.0" encoding="utf-8"?>
 <p:sldLayout xmlns:a="http://schemas.openxmlformats.org/drawingml/2006/main" xmlns:r="http://schemas.openxmlformats.org/officeDocument/2006/relationships" xmlns:p="http://schemas.openxmlformats.org/presentationml/2006/main" preserve="1" userDrawn="1">
   <p:cSld name="Capa - Quaresma">
     <p:bg>
@@ -7129,7 +8592,7 @@
 </p:sldLayout>
 </file>
 
-<file path=ppt/slideLayouts/slideLayout6.xml><?xml version="1.0" encoding="utf-8"?>
+<file path=ppt/slideLayouts/slideLayout8.xml><?xml version="1.0" encoding="utf-8"?>
 <p:sldLayout xmlns:a="http://schemas.openxmlformats.org/drawingml/2006/main" xmlns:r="http://schemas.openxmlformats.org/officeDocument/2006/relationships" xmlns:p="http://schemas.openxmlformats.org/presentationml/2006/main" preserve="1" userDrawn="1">
   <p:cSld name="Capa - Domingo IV Quaresma">
     <p:bg>
@@ -7463,16 +8926,16 @@
 </p:sldLayout>
 </file>
 
-<file path=ppt/slideLayouts/slideLayout7.xml><?xml version="1.0" encoding="utf-8"?>
+<file path=ppt/slideLayouts/slideLayout9.xml><?xml version="1.0" encoding="utf-8"?>
 <p:sldLayout xmlns:a="http://schemas.openxmlformats.org/drawingml/2006/main" xmlns:r="http://schemas.openxmlformats.org/officeDocument/2006/relationships" xmlns:p="http://schemas.openxmlformats.org/presentationml/2006/main" preserve="1" userDrawn="1">
   <p:cSld name="Capa - Ramos">
     <p:bg>
       <p:bgPr>
         <a:solidFill>
           <a:schemeClr val="accent5">
-            <a:lumMod val="40000"/>
-            <a:lumOff val="60000"/>
-            <a:alpha val="25000"/>
+            <a:lumMod val="60000"/>
+            <a:lumOff val="40000"/>
+            <a:alpha val="20000"/>
           </a:schemeClr>
         </a:solidFill>
         <a:effectLst/>
@@ -7788,678 +9251,6 @@
     <p:extLst>
       <p:ext uri="{BB962C8B-B14F-4D97-AF65-F5344CB8AC3E}">
         <p14:creationId xmlns:p14="http://schemas.microsoft.com/office/powerpoint/2010/main" val="3202388809"/>
-      </p:ext>
-    </p:extLst>
-  </p:cSld>
-  <p:clrMapOvr>
-    <a:masterClrMapping/>
-  </p:clrMapOvr>
-</p:sldLayout>
-</file>
-
-<file path=ppt/slideLayouts/slideLayout8.xml><?xml version="1.0" encoding="utf-8"?>
-<p:sldLayout xmlns:a="http://schemas.openxmlformats.org/drawingml/2006/main" xmlns:r="http://schemas.openxmlformats.org/officeDocument/2006/relationships" xmlns:p="http://schemas.openxmlformats.org/presentationml/2006/main" preserve="1" userDrawn="1">
-  <p:cSld name="Capa - Páscoa">
-    <p:bg>
-      <p:bgPr>
-        <a:solidFill>
-          <a:schemeClr val="accent4">
-            <a:lumMod val="20000"/>
-            <a:lumOff val="80000"/>
-            <a:alpha val="20000"/>
-          </a:schemeClr>
-        </a:solidFill>
-        <a:effectLst/>
-      </p:bgPr>
-    </p:bg>
-    <p:spTree>
-      <p:nvGrpSpPr>
-        <p:cNvPr id="1" name=""/>
-        <p:cNvGrpSpPr/>
-        <p:nvPr/>
-      </p:nvGrpSpPr>
-      <p:grpSpPr>
-        <a:xfrm>
-          <a:off x="0" y="0"/>
-          <a:ext cx="0" cy="0"/>
-          <a:chOff x="0" y="0"/>
-          <a:chExt cx="0" cy="0"/>
-        </a:xfrm>
-      </p:grpSpPr>
-      <p:sp>
-        <p:nvSpPr>
-          <p:cNvPr id="2" name="Domingo">
-            <a:extLst>
-              <a:ext uri="{FF2B5EF4-FFF2-40B4-BE49-F238E27FC236}">
-                <a16:creationId xmlns:a16="http://schemas.microsoft.com/office/drawing/2014/main" id="{AC6EEB27-5DD2-414A-A29B-10D30F19AC21}"/>
-              </a:ext>
-            </a:extLst>
-          </p:cNvPr>
-          <p:cNvSpPr>
-            <a:spLocks noGrp="1"/>
-          </p:cNvSpPr>
-          <p:nvPr>
-            <p:ph type="ctrTitle" hasCustomPrompt="1"/>
-          </p:nvPr>
-        </p:nvSpPr>
-        <p:spPr>
-          <a:xfrm>
-            <a:off x="1143000" y="1129506"/>
-            <a:ext cx="6858000" cy="1106127"/>
-          </a:xfrm>
-        </p:spPr>
-        <p:txBody>
-          <a:bodyPr anchor="b">
-            <a:normAutofit/>
-          </a:bodyPr>
-          <a:lstStyle>
-            <a:lvl1pPr algn="ctr">
-              <a:defRPr sz="6600" b="1">
-                <a:solidFill>
-                  <a:schemeClr val="accent4"/>
-                </a:solidFill>
-                <a:latin typeface="Playfair Display" pitchFamily="2" charset="0"/>
-              </a:defRPr>
-            </a:lvl1pPr>
-          </a:lstStyle>
-          <a:p>
-            <a:r>
-              <a:rPr lang="en-US" dirty="0"/>
-              <a:t>Domingo VIII</a:t>
-            </a:r>
-            <a:endParaRPr lang="pt-PT" dirty="0"/>
-          </a:p>
-        </p:txBody>
-      </p:sp>
-      <p:sp>
-        <p:nvSpPr>
-          <p:cNvPr id="10" name="Versiculo">
-            <a:extLst>
-              <a:ext uri="{FF2B5EF4-FFF2-40B4-BE49-F238E27FC236}">
-                <a16:creationId xmlns:a16="http://schemas.microsoft.com/office/drawing/2014/main" id="{5E840FDF-3863-C2D2-A15A-5646F8E54972}"/>
-              </a:ext>
-            </a:extLst>
-          </p:cNvPr>
-          <p:cNvSpPr>
-            <a:spLocks noGrp="1"/>
-          </p:cNvSpPr>
-          <p:nvPr>
-            <p:ph type="body" sz="quarter" idx="11" hasCustomPrompt="1"/>
-          </p:nvPr>
-        </p:nvSpPr>
-        <p:spPr>
-          <a:xfrm>
-            <a:off x="2597150" y="3439932"/>
-            <a:ext cx="3949700" cy="369838"/>
-          </a:xfrm>
-        </p:spPr>
-        <p:txBody>
-          <a:bodyPr>
-            <a:noAutofit/>
-          </a:bodyPr>
-          <a:lstStyle>
-            <a:lvl1pPr algn="ctr">
-              <a:defRPr lang="pt-PT" sz="1600" b="0" kern="1200" cap="small" spc="0" baseline="0" dirty="0">
-                <a:solidFill>
-                  <a:schemeClr val="tx1"/>
-                </a:solidFill>
-                <a:latin typeface="Livvic" pitchFamily="2" charset="0"/>
-                <a:ea typeface="+mn-ea"/>
-                <a:cs typeface="+mn-cs"/>
-              </a:defRPr>
-            </a:lvl1pPr>
-            <a:lvl2pPr>
-              <a:defRPr sz="1800"/>
-            </a:lvl2pPr>
-            <a:lvl3pPr>
-              <a:defRPr sz="1600"/>
-            </a:lvl3pPr>
-            <a:lvl4pPr>
-              <a:defRPr sz="1600"/>
-            </a:lvl4pPr>
-            <a:lvl5pPr>
-              <a:defRPr sz="1600"/>
-            </a:lvl5pPr>
-          </a:lstStyle>
-          <a:p>
-            <a:pPr marL="0" lvl="0" indent="0" algn="ctr" defTabSz="685800" rtl="0" eaLnBrk="1" latinLnBrk="0" hangingPunct="1">
-              <a:lnSpc>
-                <a:spcPct val="90000"/>
-              </a:lnSpc>
-              <a:spcBef>
-                <a:spcPts val="750"/>
-              </a:spcBef>
-              <a:buFont typeface="Arial" panose="020B0604020202020204" pitchFamily="34" charset="0"/>
-              <a:buNone/>
-            </a:pPr>
-            <a:r>
-              <a:rPr lang="en-US" dirty="0"/>
-              <a:t>Mt 25, 14-30</a:t>
-            </a:r>
-            <a:endParaRPr lang="pt-PT" dirty="0"/>
-          </a:p>
-        </p:txBody>
-      </p:sp>
-      <p:pic>
-        <p:nvPicPr>
-          <p:cNvPr id="5" name="Picture 4">
-            <a:extLst>
-              <a:ext uri="{FF2B5EF4-FFF2-40B4-BE49-F238E27FC236}">
-                <a16:creationId xmlns:a16="http://schemas.microsoft.com/office/drawing/2014/main" id="{CFFB9FFB-187A-E58F-9BD3-81D67A3BC287}"/>
-              </a:ext>
-            </a:extLst>
-          </p:cNvPr>
-          <p:cNvPicPr>
-            <a:picLocks noChangeAspect="1"/>
-          </p:cNvPicPr>
-          <p:nvPr userDrawn="1"/>
-        </p:nvPicPr>
-        <p:blipFill>
-          <a:blip r:embed="rId2">
-            <a:extLst>
-              <a:ext uri="{28A0092B-C50C-407E-A947-70E740481C1C}">
-                <a14:useLocalDpi xmlns:a14="http://schemas.microsoft.com/office/drawing/2010/main" val="0"/>
-              </a:ext>
-            </a:extLst>
-          </a:blip>
-          <a:srcRect t="13134" b="13134"/>
-          <a:stretch/>
-        </p:blipFill>
-        <p:spPr>
-          <a:xfrm>
-            <a:off x="2597150" y="3940404"/>
-            <a:ext cx="3867487" cy="2851608"/>
-          </a:xfrm>
-          <a:prstGeom prst="rect">
-            <a:avLst/>
-          </a:prstGeom>
-        </p:spPr>
-      </p:pic>
-      <p:sp>
-        <p:nvSpPr>
-          <p:cNvPr id="4" name="Tempo">
-            <a:extLst>
-              <a:ext uri="{FF2B5EF4-FFF2-40B4-BE49-F238E27FC236}">
-                <a16:creationId xmlns:a16="http://schemas.microsoft.com/office/drawing/2014/main" id="{FC37DF36-BF80-AA4F-FD0F-95E21C3011EC}"/>
-              </a:ext>
-            </a:extLst>
-          </p:cNvPr>
-          <p:cNvSpPr>
-            <a:spLocks noGrp="1"/>
-          </p:cNvSpPr>
-          <p:nvPr>
-            <p:ph type="body" sz="quarter" idx="10" hasCustomPrompt="1"/>
-          </p:nvPr>
-        </p:nvSpPr>
-        <p:spPr>
-          <a:xfrm>
-            <a:off x="2074048" y="654543"/>
-            <a:ext cx="4913689" cy="369838"/>
-          </a:xfrm>
-        </p:spPr>
-        <p:txBody>
-          <a:bodyPr>
-            <a:noAutofit/>
-          </a:bodyPr>
-          <a:lstStyle>
-            <a:lvl1pPr algn="ctr">
-              <a:defRPr sz="1800" b="0" cap="small" spc="600" baseline="0">
-                <a:latin typeface="Livvic" pitchFamily="2" charset="0"/>
-              </a:defRPr>
-            </a:lvl1pPr>
-            <a:lvl2pPr>
-              <a:defRPr sz="1800"/>
-            </a:lvl2pPr>
-            <a:lvl3pPr>
-              <a:defRPr sz="1600"/>
-            </a:lvl3pPr>
-            <a:lvl4pPr>
-              <a:defRPr sz="1600"/>
-            </a:lvl4pPr>
-            <a:lvl5pPr>
-              <a:defRPr sz="1600"/>
-            </a:lvl5pPr>
-          </a:lstStyle>
-          <a:p>
-            <a:pPr lvl="0"/>
-            <a:r>
-              <a:rPr lang="en-US" dirty="0"/>
-              <a:t>Tempo de Páscoa </a:t>
-            </a:r>
-            <a:r>
-              <a:rPr lang="pt-PT" dirty="0"/>
-              <a:t>· </a:t>
-            </a:r>
-            <a:r>
-              <a:rPr lang="en-US" dirty="0"/>
-              <a:t>Ano A</a:t>
-            </a:r>
-            <a:endParaRPr lang="pt-PT" dirty="0"/>
-          </a:p>
-        </p:txBody>
-      </p:sp>
-      <p:sp>
-        <p:nvSpPr>
-          <p:cNvPr id="6" name="Frase">
-            <a:extLst>
-              <a:ext uri="{FF2B5EF4-FFF2-40B4-BE49-F238E27FC236}">
-                <a16:creationId xmlns:a16="http://schemas.microsoft.com/office/drawing/2014/main" id="{D08124FD-CC6B-7059-0C41-242782CD53AF}"/>
-              </a:ext>
-            </a:extLst>
-          </p:cNvPr>
-          <p:cNvSpPr>
-            <a:spLocks noGrp="1"/>
-          </p:cNvSpPr>
-          <p:nvPr>
-            <p:ph type="subTitle" idx="1" hasCustomPrompt="1"/>
-          </p:nvPr>
-        </p:nvSpPr>
-        <p:spPr>
-          <a:xfrm>
-            <a:off x="494907" y="2525677"/>
-            <a:ext cx="8154186" cy="914255"/>
-          </a:xfrm>
-        </p:spPr>
-        <p:txBody>
-          <a:bodyPr anchor="ctr" anchorCtr="0">
-            <a:noAutofit/>
-          </a:bodyPr>
-          <a:lstStyle>
-            <a:lvl1pPr marL="0" indent="0" algn="ctr">
-              <a:buNone/>
-              <a:defRPr sz="2400">
-                <a:latin typeface="Shadows Into Light Two" panose="02000506000000020004" pitchFamily="2" charset="0"/>
-              </a:defRPr>
-            </a:lvl1pPr>
-            <a:lvl2pPr marL="342900" indent="0" algn="ctr">
-              <a:buNone/>
-              <a:defRPr sz="1500"/>
-            </a:lvl2pPr>
-            <a:lvl3pPr marL="685800" indent="0" algn="ctr">
-              <a:buNone/>
-              <a:defRPr sz="1350"/>
-            </a:lvl3pPr>
-            <a:lvl4pPr marL="1028700" indent="0" algn="ctr">
-              <a:buNone/>
-              <a:defRPr sz="1200"/>
-            </a:lvl4pPr>
-            <a:lvl5pPr marL="1371600" indent="0" algn="ctr">
-              <a:buNone/>
-              <a:defRPr sz="1200"/>
-            </a:lvl5pPr>
-            <a:lvl6pPr marL="1714500" indent="0" algn="ctr">
-              <a:buNone/>
-              <a:defRPr sz="1200"/>
-            </a:lvl6pPr>
-            <a:lvl7pPr marL="2057400" indent="0" algn="ctr">
-              <a:buNone/>
-              <a:defRPr sz="1200"/>
-            </a:lvl7pPr>
-            <a:lvl8pPr marL="2400300" indent="0" algn="ctr">
-              <a:buNone/>
-              <a:defRPr sz="1200"/>
-            </a:lvl8pPr>
-            <a:lvl9pPr marL="2743200" indent="0" algn="ctr">
-              <a:buNone/>
-              <a:defRPr sz="1200"/>
-            </a:lvl9pPr>
-          </a:lstStyle>
-          <a:p>
-            <a:r>
-              <a:rPr lang="pt-PT" dirty="0"/>
-              <a:t>«Foste fiel em coisas pequenas:</a:t>
-            </a:r>
-          </a:p>
-          <a:p>
-            <a:r>
-              <a:rPr lang="pt-PT" dirty="0"/>
-              <a:t>vem tomar parte na alegria do teu Senhor»</a:t>
-            </a:r>
-          </a:p>
-        </p:txBody>
-      </p:sp>
-    </p:spTree>
-    <p:extLst>
-      <p:ext uri="{BB962C8B-B14F-4D97-AF65-F5344CB8AC3E}">
-        <p14:creationId xmlns:p14="http://schemas.microsoft.com/office/powerpoint/2010/main" val="3276494890"/>
-      </p:ext>
-    </p:extLst>
-  </p:cSld>
-  <p:clrMapOvr>
-    <a:masterClrMapping/>
-  </p:clrMapOvr>
-</p:sldLayout>
-</file>
-
-<file path=ppt/slideLayouts/slideLayout9.xml><?xml version="1.0" encoding="utf-8"?>
-<p:sldLayout xmlns:a="http://schemas.openxmlformats.org/drawingml/2006/main" xmlns:r="http://schemas.openxmlformats.org/officeDocument/2006/relationships" xmlns:p="http://schemas.openxmlformats.org/presentationml/2006/main" preserve="1" userDrawn="1">
-  <p:cSld name="Capa - Pentecostes">
-    <p:bg>
-      <p:bgPr>
-        <a:solidFill>
-          <a:schemeClr val="accent5">
-            <a:lumMod val="40000"/>
-            <a:lumOff val="60000"/>
-            <a:alpha val="25000"/>
-          </a:schemeClr>
-        </a:solidFill>
-        <a:effectLst/>
-      </p:bgPr>
-    </p:bg>
-    <p:spTree>
-      <p:nvGrpSpPr>
-        <p:cNvPr id="1" name=""/>
-        <p:cNvGrpSpPr/>
-        <p:nvPr/>
-      </p:nvGrpSpPr>
-      <p:grpSpPr>
-        <a:xfrm>
-          <a:off x="0" y="0"/>
-          <a:ext cx="0" cy="0"/>
-          <a:chOff x="0" y="0"/>
-          <a:chExt cx="0" cy="0"/>
-        </a:xfrm>
-      </p:grpSpPr>
-      <p:sp>
-        <p:nvSpPr>
-          <p:cNvPr id="2" name="Domingo">
-            <a:extLst>
-              <a:ext uri="{FF2B5EF4-FFF2-40B4-BE49-F238E27FC236}">
-                <a16:creationId xmlns:a16="http://schemas.microsoft.com/office/drawing/2014/main" id="{AC6EEB27-5DD2-414A-A29B-10D30F19AC21}"/>
-              </a:ext>
-            </a:extLst>
-          </p:cNvPr>
-          <p:cNvSpPr>
-            <a:spLocks noGrp="1"/>
-          </p:cNvSpPr>
-          <p:nvPr>
-            <p:ph type="ctrTitle" hasCustomPrompt="1"/>
-          </p:nvPr>
-        </p:nvSpPr>
-        <p:spPr>
-          <a:xfrm>
-            <a:off x="0" y="1129506"/>
-            <a:ext cx="9144000" cy="1106127"/>
-          </a:xfrm>
-        </p:spPr>
-        <p:txBody>
-          <a:bodyPr anchor="b">
-            <a:noAutofit/>
-          </a:bodyPr>
-          <a:lstStyle>
-            <a:lvl1pPr algn="ctr">
-              <a:defRPr sz="6000" b="1">
-                <a:solidFill>
-                  <a:schemeClr val="accent5"/>
-                </a:solidFill>
-                <a:latin typeface="Playfair Display" pitchFamily="2" charset="0"/>
-              </a:defRPr>
-            </a:lvl1pPr>
-          </a:lstStyle>
-          <a:p>
-            <a:r>
-              <a:rPr lang="en-US" dirty="0"/>
-              <a:t>Domingo de </a:t>
-            </a:r>
-            <a:r>
-              <a:rPr lang="en-US" dirty="0" err="1"/>
-              <a:t>Pentecostes</a:t>
-            </a:r>
-            <a:endParaRPr lang="pt-PT" dirty="0"/>
-          </a:p>
-        </p:txBody>
-      </p:sp>
-      <p:sp>
-        <p:nvSpPr>
-          <p:cNvPr id="10" name="Versiculo">
-            <a:extLst>
-              <a:ext uri="{FF2B5EF4-FFF2-40B4-BE49-F238E27FC236}">
-                <a16:creationId xmlns:a16="http://schemas.microsoft.com/office/drawing/2014/main" id="{5E840FDF-3863-C2D2-A15A-5646F8E54972}"/>
-              </a:ext>
-            </a:extLst>
-          </p:cNvPr>
-          <p:cNvSpPr>
-            <a:spLocks noGrp="1"/>
-          </p:cNvSpPr>
-          <p:nvPr>
-            <p:ph type="body" sz="quarter" idx="11" hasCustomPrompt="1"/>
-          </p:nvPr>
-        </p:nvSpPr>
-        <p:spPr>
-          <a:xfrm>
-            <a:off x="2597150" y="3439932"/>
-            <a:ext cx="3949700" cy="369838"/>
-          </a:xfrm>
-        </p:spPr>
-        <p:txBody>
-          <a:bodyPr>
-            <a:noAutofit/>
-          </a:bodyPr>
-          <a:lstStyle>
-            <a:lvl1pPr algn="ctr">
-              <a:defRPr lang="pt-PT" sz="1600" b="0" kern="1200" cap="small" spc="0" baseline="0" dirty="0">
-                <a:solidFill>
-                  <a:schemeClr val="tx1"/>
-                </a:solidFill>
-                <a:latin typeface="Livvic" pitchFamily="2" charset="0"/>
-                <a:ea typeface="+mn-ea"/>
-                <a:cs typeface="+mn-cs"/>
-              </a:defRPr>
-            </a:lvl1pPr>
-            <a:lvl2pPr>
-              <a:defRPr sz="1800"/>
-            </a:lvl2pPr>
-            <a:lvl3pPr>
-              <a:defRPr sz="1600"/>
-            </a:lvl3pPr>
-            <a:lvl4pPr>
-              <a:defRPr sz="1600"/>
-            </a:lvl4pPr>
-            <a:lvl5pPr>
-              <a:defRPr sz="1600"/>
-            </a:lvl5pPr>
-          </a:lstStyle>
-          <a:p>
-            <a:pPr marL="0" lvl="0" indent="0" algn="ctr" defTabSz="685800" rtl="0" eaLnBrk="1" latinLnBrk="0" hangingPunct="1">
-              <a:lnSpc>
-                <a:spcPct val="90000"/>
-              </a:lnSpc>
-              <a:spcBef>
-                <a:spcPts val="750"/>
-              </a:spcBef>
-              <a:buFont typeface="Arial" panose="020B0604020202020204" pitchFamily="34" charset="0"/>
-              <a:buNone/>
-            </a:pPr>
-            <a:r>
-              <a:rPr lang="en-US" dirty="0"/>
-              <a:t>Mt 25, 14-30</a:t>
-            </a:r>
-            <a:endParaRPr lang="pt-PT" dirty="0"/>
-          </a:p>
-        </p:txBody>
-      </p:sp>
-      <p:pic>
-        <p:nvPicPr>
-          <p:cNvPr id="5" name="Picture 4">
-            <a:extLst>
-              <a:ext uri="{FF2B5EF4-FFF2-40B4-BE49-F238E27FC236}">
-                <a16:creationId xmlns:a16="http://schemas.microsoft.com/office/drawing/2014/main" id="{CFFB9FFB-187A-E58F-9BD3-81D67A3BC287}"/>
-              </a:ext>
-            </a:extLst>
-          </p:cNvPr>
-          <p:cNvPicPr>
-            <a:picLocks noChangeAspect="1"/>
-          </p:cNvPicPr>
-          <p:nvPr userDrawn="1"/>
-        </p:nvPicPr>
-        <p:blipFill>
-          <a:blip r:embed="rId2">
-            <a:extLst>
-              <a:ext uri="{28A0092B-C50C-407E-A947-70E740481C1C}">
-                <a14:useLocalDpi xmlns:a14="http://schemas.microsoft.com/office/drawing/2010/main" val="0"/>
-              </a:ext>
-            </a:extLst>
-          </a:blip>
-          <a:srcRect t="13134" b="13134"/>
-          <a:stretch/>
-        </p:blipFill>
-        <p:spPr>
-          <a:xfrm>
-            <a:off x="2597150" y="3940404"/>
-            <a:ext cx="3867487" cy="2851608"/>
-          </a:xfrm>
-          <a:prstGeom prst="rect">
-            <a:avLst/>
-          </a:prstGeom>
-        </p:spPr>
-      </p:pic>
-      <p:sp>
-        <p:nvSpPr>
-          <p:cNvPr id="4" name="Tempo">
-            <a:extLst>
-              <a:ext uri="{FF2B5EF4-FFF2-40B4-BE49-F238E27FC236}">
-                <a16:creationId xmlns:a16="http://schemas.microsoft.com/office/drawing/2014/main" id="{FC37DF36-BF80-AA4F-FD0F-95E21C3011EC}"/>
-              </a:ext>
-            </a:extLst>
-          </p:cNvPr>
-          <p:cNvSpPr>
-            <a:spLocks noGrp="1"/>
-          </p:cNvSpPr>
-          <p:nvPr>
-            <p:ph type="body" sz="quarter" idx="10" hasCustomPrompt="1"/>
-          </p:nvPr>
-        </p:nvSpPr>
-        <p:spPr>
-          <a:xfrm>
-            <a:off x="2074048" y="654543"/>
-            <a:ext cx="4913689" cy="369838"/>
-          </a:xfrm>
-        </p:spPr>
-        <p:txBody>
-          <a:bodyPr>
-            <a:noAutofit/>
-          </a:bodyPr>
-          <a:lstStyle>
-            <a:lvl1pPr algn="ctr">
-              <a:defRPr sz="1800" b="0" cap="small" spc="600" baseline="0">
-                <a:latin typeface="Livvic" pitchFamily="2" charset="0"/>
-              </a:defRPr>
-            </a:lvl1pPr>
-            <a:lvl2pPr>
-              <a:defRPr sz="1800"/>
-            </a:lvl2pPr>
-            <a:lvl3pPr>
-              <a:defRPr sz="1600"/>
-            </a:lvl3pPr>
-            <a:lvl4pPr>
-              <a:defRPr sz="1600"/>
-            </a:lvl4pPr>
-            <a:lvl5pPr>
-              <a:defRPr sz="1600"/>
-            </a:lvl5pPr>
-          </a:lstStyle>
-          <a:p>
-            <a:pPr lvl="0"/>
-            <a:r>
-              <a:rPr lang="en-US" dirty="0"/>
-              <a:t>Tempo de Páscoa </a:t>
-            </a:r>
-            <a:r>
-              <a:rPr lang="pt-PT" dirty="0"/>
-              <a:t>· </a:t>
-            </a:r>
-            <a:r>
-              <a:rPr lang="en-US" dirty="0"/>
-              <a:t>Ano A</a:t>
-            </a:r>
-            <a:endParaRPr lang="pt-PT" dirty="0"/>
-          </a:p>
-        </p:txBody>
-      </p:sp>
-      <p:sp>
-        <p:nvSpPr>
-          <p:cNvPr id="6" name="Frase">
-            <a:extLst>
-              <a:ext uri="{FF2B5EF4-FFF2-40B4-BE49-F238E27FC236}">
-                <a16:creationId xmlns:a16="http://schemas.microsoft.com/office/drawing/2014/main" id="{0E697FAB-DEF7-E708-A0BC-88BF5E9C774F}"/>
-              </a:ext>
-            </a:extLst>
-          </p:cNvPr>
-          <p:cNvSpPr>
-            <a:spLocks noGrp="1"/>
-          </p:cNvSpPr>
-          <p:nvPr>
-            <p:ph type="subTitle" idx="1" hasCustomPrompt="1"/>
-          </p:nvPr>
-        </p:nvSpPr>
-        <p:spPr>
-          <a:xfrm>
-            <a:off x="494907" y="2525677"/>
-            <a:ext cx="8154186" cy="914255"/>
-          </a:xfrm>
-        </p:spPr>
-        <p:txBody>
-          <a:bodyPr anchor="ctr" anchorCtr="0">
-            <a:noAutofit/>
-          </a:bodyPr>
-          <a:lstStyle>
-            <a:lvl1pPr marL="0" indent="0" algn="ctr">
-              <a:buNone/>
-              <a:defRPr sz="2400">
-                <a:latin typeface="Shadows Into Light Two" panose="02000506000000020004" pitchFamily="2" charset="0"/>
-              </a:defRPr>
-            </a:lvl1pPr>
-            <a:lvl2pPr marL="342900" indent="0" algn="ctr">
-              <a:buNone/>
-              <a:defRPr sz="1500"/>
-            </a:lvl2pPr>
-            <a:lvl3pPr marL="685800" indent="0" algn="ctr">
-              <a:buNone/>
-              <a:defRPr sz="1350"/>
-            </a:lvl3pPr>
-            <a:lvl4pPr marL="1028700" indent="0" algn="ctr">
-              <a:buNone/>
-              <a:defRPr sz="1200"/>
-            </a:lvl4pPr>
-            <a:lvl5pPr marL="1371600" indent="0" algn="ctr">
-              <a:buNone/>
-              <a:defRPr sz="1200"/>
-            </a:lvl5pPr>
-            <a:lvl6pPr marL="1714500" indent="0" algn="ctr">
-              <a:buNone/>
-              <a:defRPr sz="1200"/>
-            </a:lvl6pPr>
-            <a:lvl7pPr marL="2057400" indent="0" algn="ctr">
-              <a:buNone/>
-              <a:defRPr sz="1200"/>
-            </a:lvl7pPr>
-            <a:lvl8pPr marL="2400300" indent="0" algn="ctr">
-              <a:buNone/>
-              <a:defRPr sz="1200"/>
-            </a:lvl8pPr>
-            <a:lvl9pPr marL="2743200" indent="0" algn="ctr">
-              <a:buNone/>
-              <a:defRPr sz="1200"/>
-            </a:lvl9pPr>
-          </a:lstStyle>
-          <a:p>
-            <a:r>
-              <a:rPr lang="pt-PT" dirty="0"/>
-              <a:t>«Foste fiel em coisas pequenas:</a:t>
-            </a:r>
-          </a:p>
-          <a:p>
-            <a:r>
-              <a:rPr lang="pt-PT" dirty="0"/>
-              <a:t>vem tomar parte na alegria do teu Senhor»</a:t>
-            </a:r>
-          </a:p>
-        </p:txBody>
-      </p:sp>
-    </p:spTree>
-    <p:extLst>
-      <p:ext uri="{BB962C8B-B14F-4D97-AF65-F5344CB8AC3E}">
-        <p14:creationId xmlns:p14="http://schemas.microsoft.com/office/powerpoint/2010/main" val="447228626"/>
       </p:ext>
     </p:extLst>
   </p:cSld>
@@ -8745,44 +9536,46 @@
   <p:clrMap bg1="lt1" tx1="dk1" bg2="lt2" tx2="dk2" accent1="accent1" accent2="accent2" accent3="accent3" accent4="accent4" accent5="accent5" accent6="accent6" hlink="hlink" folHlink="folHlink"/>
   <p:sldLayoutIdLst>
     <p:sldLayoutId id="2147483649" r:id="rId1"/>
-    <p:sldLayoutId id="2147483660" r:id="rId2"/>
-    <p:sldLayoutId id="2147483661" r:id="rId3"/>
-    <p:sldLayoutId id="2147483662" r:id="rId4"/>
-    <p:sldLayoutId id="2147483663" r:id="rId5"/>
-    <p:sldLayoutId id="2147483664" r:id="rId6"/>
-    <p:sldLayoutId id="2147483669" r:id="rId7"/>
-    <p:sldLayoutId id="2147483665" r:id="rId8"/>
-    <p:sldLayoutId id="2147483668" r:id="rId9"/>
-    <p:sldLayoutId id="2147483650" r:id="rId10"/>
-    <p:sldLayoutId id="2147483667" r:id="rId11"/>
-    <p:sldLayoutId id="2147483666" r:id="rId12"/>
-    <p:sldLayoutId id="2147483670" r:id="rId13"/>
-    <p:sldLayoutId id="2147483672" r:id="rId14"/>
-    <p:sldLayoutId id="2147483673" r:id="rId15"/>
-    <p:sldLayoutId id="2147483674" r:id="rId16"/>
-    <p:sldLayoutId id="2147483675" r:id="rId17"/>
-    <p:sldLayoutId id="2147483677" r:id="rId18"/>
-    <p:sldLayoutId id="2147483678" r:id="rId19"/>
-    <p:sldLayoutId id="2147483679" r:id="rId20"/>
-    <p:sldLayoutId id="2147483680" r:id="rId21"/>
-    <p:sldLayoutId id="2147483681" r:id="rId22"/>
-    <p:sldLayoutId id="2147483682" r:id="rId23"/>
-    <p:sldLayoutId id="2147483683" r:id="rId24"/>
-    <p:sldLayoutId id="2147483684" r:id="rId25"/>
-    <p:sldLayoutId id="2147483685" r:id="rId26"/>
-    <p:sldLayoutId id="2147483686" r:id="rId27"/>
-    <p:sldLayoutId id="2147483687" r:id="rId28"/>
-    <p:sldLayoutId id="2147483688" r:id="rId29"/>
-    <p:sldLayoutId id="2147483693" r:id="rId30"/>
-    <p:sldLayoutId id="2147483689" r:id="rId31"/>
-    <p:sldLayoutId id="2147483690" r:id="rId32"/>
-    <p:sldLayoutId id="2147483692" r:id="rId33"/>
-    <p:sldLayoutId id="2147483691" r:id="rId34"/>
-    <p:sldLayoutId id="2147483694" r:id="rId35"/>
-    <p:sldLayoutId id="2147483700" r:id="rId36"/>
-    <p:sldLayoutId id="2147483701" r:id="rId37"/>
-    <p:sldLayoutId id="2147483703" r:id="rId38"/>
-    <p:sldLayoutId id="2147483702" r:id="rId39"/>
+    <p:sldLayoutId id="2147483704" r:id="rId2"/>
+    <p:sldLayoutId id="2147483705" r:id="rId3"/>
+    <p:sldLayoutId id="2147483660" r:id="rId4"/>
+    <p:sldLayoutId id="2147483661" r:id="rId5"/>
+    <p:sldLayoutId id="2147483662" r:id="rId6"/>
+    <p:sldLayoutId id="2147483663" r:id="rId7"/>
+    <p:sldLayoutId id="2147483664" r:id="rId8"/>
+    <p:sldLayoutId id="2147483669" r:id="rId9"/>
+    <p:sldLayoutId id="2147483665" r:id="rId10"/>
+    <p:sldLayoutId id="2147483668" r:id="rId11"/>
+    <p:sldLayoutId id="2147483650" r:id="rId12"/>
+    <p:sldLayoutId id="2147483667" r:id="rId13"/>
+    <p:sldLayoutId id="2147483666" r:id="rId14"/>
+    <p:sldLayoutId id="2147483670" r:id="rId15"/>
+    <p:sldLayoutId id="2147483672" r:id="rId16"/>
+    <p:sldLayoutId id="2147483673" r:id="rId17"/>
+    <p:sldLayoutId id="2147483674" r:id="rId18"/>
+    <p:sldLayoutId id="2147483675" r:id="rId19"/>
+    <p:sldLayoutId id="2147483677" r:id="rId20"/>
+    <p:sldLayoutId id="2147483678" r:id="rId21"/>
+    <p:sldLayoutId id="2147483679" r:id="rId22"/>
+    <p:sldLayoutId id="2147483680" r:id="rId23"/>
+    <p:sldLayoutId id="2147483681" r:id="rId24"/>
+    <p:sldLayoutId id="2147483682" r:id="rId25"/>
+    <p:sldLayoutId id="2147483683" r:id="rId26"/>
+    <p:sldLayoutId id="2147483684" r:id="rId27"/>
+    <p:sldLayoutId id="2147483685" r:id="rId28"/>
+    <p:sldLayoutId id="2147483686" r:id="rId29"/>
+    <p:sldLayoutId id="2147483687" r:id="rId30"/>
+    <p:sldLayoutId id="2147483688" r:id="rId31"/>
+    <p:sldLayoutId id="2147483693" r:id="rId32"/>
+    <p:sldLayoutId id="2147483689" r:id="rId33"/>
+    <p:sldLayoutId id="2147483690" r:id="rId34"/>
+    <p:sldLayoutId id="2147483692" r:id="rId35"/>
+    <p:sldLayoutId id="2147483691" r:id="rId36"/>
+    <p:sldLayoutId id="2147483694" r:id="rId37"/>
+    <p:sldLayoutId id="2147483700" r:id="rId38"/>
+    <p:sldLayoutId id="2147483701" r:id="rId39"/>
+    <p:sldLayoutId id="2147483703" r:id="rId40"/>
+    <p:sldLayoutId id="2147483702" r:id="rId41"/>
   </p:sldLayoutIdLst>
   <p:txStyles>
     <p:titleStyle>

</xml_diff>

<commit_message>
feature: serve a local page to build a song deck
</commit_message>
<xml_diff>
--- a/backend/data/template_4x3.pptx
+++ b/backend/data/template_4x3.pptx
@@ -1645,7 +1645,7 @@
         </p:nvCxnSpPr>
         <p:spPr>
           <a:xfrm flipH="1">
-            <a:off x="549995" y="687235"/>
+            <a:off x="444681" y="687235"/>
             <a:ext cx="8254639" cy="0"/>
           </a:xfrm>
           <a:prstGeom prst="line">
@@ -5846,7 +5846,7 @@
         </p:nvCxnSpPr>
         <p:spPr>
           <a:xfrm flipH="1">
-            <a:off x="444680" y="1093829"/>
+            <a:off x="444681" y="1093829"/>
             <a:ext cx="8254639" cy="0"/>
           </a:xfrm>
           <a:prstGeom prst="line">

</xml_diff>

<commit_message>
chore: refactor to user webview2
</commit_message>
<xml_diff>
--- a/backend/data/template_4x3.pptx
+++ b/backend/data/template_4x3.pptx
@@ -209,7 +209,7 @@
           <a:p>
             <a:fld id="{0C3A9764-8E67-4755-B19F-6AABFF615031}" type="datetimeFigureOut">
               <a:rPr lang="pt-PT" smtClean="0"/>
-              <a:t>15/10/2026</a:t>
+              <a:t>17/10/2026</a:t>
             </a:fld>
             <a:endParaRPr lang="pt-PT"/>
           </a:p>
@@ -9430,7 +9430,7 @@
           <a:p>
             <a:fld id="{9F2806AE-2D5A-4F99-BCA8-3392766A92A2}" type="datetimeFigureOut">
               <a:rPr lang="pt-PT" smtClean="0"/>
-              <a:t>15/10/2026</a:t>
+              <a:t>17/10/2026</a:t>
             </a:fld>
             <a:endParaRPr lang="pt-PT"/>
           </a:p>

</xml_diff>

<commit_message>
feature: add a song library and keep italic and underline in the verses
</commit_message>
<xml_diff>
--- a/backend/data/template_4x3.pptx
+++ b/backend/data/template_4x3.pptx
@@ -209,7 +209,7 @@
           <a:p>
             <a:fld id="{0C3A9764-8E67-4755-B19F-6AABFF615031}" type="datetimeFigureOut">
               <a:rPr lang="pt-PT" smtClean="0"/>
-              <a:t>22/10/2026</a:t>
+              <a:t>26/10/2026</a:t>
             </a:fld>
             <a:endParaRPr lang="pt-PT"/>
           </a:p>
@@ -1123,41 +1123,6 @@
           </a:p>
         </p:txBody>
       </p:sp>
-      <p:pic>
-        <p:nvPicPr>
-          <p:cNvPr id="5" name="Picture 4">
-            <a:extLst>
-              <a:ext uri="{FF2B5EF4-FFF2-40B4-BE49-F238E27FC236}">
-                <a16:creationId xmlns:a16="http://schemas.microsoft.com/office/drawing/2014/main" id="{CFFB9FFB-187A-E58F-9BD3-81D67A3BC287}"/>
-              </a:ext>
-            </a:extLst>
-          </p:cNvPr>
-          <p:cNvPicPr>
-            <a:picLocks noChangeAspect="1"/>
-          </p:cNvPicPr>
-          <p:nvPr userDrawn="1"/>
-        </p:nvPicPr>
-        <p:blipFill>
-          <a:blip r:embed="rId2">
-            <a:extLst>
-              <a:ext uri="{28A0092B-C50C-407E-A947-70E740481C1C}">
-                <a14:useLocalDpi xmlns:a14="http://schemas.microsoft.com/office/drawing/2010/main" val="0"/>
-              </a:ext>
-            </a:extLst>
-          </a:blip>
-          <a:srcRect t="13134" b="13134"/>
-          <a:stretch/>
-        </p:blipFill>
-        <p:spPr>
-          <a:xfrm>
-            <a:off x="2597150" y="3940404"/>
-            <a:ext cx="3867487" cy="2851608"/>
-          </a:xfrm>
-          <a:prstGeom prst="rect">
-            <a:avLst/>
-          </a:prstGeom>
-        </p:spPr>
-      </p:pic>
       <p:sp>
         <p:nvSpPr>
           <p:cNvPr id="4" name="Tempo">
@@ -1301,6 +1266,42 @@
           </a:p>
         </p:txBody>
       </p:sp>
+      <p:pic>
+        <p:nvPicPr>
+          <p:cNvPr id="7" name="Picture 6">
+            <a:extLst>
+              <a:ext uri="{FF2B5EF4-FFF2-40B4-BE49-F238E27FC236}">
+                <a16:creationId xmlns:a16="http://schemas.microsoft.com/office/drawing/2014/main" id="{26F0B481-628F-AC90-F243-FFB355C0BBC2}"/>
+              </a:ext>
+            </a:extLst>
+          </p:cNvPr>
+          <p:cNvPicPr>
+            <a:picLocks noChangeAspect="1"/>
+          </p:cNvPicPr>
+          <p:nvPr userDrawn="1"/>
+        </p:nvPicPr>
+        <p:blipFill>
+          <a:blip r:embed="rId2">
+            <a:extLst>
+              <a:ext uri="{28A0092B-C50C-407E-A947-70E740481C1C}">
+                <a14:useLocalDpi xmlns:a14="http://schemas.microsoft.com/office/drawing/2010/main" val="0"/>
+              </a:ext>
+            </a:extLst>
+          </a:blip>
+          <a:stretch>
+            <a:fillRect/>
+          </a:stretch>
+        </p:blipFill>
+        <p:spPr>
+          <a:xfrm>
+            <a:off x="2826000" y="3523764"/>
+            <a:ext cx="3492000" cy="3492000"/>
+          </a:xfrm>
+          <a:prstGeom prst="rect">
+            <a:avLst/>
+          </a:prstGeom>
+        </p:spPr>
+      </p:pic>
     </p:spTree>
     <p:extLst>
       <p:ext uri="{BB962C8B-B14F-4D97-AF65-F5344CB8AC3E}">
@@ -1998,9 +1999,7 @@
     <p:bg>
       <p:bgPr>
         <a:solidFill>
-          <a:srgbClr val="DF5A1F">
-            <a:alpha val="20000"/>
-          </a:srgbClr>
+          <a:srgbClr val="E37931"/>
         </a:solidFill>
         <a:effectLst/>
       </p:bgPr>
@@ -2049,7 +2048,10 @@
             <a:lvl1pPr algn="ctr">
               <a:defRPr sz="6000" b="1">
                 <a:solidFill>
-                  <a:srgbClr val="DF5A1F"/>
+                  <a:schemeClr val="accent4">
+                    <a:lumMod val="60000"/>
+                    <a:lumOff val="40000"/>
+                  </a:schemeClr>
                 </a:solidFill>
                 <a:latin typeface="Playfair Display" pitchFamily="2" charset="0"/>
               </a:defRPr>
@@ -2282,10 +2284,10 @@
       </p:sp>
       <p:pic>
         <p:nvPicPr>
-          <p:cNvPr id="3" name="Picture 2" descr="Copyright information - Taizé">
-            <a:extLst>
-              <a:ext uri="{FF2B5EF4-FFF2-40B4-BE49-F238E27FC236}">
-                <a16:creationId xmlns:a16="http://schemas.microsoft.com/office/drawing/2014/main" id="{14615D30-4B3C-BA4C-8A04-E1BFB724EC4F}"/>
+          <p:cNvPr id="15" name="Picture 14">
+            <a:extLst>
+              <a:ext uri="{FF2B5EF4-FFF2-40B4-BE49-F238E27FC236}">
+                <a16:creationId xmlns:a16="http://schemas.microsoft.com/office/drawing/2014/main" id="{9A7F02BD-D265-EE40-1169-9436D38F3E08}"/>
               </a:ext>
             </a:extLst>
           </p:cNvPr>
@@ -2295,15 +2297,21 @@
           <p:nvPr userDrawn="1"/>
         </p:nvPicPr>
         <p:blipFill>
-          <a:blip r:embed="rId2"/>
+          <a:blip r:embed="rId2">
+            <a:extLst>
+              <a:ext uri="{28A0092B-C50C-407E-A947-70E740481C1C}">
+                <a14:useLocalDpi xmlns:a14="http://schemas.microsoft.com/office/drawing/2010/main" val="0"/>
+              </a:ext>
+            </a:extLst>
+          </a:blip>
           <a:stretch>
             <a:fillRect/>
           </a:stretch>
         </p:blipFill>
         <p:spPr>
           <a:xfrm>
-            <a:off x="3312320" y="3978111"/>
-            <a:ext cx="2519360" cy="2658359"/>
+            <a:off x="3028950" y="3771898"/>
+            <a:ext cx="3086101" cy="3086101"/>
           </a:xfrm>
           <a:prstGeom prst="rect">
             <a:avLst/>
@@ -10446,7 +10454,7 @@
           <a:p>
             <a:fld id="{9F2806AE-2D5A-4F99-BCA8-3392766A92A2}" type="datetimeFigureOut">
               <a:rPr lang="pt-PT" smtClean="0"/>
-              <a:t>22/10/2026</a:t>
+              <a:t>26/10/2026</a:t>
             </a:fld>
             <a:endParaRPr lang="pt-PT"/>
           </a:p>

</xml_diff>